<commit_message>
Explainer: diagram takeaway bar (#46)
</commit_message>
<xml_diff>
--- a/docs/samples/house-style-explainer-v1.pptx
+++ b/docs/samples/house-style-explainer-v1.pptx
@@ -6424,7 +6424,7 @@
         <p:spPr>
           <a:xfrm>
             <a:off x="762000" y="1587500"/>
-            <a:ext cx="10668000" cy="4559300"/>
+            <a:ext cx="10668000" cy="3683000"/>
           </a:xfrm>
           <a:prstGeom prst="rect">
             <a:avLst/>
@@ -6439,7 +6439,7 @@
         </p:nvSpPr>
         <p:spPr>
           <a:xfrm>
-            <a:off x="1504950" y="3568700"/>
+            <a:off x="1504950" y="3765550"/>
             <a:ext cx="1117600" cy="260350"/>
           </a:xfrm>
           <a:prstGeom prst="rect">
@@ -6484,7 +6484,7 @@
         </p:nvSpPr>
         <p:spPr>
           <a:xfrm>
-            <a:off x="1543050" y="3873500"/>
+            <a:off x="1543050" y="4070350"/>
             <a:ext cx="1041400" cy="190500"/>
           </a:xfrm>
           <a:prstGeom prst="rect">
@@ -6529,7 +6529,7 @@
         </p:nvSpPr>
         <p:spPr>
           <a:xfrm>
-            <a:off x="4162425" y="3568700"/>
+            <a:off x="4162425" y="3765550"/>
             <a:ext cx="1016000" cy="260350"/>
           </a:xfrm>
           <a:prstGeom prst="rect">
@@ -6574,7 +6574,7 @@
         </p:nvSpPr>
         <p:spPr>
           <a:xfrm>
-            <a:off x="4127500" y="3873500"/>
+            <a:off x="4127500" y="4070350"/>
             <a:ext cx="1079500" cy="190500"/>
           </a:xfrm>
           <a:prstGeom prst="rect">
@@ -6619,7 +6619,7 @@
         </p:nvSpPr>
         <p:spPr>
           <a:xfrm>
-            <a:off x="6842125" y="3568700"/>
+            <a:off x="6842125" y="3765550"/>
             <a:ext cx="857250" cy="260350"/>
           </a:xfrm>
           <a:prstGeom prst="rect">
@@ -6664,7 +6664,7 @@
         </p:nvSpPr>
         <p:spPr>
           <a:xfrm>
-            <a:off x="6308725" y="3873500"/>
+            <a:off x="6308725" y="4070350"/>
             <a:ext cx="1924050" cy="190500"/>
           </a:xfrm>
           <a:prstGeom prst="rect">
@@ -6709,7 +6709,7 @@
         </p:nvSpPr>
         <p:spPr>
           <a:xfrm>
-            <a:off x="9385300" y="3568700"/>
+            <a:off x="9385300" y="3765550"/>
             <a:ext cx="977900" cy="260350"/>
           </a:xfrm>
           <a:prstGeom prst="rect">
@@ -6754,7 +6754,7 @@
         </p:nvSpPr>
         <p:spPr>
           <a:xfrm>
-            <a:off x="9105900" y="3873500"/>
+            <a:off x="9105900" y="4070350"/>
             <a:ext cx="1536700" cy="190500"/>
           </a:xfrm>
           <a:prstGeom prst="rect">
@@ -6799,7 +6799,7 @@
         </p:nvSpPr>
         <p:spPr>
           <a:xfrm>
-            <a:off x="4625975" y="2597150"/>
+            <a:off x="4625975" y="2794000"/>
             <a:ext cx="2940050" cy="209550"/>
           </a:xfrm>
           <a:prstGeom prst="rect">
@@ -6839,6 +6839,128 @@
       <p:sp>
         <p:nvSpPr>
           <p:cNvPr id="14" name="Box"/>
+          <p:cNvSpPr/>
+          <p:nvPr/>
+        </p:nvSpPr>
+        <p:spPr>
+          <a:xfrm>
+            <a:off x="762000" y="5461000"/>
+            <a:ext cx="10668000" cy="635000"/>
+          </a:xfrm>
+          <a:prstGeom prst="roundRect">
+            <a:avLst>
+              <a:gd name="adj" fmla="val 16000"/>
+            </a:avLst>
+          </a:prstGeom>
+          <a:solidFill>
+            <a:srgbClr val="1D2433"/>
+          </a:solidFill>
+          <a:ln>
+            <a:noFill/>
+          </a:ln>
+          <a:effectLst/>
+        </p:spPr>
+        <p:txBody>
+          <a:bodyPr rtlCol="0" anchor="ctr"/>
+          <a:lstStyle/>
+          <a:p>
+            <a:pPr algn="ctr"/>
+          </a:p>
+        </p:txBody>
+      </p:sp>
+      <p:sp>
+        <p:nvSpPr>
+          <p:cNvPr id="15" name="Text"/>
+          <p:cNvSpPr txBox="1"/>
+          <p:nvPr/>
+        </p:nvSpPr>
+        <p:spPr>
+          <a:xfrm>
+            <a:off x="990600" y="5700662"/>
+            <a:ext cx="680541" cy="155677"/>
+          </a:xfrm>
+          <a:prstGeom prst="rect">
+            <a:avLst/>
+          </a:prstGeom>
+          <a:noFill/>
+        </p:spPr>
+        <p:txBody>
+          <a:bodyPr wrap="none" lIns="0" rIns="0" tIns="0" bIns="0" anchor="t">
+            <a:noAutofit/>
+          </a:bodyPr>
+          <a:lstStyle/>
+          <a:p>
+            <a:pPr algn="l">
+              <a:lnSpc>
+                <a:spcPts val="1225"/>
+              </a:lnSpc>
+              <a:spcBef>
+                <a:spcPts val="0"/>
+              </a:spcBef>
+              <a:spcAft>
+                <a:spcPts val="0"/>
+              </a:spcAft>
+            </a:pPr>
+            <a:r>
+              <a:rPr sz="900" b="1" i="0" spc="126">
+                <a:solidFill>
+                  <a:srgbClr val="B3A9FF"/>
+                </a:solidFill>
+                <a:latin typeface="Noto Sans"/>
+              </a:rPr>
+              <a:t>IN SHORT</a:t>
+            </a:r>
+          </a:p>
+        </p:txBody>
+      </p:sp>
+      <p:sp>
+        <p:nvSpPr>
+          <p:cNvPr id="16" name="Text"/>
+          <p:cNvSpPr txBox="1"/>
+          <p:nvPr/>
+        </p:nvSpPr>
+        <p:spPr>
+          <a:xfrm>
+            <a:off x="1848941" y="5648770"/>
+            <a:ext cx="5906072" cy="259461"/>
+          </a:xfrm>
+          <a:prstGeom prst="rect">
+            <a:avLst/>
+          </a:prstGeom>
+          <a:noFill/>
+        </p:spPr>
+        <p:txBody>
+          <a:bodyPr wrap="square" lIns="0" rIns="0" tIns="0" bIns="0" anchor="t">
+            <a:noAutofit/>
+          </a:bodyPr>
+          <a:lstStyle/>
+          <a:p>
+            <a:pPr algn="l">
+              <a:lnSpc>
+                <a:spcPts val="2043"/>
+              </a:lnSpc>
+              <a:spcBef>
+                <a:spcPts val="0"/>
+              </a:spcBef>
+              <a:spcAft>
+                <a:spcPts val="0"/>
+              </a:spcAft>
+            </a:pPr>
+            <a:r>
+              <a:rPr sz="1500" b="0" i="0">
+                <a:solidFill>
+                  <a:srgbClr val="FFFFFF"/>
+                </a:solidFill>
+                <a:latin typeface="Noto Sans"/>
+              </a:rPr>
+              <a:t>A tool that comes back clean is why the hooks never stay empty.</a:t>
+            </a:r>
+          </a:p>
+        </p:txBody>
+      </p:sp>
+      <p:sp>
+        <p:nvSpPr>
+          <p:cNvPr id="17" name="Box"/>
           <p:cNvSpPr/>
           <p:nvPr/>
         </p:nvSpPr>
@@ -6868,7 +6990,7 @@
       </p:sp>
       <p:sp>
         <p:nvSpPr>
-          <p:cNvPr id="15" name="Text"/>
+          <p:cNvPr id="18" name="Text"/>
           <p:cNvSpPr txBox="1"/>
           <p:nvPr/>
         </p:nvSpPr>
@@ -6922,7 +7044,7 @@
       </p:sp>
       <p:sp>
         <p:nvSpPr>
-          <p:cNvPr id="16" name="Text"/>
+          <p:cNvPr id="19" name="Text"/>
           <p:cNvSpPr txBox="1"/>
           <p:nvPr/>
         </p:nvSpPr>

</xml_diff>

<commit_message>
Explainer: cover title at the exemplar size, presenter 34px (#46)
</commit_message>
<xml_diff>
--- a/docs/samples/house-style-explainer-v1.pptx
+++ b/docs/samples/house-style-explainer-v1.pptx
@@ -4423,8 +4423,8 @@
         </p:nvSpPr>
         <p:spPr>
           <a:xfrm>
-            <a:off x="1016000" y="5645594"/>
-            <a:ext cx="1484694" cy="259461"/>
+            <a:off x="1016000" y="5612422"/>
+            <a:ext cx="1680908" cy="294056"/>
           </a:xfrm>
           <a:prstGeom prst="rect">
             <a:avLst/>
@@ -4439,7 +4439,7 @@
           <a:p>
             <a:pPr algn="l">
               <a:lnSpc>
-                <a:spcPts val="2043"/>
+                <a:spcPts val="2315"/>
               </a:lnSpc>
               <a:spcBef>
                 <a:spcPts val="0"/>
@@ -4449,7 +4449,7 @@
               </a:spcAft>
             </a:pPr>
             <a:r>
-              <a:rPr sz="1500" b="0" i="0">
+              <a:rPr sz="1700" b="0" i="0">
                 <a:solidFill>
                   <a:srgbClr val="C9CBE0"/>
                 </a:solidFill>

</xml_diff>

<commit_message>
Explainer: diagram box 1760 wide for scale parity; v0.15.0 (#46)
</commit_message>
<xml_diff>
--- a/docs/samples/house-style-explainer-v1.pptx
+++ b/docs/samples/house-style-explainer-v1.pptx
@@ -6423,8 +6423,8 @@
         </p:blipFill>
         <p:spPr>
           <a:xfrm>
-            <a:off x="762000" y="1587500"/>
-            <a:ext cx="10668000" cy="4559300"/>
+            <a:off x="508000" y="1587500"/>
+            <a:ext cx="11176000" cy="4559300"/>
           </a:xfrm>
           <a:prstGeom prst="rect">
             <a:avLst/>
@@ -6439,8 +6439,8 @@
         </p:nvSpPr>
         <p:spPr>
           <a:xfrm>
-            <a:off x="1504950" y="3568700"/>
-            <a:ext cx="1117600" cy="260350"/>
+            <a:off x="1287538" y="3551464"/>
+            <a:ext cx="1168400" cy="273050"/>
           </a:xfrm>
           <a:prstGeom prst="rect">
             <a:avLst/>
@@ -6455,7 +6455,7 @@
           <a:p>
             <a:pPr algn="ctr">
               <a:lnSpc>
-                <a:spcPts val="2050"/>
+                <a:spcPts val="2150"/>
               </a:lnSpc>
               <a:spcBef>
                 <a:spcPts val="0"/>
@@ -6465,7 +6465,7 @@
               </a:spcAft>
             </a:pPr>
             <a:r>
-              <a:rPr sz="1500" b="1" i="0">
+              <a:rPr sz="1575" b="1" i="0">
                 <a:solidFill>
                   <a:srgbClr val="1D2433"/>
                 </a:solidFill>
@@ -6484,8 +6484,8 @@
         </p:nvSpPr>
         <p:spPr>
           <a:xfrm>
-            <a:off x="1543050" y="3873500"/>
-            <a:ext cx="1041400" cy="190500"/>
+            <a:off x="1328813" y="3874709"/>
+            <a:ext cx="1085850" cy="203200"/>
           </a:xfrm>
           <a:prstGeom prst="rect">
             <a:avLst/>
@@ -6500,7 +6500,7 @@
           <a:p>
             <a:pPr algn="ctr">
               <a:lnSpc>
-                <a:spcPts val="1500"/>
+                <a:spcPts val="1600"/>
               </a:lnSpc>
               <a:spcBef>
                 <a:spcPts val="0"/>
@@ -6510,7 +6510,7 @@
               </a:spcAft>
             </a:pPr>
             <a:r>
-              <a:rPr sz="1100" b="0" i="0">
+              <a:rPr sz="1150" b="0" i="0">
                 <a:solidFill>
                   <a:srgbClr val="4A5163"/>
                 </a:solidFill>
@@ -6529,8 +6529,8 @@
         </p:nvSpPr>
         <p:spPr>
           <a:xfrm>
-            <a:off x="4162425" y="3568700"/>
-            <a:ext cx="1016000" cy="260350"/>
+            <a:off x="4072164" y="3551464"/>
+            <a:ext cx="1054100" cy="273050"/>
           </a:xfrm>
           <a:prstGeom prst="rect">
             <a:avLst/>
@@ -6545,7 +6545,7 @@
           <a:p>
             <a:pPr algn="ctr">
               <a:lnSpc>
-                <a:spcPts val="2050"/>
+                <a:spcPts val="2150"/>
               </a:lnSpc>
               <a:spcBef>
                 <a:spcPts val="0"/>
@@ -6555,7 +6555,7 @@
               </a:spcAft>
             </a:pPr>
             <a:r>
-              <a:rPr sz="1500" b="1" i="0">
+              <a:rPr sz="1575" b="1" i="0">
                 <a:solidFill>
                   <a:srgbClr val="FFFFFF"/>
                 </a:solidFill>
@@ -6574,8 +6574,8 @@
         </p:nvSpPr>
         <p:spPr>
           <a:xfrm>
-            <a:off x="4127500" y="3873500"/>
-            <a:ext cx="1079500" cy="190500"/>
+            <a:off x="4037239" y="3874709"/>
+            <a:ext cx="1123950" cy="203200"/>
           </a:xfrm>
           <a:prstGeom prst="rect">
             <a:avLst/>
@@ -6590,7 +6590,7 @@
           <a:p>
             <a:pPr algn="ctr">
               <a:lnSpc>
-                <a:spcPts val="1500"/>
+                <a:spcPts val="1600"/>
               </a:lnSpc>
               <a:spcBef>
                 <a:spcPts val="0"/>
@@ -6600,7 +6600,7 @@
               </a:spcAft>
             </a:pPr>
             <a:r>
-              <a:rPr sz="1100" b="0" i="0">
+              <a:rPr sz="1150" b="0" i="0">
                 <a:solidFill>
                   <a:srgbClr val="E4E0FF"/>
                 </a:solidFill>
@@ -6619,8 +6619,8 @@
         </p:nvSpPr>
         <p:spPr>
           <a:xfrm>
-            <a:off x="6842125" y="3568700"/>
-            <a:ext cx="857250" cy="260350"/>
+            <a:off x="6882190" y="3551464"/>
+            <a:ext cx="889000" cy="273050"/>
           </a:xfrm>
           <a:prstGeom prst="rect">
             <a:avLst/>
@@ -6635,7 +6635,7 @@
           <a:p>
             <a:pPr algn="ctr">
               <a:lnSpc>
-                <a:spcPts val="2050"/>
+                <a:spcPts val="2150"/>
               </a:lnSpc>
               <a:spcBef>
                 <a:spcPts val="0"/>
@@ -6645,7 +6645,7 @@
               </a:spcAft>
             </a:pPr>
             <a:r>
-              <a:rPr sz="1500" b="1" i="0">
+              <a:rPr sz="1575" b="1" i="0">
                 <a:solidFill>
                   <a:srgbClr val="1D2433"/>
                 </a:solidFill>
@@ -6664,8 +6664,8 @@
         </p:nvSpPr>
         <p:spPr>
           <a:xfrm>
-            <a:off x="6308725" y="3873500"/>
-            <a:ext cx="1924050" cy="190500"/>
+            <a:off x="6339265" y="3874709"/>
+            <a:ext cx="1974850" cy="203200"/>
           </a:xfrm>
           <a:prstGeom prst="rect">
             <a:avLst/>
@@ -6680,7 +6680,7 @@
           <a:p>
             <a:pPr algn="ctr">
               <a:lnSpc>
-                <a:spcPts val="1500"/>
+                <a:spcPts val="1600"/>
               </a:lnSpc>
               <a:spcBef>
                 <a:spcPts val="0"/>
@@ -6690,7 +6690,7 @@
               </a:spcAft>
             </a:pPr>
             <a:r>
-              <a:rPr sz="1100" b="0" i="0">
+              <a:rPr sz="1150" b="0" i="0">
                 <a:solidFill>
                   <a:srgbClr val="4A5163"/>
                 </a:solidFill>
@@ -6709,8 +6709,8 @@
         </p:nvSpPr>
         <p:spPr>
           <a:xfrm>
-            <a:off x="9385300" y="3568700"/>
-            <a:ext cx="977900" cy="260350"/>
+            <a:off x="9536641" y="3551464"/>
+            <a:ext cx="1035050" cy="273050"/>
           </a:xfrm>
           <a:prstGeom prst="rect">
             <a:avLst/>
@@ -6725,7 +6725,7 @@
           <a:p>
             <a:pPr algn="ctr">
               <a:lnSpc>
-                <a:spcPts val="2050"/>
+                <a:spcPts val="2150"/>
               </a:lnSpc>
               <a:spcBef>
                 <a:spcPts val="0"/>
@@ -6735,7 +6735,7 @@
               </a:spcAft>
             </a:pPr>
             <a:r>
-              <a:rPr sz="1500" b="1" i="0">
+              <a:rPr sz="1575" b="1" i="0">
                 <a:solidFill>
                   <a:srgbClr val="1D2433"/>
                 </a:solidFill>
@@ -6754,8 +6754,8 @@
         </p:nvSpPr>
         <p:spPr>
           <a:xfrm>
-            <a:off x="9105900" y="3873500"/>
-            <a:ext cx="1536700" cy="190500"/>
+            <a:off x="9266767" y="3874709"/>
+            <a:ext cx="1574800" cy="203200"/>
           </a:xfrm>
           <a:prstGeom prst="rect">
             <a:avLst/>
@@ -6770,7 +6770,7 @@
           <a:p>
             <a:pPr algn="ctr">
               <a:lnSpc>
-                <a:spcPts val="1500"/>
+                <a:spcPts val="1600"/>
               </a:lnSpc>
               <a:spcBef>
                 <a:spcPts val="0"/>
@@ -6780,7 +6780,7 @@
               </a:spcAft>
             </a:pPr>
             <a:r>
-              <a:rPr sz="1100" b="0" i="0">
+              <a:rPr sz="1150" b="0" i="0">
                 <a:solidFill>
                   <a:srgbClr val="4A5163"/>
                 </a:solidFill>
@@ -6799,8 +6799,8 @@
         </p:nvSpPr>
         <p:spPr>
           <a:xfrm>
-            <a:off x="4625975" y="2597150"/>
-            <a:ext cx="2940050" cy="209550"/>
+            <a:off x="4530725" y="2538186"/>
+            <a:ext cx="3130550" cy="215900"/>
           </a:xfrm>
           <a:prstGeom prst="rect">
             <a:avLst/>
@@ -6815,7 +6815,7 @@
           <a:p>
             <a:pPr algn="ctr">
               <a:lnSpc>
-                <a:spcPts val="1650"/>
+                <a:spcPts val="1700"/>
               </a:lnSpc>
               <a:spcBef>
                 <a:spcPts val="0"/>
@@ -6825,7 +6825,7 @@
               </a:spcAft>
             </a:pPr>
             <a:r>
-              <a:rPr sz="1200" b="1" i="0">
+              <a:rPr sz="1250" b="1" i="0">
                 <a:solidFill>
                   <a:srgbClr val="5B4BD6"/>
                 </a:solidFill>

</xml_diff>

<commit_message>
Explainer: diagram takeaway bar (#46, 2/4) (#48)
* Explainer: diagram takeaway bar (#46)

* tests: takeaway layout test in its own file (no clash with the other slices)

* tests: takeaway test leaves the diagram's width to the sizing slice
</commit_message>
<xml_diff>
--- a/docs/samples/house-style-explainer-v1.pptx
+++ b/docs/samples/house-style-explainer-v1.pptx
@@ -6424,7 +6424,7 @@
         <p:spPr>
           <a:xfrm>
             <a:off x="762000" y="1587500"/>
-            <a:ext cx="10668000" cy="4559300"/>
+            <a:ext cx="10668000" cy="3683000"/>
           </a:xfrm>
           <a:prstGeom prst="rect">
             <a:avLst/>
@@ -6439,7 +6439,7 @@
         </p:nvSpPr>
         <p:spPr>
           <a:xfrm>
-            <a:off x="1504950" y="3568700"/>
+            <a:off x="1504950" y="3765550"/>
             <a:ext cx="1117600" cy="260350"/>
           </a:xfrm>
           <a:prstGeom prst="rect">
@@ -6484,7 +6484,7 @@
         </p:nvSpPr>
         <p:spPr>
           <a:xfrm>
-            <a:off x="1543050" y="3873500"/>
+            <a:off x="1543050" y="4070350"/>
             <a:ext cx="1041400" cy="190500"/>
           </a:xfrm>
           <a:prstGeom prst="rect">
@@ -6529,7 +6529,7 @@
         </p:nvSpPr>
         <p:spPr>
           <a:xfrm>
-            <a:off x="4162425" y="3568700"/>
+            <a:off x="4162425" y="3765550"/>
             <a:ext cx="1016000" cy="260350"/>
           </a:xfrm>
           <a:prstGeom prst="rect">
@@ -6574,7 +6574,7 @@
         </p:nvSpPr>
         <p:spPr>
           <a:xfrm>
-            <a:off x="4127500" y="3873500"/>
+            <a:off x="4127500" y="4070350"/>
             <a:ext cx="1079500" cy="190500"/>
           </a:xfrm>
           <a:prstGeom prst="rect">
@@ -6619,7 +6619,7 @@
         </p:nvSpPr>
         <p:spPr>
           <a:xfrm>
-            <a:off x="6842125" y="3568700"/>
+            <a:off x="6842125" y="3765550"/>
             <a:ext cx="857250" cy="260350"/>
           </a:xfrm>
           <a:prstGeom prst="rect">
@@ -6664,7 +6664,7 @@
         </p:nvSpPr>
         <p:spPr>
           <a:xfrm>
-            <a:off x="6308725" y="3873500"/>
+            <a:off x="6308725" y="4070350"/>
             <a:ext cx="1924050" cy="190500"/>
           </a:xfrm>
           <a:prstGeom prst="rect">
@@ -6709,7 +6709,7 @@
         </p:nvSpPr>
         <p:spPr>
           <a:xfrm>
-            <a:off x="9385300" y="3568700"/>
+            <a:off x="9385300" y="3765550"/>
             <a:ext cx="977900" cy="260350"/>
           </a:xfrm>
           <a:prstGeom prst="rect">
@@ -6754,7 +6754,7 @@
         </p:nvSpPr>
         <p:spPr>
           <a:xfrm>
-            <a:off x="9105900" y="3873500"/>
+            <a:off x="9105900" y="4070350"/>
             <a:ext cx="1536700" cy="190500"/>
           </a:xfrm>
           <a:prstGeom prst="rect">
@@ -6799,7 +6799,7 @@
         </p:nvSpPr>
         <p:spPr>
           <a:xfrm>
-            <a:off x="4625975" y="2597150"/>
+            <a:off x="4625975" y="2794000"/>
             <a:ext cx="2940050" cy="209550"/>
           </a:xfrm>
           <a:prstGeom prst="rect">
@@ -6839,6 +6839,128 @@
       <p:sp>
         <p:nvSpPr>
           <p:cNvPr id="14" name="Box"/>
+          <p:cNvSpPr/>
+          <p:nvPr/>
+        </p:nvSpPr>
+        <p:spPr>
+          <a:xfrm>
+            <a:off x="762000" y="5461000"/>
+            <a:ext cx="10668000" cy="635000"/>
+          </a:xfrm>
+          <a:prstGeom prst="roundRect">
+            <a:avLst>
+              <a:gd name="adj" fmla="val 16000"/>
+            </a:avLst>
+          </a:prstGeom>
+          <a:solidFill>
+            <a:srgbClr val="1D2433"/>
+          </a:solidFill>
+          <a:ln>
+            <a:noFill/>
+          </a:ln>
+          <a:effectLst/>
+        </p:spPr>
+        <p:txBody>
+          <a:bodyPr rtlCol="0" anchor="ctr"/>
+          <a:lstStyle/>
+          <a:p>
+            <a:pPr algn="ctr"/>
+          </a:p>
+        </p:txBody>
+      </p:sp>
+      <p:sp>
+        <p:nvSpPr>
+          <p:cNvPr id="15" name="Text"/>
+          <p:cNvSpPr txBox="1"/>
+          <p:nvPr/>
+        </p:nvSpPr>
+        <p:spPr>
+          <a:xfrm>
+            <a:off x="990600" y="5700662"/>
+            <a:ext cx="680541" cy="155677"/>
+          </a:xfrm>
+          <a:prstGeom prst="rect">
+            <a:avLst/>
+          </a:prstGeom>
+          <a:noFill/>
+        </p:spPr>
+        <p:txBody>
+          <a:bodyPr wrap="none" lIns="0" rIns="0" tIns="0" bIns="0" anchor="t">
+            <a:noAutofit/>
+          </a:bodyPr>
+          <a:lstStyle/>
+          <a:p>
+            <a:pPr algn="l">
+              <a:lnSpc>
+                <a:spcPts val="1225"/>
+              </a:lnSpc>
+              <a:spcBef>
+                <a:spcPts val="0"/>
+              </a:spcBef>
+              <a:spcAft>
+                <a:spcPts val="0"/>
+              </a:spcAft>
+            </a:pPr>
+            <a:r>
+              <a:rPr sz="900" b="1" i="0" spc="126">
+                <a:solidFill>
+                  <a:srgbClr val="B3A9FF"/>
+                </a:solidFill>
+                <a:latin typeface="Noto Sans"/>
+              </a:rPr>
+              <a:t>IN SHORT</a:t>
+            </a:r>
+          </a:p>
+        </p:txBody>
+      </p:sp>
+      <p:sp>
+        <p:nvSpPr>
+          <p:cNvPr id="16" name="Text"/>
+          <p:cNvSpPr txBox="1"/>
+          <p:nvPr/>
+        </p:nvSpPr>
+        <p:spPr>
+          <a:xfrm>
+            <a:off x="1848941" y="5648770"/>
+            <a:ext cx="5906072" cy="259461"/>
+          </a:xfrm>
+          <a:prstGeom prst="rect">
+            <a:avLst/>
+          </a:prstGeom>
+          <a:noFill/>
+        </p:spPr>
+        <p:txBody>
+          <a:bodyPr wrap="square" lIns="0" rIns="0" tIns="0" bIns="0" anchor="t">
+            <a:noAutofit/>
+          </a:bodyPr>
+          <a:lstStyle/>
+          <a:p>
+            <a:pPr algn="l">
+              <a:lnSpc>
+                <a:spcPts val="2043"/>
+              </a:lnSpc>
+              <a:spcBef>
+                <a:spcPts val="0"/>
+              </a:spcBef>
+              <a:spcAft>
+                <a:spcPts val="0"/>
+              </a:spcAft>
+            </a:pPr>
+            <a:r>
+              <a:rPr sz="1500" b="0" i="0">
+                <a:solidFill>
+                  <a:srgbClr val="FFFFFF"/>
+                </a:solidFill>
+                <a:latin typeface="Noto Sans"/>
+              </a:rPr>
+              <a:t>A tool that comes back clean is why the hooks never stay empty.</a:t>
+            </a:r>
+          </a:p>
+        </p:txBody>
+      </p:sp>
+      <p:sp>
+        <p:nvSpPr>
+          <p:cNvPr id="17" name="Box"/>
           <p:cNvSpPr/>
           <p:nvPr/>
         </p:nvSpPr>
@@ -6868,7 +6990,7 @@
       </p:sp>
       <p:sp>
         <p:nvSpPr>
-          <p:cNvPr id="15" name="Text"/>
+          <p:cNvPr id="18" name="Text"/>
           <p:cNvSpPr txBox="1"/>
           <p:nvPr/>
         </p:nvSpPr>
@@ -6922,7 +7044,7 @@
       </p:sp>
       <p:sp>
         <p:nvSpPr>
-          <p:cNvPr id="16" name="Text"/>
+          <p:cNvPr id="19" name="Text"/>
           <p:cNvSpPr txBox="1"/>
           <p:nvPr/>
         </p:nvSpPr>

</xml_diff>

<commit_message>
Explainer cover: title fits one line or wraps balanced, 40px gap to the subtitle (#46)
</commit_message>
<xml_diff>
--- a/docs/samples/house-style-explainer-v1.pptx
+++ b/docs/samples/house-style-explainer-v1.pptx
@@ -4369,8 +4369,8 @@
         </p:nvSpPr>
         <p:spPr>
           <a:xfrm>
-            <a:off x="1016000" y="2156841"/>
-            <a:ext cx="9810750" cy="1316684"/>
+            <a:off x="1016000" y="2028825"/>
+            <a:ext cx="9810750" cy="514350"/>
           </a:xfrm>
         </p:spPr>
         <p:txBody>
@@ -4381,17 +4381,17 @@
           <a:p>
             <a:pPr algn="l">
               <a:lnSpc>
-                <a:spcPts val="5184"/>
-              </a:lnSpc>
-              <a:spcBef>
-                <a:spcPts val="0"/>
-              </a:spcBef>
-              <a:spcAft>
-                <a:spcPts val="0"/>
-              </a:spcAft>
-            </a:pPr>
-            <a:r>
-              <a:rPr sz="4800" b="1" i="0" spc="-48">
+                <a:spcPts val="4050"/>
+              </a:lnSpc>
+              <a:spcBef>
+                <a:spcPts val="0"/>
+              </a:spcBef>
+              <a:spcAft>
+                <a:spcPts val="0"/>
+              </a:spcAft>
+            </a:pPr>
+            <a:r>
+              <a:rPr sz="3750" b="1" i="0" spc="-75">
                 <a:solidFill>
                   <a:srgbClr val="FFFFFF"/>
                 </a:solidFill>
@@ -4455,7 +4455,7 @@
         </p:nvSpPr>
         <p:spPr>
           <a:xfrm>
-            <a:off x="1016000" y="3586758"/>
+            <a:off x="1016000" y="2797175"/>
             <a:ext cx="9156700" cy="317500"/>
           </a:xfrm>
           <a:prstGeom prst="rect">

</xml_diff>

<commit_message>
Explainer cards, story and two-column panels are compact, not stretched to fill (#46)
</commit_message>
<xml_diff>
--- a/docs/samples/house-style-explainer-v1.pptx
+++ b/docs/samples/house-style-explainer-v1.pptx
@@ -9336,11 +9336,11 @@
         <p:spPr>
           <a:xfrm>
             <a:off x="762000" y="1778000"/>
-            <a:ext cx="3437434" cy="3492500"/>
+            <a:ext cx="3437434" cy="2126952"/>
           </a:xfrm>
           <a:prstGeom prst="roundRect">
             <a:avLst>
-              <a:gd name="adj" fmla="val 2955"/>
+              <a:gd name="adj" fmla="val 4776"/>
             </a:avLst>
           </a:prstGeom>
           <a:solidFill>
@@ -9368,11 +9368,11 @@
         <p:spPr>
           <a:xfrm>
             <a:off x="762000" y="1841500"/>
-            <a:ext cx="3437434" cy="3429000"/>
+            <a:ext cx="3437434" cy="2063452"/>
           </a:xfrm>
           <a:prstGeom prst="roundRect">
             <a:avLst>
-              <a:gd name="adj" fmla="val 1111"/>
+              <a:gd name="adj" fmla="val 1846"/>
             </a:avLst>
           </a:prstGeom>
           <a:solidFill>
@@ -9490,11 +9490,11 @@
         <p:spPr>
           <a:xfrm>
             <a:off x="4377234" y="1778000"/>
-            <a:ext cx="3437434" cy="3492500"/>
+            <a:ext cx="3437434" cy="2126952"/>
           </a:xfrm>
           <a:prstGeom prst="roundRect">
             <a:avLst>
-              <a:gd name="adj" fmla="val 2955"/>
+              <a:gd name="adj" fmla="val 4776"/>
             </a:avLst>
           </a:prstGeom>
           <a:solidFill>
@@ -9522,11 +9522,11 @@
         <p:spPr>
           <a:xfrm>
             <a:off x="4377234" y="1841500"/>
-            <a:ext cx="3437434" cy="3429000"/>
+            <a:ext cx="3437434" cy="2063452"/>
           </a:xfrm>
           <a:prstGeom prst="roundRect">
             <a:avLst>
-              <a:gd name="adj" fmla="val 1111"/>
+              <a:gd name="adj" fmla="val 1846"/>
             </a:avLst>
           </a:prstGeom>
           <a:solidFill>
@@ -9644,11 +9644,11 @@
         <p:spPr>
           <a:xfrm>
             <a:off x="7992467" y="1778000"/>
-            <a:ext cx="3437434" cy="3492500"/>
+            <a:ext cx="3437434" cy="2126952"/>
           </a:xfrm>
           <a:prstGeom prst="roundRect">
             <a:avLst>
-              <a:gd name="adj" fmla="val 2955"/>
+              <a:gd name="adj" fmla="val 4776"/>
             </a:avLst>
           </a:prstGeom>
           <a:solidFill>
@@ -9676,11 +9676,11 @@
         <p:spPr>
           <a:xfrm>
             <a:off x="7992467" y="1841500"/>
-            <a:ext cx="3437434" cy="3429000"/>
+            <a:ext cx="3437434" cy="2063452"/>
           </a:xfrm>
           <a:prstGeom prst="roundRect">
             <a:avLst>
-              <a:gd name="adj" fmla="val 1111"/>
+              <a:gd name="adj" fmla="val 1846"/>
             </a:avLst>
           </a:prstGeom>
           <a:solidFill>
@@ -10210,11 +10210,11 @@
         <p:spPr>
           <a:xfrm>
             <a:off x="762000" y="2095500"/>
-            <a:ext cx="3437434" cy="3175000"/>
+            <a:ext cx="3437434" cy="1627981"/>
           </a:xfrm>
           <a:prstGeom prst="roundRect">
             <a:avLst>
-              <a:gd name="adj" fmla="val 3200"/>
+              <a:gd name="adj" fmla="val 6240"/>
             </a:avLst>
           </a:prstGeom>
           <a:solidFill>
@@ -10334,11 +10334,11 @@
         <p:spPr>
           <a:xfrm>
             <a:off x="4377234" y="2095500"/>
-            <a:ext cx="3437434" cy="3175000"/>
+            <a:ext cx="3437434" cy="1627981"/>
           </a:xfrm>
           <a:prstGeom prst="roundRect">
             <a:avLst>
-              <a:gd name="adj" fmla="val 3200"/>
+              <a:gd name="adj" fmla="val 6240"/>
             </a:avLst>
           </a:prstGeom>
           <a:solidFill>
@@ -10458,11 +10458,11 @@
         <p:spPr>
           <a:xfrm>
             <a:off x="7992467" y="2095500"/>
-            <a:ext cx="3437434" cy="3175000"/>
+            <a:ext cx="3437434" cy="1627981"/>
           </a:xfrm>
           <a:prstGeom prst="roundRect">
             <a:avLst>
-              <a:gd name="adj" fmla="val 3200"/>
+              <a:gd name="adj" fmla="val 6240"/>
             </a:avLst>
           </a:prstGeom>
           <a:solidFill>
@@ -14210,11 +14210,11 @@
         <p:spPr>
           <a:xfrm>
             <a:off x="762000" y="1905000"/>
-            <a:ext cx="5245100" cy="4191000"/>
+            <a:ext cx="5245100" cy="2384822"/>
           </a:xfrm>
           <a:prstGeom prst="roundRect">
             <a:avLst>
-              <a:gd name="adj" fmla="val 2424"/>
+              <a:gd name="adj" fmla="val 4260"/>
             </a:avLst>
           </a:prstGeom>
           <a:solidFill>
@@ -14242,11 +14242,11 @@
         <p:spPr>
           <a:xfrm>
             <a:off x="762000" y="1968500"/>
-            <a:ext cx="5245100" cy="4127500"/>
+            <a:ext cx="5245100" cy="2321322"/>
           </a:xfrm>
           <a:prstGeom prst="roundRect">
             <a:avLst>
-              <a:gd name="adj" fmla="val 923"/>
+              <a:gd name="adj" fmla="val 1641"/>
             </a:avLst>
           </a:prstGeom>
           <a:solidFill>
@@ -14627,11 +14627,11 @@
         <p:spPr>
           <a:xfrm>
             <a:off x="6184900" y="1905000"/>
-            <a:ext cx="5245100" cy="4191000"/>
+            <a:ext cx="5245100" cy="2384822"/>
           </a:xfrm>
           <a:prstGeom prst="roundRect">
             <a:avLst>
-              <a:gd name="adj" fmla="val 2424"/>
+              <a:gd name="adj" fmla="val 4260"/>
             </a:avLst>
           </a:prstGeom>
           <a:solidFill>
@@ -14659,11 +14659,11 @@
         <p:spPr>
           <a:xfrm>
             <a:off x="6184900" y="1968500"/>
-            <a:ext cx="5245100" cy="4127500"/>
+            <a:ext cx="5245100" cy="2321322"/>
           </a:xfrm>
           <a:prstGeom prst="roundRect">
             <a:avLst>
-              <a:gd name="adj" fmla="val 923"/>
+              <a:gd name="adj" fmla="val 1641"/>
             </a:avLst>
           </a:prstGeom>
           <a:solidFill>

</xml_diff>

<commit_message>
Explainer: section title gap, source label contrast, sub lines, six-card sample (#46)
</commit_message>
<xml_diff>
--- a/docs/samples/house-style-explainer-v1.pptx
+++ b/docs/samples/house-style-explainer-v1.pptx
@@ -516,6 +516,12 @@
               <a:t>This deck is an invented example. It shows every kind of slide in the explainer format: title, agenda, statement, diagram, cards, story, mapping table, contrast, two columns, section, quote and closing. The tool shed is made up, and so is every number in it.</a:t>
             </a:r>
           </a:p>
+          <a:p/>
+          <a:p>
+            <a:r>
+              <a:t>Source: Invented example; no real shed</a:t>
+            </a:r>
+          </a:p>
         </p:txBody>
       </p:sp>
       <p:sp>
@@ -586,6 +592,12 @@
               <a:t>A section slide marks a change of subject. Say what comes next in one sentence.</a:t>
             </a:r>
           </a:p>
+          <a:p/>
+          <a:p>
+            <a:r>
+              <a:t>Source: Invented example</a:t>
+            </a:r>
+          </a:p>
         </p:txBody>
       </p:sp>
       <p:sp>
@@ -1033,7 +1045,7 @@
           <a:lstStyle/>
           <a:p>
             <a:r>
-              <a:t>The three jobs. The registrar writes ledger lines. The checker decides what is fit to hang. The host opens the shed. The lesson: every job has a single test, which is why a new volunteer is useful quickly.</a:t>
+              <a:t>Six jobs in a grid of two rows. The registrar writes ledger lines. The checker decides what is fit to hang. The host opens the shed. The mender fixes what the checker sets aside, and the stocker fills the gaps. The last card is grey: a place for helpers who have not taken a job yet. The lesson: every job has a single test, which is why a new volunteer is useful quickly.</a:t>
             </a:r>
           </a:p>
           <a:p/>
@@ -4575,6 +4587,60 @@
         </p:nvSpPr>
         <p:spPr>
           <a:xfrm>
+            <a:off x="762000" y="6495561"/>
+            <a:ext cx="2025650" cy="147028"/>
+          </a:xfrm>
+          <a:prstGeom prst="rect">
+            <a:avLst/>
+          </a:prstGeom>
+          <a:noFill/>
+        </p:spPr>
+        <p:txBody>
+          <a:bodyPr wrap="none" lIns="0" rIns="0" tIns="0" bIns="0" anchor="t">
+            <a:noAutofit/>
+          </a:bodyPr>
+          <a:lstStyle/>
+          <a:p>
+            <a:pPr algn="l">
+              <a:lnSpc>
+                <a:spcPts val="1157"/>
+              </a:lnSpc>
+              <a:spcBef>
+                <a:spcPts val="0"/>
+              </a:spcBef>
+              <a:spcAft>
+                <a:spcPts val="0"/>
+              </a:spcAft>
+            </a:pPr>
+            <a:r>
+              <a:rPr sz="850" b="1" i="0">
+                <a:solidFill>
+                  <a:srgbClr val="8F93AD"/>
+                </a:solidFill>
+                <a:latin typeface="Noto Sans"/>
+              </a:rPr>
+              <a:t>Source:</a:t>
+            </a:r>
+            <a:r>
+              <a:rPr sz="850" b="0" i="0">
+                <a:solidFill>
+                  <a:srgbClr val="8F93AD"/>
+                </a:solidFill>
+                <a:latin typeface="Noto Sans"/>
+              </a:rPr>
+              <a:t> Invented example; no real shed</a:t>
+            </a:r>
+          </a:p>
+        </p:txBody>
+      </p:sp>
+      <p:sp>
+        <p:nvSpPr>
+          <p:cNvPr id="8" name="Text"/>
+          <p:cNvSpPr txBox="1"/>
+          <p:nvPr/>
+        </p:nvSpPr>
+        <p:spPr>
+          <a:xfrm>
             <a:off x="11150600" y="6495561"/>
             <a:ext cx="287782" cy="147028"/>
           </a:xfrm>
@@ -4650,7 +4716,7 @@
         </p:nvSpPr>
         <p:spPr>
           <a:xfrm>
-            <a:off x="1016000" y="1675257"/>
+            <a:off x="1016000" y="2348357"/>
             <a:ext cx="8829675" cy="630936"/>
           </a:xfrm>
         </p:spPr>
@@ -4781,7 +4847,7 @@
         </p:nvSpPr>
         <p:spPr>
           <a:xfrm>
-            <a:off x="1016000" y="2418457"/>
+            <a:off x="1016000" y="3091557"/>
             <a:ext cx="8502650" cy="317500"/>
           </a:xfrm>
           <a:prstGeom prst="rect">
@@ -4851,6 +4917,60 @@
       <p:sp>
         <p:nvSpPr>
           <p:cNvPr id="7" name="Text"/>
+          <p:cNvSpPr txBox="1"/>
+          <p:nvPr/>
+        </p:nvSpPr>
+        <p:spPr>
+          <a:xfrm>
+            <a:off x="762000" y="6495561"/>
+            <a:ext cx="1339850" cy="147028"/>
+          </a:xfrm>
+          <a:prstGeom prst="rect">
+            <a:avLst/>
+          </a:prstGeom>
+          <a:noFill/>
+        </p:spPr>
+        <p:txBody>
+          <a:bodyPr wrap="none" lIns="0" rIns="0" tIns="0" bIns="0" anchor="t">
+            <a:noAutofit/>
+          </a:bodyPr>
+          <a:lstStyle/>
+          <a:p>
+            <a:pPr algn="l">
+              <a:lnSpc>
+                <a:spcPts val="1157"/>
+              </a:lnSpc>
+              <a:spcBef>
+                <a:spcPts val="0"/>
+              </a:spcBef>
+              <a:spcAft>
+                <a:spcPts val="0"/>
+              </a:spcAft>
+            </a:pPr>
+            <a:r>
+              <a:rPr sz="850" b="1" i="0">
+                <a:solidFill>
+                  <a:srgbClr val="D6D1FF"/>
+                </a:solidFill>
+                <a:latin typeface="Noto Sans"/>
+              </a:rPr>
+              <a:t>Source:</a:t>
+            </a:r>
+            <a:r>
+              <a:rPr sz="850" b="0" i="0">
+                <a:solidFill>
+                  <a:srgbClr val="D6D1FF"/>
+                </a:solidFill>
+                <a:latin typeface="Noto Sans"/>
+              </a:rPr>
+              <a:t> Invented example</a:t>
+            </a:r>
+          </a:p>
+        </p:txBody>
+      </p:sp>
+      <p:sp>
+        <p:nvSpPr>
+          <p:cNvPr id="8" name="Text"/>
           <p:cNvSpPr txBox="1"/>
           <p:nvPr/>
         </p:nvSpPr>
@@ -5017,39 +5137,39 @@
         </p:nvSpPr>
         <p:spPr>
           <a:xfrm>
-            <a:off x="482600" y="1625600"/>
-            <a:ext cx="1524000" cy="1651000"/>
-          </a:xfrm>
-          <a:prstGeom prst="rect">
-            <a:avLst/>
-          </a:prstGeom>
-          <a:noFill/>
-        </p:spPr>
-        <p:txBody>
-          <a:bodyPr wrap="none" lIns="0" rIns="0" tIns="0" bIns="0" anchor="t">
+            <a:off x="762000" y="1389757"/>
+            <a:ext cx="9810750" cy="269875"/>
+          </a:xfrm>
+          <a:prstGeom prst="rect">
+            <a:avLst/>
+          </a:prstGeom>
+          <a:noFill/>
+        </p:spPr>
+        <p:txBody>
+          <a:bodyPr wrap="square" lIns="0" rIns="0" tIns="0" bIns="0" anchor="t">
             <a:noAutofit/>
           </a:bodyPr>
           <a:lstStyle/>
           <a:p>
             <a:pPr algn="l">
               <a:lnSpc>
-                <a:spcPts val="13000"/>
-              </a:lnSpc>
-              <a:spcBef>
-                <a:spcPts val="0"/>
-              </a:spcBef>
-              <a:spcAft>
-                <a:spcPts val="0"/>
-              </a:spcAft>
-            </a:pPr>
-            <a:r>
-              <a:rPr sz="10000" b="0" i="0">
-                <a:solidFill>
-                  <a:srgbClr val="C0BAE8"/>
-                </a:solidFill>
-                <a:latin typeface="Noto Serif"/>
-              </a:rPr>
-              <a:t>“</a:t>
+                <a:spcPts val="2125"/>
+              </a:lnSpc>
+              <a:spcBef>
+                <a:spcPts val="0"/>
+              </a:spcBef>
+              <a:spcAft>
+                <a:spcPts val="0"/>
+              </a:spcAft>
+            </a:pPr>
+            <a:r>
+              <a:rPr sz="1700" b="0" i="0">
+                <a:solidFill>
+                  <a:srgbClr val="4A5163"/>
+                </a:solidFill>
+                <a:latin typeface="Noto Sans"/>
+              </a:rPr>
+              <a:t>Said at the end of a first Saturday.</a:t>
             </a:r>
           </a:p>
         </p:txBody>
@@ -5062,57 +5182,39 @@
         </p:nvSpPr>
         <p:spPr>
           <a:xfrm>
-            <a:off x="1168400" y="1900936"/>
-            <a:ext cx="9784588" cy="905165"/>
-          </a:xfrm>
-          <a:prstGeom prst="rect">
-            <a:avLst/>
-          </a:prstGeom>
-          <a:noFill/>
-        </p:spPr>
-        <p:txBody>
-          <a:bodyPr wrap="square" lIns="0" rIns="0" tIns="0" bIns="0" anchor="t">
+            <a:off x="482600" y="1879600"/>
+            <a:ext cx="1524000" cy="1651000"/>
+          </a:xfrm>
+          <a:prstGeom prst="rect">
+            <a:avLst/>
+          </a:prstGeom>
+          <a:noFill/>
+        </p:spPr>
+        <p:txBody>
+          <a:bodyPr wrap="none" lIns="0" rIns="0" tIns="0" bIns="0" anchor="t">
             <a:noAutofit/>
           </a:bodyPr>
           <a:lstStyle/>
           <a:p>
             <a:pPr algn="l">
               <a:lnSpc>
-                <a:spcPts val="3564"/>
-              </a:lnSpc>
-              <a:spcBef>
-                <a:spcPts val="0"/>
-              </a:spcBef>
-              <a:spcAft>
-                <a:spcPts val="0"/>
-              </a:spcAft>
-            </a:pPr>
-            <a:r>
-              <a:rPr sz="2700" b="0" i="0">
-                <a:solidFill>
-                  <a:srgbClr val="1D2433"/>
-                </a:solidFill>
-                <a:latin typeface="Noto Sans"/>
-              </a:rPr>
-              <a:t>I came for a ladder and left with </a:t>
-            </a:r>
-            <a:r>
-              <a:rPr sz="2700" b="1" i="0">
-                <a:solidFill>
-                  <a:srgbClr val="5B4BD6"/>
-                </a:solidFill>
-                <a:latin typeface="Noto Sans"/>
-              </a:rPr>
-              <a:t>the confidence</a:t>
-            </a:r>
-            <a:r>
-              <a:rPr sz="2700" b="0" i="0">
-                <a:solidFill>
-                  <a:srgbClr val="1D2433"/>
-                </a:solidFill>
-                <a:latin typeface="Noto Sans"/>
-              </a:rPr>
-              <a:t> to ask for a second tool next week.</a:t>
+                <a:spcPts val="13000"/>
+              </a:lnSpc>
+              <a:spcBef>
+                <a:spcPts val="0"/>
+              </a:spcBef>
+              <a:spcAft>
+                <a:spcPts val="0"/>
+              </a:spcAft>
+            </a:pPr>
+            <a:r>
+              <a:rPr sz="10000" b="0" i="0">
+                <a:solidFill>
+                  <a:srgbClr val="C0BAE8"/>
+                </a:solidFill>
+                <a:latin typeface="Noto Serif"/>
+              </a:rPr>
+              <a:t>“</a:t>
             </a:r>
           </a:p>
         </p:txBody>
@@ -5125,7 +5227,70 @@
         </p:nvSpPr>
         <p:spPr>
           <a:xfrm>
-            <a:off x="1168400" y="3038242"/>
+            <a:off x="1168400" y="2154936"/>
+            <a:ext cx="9784588" cy="905165"/>
+          </a:xfrm>
+          <a:prstGeom prst="rect">
+            <a:avLst/>
+          </a:prstGeom>
+          <a:noFill/>
+        </p:spPr>
+        <p:txBody>
+          <a:bodyPr wrap="square" lIns="0" rIns="0" tIns="0" bIns="0" anchor="t">
+            <a:noAutofit/>
+          </a:bodyPr>
+          <a:lstStyle/>
+          <a:p>
+            <a:pPr algn="l">
+              <a:lnSpc>
+                <a:spcPts val="3564"/>
+              </a:lnSpc>
+              <a:spcBef>
+                <a:spcPts val="0"/>
+              </a:spcBef>
+              <a:spcAft>
+                <a:spcPts val="0"/>
+              </a:spcAft>
+            </a:pPr>
+            <a:r>
+              <a:rPr sz="2700" b="0" i="0">
+                <a:solidFill>
+                  <a:srgbClr val="1D2433"/>
+                </a:solidFill>
+                <a:latin typeface="Noto Sans"/>
+              </a:rPr>
+              <a:t>I came for a ladder and left with </a:t>
+            </a:r>
+            <a:r>
+              <a:rPr sz="2700" b="1" i="0">
+                <a:solidFill>
+                  <a:srgbClr val="5B4BD6"/>
+                </a:solidFill>
+                <a:latin typeface="Noto Sans"/>
+              </a:rPr>
+              <a:t>the confidence</a:t>
+            </a:r>
+            <a:r>
+              <a:rPr sz="2700" b="0" i="0">
+                <a:solidFill>
+                  <a:srgbClr val="1D2433"/>
+                </a:solidFill>
+                <a:latin typeface="Noto Sans"/>
+              </a:rPr>
+              <a:t> to ask for a second tool next week.</a:t>
+            </a:r>
+          </a:p>
+        </p:txBody>
+      </p:sp>
+      <p:sp>
+        <p:nvSpPr>
+          <p:cNvPr id="7" name="Text"/>
+          <p:cNvSpPr txBox="1"/>
+          <p:nvPr/>
+        </p:nvSpPr>
+        <p:spPr>
+          <a:xfrm>
+            <a:off x="1168400" y="3292242"/>
             <a:ext cx="10569448" cy="242164"/>
           </a:xfrm>
           <a:prstGeom prst="rect">
@@ -5164,7 +5329,7 @@
       </p:sp>
       <p:sp>
         <p:nvSpPr>
-          <p:cNvPr id="7" name="Box"/>
+          <p:cNvPr id="8" name="Box"/>
           <p:cNvSpPr/>
           <p:nvPr/>
         </p:nvSpPr>
@@ -5194,7 +5359,7 @@
       </p:sp>
       <p:sp>
         <p:nvSpPr>
-          <p:cNvPr id="8" name="Text"/>
+          <p:cNvPr id="9" name="Text"/>
           <p:cNvSpPr txBox="1"/>
           <p:nvPr/>
         </p:nvSpPr>
@@ -5248,7 +5413,7 @@
       </p:sp>
       <p:sp>
         <p:nvSpPr>
-          <p:cNvPr id="9" name="Text"/>
+          <p:cNvPr id="10" name="Text"/>
           <p:cNvSpPr txBox="1"/>
           <p:nvPr/>
         </p:nvSpPr>
@@ -5884,7 +6049,7 @@
             <a:r>
               <a:rPr sz="850" b="1" i="0">
                 <a:solidFill>
-                  <a:srgbClr val="4A5163"/>
+                  <a:srgbClr val="8F93AD"/>
                 </a:solidFill>
                 <a:latin typeface="Noto Sans"/>
               </a:rPr>
@@ -7831,13 +7996,58 @@
       </p:sp>
       <p:sp>
         <p:nvSpPr>
-          <p:cNvPr id="4" name="Box"/>
+          <p:cNvPr id="4" name="Text"/>
+          <p:cNvSpPr txBox="1"/>
+          <p:nvPr/>
+        </p:nvSpPr>
+        <p:spPr>
+          <a:xfrm>
+            <a:off x="762000" y="1389757"/>
+            <a:ext cx="9810750" cy="269875"/>
+          </a:xfrm>
+          <a:prstGeom prst="rect">
+            <a:avLst/>
+          </a:prstGeom>
+          <a:noFill/>
+        </p:spPr>
+        <p:txBody>
+          <a:bodyPr wrap="square" lIns="0" rIns="0" tIns="0" bIns="0" anchor="t">
+            <a:noAutofit/>
+          </a:bodyPr>
+          <a:lstStyle/>
+          <a:p>
+            <a:pPr algn="l">
+              <a:lnSpc>
+                <a:spcPts val="2125"/>
+              </a:lnSpc>
+              <a:spcBef>
+                <a:spcPts val="0"/>
+              </a:spcBef>
+              <a:spcAft>
+                <a:spcPts val="0"/>
+              </a:spcAft>
+            </a:pPr>
+            <a:r>
+              <a:rPr sz="1700" b="0" i="0">
+                <a:solidFill>
+                  <a:srgbClr val="4A5163"/>
+                </a:solidFill>
+                <a:latin typeface="Noto Sans"/>
+              </a:rPr>
+              <a:t>Four ideas carry the whole deck.</a:t>
+            </a:r>
+          </a:p>
+        </p:txBody>
+      </p:sp>
+      <p:sp>
+        <p:nvSpPr>
+          <p:cNvPr id="5" name="Box"/>
           <p:cNvSpPr/>
           <p:nvPr/>
         </p:nvSpPr>
         <p:spPr>
           <a:xfrm>
-            <a:off x="787400" y="2012950"/>
+            <a:off x="787400" y="2203450"/>
             <a:ext cx="101600" cy="101600"/>
           </a:xfrm>
           <a:prstGeom prst="roundRect">
@@ -7863,13 +8073,13 @@
       </p:sp>
       <p:sp>
         <p:nvSpPr>
-          <p:cNvPr id="5" name="Text"/>
+          <p:cNvPr id="6" name="Text"/>
           <p:cNvSpPr txBox="1"/>
           <p:nvPr/>
         </p:nvSpPr>
         <p:spPr>
           <a:xfrm>
-            <a:off x="1054100" y="1900873"/>
+            <a:off x="1054100" y="2091373"/>
             <a:ext cx="9902317" cy="325755"/>
           </a:xfrm>
           <a:prstGeom prst="rect">
@@ -7926,13 +8136,13 @@
       </p:sp>
       <p:sp>
         <p:nvSpPr>
-          <p:cNvPr id="6" name="Box"/>
+          <p:cNvPr id="7" name="Box"/>
           <p:cNvSpPr/>
           <p:nvPr/>
         </p:nvSpPr>
         <p:spPr>
           <a:xfrm>
-            <a:off x="787400" y="2503785"/>
+            <a:off x="787400" y="2694285"/>
             <a:ext cx="101600" cy="101600"/>
           </a:xfrm>
           <a:prstGeom prst="roundRect">
@@ -7958,13 +8168,13 @@
       </p:sp>
       <p:sp>
         <p:nvSpPr>
-          <p:cNvPr id="7" name="Text"/>
+          <p:cNvPr id="8" name="Text"/>
           <p:cNvSpPr txBox="1"/>
           <p:nvPr/>
         </p:nvSpPr>
         <p:spPr>
           <a:xfrm>
-            <a:off x="1054100" y="2391708"/>
+            <a:off x="1054100" y="2582208"/>
             <a:ext cx="9902317" cy="325755"/>
           </a:xfrm>
           <a:prstGeom prst="rect">
@@ -8021,13 +8231,13 @@
       </p:sp>
       <p:sp>
         <p:nvSpPr>
-          <p:cNvPr id="8" name="Box"/>
+          <p:cNvPr id="9" name="Box"/>
           <p:cNvSpPr/>
           <p:nvPr/>
         </p:nvSpPr>
         <p:spPr>
           <a:xfrm>
-            <a:off x="787400" y="2994620"/>
+            <a:off x="787400" y="3185120"/>
             <a:ext cx="101600" cy="101600"/>
           </a:xfrm>
           <a:prstGeom prst="roundRect">
@@ -8053,13 +8263,13 @@
       </p:sp>
       <p:sp>
         <p:nvSpPr>
-          <p:cNvPr id="9" name="Text"/>
+          <p:cNvPr id="10" name="Text"/>
           <p:cNvSpPr txBox="1"/>
           <p:nvPr/>
         </p:nvSpPr>
         <p:spPr>
           <a:xfrm>
-            <a:off x="1054100" y="2882543"/>
+            <a:off x="1054100" y="3073043"/>
             <a:ext cx="9902317" cy="325755"/>
           </a:xfrm>
           <a:prstGeom prst="rect">
@@ -8116,13 +8326,13 @@
       </p:sp>
       <p:sp>
         <p:nvSpPr>
-          <p:cNvPr id="10" name="Box"/>
+          <p:cNvPr id="11" name="Box"/>
           <p:cNvSpPr/>
           <p:nvPr/>
         </p:nvSpPr>
         <p:spPr>
           <a:xfrm>
-            <a:off x="787400" y="3485455"/>
+            <a:off x="787400" y="3675955"/>
             <a:ext cx="101600" cy="101600"/>
           </a:xfrm>
           <a:prstGeom prst="roundRect">
@@ -8148,13 +8358,13 @@
       </p:sp>
       <p:sp>
         <p:nvSpPr>
-          <p:cNvPr id="11" name="Text"/>
+          <p:cNvPr id="12" name="Text"/>
           <p:cNvSpPr txBox="1"/>
           <p:nvPr/>
         </p:nvSpPr>
         <p:spPr>
           <a:xfrm>
-            <a:off x="1054100" y="3373378"/>
+            <a:off x="1054100" y="3563878"/>
             <a:ext cx="9902317" cy="325755"/>
           </a:xfrm>
           <a:prstGeom prst="rect">
@@ -8211,13 +8421,13 @@
       </p:sp>
       <p:sp>
         <p:nvSpPr>
-          <p:cNvPr id="12" name="Box"/>
+          <p:cNvPr id="13" name="Box"/>
           <p:cNvSpPr/>
           <p:nvPr/>
         </p:nvSpPr>
         <p:spPr>
           <a:xfrm>
-            <a:off x="787400" y="3976291"/>
+            <a:off x="787400" y="4166791"/>
             <a:ext cx="101600" cy="101600"/>
           </a:xfrm>
           <a:prstGeom prst="roundRect">
@@ -8243,13 +8453,13 @@
       </p:sp>
       <p:sp>
         <p:nvSpPr>
-          <p:cNvPr id="13" name="Text"/>
+          <p:cNvPr id="14" name="Text"/>
           <p:cNvSpPr txBox="1"/>
           <p:nvPr/>
         </p:nvSpPr>
         <p:spPr>
           <a:xfrm>
-            <a:off x="1054100" y="3864213"/>
+            <a:off x="1054100" y="4054713"/>
             <a:ext cx="9902317" cy="325755"/>
           </a:xfrm>
           <a:prstGeom prst="rect">
@@ -8288,7 +8498,7 @@
       </p:sp>
       <p:sp>
         <p:nvSpPr>
-          <p:cNvPr id="14" name="Box"/>
+          <p:cNvPr id="15" name="Box"/>
           <p:cNvSpPr/>
           <p:nvPr/>
         </p:nvSpPr>
@@ -8318,7 +8528,7 @@
       </p:sp>
       <p:sp>
         <p:nvSpPr>
-          <p:cNvPr id="15" name="Text"/>
+          <p:cNvPr id="16" name="Text"/>
           <p:cNvSpPr txBox="1"/>
           <p:nvPr/>
         </p:nvSpPr>
@@ -8372,7 +8582,7 @@
       </p:sp>
       <p:sp>
         <p:nvSpPr>
-          <p:cNvPr id="16" name="Text"/>
+          <p:cNvPr id="17" name="Text"/>
           <p:cNvSpPr txBox="1"/>
           <p:nvPr/>
         </p:nvSpPr>
@@ -9277,7 +9487,7 @@
                 </a:solidFill>
                 <a:latin typeface="Noto Sans"/>
               </a:rPr>
-              <a:t>Three volunteers keep the shed open</a:t>
+              <a:t>Six jobs keep the shed open</a:t>
             </a:r>
           </a:p>
         </p:txBody>
@@ -9322,20 +9532,65 @@
                 </a:solidFill>
                 <a:latin typeface="Noto Sans"/>
               </a:rPr>
-              <a:t>THREE JOBS</a:t>
-            </a:r>
-          </a:p>
-        </p:txBody>
-      </p:sp>
-      <p:sp>
-        <p:nvSpPr>
-          <p:cNvPr id="4" name="Box"/>
+              <a:t>SIX JOBS</a:t>
+            </a:r>
+          </a:p>
+        </p:txBody>
+      </p:sp>
+      <p:sp>
+        <p:nvSpPr>
+          <p:cNvPr id="4" name="Text"/>
+          <p:cNvSpPr txBox="1"/>
+          <p:nvPr/>
+        </p:nvSpPr>
+        <p:spPr>
+          <a:xfrm>
+            <a:off x="762000" y="1389757"/>
+            <a:ext cx="9810750" cy="269875"/>
+          </a:xfrm>
+          <a:prstGeom prst="rect">
+            <a:avLst/>
+          </a:prstGeom>
+          <a:noFill/>
+        </p:spPr>
+        <p:txBody>
+          <a:bodyPr wrap="square" lIns="0" rIns="0" tIns="0" bIns="0" anchor="t">
+            <a:noAutofit/>
+          </a:bodyPr>
+          <a:lstStyle/>
+          <a:p>
+            <a:pPr algn="l">
+              <a:lnSpc>
+                <a:spcPts val="2125"/>
+              </a:lnSpc>
+              <a:spcBef>
+                <a:spcPts val="0"/>
+              </a:spcBef>
+              <a:spcAft>
+                <a:spcPts val="0"/>
+              </a:spcAft>
+            </a:pPr>
+            <a:r>
+              <a:rPr sz="1700" b="0" i="0">
+                <a:solidFill>
+                  <a:srgbClr val="4A5163"/>
+                </a:solidFill>
+                <a:latin typeface="Noto Sans"/>
+              </a:rPr>
+              <a:t>Each job is small and has one test.</a:t>
+            </a:r>
+          </a:p>
+        </p:txBody>
+      </p:sp>
+      <p:sp>
+        <p:nvSpPr>
+          <p:cNvPr id="5" name="Box"/>
           <p:cNvSpPr/>
           <p:nvPr/>
         </p:nvSpPr>
         <p:spPr>
           <a:xfrm>
-            <a:off x="762000" y="1778000"/>
+            <a:off x="762000" y="2159000"/>
             <a:ext cx="3437434" cy="2126952"/>
           </a:xfrm>
           <a:prstGeom prst="roundRect">
@@ -9361,13 +9616,13 @@
       </p:sp>
       <p:sp>
         <p:nvSpPr>
-          <p:cNvPr id="5" name="Box"/>
+          <p:cNvPr id="6" name="Box"/>
           <p:cNvSpPr/>
           <p:nvPr/>
         </p:nvSpPr>
         <p:spPr>
           <a:xfrm>
-            <a:off x="762000" y="1841500"/>
+            <a:off x="762000" y="2222500"/>
             <a:ext cx="3437434" cy="2063452"/>
           </a:xfrm>
           <a:prstGeom prst="roundRect">
@@ -9393,58 +9648,58 @@
       </p:sp>
       <p:sp>
         <p:nvSpPr>
-          <p:cNvPr id="6" name="Text"/>
-          <p:cNvSpPr txBox="1"/>
-          <p:nvPr/>
-        </p:nvSpPr>
-        <p:spPr>
-          <a:xfrm>
-            <a:off x="965200" y="2031022"/>
-            <a:ext cx="3121965" cy="294056"/>
-          </a:xfrm>
-          <a:prstGeom prst="rect">
-            <a:avLst/>
-          </a:prstGeom>
-          <a:noFill/>
-        </p:spPr>
-        <p:txBody>
-          <a:bodyPr wrap="square" lIns="0" rIns="0" tIns="0" bIns="0" anchor="t">
-            <a:noAutofit/>
-          </a:bodyPr>
-          <a:lstStyle/>
-          <a:p>
-            <a:pPr algn="l">
-              <a:lnSpc>
-                <a:spcPts val="2315"/>
-              </a:lnSpc>
-              <a:spcBef>
-                <a:spcPts val="0"/>
-              </a:spcBef>
-              <a:spcAft>
-                <a:spcPts val="0"/>
-              </a:spcAft>
-            </a:pPr>
-            <a:r>
-              <a:rPr sz="1700" b="1" i="0">
-                <a:solidFill>
-                  <a:srgbClr val="5B4BD6"/>
-                </a:solidFill>
-                <a:latin typeface="Noto Sans"/>
-              </a:rPr>
-              <a:t>The registrar</a:t>
-            </a:r>
-          </a:p>
-        </p:txBody>
-      </p:sp>
-      <p:sp>
-        <p:nvSpPr>
           <p:cNvPr id="7" name="Text"/>
           <p:cNvSpPr txBox="1"/>
           <p:nvPr/>
         </p:nvSpPr>
         <p:spPr>
           <a:xfrm>
-            <a:off x="965200" y="2399030"/>
+            <a:off x="965200" y="2412022"/>
+            <a:ext cx="3121965" cy="294056"/>
+          </a:xfrm>
+          <a:prstGeom prst="rect">
+            <a:avLst/>
+          </a:prstGeom>
+          <a:noFill/>
+        </p:spPr>
+        <p:txBody>
+          <a:bodyPr wrap="square" lIns="0" rIns="0" tIns="0" bIns="0" anchor="t">
+            <a:noAutofit/>
+          </a:bodyPr>
+          <a:lstStyle/>
+          <a:p>
+            <a:pPr algn="l">
+              <a:lnSpc>
+                <a:spcPts val="2315"/>
+              </a:lnSpc>
+              <a:spcBef>
+                <a:spcPts val="0"/>
+              </a:spcBef>
+              <a:spcAft>
+                <a:spcPts val="0"/>
+              </a:spcAft>
+            </a:pPr>
+            <a:r>
+              <a:rPr sz="1700" b="1" i="0">
+                <a:solidFill>
+                  <a:srgbClr val="5B4BD6"/>
+                </a:solidFill>
+                <a:latin typeface="Noto Sans"/>
+              </a:rPr>
+              <a:t>The registrar</a:t>
+            </a:r>
+          </a:p>
+        </p:txBody>
+      </p:sp>
+      <p:sp>
+        <p:nvSpPr>
+          <p:cNvPr id="8" name="Text"/>
+          <p:cNvSpPr txBox="1"/>
+          <p:nvPr/>
+        </p:nvSpPr>
+        <p:spPr>
+          <a:xfrm>
+            <a:off x="965200" y="2780030"/>
             <a:ext cx="3121965" cy="788551"/>
           </a:xfrm>
           <a:prstGeom prst="rect">
@@ -9483,13 +9738,13 @@
       </p:sp>
       <p:sp>
         <p:nvSpPr>
-          <p:cNvPr id="8" name="Box"/>
+          <p:cNvPr id="9" name="Box"/>
           <p:cNvSpPr/>
           <p:nvPr/>
         </p:nvSpPr>
         <p:spPr>
           <a:xfrm>
-            <a:off x="4377234" y="1778000"/>
+            <a:off x="4377234" y="2159000"/>
             <a:ext cx="3437434" cy="2126952"/>
           </a:xfrm>
           <a:prstGeom prst="roundRect">
@@ -9515,13 +9770,13 @@
       </p:sp>
       <p:sp>
         <p:nvSpPr>
-          <p:cNvPr id="9" name="Box"/>
+          <p:cNvPr id="10" name="Box"/>
           <p:cNvSpPr/>
           <p:nvPr/>
         </p:nvSpPr>
         <p:spPr>
           <a:xfrm>
-            <a:off x="4377234" y="1841500"/>
+            <a:off x="4377234" y="2222500"/>
             <a:ext cx="3437434" cy="2063452"/>
           </a:xfrm>
           <a:prstGeom prst="roundRect">
@@ -9547,58 +9802,58 @@
       </p:sp>
       <p:sp>
         <p:nvSpPr>
-          <p:cNvPr id="10" name="Text"/>
-          <p:cNvSpPr txBox="1"/>
-          <p:nvPr/>
-        </p:nvSpPr>
-        <p:spPr>
-          <a:xfrm>
-            <a:off x="4580434" y="2031022"/>
-            <a:ext cx="3121965" cy="294056"/>
-          </a:xfrm>
-          <a:prstGeom prst="rect">
-            <a:avLst/>
-          </a:prstGeom>
-          <a:noFill/>
-        </p:spPr>
-        <p:txBody>
-          <a:bodyPr wrap="square" lIns="0" rIns="0" tIns="0" bIns="0" anchor="t">
-            <a:noAutofit/>
-          </a:bodyPr>
-          <a:lstStyle/>
-          <a:p>
-            <a:pPr algn="l">
-              <a:lnSpc>
-                <a:spcPts val="2315"/>
-              </a:lnSpc>
-              <a:spcBef>
-                <a:spcPts val="0"/>
-              </a:spcBef>
-              <a:spcAft>
-                <a:spcPts val="0"/>
-              </a:spcAft>
-            </a:pPr>
-            <a:r>
-              <a:rPr sz="1700" b="1" i="0">
-                <a:solidFill>
-                  <a:srgbClr val="3F9FA6"/>
-                </a:solidFill>
-                <a:latin typeface="Noto Sans"/>
-              </a:rPr>
-              <a:t>The checker</a:t>
-            </a:r>
-          </a:p>
-        </p:txBody>
-      </p:sp>
-      <p:sp>
-        <p:nvSpPr>
           <p:cNvPr id="11" name="Text"/>
           <p:cNvSpPr txBox="1"/>
           <p:nvPr/>
         </p:nvSpPr>
         <p:spPr>
           <a:xfrm>
-            <a:off x="4580434" y="2399030"/>
+            <a:off x="4580434" y="2412022"/>
+            <a:ext cx="3121965" cy="294056"/>
+          </a:xfrm>
+          <a:prstGeom prst="rect">
+            <a:avLst/>
+          </a:prstGeom>
+          <a:noFill/>
+        </p:spPr>
+        <p:txBody>
+          <a:bodyPr wrap="square" lIns="0" rIns="0" tIns="0" bIns="0" anchor="t">
+            <a:noAutofit/>
+          </a:bodyPr>
+          <a:lstStyle/>
+          <a:p>
+            <a:pPr algn="l">
+              <a:lnSpc>
+                <a:spcPts val="2315"/>
+              </a:lnSpc>
+              <a:spcBef>
+                <a:spcPts val="0"/>
+              </a:spcBef>
+              <a:spcAft>
+                <a:spcPts val="0"/>
+              </a:spcAft>
+            </a:pPr>
+            <a:r>
+              <a:rPr sz="1700" b="1" i="0">
+                <a:solidFill>
+                  <a:srgbClr val="3F9FA6"/>
+                </a:solidFill>
+                <a:latin typeface="Noto Sans"/>
+              </a:rPr>
+              <a:t>The checker</a:t>
+            </a:r>
+          </a:p>
+        </p:txBody>
+      </p:sp>
+      <p:sp>
+        <p:nvSpPr>
+          <p:cNvPr id="12" name="Text"/>
+          <p:cNvSpPr txBox="1"/>
+          <p:nvPr/>
+        </p:nvSpPr>
+        <p:spPr>
+          <a:xfrm>
+            <a:off x="4580434" y="2780030"/>
             <a:ext cx="3121965" cy="1314212"/>
           </a:xfrm>
           <a:prstGeom prst="rect">
@@ -9637,13 +9892,13 @@
       </p:sp>
       <p:sp>
         <p:nvSpPr>
-          <p:cNvPr id="12" name="Box"/>
+          <p:cNvPr id="13" name="Box"/>
           <p:cNvSpPr/>
           <p:nvPr/>
         </p:nvSpPr>
         <p:spPr>
           <a:xfrm>
-            <a:off x="7992467" y="1778000"/>
+            <a:off x="7992467" y="2159000"/>
             <a:ext cx="3437434" cy="2126952"/>
           </a:xfrm>
           <a:prstGeom prst="roundRect">
@@ -9669,13 +9924,13 @@
       </p:sp>
       <p:sp>
         <p:nvSpPr>
-          <p:cNvPr id="13" name="Box"/>
+          <p:cNvPr id="14" name="Box"/>
           <p:cNvSpPr/>
           <p:nvPr/>
         </p:nvSpPr>
         <p:spPr>
           <a:xfrm>
-            <a:off x="7992467" y="1841500"/>
+            <a:off x="7992467" y="2222500"/>
             <a:ext cx="3437434" cy="2063452"/>
           </a:xfrm>
           <a:prstGeom prst="roundRect">
@@ -9701,58 +9956,58 @@
       </p:sp>
       <p:sp>
         <p:nvSpPr>
-          <p:cNvPr id="14" name="Text"/>
-          <p:cNvSpPr txBox="1"/>
-          <p:nvPr/>
-        </p:nvSpPr>
-        <p:spPr>
-          <a:xfrm>
-            <a:off x="8195667" y="2031022"/>
-            <a:ext cx="3121965" cy="294056"/>
-          </a:xfrm>
-          <a:prstGeom prst="rect">
-            <a:avLst/>
-          </a:prstGeom>
-          <a:noFill/>
-        </p:spPr>
-        <p:txBody>
-          <a:bodyPr wrap="square" lIns="0" rIns="0" tIns="0" bIns="0" anchor="t">
-            <a:noAutofit/>
-          </a:bodyPr>
-          <a:lstStyle/>
-          <a:p>
-            <a:pPr algn="l">
-              <a:lnSpc>
-                <a:spcPts val="2315"/>
-              </a:lnSpc>
-              <a:spcBef>
-                <a:spcPts val="0"/>
-              </a:spcBef>
-              <a:spcAft>
-                <a:spcPts val="0"/>
-              </a:spcAft>
-            </a:pPr>
-            <a:r>
-              <a:rPr sz="1700" b="1" i="0">
-                <a:solidFill>
-                  <a:srgbClr val="2E9E6B"/>
-                </a:solidFill>
-                <a:latin typeface="Noto Sans"/>
-              </a:rPr>
-              <a:t>The host</a:t>
-            </a:r>
-          </a:p>
-        </p:txBody>
-      </p:sp>
-      <p:sp>
-        <p:nvSpPr>
           <p:cNvPr id="15" name="Text"/>
           <p:cNvSpPr txBox="1"/>
           <p:nvPr/>
         </p:nvSpPr>
         <p:spPr>
           <a:xfrm>
-            <a:off x="8195667" y="2399030"/>
+            <a:off x="8195667" y="2412022"/>
+            <a:ext cx="3121965" cy="294056"/>
+          </a:xfrm>
+          <a:prstGeom prst="rect">
+            <a:avLst/>
+          </a:prstGeom>
+          <a:noFill/>
+        </p:spPr>
+        <p:txBody>
+          <a:bodyPr wrap="square" lIns="0" rIns="0" tIns="0" bIns="0" anchor="t">
+            <a:noAutofit/>
+          </a:bodyPr>
+          <a:lstStyle/>
+          <a:p>
+            <a:pPr algn="l">
+              <a:lnSpc>
+                <a:spcPts val="2315"/>
+              </a:lnSpc>
+              <a:spcBef>
+                <a:spcPts val="0"/>
+              </a:spcBef>
+              <a:spcAft>
+                <a:spcPts val="0"/>
+              </a:spcAft>
+            </a:pPr>
+            <a:r>
+              <a:rPr sz="1700" b="1" i="0">
+                <a:solidFill>
+                  <a:srgbClr val="2E9E6B"/>
+                </a:solidFill>
+                <a:latin typeface="Noto Sans"/>
+              </a:rPr>
+              <a:t>The host</a:t>
+            </a:r>
+          </a:p>
+        </p:txBody>
+      </p:sp>
+      <p:sp>
+        <p:nvSpPr>
+          <p:cNvPr id="16" name="Text"/>
+          <p:cNvSpPr txBox="1"/>
+          <p:nvPr/>
+        </p:nvSpPr>
+        <p:spPr>
+          <a:xfrm>
+            <a:off x="8195667" y="2780030"/>
             <a:ext cx="3121965" cy="1051381"/>
           </a:xfrm>
           <a:prstGeom prst="rect">
@@ -9791,18 +10046,18 @@
       </p:sp>
       <p:sp>
         <p:nvSpPr>
-          <p:cNvPr id="16" name="Box"/>
+          <p:cNvPr id="17" name="Box"/>
           <p:cNvSpPr/>
           <p:nvPr/>
         </p:nvSpPr>
         <p:spPr>
           <a:xfrm>
-            <a:off x="762000" y="5461000"/>
-            <a:ext cx="10668000" cy="635000"/>
+            <a:off x="762000" y="4463752"/>
+            <a:ext cx="3437434" cy="1601291"/>
           </a:xfrm>
           <a:prstGeom prst="roundRect">
             <a:avLst>
-              <a:gd name="adj" fmla="val 16000"/>
+              <a:gd name="adj" fmla="val 6344"/>
             </a:avLst>
           </a:prstGeom>
           <a:solidFill>
@@ -9823,59 +10078,91 @@
       </p:sp>
       <p:sp>
         <p:nvSpPr>
-          <p:cNvPr id="17" name="Text"/>
+          <p:cNvPr id="18" name="Box"/>
+          <p:cNvSpPr/>
+          <p:nvPr/>
+        </p:nvSpPr>
+        <p:spPr>
+          <a:xfrm>
+            <a:off x="762000" y="4527252"/>
+            <a:ext cx="3437434" cy="1537791"/>
+          </a:xfrm>
+          <a:prstGeom prst="roundRect">
+            <a:avLst>
+              <a:gd name="adj" fmla="val 2477"/>
+            </a:avLst>
+          </a:prstGeom>
+          <a:solidFill>
+            <a:srgbClr val="FFFFFF"/>
+          </a:solidFill>
+          <a:ln>
+            <a:noFill/>
+          </a:ln>
+          <a:effectLst/>
+        </p:spPr>
+        <p:txBody>
+          <a:bodyPr rtlCol="0" anchor="ctr"/>
+          <a:lstStyle/>
+          <a:p>
+            <a:pPr algn="ctr"/>
+          </a:p>
+        </p:txBody>
+      </p:sp>
+      <p:sp>
+        <p:nvSpPr>
+          <p:cNvPr id="19" name="Text"/>
           <p:cNvSpPr txBox="1"/>
           <p:nvPr/>
         </p:nvSpPr>
         <p:spPr>
           <a:xfrm>
-            <a:off x="990600" y="5700662"/>
-            <a:ext cx="1042988" cy="155677"/>
-          </a:xfrm>
-          <a:prstGeom prst="rect">
-            <a:avLst/>
-          </a:prstGeom>
-          <a:noFill/>
-        </p:spPr>
-        <p:txBody>
-          <a:bodyPr wrap="none" lIns="0" rIns="0" tIns="0" bIns="0" anchor="t">
+            <a:off x="965200" y="4716774"/>
+            <a:ext cx="3121965" cy="294056"/>
+          </a:xfrm>
+          <a:prstGeom prst="rect">
+            <a:avLst/>
+          </a:prstGeom>
+          <a:noFill/>
+        </p:spPr>
+        <p:txBody>
+          <a:bodyPr wrap="square" lIns="0" rIns="0" tIns="0" bIns="0" anchor="t">
             <a:noAutofit/>
           </a:bodyPr>
           <a:lstStyle/>
           <a:p>
             <a:pPr algn="l">
               <a:lnSpc>
-                <a:spcPts val="1225"/>
-              </a:lnSpc>
-              <a:spcBef>
-                <a:spcPts val="0"/>
-              </a:spcBef>
-              <a:spcAft>
-                <a:spcPts val="0"/>
-              </a:spcAft>
-            </a:pPr>
-            <a:r>
-              <a:rPr sz="900" b="1" i="0" spc="126">
-                <a:solidFill>
-                  <a:srgbClr val="B3A9FF"/>
-                </a:solidFill>
-                <a:latin typeface="Noto Sans"/>
-              </a:rPr>
-              <a:t>WHY IT WORKS</a:t>
-            </a:r>
-          </a:p>
-        </p:txBody>
-      </p:sp>
-      <p:sp>
-        <p:nvSpPr>
-          <p:cNvPr id="18" name="Text"/>
+                <a:spcPts val="2315"/>
+              </a:lnSpc>
+              <a:spcBef>
+                <a:spcPts val="0"/>
+              </a:spcBef>
+              <a:spcAft>
+                <a:spcPts val="0"/>
+              </a:spcAft>
+            </a:pPr>
+            <a:r>
+              <a:rPr sz="1700" b="1" i="0">
+                <a:solidFill>
+                  <a:srgbClr val="1D2433"/>
+                </a:solidFill>
+                <a:latin typeface="Noto Sans"/>
+              </a:rPr>
+              <a:t>The mender</a:t>
+            </a:r>
+          </a:p>
+        </p:txBody>
+      </p:sp>
+      <p:sp>
+        <p:nvSpPr>
+          <p:cNvPr id="20" name="Text"/>
           <p:cNvSpPr txBox="1"/>
           <p:nvPr/>
         </p:nvSpPr>
         <p:spPr>
           <a:xfrm>
-            <a:off x="2211388" y="5648770"/>
-            <a:ext cx="6854444" cy="259461"/>
+            <a:off x="965200" y="5084782"/>
+            <a:ext cx="3121965" cy="788551"/>
           </a:xfrm>
           <a:prstGeom prst="rect">
             <a:avLst/>
@@ -9890,7 +10177,7 @@
           <a:p>
             <a:pPr algn="l">
               <a:lnSpc>
-                <a:spcPts val="2043"/>
+                <a:spcPts val="2070"/>
               </a:lnSpc>
               <a:spcBef>
                 <a:spcPts val="0"/>
@@ -9902,18 +10189,326 @@
             <a:r>
               <a:rPr sz="1500" b="0" i="0">
                 <a:solidFill>
-                  <a:srgbClr val="FFFFFF"/>
-                </a:solidFill>
-                <a:latin typeface="Noto Sans"/>
-              </a:rPr>
-              <a:t>Each job is small and has one test, so a new volunteer can start in an hour.</a:t>
-            </a:r>
-          </a:p>
-        </p:txBody>
-      </p:sp>
-      <p:sp>
-        <p:nvSpPr>
-          <p:cNvPr id="19" name="Box"/>
+                  <a:srgbClr val="4A5163"/>
+                </a:solidFill>
+                <a:latin typeface="Noto Sans"/>
+              </a:rPr>
+              <a:t>Sharpens, oils and fixes at the repair bench, and signs the ledger line when a tool is fit.</a:t>
+            </a:r>
+          </a:p>
+        </p:txBody>
+      </p:sp>
+      <p:sp>
+        <p:nvSpPr>
+          <p:cNvPr id="21" name="Box"/>
+          <p:cNvSpPr/>
+          <p:nvPr/>
+        </p:nvSpPr>
+        <p:spPr>
+          <a:xfrm>
+            <a:off x="4377234" y="4463752"/>
+            <a:ext cx="3437434" cy="1601291"/>
+          </a:xfrm>
+          <a:prstGeom prst="roundRect">
+            <a:avLst>
+              <a:gd name="adj" fmla="val 6344"/>
+            </a:avLst>
+          </a:prstGeom>
+          <a:solidFill>
+            <a:srgbClr val="E3A33B"/>
+          </a:solidFill>
+          <a:ln>
+            <a:noFill/>
+          </a:ln>
+          <a:effectLst/>
+        </p:spPr>
+        <p:txBody>
+          <a:bodyPr rtlCol="0" anchor="ctr"/>
+          <a:lstStyle/>
+          <a:p>
+            <a:pPr algn="ctr"/>
+          </a:p>
+        </p:txBody>
+      </p:sp>
+      <p:sp>
+        <p:nvSpPr>
+          <p:cNvPr id="22" name="Box"/>
+          <p:cNvSpPr/>
+          <p:nvPr/>
+        </p:nvSpPr>
+        <p:spPr>
+          <a:xfrm>
+            <a:off x="4377234" y="4527252"/>
+            <a:ext cx="3437434" cy="1537791"/>
+          </a:xfrm>
+          <a:prstGeom prst="roundRect">
+            <a:avLst>
+              <a:gd name="adj" fmla="val 2477"/>
+            </a:avLst>
+          </a:prstGeom>
+          <a:solidFill>
+            <a:srgbClr val="FFFFFF"/>
+          </a:solidFill>
+          <a:ln>
+            <a:noFill/>
+          </a:ln>
+          <a:effectLst/>
+        </p:spPr>
+        <p:txBody>
+          <a:bodyPr rtlCol="0" anchor="ctr"/>
+          <a:lstStyle/>
+          <a:p>
+            <a:pPr algn="ctr"/>
+          </a:p>
+        </p:txBody>
+      </p:sp>
+      <p:sp>
+        <p:nvSpPr>
+          <p:cNvPr id="23" name="Text"/>
+          <p:cNvSpPr txBox="1"/>
+          <p:nvPr/>
+        </p:nvSpPr>
+        <p:spPr>
+          <a:xfrm>
+            <a:off x="4580434" y="4716774"/>
+            <a:ext cx="3121965" cy="294056"/>
+          </a:xfrm>
+          <a:prstGeom prst="rect">
+            <a:avLst/>
+          </a:prstGeom>
+          <a:noFill/>
+        </p:spPr>
+        <p:txBody>
+          <a:bodyPr wrap="square" lIns="0" rIns="0" tIns="0" bIns="0" anchor="t">
+            <a:noAutofit/>
+          </a:bodyPr>
+          <a:lstStyle/>
+          <a:p>
+            <a:pPr algn="l">
+              <a:lnSpc>
+                <a:spcPts val="2315"/>
+              </a:lnSpc>
+              <a:spcBef>
+                <a:spcPts val="0"/>
+              </a:spcBef>
+              <a:spcAft>
+                <a:spcPts val="0"/>
+              </a:spcAft>
+            </a:pPr>
+            <a:r>
+              <a:rPr sz="1700" b="1" i="0">
+                <a:solidFill>
+                  <a:srgbClr val="E3A33B"/>
+                </a:solidFill>
+                <a:latin typeface="Noto Sans"/>
+              </a:rPr>
+              <a:t>The stocker</a:t>
+            </a:r>
+          </a:p>
+        </p:txBody>
+      </p:sp>
+      <p:sp>
+        <p:nvSpPr>
+          <p:cNvPr id="24" name="Text"/>
+          <p:cNvSpPr txBox="1"/>
+          <p:nvPr/>
+        </p:nvSpPr>
+        <p:spPr>
+          <a:xfrm>
+            <a:off x="4580434" y="5084782"/>
+            <a:ext cx="3121965" cy="788551"/>
+          </a:xfrm>
+          <a:prstGeom prst="rect">
+            <a:avLst/>
+          </a:prstGeom>
+          <a:noFill/>
+        </p:spPr>
+        <p:txBody>
+          <a:bodyPr wrap="square" lIns="0" rIns="0" tIns="0" bIns="0" anchor="t">
+            <a:noAutofit/>
+          </a:bodyPr>
+          <a:lstStyle/>
+          <a:p>
+            <a:pPr algn="l">
+              <a:lnSpc>
+                <a:spcPts val="2070"/>
+              </a:lnSpc>
+              <a:spcBef>
+                <a:spcPts val="0"/>
+              </a:spcBef>
+              <a:spcAft>
+                <a:spcPts val="0"/>
+              </a:spcAft>
+            </a:pPr>
+            <a:r>
+              <a:rPr sz="1500" b="0" i="0">
+                <a:solidFill>
+                  <a:srgbClr val="4A5163"/>
+                </a:solidFill>
+                <a:latin typeface="Noto Sans"/>
+              </a:rPr>
+              <a:t>Watches the gaps on the hooks and asks neighbours for the tools the shed is missing.</a:t>
+            </a:r>
+          </a:p>
+        </p:txBody>
+      </p:sp>
+      <p:sp>
+        <p:nvSpPr>
+          <p:cNvPr id="25" name="Box"/>
+          <p:cNvSpPr/>
+          <p:nvPr/>
+        </p:nvSpPr>
+        <p:spPr>
+          <a:xfrm>
+            <a:off x="7992467" y="4463752"/>
+            <a:ext cx="3437434" cy="1601291"/>
+          </a:xfrm>
+          <a:prstGeom prst="roundRect">
+            <a:avLst>
+              <a:gd name="adj" fmla="val 6344"/>
+            </a:avLst>
+          </a:prstGeom>
+          <a:solidFill>
+            <a:srgbClr val="B9BEC8"/>
+          </a:solidFill>
+          <a:ln>
+            <a:noFill/>
+          </a:ln>
+          <a:effectLst/>
+        </p:spPr>
+        <p:txBody>
+          <a:bodyPr rtlCol="0" anchor="ctr"/>
+          <a:lstStyle/>
+          <a:p>
+            <a:pPr algn="ctr"/>
+          </a:p>
+        </p:txBody>
+      </p:sp>
+      <p:sp>
+        <p:nvSpPr>
+          <p:cNvPr id="26" name="Box"/>
+          <p:cNvSpPr/>
+          <p:nvPr/>
+        </p:nvSpPr>
+        <p:spPr>
+          <a:xfrm>
+            <a:off x="7992467" y="4527252"/>
+            <a:ext cx="3437434" cy="1537791"/>
+          </a:xfrm>
+          <a:prstGeom prst="roundRect">
+            <a:avLst>
+              <a:gd name="adj" fmla="val 2477"/>
+            </a:avLst>
+          </a:prstGeom>
+          <a:solidFill>
+            <a:srgbClr val="FFFFFF"/>
+          </a:solidFill>
+          <a:ln>
+            <a:noFill/>
+          </a:ln>
+          <a:effectLst/>
+        </p:spPr>
+        <p:txBody>
+          <a:bodyPr rtlCol="0" anchor="ctr"/>
+          <a:lstStyle/>
+          <a:p>
+            <a:pPr algn="ctr"/>
+          </a:p>
+        </p:txBody>
+      </p:sp>
+      <p:sp>
+        <p:nvSpPr>
+          <p:cNvPr id="27" name="Text"/>
+          <p:cNvSpPr txBox="1"/>
+          <p:nvPr/>
+        </p:nvSpPr>
+        <p:spPr>
+          <a:xfrm>
+            <a:off x="8195667" y="4716774"/>
+            <a:ext cx="3121965" cy="294056"/>
+          </a:xfrm>
+          <a:prstGeom prst="rect">
+            <a:avLst/>
+          </a:prstGeom>
+          <a:noFill/>
+        </p:spPr>
+        <p:txBody>
+          <a:bodyPr wrap="square" lIns="0" rIns="0" tIns="0" bIns="0" anchor="t">
+            <a:noAutofit/>
+          </a:bodyPr>
+          <a:lstStyle/>
+          <a:p>
+            <a:pPr algn="l">
+              <a:lnSpc>
+                <a:spcPts val="2315"/>
+              </a:lnSpc>
+              <a:spcBef>
+                <a:spcPts val="0"/>
+              </a:spcBef>
+              <a:spcAft>
+                <a:spcPts val="0"/>
+              </a:spcAft>
+            </a:pPr>
+            <a:r>
+              <a:rPr sz="1700" b="1" i="0">
+                <a:solidFill>
+                  <a:srgbClr val="B9BEC8"/>
+                </a:solidFill>
+                <a:latin typeface="Noto Sans"/>
+              </a:rPr>
+              <a:t>The spare hands</a:t>
+            </a:r>
+          </a:p>
+        </p:txBody>
+      </p:sp>
+      <p:sp>
+        <p:nvSpPr>
+          <p:cNvPr id="28" name="Text"/>
+          <p:cNvSpPr txBox="1"/>
+          <p:nvPr/>
+        </p:nvSpPr>
+        <p:spPr>
+          <a:xfrm>
+            <a:off x="8195667" y="5084782"/>
+            <a:ext cx="3121965" cy="788551"/>
+          </a:xfrm>
+          <a:prstGeom prst="rect">
+            <a:avLst/>
+          </a:prstGeom>
+          <a:noFill/>
+        </p:spPr>
+        <p:txBody>
+          <a:bodyPr wrap="square" lIns="0" rIns="0" tIns="0" bIns="0" anchor="t">
+            <a:noAutofit/>
+          </a:bodyPr>
+          <a:lstStyle/>
+          <a:p>
+            <a:pPr algn="l">
+              <a:lnSpc>
+                <a:spcPts val="2070"/>
+              </a:lnSpc>
+              <a:spcBef>
+                <a:spcPts val="0"/>
+              </a:spcBef>
+              <a:spcAft>
+                <a:spcPts val="0"/>
+              </a:spcAft>
+            </a:pPr>
+            <a:r>
+              <a:rPr sz="1500" b="0" i="0">
+                <a:solidFill>
+                  <a:srgbClr val="4A5163"/>
+                </a:solidFill>
+                <a:latin typeface="Noto Sans"/>
+              </a:rPr>
+              <a:t>Not a job yet: anyone who helps on a Saturday and may take a job later.</a:t>
+            </a:r>
+          </a:p>
+        </p:txBody>
+      </p:sp>
+      <p:sp>
+        <p:nvSpPr>
+          <p:cNvPr id="29" name="Box"/>
           <p:cNvSpPr/>
           <p:nvPr/>
         </p:nvSpPr>
@@ -9943,7 +10538,7 @@
       </p:sp>
       <p:sp>
         <p:nvSpPr>
-          <p:cNvPr id="20" name="Text"/>
+          <p:cNvPr id="30" name="Text"/>
           <p:cNvSpPr txBox="1"/>
           <p:nvPr/>
         </p:nvSpPr>
@@ -9997,7 +10592,7 @@
       </p:sp>
       <p:sp>
         <p:nvSpPr>
-          <p:cNvPr id="21" name="Text"/>
+          <p:cNvPr id="31" name="Text"/>
           <p:cNvSpPr txBox="1"/>
           <p:nvPr/>
         </p:nvSpPr>
@@ -14203,13 +14798,58 @@
       </p:sp>
       <p:sp>
         <p:nvSpPr>
-          <p:cNvPr id="4" name="Box"/>
+          <p:cNvPr id="4" name="Text"/>
+          <p:cNvSpPr txBox="1"/>
+          <p:nvPr/>
+        </p:nvSpPr>
+        <p:spPr>
+          <a:xfrm>
+            <a:off x="762000" y="1389757"/>
+            <a:ext cx="9810750" cy="269875"/>
+          </a:xfrm>
+          <a:prstGeom prst="rect">
+            <a:avLst/>
+          </a:prstGeom>
+          <a:noFill/>
+        </p:spPr>
+        <p:txBody>
+          <a:bodyPr wrap="square" lIns="0" rIns="0" tIns="0" bIns="0" anchor="t">
+            <a:noAutofit/>
+          </a:bodyPr>
+          <a:lstStyle/>
+          <a:p>
+            <a:pPr algn="l">
+              <a:lnSpc>
+                <a:spcPts val="2125"/>
+              </a:lnSpc>
+              <a:spcBef>
+                <a:spcPts val="0"/>
+              </a:spcBef>
+              <a:spcAft>
+                <a:spcPts val="0"/>
+              </a:spcAft>
+            </a:pPr>
+            <a:r>
+              <a:rPr sz="1700" b="0" i="0">
+                <a:solidFill>
+                  <a:srgbClr val="4A5163"/>
+                </a:solidFill>
+                <a:latin typeface="Noto Sans"/>
+              </a:rPr>
+              <a:t>Two lists, four short lines each.</a:t>
+            </a:r>
+          </a:p>
+        </p:txBody>
+      </p:sp>
+      <p:sp>
+        <p:nvSpPr>
+          <p:cNvPr id="5" name="Box"/>
           <p:cNvSpPr/>
           <p:nvPr/>
         </p:nvSpPr>
         <p:spPr>
           <a:xfrm>
-            <a:off x="762000" y="1905000"/>
+            <a:off x="762000" y="2159000"/>
             <a:ext cx="5245100" cy="2384822"/>
           </a:xfrm>
           <a:prstGeom prst="roundRect">
@@ -14235,13 +14875,13 @@
       </p:sp>
       <p:sp>
         <p:nvSpPr>
-          <p:cNvPr id="5" name="Box"/>
+          <p:cNvPr id="6" name="Box"/>
           <p:cNvSpPr/>
           <p:nvPr/>
         </p:nvSpPr>
         <p:spPr>
           <a:xfrm>
-            <a:off x="762000" y="1968500"/>
+            <a:off x="762000" y="2222500"/>
             <a:ext cx="5245100" cy="2321322"/>
           </a:xfrm>
           <a:prstGeom prst="roundRect">
@@ -14267,13 +14907,13 @@
       </p:sp>
       <p:sp>
         <p:nvSpPr>
-          <p:cNvPr id="6" name="Text"/>
+          <p:cNvPr id="7" name="Text"/>
           <p:cNvSpPr txBox="1"/>
           <p:nvPr/>
         </p:nvSpPr>
         <p:spPr>
           <a:xfrm>
-            <a:off x="965200" y="2158022"/>
+            <a:off x="965200" y="2412022"/>
             <a:ext cx="4983861" cy="294056"/>
           </a:xfrm>
           <a:prstGeom prst="rect">
@@ -14312,13 +14952,13 @@
       </p:sp>
       <p:sp>
         <p:nvSpPr>
-          <p:cNvPr id="7" name="Box"/>
+          <p:cNvPr id="8" name="Box"/>
           <p:cNvSpPr/>
           <p:nvPr/>
         </p:nvSpPr>
         <p:spPr>
           <a:xfrm>
-            <a:off x="990600" y="2616200"/>
+            <a:off x="990600" y="2870200"/>
             <a:ext cx="101600" cy="101600"/>
           </a:xfrm>
           <a:prstGeom prst="roundRect">
@@ -14344,13 +14984,13 @@
       </p:sp>
       <p:sp>
         <p:nvSpPr>
-          <p:cNvPr id="8" name="Text"/>
+          <p:cNvPr id="9" name="Text"/>
           <p:cNvSpPr txBox="1"/>
           <p:nvPr/>
         </p:nvSpPr>
         <p:spPr>
           <a:xfrm>
-            <a:off x="1257300" y="2521268"/>
+            <a:off x="1257300" y="2775268"/>
             <a:ext cx="4682998" cy="291465"/>
           </a:xfrm>
           <a:prstGeom prst="rect">
@@ -14389,13 +15029,13 @@
       </p:sp>
       <p:sp>
         <p:nvSpPr>
-          <p:cNvPr id="9" name="Box"/>
+          <p:cNvPr id="10" name="Box"/>
           <p:cNvSpPr/>
           <p:nvPr/>
         </p:nvSpPr>
         <p:spPr>
           <a:xfrm>
-            <a:off x="990600" y="3009205"/>
+            <a:off x="990600" y="3263205"/>
             <a:ext cx="101600" cy="101600"/>
           </a:xfrm>
           <a:prstGeom prst="roundRect">
@@ -14421,13 +15061,13 @@
       </p:sp>
       <p:sp>
         <p:nvSpPr>
-          <p:cNvPr id="10" name="Text"/>
+          <p:cNvPr id="11" name="Text"/>
           <p:cNvSpPr txBox="1"/>
           <p:nvPr/>
         </p:nvSpPr>
         <p:spPr>
           <a:xfrm>
-            <a:off x="1257300" y="2914273"/>
+            <a:off x="1257300" y="3168273"/>
             <a:ext cx="4682998" cy="291465"/>
           </a:xfrm>
           <a:prstGeom prst="rect">
@@ -14466,13 +15106,13 @@
       </p:sp>
       <p:sp>
         <p:nvSpPr>
-          <p:cNvPr id="11" name="Box"/>
+          <p:cNvPr id="12" name="Box"/>
           <p:cNvSpPr/>
           <p:nvPr/>
         </p:nvSpPr>
         <p:spPr>
           <a:xfrm>
-            <a:off x="990600" y="3402211"/>
+            <a:off x="990600" y="3656211"/>
             <a:ext cx="101600" cy="101600"/>
           </a:xfrm>
           <a:prstGeom prst="roundRect">
@@ -14498,13 +15138,13 @@
       </p:sp>
       <p:sp>
         <p:nvSpPr>
-          <p:cNvPr id="12" name="Text"/>
+          <p:cNvPr id="13" name="Text"/>
           <p:cNvSpPr txBox="1"/>
           <p:nvPr/>
         </p:nvSpPr>
         <p:spPr>
           <a:xfrm>
-            <a:off x="1257300" y="3307278"/>
+            <a:off x="1257300" y="3561278"/>
             <a:ext cx="4682998" cy="291465"/>
           </a:xfrm>
           <a:prstGeom prst="rect">
@@ -14543,13 +15183,13 @@
       </p:sp>
       <p:sp>
         <p:nvSpPr>
-          <p:cNvPr id="13" name="Box"/>
+          <p:cNvPr id="14" name="Box"/>
           <p:cNvSpPr/>
           <p:nvPr/>
         </p:nvSpPr>
         <p:spPr>
           <a:xfrm>
-            <a:off x="990600" y="3795216"/>
+            <a:off x="990600" y="4049216"/>
             <a:ext cx="101600" cy="101600"/>
           </a:xfrm>
           <a:prstGeom prst="roundRect">
@@ -14575,13 +15215,13 @@
       </p:sp>
       <p:sp>
         <p:nvSpPr>
-          <p:cNvPr id="14" name="Text"/>
+          <p:cNvPr id="15" name="Text"/>
           <p:cNvSpPr txBox="1"/>
           <p:nvPr/>
         </p:nvSpPr>
         <p:spPr>
           <a:xfrm>
-            <a:off x="1257300" y="3700284"/>
+            <a:off x="1257300" y="3954284"/>
             <a:ext cx="4682998" cy="291465"/>
           </a:xfrm>
           <a:prstGeom prst="rect">
@@ -14620,13 +15260,13 @@
       </p:sp>
       <p:sp>
         <p:nvSpPr>
-          <p:cNvPr id="15" name="Box"/>
+          <p:cNvPr id="16" name="Box"/>
           <p:cNvSpPr/>
           <p:nvPr/>
         </p:nvSpPr>
         <p:spPr>
           <a:xfrm>
-            <a:off x="6184900" y="1905000"/>
+            <a:off x="6184900" y="2159000"/>
             <a:ext cx="5245100" cy="2384822"/>
           </a:xfrm>
           <a:prstGeom prst="roundRect">
@@ -14652,13 +15292,13 @@
       </p:sp>
       <p:sp>
         <p:nvSpPr>
-          <p:cNvPr id="16" name="Box"/>
+          <p:cNvPr id="17" name="Box"/>
           <p:cNvSpPr/>
           <p:nvPr/>
         </p:nvSpPr>
         <p:spPr>
           <a:xfrm>
-            <a:off x="6184900" y="1968500"/>
+            <a:off x="6184900" y="2222500"/>
             <a:ext cx="5245100" cy="2321322"/>
           </a:xfrm>
           <a:prstGeom prst="roundRect">
@@ -14684,13 +15324,13 @@
       </p:sp>
       <p:sp>
         <p:nvSpPr>
-          <p:cNvPr id="17" name="Text"/>
+          <p:cNvPr id="18" name="Text"/>
           <p:cNvSpPr txBox="1"/>
           <p:nvPr/>
         </p:nvSpPr>
         <p:spPr>
           <a:xfrm>
-            <a:off x="6388100" y="2158022"/>
+            <a:off x="6388100" y="2412022"/>
             <a:ext cx="4983861" cy="294056"/>
           </a:xfrm>
           <a:prstGeom prst="rect">
@@ -14729,13 +15369,13 @@
       </p:sp>
       <p:sp>
         <p:nvSpPr>
-          <p:cNvPr id="18" name="Box"/>
+          <p:cNvPr id="19" name="Box"/>
           <p:cNvSpPr/>
           <p:nvPr/>
         </p:nvSpPr>
         <p:spPr>
           <a:xfrm>
-            <a:off x="6413500" y="2616200"/>
+            <a:off x="6413500" y="2870200"/>
             <a:ext cx="101600" cy="101600"/>
           </a:xfrm>
           <a:prstGeom prst="roundRect">
@@ -14761,13 +15401,13 @@
       </p:sp>
       <p:sp>
         <p:nvSpPr>
-          <p:cNvPr id="19" name="Text"/>
+          <p:cNvPr id="20" name="Text"/>
           <p:cNvSpPr txBox="1"/>
           <p:nvPr/>
         </p:nvSpPr>
         <p:spPr>
           <a:xfrm>
-            <a:off x="6680200" y="2521268"/>
+            <a:off x="6680200" y="2775268"/>
             <a:ext cx="4682998" cy="291465"/>
           </a:xfrm>
           <a:prstGeom prst="rect">
@@ -14806,13 +15446,13 @@
       </p:sp>
       <p:sp>
         <p:nvSpPr>
-          <p:cNvPr id="20" name="Box"/>
+          <p:cNvPr id="21" name="Box"/>
           <p:cNvSpPr/>
           <p:nvPr/>
         </p:nvSpPr>
         <p:spPr>
           <a:xfrm>
-            <a:off x="6413500" y="3009205"/>
+            <a:off x="6413500" y="3263205"/>
             <a:ext cx="101600" cy="101600"/>
           </a:xfrm>
           <a:prstGeom prst="roundRect">
@@ -14838,13 +15478,13 @@
       </p:sp>
       <p:sp>
         <p:nvSpPr>
-          <p:cNvPr id="21" name="Text"/>
+          <p:cNvPr id="22" name="Text"/>
           <p:cNvSpPr txBox="1"/>
           <p:nvPr/>
         </p:nvSpPr>
         <p:spPr>
           <a:xfrm>
-            <a:off x="6680200" y="2914273"/>
+            <a:off x="6680200" y="3168273"/>
             <a:ext cx="4682998" cy="291465"/>
           </a:xfrm>
           <a:prstGeom prst="rect">
@@ -14883,13 +15523,13 @@
       </p:sp>
       <p:sp>
         <p:nvSpPr>
-          <p:cNvPr id="22" name="Box"/>
+          <p:cNvPr id="23" name="Box"/>
           <p:cNvSpPr/>
           <p:nvPr/>
         </p:nvSpPr>
         <p:spPr>
           <a:xfrm>
-            <a:off x="6413500" y="3402211"/>
+            <a:off x="6413500" y="3656211"/>
             <a:ext cx="101600" cy="101600"/>
           </a:xfrm>
           <a:prstGeom prst="roundRect">
@@ -14915,13 +15555,13 @@
       </p:sp>
       <p:sp>
         <p:nvSpPr>
-          <p:cNvPr id="23" name="Text"/>
+          <p:cNvPr id="24" name="Text"/>
           <p:cNvSpPr txBox="1"/>
           <p:nvPr/>
         </p:nvSpPr>
         <p:spPr>
           <a:xfrm>
-            <a:off x="6680200" y="3307278"/>
+            <a:off x="6680200" y="3561278"/>
             <a:ext cx="4682998" cy="291465"/>
           </a:xfrm>
           <a:prstGeom prst="rect">
@@ -14960,13 +15600,13 @@
       </p:sp>
       <p:sp>
         <p:nvSpPr>
-          <p:cNvPr id="24" name="Box"/>
+          <p:cNvPr id="25" name="Box"/>
           <p:cNvSpPr/>
           <p:nvPr/>
         </p:nvSpPr>
         <p:spPr>
           <a:xfrm>
-            <a:off x="6413500" y="3795216"/>
+            <a:off x="6413500" y="4049216"/>
             <a:ext cx="101600" cy="101600"/>
           </a:xfrm>
           <a:prstGeom prst="roundRect">
@@ -14992,13 +15632,13 @@
       </p:sp>
       <p:sp>
         <p:nvSpPr>
-          <p:cNvPr id="25" name="Text"/>
+          <p:cNvPr id="26" name="Text"/>
           <p:cNvSpPr txBox="1"/>
           <p:nvPr/>
         </p:nvSpPr>
         <p:spPr>
           <a:xfrm>
-            <a:off x="6680200" y="3700284"/>
+            <a:off x="6680200" y="3954284"/>
             <a:ext cx="4682998" cy="291465"/>
           </a:xfrm>
           <a:prstGeom prst="rect">
@@ -15037,7 +15677,7 @@
       </p:sp>
       <p:sp>
         <p:nvSpPr>
-          <p:cNvPr id="26" name="Box"/>
+          <p:cNvPr id="27" name="Box"/>
           <p:cNvSpPr/>
           <p:nvPr/>
         </p:nvSpPr>
@@ -15067,7 +15707,7 @@
       </p:sp>
       <p:sp>
         <p:nvSpPr>
-          <p:cNvPr id="27" name="Text"/>
+          <p:cNvPr id="28" name="Text"/>
           <p:cNvSpPr txBox="1"/>
           <p:nvPr/>
         </p:nvSpPr>
@@ -15121,7 +15761,7 @@
       </p:sp>
       <p:sp>
         <p:nvSpPr>
-          <p:cNvPr id="28" name="Text"/>
+          <p:cNvPr id="29" name="Text"/>
           <p:cNvSpPr txBox="1"/>
           <p:nvPr/>
         </p:nvSpPr>

</xml_diff>

<commit_message>
Explainer parity: side-by-side grid recipe; v0.16.0 (#46, slice 4) (#54)
* Explainer cover: title fits one line or wraps balanced, 40px gap to the subtitle (#46)

* Explainer cards, story and two-column panels are compact, not stretched to fill (#46)

* Explainer: section title gap, source label contrast, sub lines, six-card sample (#46)

* Parity grid recipe and tool; v0.16.0 (#46)

* Bump pins to 0.16.0 (report.toml, config docs, Dockerfiles, examples); rebuild sample (#46)
</commit_message>
<xml_diff>
--- a/docs/samples/house-style-explainer-v1.pptx
+++ b/docs/samples/house-style-explainer-v1.pptx
@@ -516,6 +516,12 @@
               <a:t>This deck is an invented example. It shows every kind of slide in the explainer format: title, agenda, statement, diagram, cards, story, mapping table, contrast, two columns, section, quote and closing. The tool shed is made up, and so is every number in it.</a:t>
             </a:r>
           </a:p>
+          <a:p/>
+          <a:p>
+            <a:r>
+              <a:t>Source: Invented example; no real shed</a:t>
+            </a:r>
+          </a:p>
         </p:txBody>
       </p:sp>
       <p:sp>
@@ -586,6 +592,12 @@
               <a:t>A section slide marks a change of subject. Say what comes next in one sentence.</a:t>
             </a:r>
           </a:p>
+          <a:p/>
+          <a:p>
+            <a:r>
+              <a:t>Source: Invented example</a:t>
+            </a:r>
+          </a:p>
         </p:txBody>
       </p:sp>
       <p:sp>
@@ -1033,7 +1045,7 @@
           <a:lstStyle/>
           <a:p>
             <a:r>
-              <a:t>The three jobs. The registrar writes ledger lines. The checker decides what is fit to hang. The host opens the shed. The lesson: every job has a single test, which is why a new volunteer is useful quickly.</a:t>
+              <a:t>Six jobs in a grid of two rows. The registrar writes ledger lines. The checker decides what is fit to hang. The host opens the shed. The mender fixes what the checker sets aside, and the stocker fills the gaps. The last card is grey: a place for helpers who have not taken a job yet. The lesson: every job has a single test, which is why a new volunteer is useful quickly.</a:t>
             </a:r>
           </a:p>
           <a:p/>
@@ -4369,8 +4381,8 @@
         </p:nvSpPr>
         <p:spPr>
           <a:xfrm>
-            <a:off x="1016000" y="2156841"/>
-            <a:ext cx="9810750" cy="1316684"/>
+            <a:off x="1016000" y="2028825"/>
+            <a:ext cx="9810750" cy="514350"/>
           </a:xfrm>
         </p:spPr>
         <p:txBody>
@@ -4381,17 +4393,17 @@
           <a:p>
             <a:pPr algn="l">
               <a:lnSpc>
-                <a:spcPts val="5184"/>
-              </a:lnSpc>
-              <a:spcBef>
-                <a:spcPts val="0"/>
-              </a:spcBef>
-              <a:spcAft>
-                <a:spcPts val="0"/>
-              </a:spcAft>
-            </a:pPr>
-            <a:r>
-              <a:rPr sz="4800" b="1" i="0" spc="-48">
+                <a:spcPts val="4050"/>
+              </a:lnSpc>
+              <a:spcBef>
+                <a:spcPts val="0"/>
+              </a:spcBef>
+              <a:spcAft>
+                <a:spcPts val="0"/>
+              </a:spcAft>
+            </a:pPr>
+            <a:r>
+              <a:rPr sz="3750" b="1" i="0" spc="-75">
                 <a:solidFill>
                   <a:srgbClr val="FFFFFF"/>
                 </a:solidFill>
@@ -4455,7 +4467,7 @@
         </p:nvSpPr>
         <p:spPr>
           <a:xfrm>
-            <a:off x="1016000" y="3586758"/>
+            <a:off x="1016000" y="2797175"/>
             <a:ext cx="9156700" cy="317500"/>
           </a:xfrm>
           <a:prstGeom prst="rect">
@@ -4570,6 +4582,60 @@
       <p:sp>
         <p:nvSpPr>
           <p:cNvPr id="7" name="Text"/>
+          <p:cNvSpPr txBox="1"/>
+          <p:nvPr/>
+        </p:nvSpPr>
+        <p:spPr>
+          <a:xfrm>
+            <a:off x="762000" y="6495561"/>
+            <a:ext cx="2025650" cy="147028"/>
+          </a:xfrm>
+          <a:prstGeom prst="rect">
+            <a:avLst/>
+          </a:prstGeom>
+          <a:noFill/>
+        </p:spPr>
+        <p:txBody>
+          <a:bodyPr wrap="none" lIns="0" rIns="0" tIns="0" bIns="0" anchor="t">
+            <a:noAutofit/>
+          </a:bodyPr>
+          <a:lstStyle/>
+          <a:p>
+            <a:pPr algn="l">
+              <a:lnSpc>
+                <a:spcPts val="1157"/>
+              </a:lnSpc>
+              <a:spcBef>
+                <a:spcPts val="0"/>
+              </a:spcBef>
+              <a:spcAft>
+                <a:spcPts val="0"/>
+              </a:spcAft>
+            </a:pPr>
+            <a:r>
+              <a:rPr sz="850" b="1" i="0">
+                <a:solidFill>
+                  <a:srgbClr val="8F93AD"/>
+                </a:solidFill>
+                <a:latin typeface="Noto Sans"/>
+              </a:rPr>
+              <a:t>Source:</a:t>
+            </a:r>
+            <a:r>
+              <a:rPr sz="850" b="0" i="0">
+                <a:solidFill>
+                  <a:srgbClr val="8F93AD"/>
+                </a:solidFill>
+                <a:latin typeface="Noto Sans"/>
+              </a:rPr>
+              <a:t> Invented example; no real shed</a:t>
+            </a:r>
+          </a:p>
+        </p:txBody>
+      </p:sp>
+      <p:sp>
+        <p:nvSpPr>
+          <p:cNvPr id="8" name="Text"/>
           <p:cNvSpPr txBox="1"/>
           <p:nvPr/>
         </p:nvSpPr>
@@ -4650,7 +4716,7 @@
         </p:nvSpPr>
         <p:spPr>
           <a:xfrm>
-            <a:off x="1016000" y="1675257"/>
+            <a:off x="1016000" y="2348357"/>
             <a:ext cx="8829675" cy="630936"/>
           </a:xfrm>
         </p:spPr>
@@ -4781,7 +4847,7 @@
         </p:nvSpPr>
         <p:spPr>
           <a:xfrm>
-            <a:off x="1016000" y="2418457"/>
+            <a:off x="1016000" y="3091557"/>
             <a:ext cx="8502650" cy="317500"/>
           </a:xfrm>
           <a:prstGeom prst="rect">
@@ -4851,6 +4917,60 @@
       <p:sp>
         <p:nvSpPr>
           <p:cNvPr id="7" name="Text"/>
+          <p:cNvSpPr txBox="1"/>
+          <p:nvPr/>
+        </p:nvSpPr>
+        <p:spPr>
+          <a:xfrm>
+            <a:off x="762000" y="6495561"/>
+            <a:ext cx="1339850" cy="147028"/>
+          </a:xfrm>
+          <a:prstGeom prst="rect">
+            <a:avLst/>
+          </a:prstGeom>
+          <a:noFill/>
+        </p:spPr>
+        <p:txBody>
+          <a:bodyPr wrap="none" lIns="0" rIns="0" tIns="0" bIns="0" anchor="t">
+            <a:noAutofit/>
+          </a:bodyPr>
+          <a:lstStyle/>
+          <a:p>
+            <a:pPr algn="l">
+              <a:lnSpc>
+                <a:spcPts val="1157"/>
+              </a:lnSpc>
+              <a:spcBef>
+                <a:spcPts val="0"/>
+              </a:spcBef>
+              <a:spcAft>
+                <a:spcPts val="0"/>
+              </a:spcAft>
+            </a:pPr>
+            <a:r>
+              <a:rPr sz="850" b="1" i="0">
+                <a:solidFill>
+                  <a:srgbClr val="D6D1FF"/>
+                </a:solidFill>
+                <a:latin typeface="Noto Sans"/>
+              </a:rPr>
+              <a:t>Source:</a:t>
+            </a:r>
+            <a:r>
+              <a:rPr sz="850" b="0" i="0">
+                <a:solidFill>
+                  <a:srgbClr val="D6D1FF"/>
+                </a:solidFill>
+                <a:latin typeface="Noto Sans"/>
+              </a:rPr>
+              <a:t> Invented example</a:t>
+            </a:r>
+          </a:p>
+        </p:txBody>
+      </p:sp>
+      <p:sp>
+        <p:nvSpPr>
+          <p:cNvPr id="8" name="Text"/>
           <p:cNvSpPr txBox="1"/>
           <p:nvPr/>
         </p:nvSpPr>
@@ -5017,39 +5137,39 @@
         </p:nvSpPr>
         <p:spPr>
           <a:xfrm>
-            <a:off x="482600" y="1625600"/>
-            <a:ext cx="1524000" cy="1651000"/>
-          </a:xfrm>
-          <a:prstGeom prst="rect">
-            <a:avLst/>
-          </a:prstGeom>
-          <a:noFill/>
-        </p:spPr>
-        <p:txBody>
-          <a:bodyPr wrap="none" lIns="0" rIns="0" tIns="0" bIns="0" anchor="t">
+            <a:off x="762000" y="1389757"/>
+            <a:ext cx="9810750" cy="269875"/>
+          </a:xfrm>
+          <a:prstGeom prst="rect">
+            <a:avLst/>
+          </a:prstGeom>
+          <a:noFill/>
+        </p:spPr>
+        <p:txBody>
+          <a:bodyPr wrap="square" lIns="0" rIns="0" tIns="0" bIns="0" anchor="t">
             <a:noAutofit/>
           </a:bodyPr>
           <a:lstStyle/>
           <a:p>
             <a:pPr algn="l">
               <a:lnSpc>
-                <a:spcPts val="13000"/>
-              </a:lnSpc>
-              <a:spcBef>
-                <a:spcPts val="0"/>
-              </a:spcBef>
-              <a:spcAft>
-                <a:spcPts val="0"/>
-              </a:spcAft>
-            </a:pPr>
-            <a:r>
-              <a:rPr sz="10000" b="0" i="0">
-                <a:solidFill>
-                  <a:srgbClr val="C0BAE8"/>
-                </a:solidFill>
-                <a:latin typeface="Noto Serif"/>
-              </a:rPr>
-              <a:t>“</a:t>
+                <a:spcPts val="2125"/>
+              </a:lnSpc>
+              <a:spcBef>
+                <a:spcPts val="0"/>
+              </a:spcBef>
+              <a:spcAft>
+                <a:spcPts val="0"/>
+              </a:spcAft>
+            </a:pPr>
+            <a:r>
+              <a:rPr sz="1700" b="0" i="0">
+                <a:solidFill>
+                  <a:srgbClr val="4A5163"/>
+                </a:solidFill>
+                <a:latin typeface="Noto Sans"/>
+              </a:rPr>
+              <a:t>Said at the end of a first Saturday.</a:t>
             </a:r>
           </a:p>
         </p:txBody>
@@ -5062,57 +5182,39 @@
         </p:nvSpPr>
         <p:spPr>
           <a:xfrm>
-            <a:off x="1168400" y="1900936"/>
-            <a:ext cx="9784588" cy="905165"/>
-          </a:xfrm>
-          <a:prstGeom prst="rect">
-            <a:avLst/>
-          </a:prstGeom>
-          <a:noFill/>
-        </p:spPr>
-        <p:txBody>
-          <a:bodyPr wrap="square" lIns="0" rIns="0" tIns="0" bIns="0" anchor="t">
+            <a:off x="482600" y="1879600"/>
+            <a:ext cx="1524000" cy="1651000"/>
+          </a:xfrm>
+          <a:prstGeom prst="rect">
+            <a:avLst/>
+          </a:prstGeom>
+          <a:noFill/>
+        </p:spPr>
+        <p:txBody>
+          <a:bodyPr wrap="none" lIns="0" rIns="0" tIns="0" bIns="0" anchor="t">
             <a:noAutofit/>
           </a:bodyPr>
           <a:lstStyle/>
           <a:p>
             <a:pPr algn="l">
               <a:lnSpc>
-                <a:spcPts val="3564"/>
-              </a:lnSpc>
-              <a:spcBef>
-                <a:spcPts val="0"/>
-              </a:spcBef>
-              <a:spcAft>
-                <a:spcPts val="0"/>
-              </a:spcAft>
-            </a:pPr>
-            <a:r>
-              <a:rPr sz="2700" b="0" i="0">
-                <a:solidFill>
-                  <a:srgbClr val="1D2433"/>
-                </a:solidFill>
-                <a:latin typeface="Noto Sans"/>
-              </a:rPr>
-              <a:t>I came for a ladder and left with </a:t>
-            </a:r>
-            <a:r>
-              <a:rPr sz="2700" b="1" i="0">
-                <a:solidFill>
-                  <a:srgbClr val="5B4BD6"/>
-                </a:solidFill>
-                <a:latin typeface="Noto Sans"/>
-              </a:rPr>
-              <a:t>the confidence</a:t>
-            </a:r>
-            <a:r>
-              <a:rPr sz="2700" b="0" i="0">
-                <a:solidFill>
-                  <a:srgbClr val="1D2433"/>
-                </a:solidFill>
-                <a:latin typeface="Noto Sans"/>
-              </a:rPr>
-              <a:t> to ask for a second tool next week.</a:t>
+                <a:spcPts val="13000"/>
+              </a:lnSpc>
+              <a:spcBef>
+                <a:spcPts val="0"/>
+              </a:spcBef>
+              <a:spcAft>
+                <a:spcPts val="0"/>
+              </a:spcAft>
+            </a:pPr>
+            <a:r>
+              <a:rPr sz="10000" b="0" i="0">
+                <a:solidFill>
+                  <a:srgbClr val="C0BAE8"/>
+                </a:solidFill>
+                <a:latin typeface="Noto Serif"/>
+              </a:rPr>
+              <a:t>“</a:t>
             </a:r>
           </a:p>
         </p:txBody>
@@ -5125,7 +5227,70 @@
         </p:nvSpPr>
         <p:spPr>
           <a:xfrm>
-            <a:off x="1168400" y="3038242"/>
+            <a:off x="1168400" y="2154936"/>
+            <a:ext cx="9784588" cy="905165"/>
+          </a:xfrm>
+          <a:prstGeom prst="rect">
+            <a:avLst/>
+          </a:prstGeom>
+          <a:noFill/>
+        </p:spPr>
+        <p:txBody>
+          <a:bodyPr wrap="square" lIns="0" rIns="0" tIns="0" bIns="0" anchor="t">
+            <a:noAutofit/>
+          </a:bodyPr>
+          <a:lstStyle/>
+          <a:p>
+            <a:pPr algn="l">
+              <a:lnSpc>
+                <a:spcPts val="3564"/>
+              </a:lnSpc>
+              <a:spcBef>
+                <a:spcPts val="0"/>
+              </a:spcBef>
+              <a:spcAft>
+                <a:spcPts val="0"/>
+              </a:spcAft>
+            </a:pPr>
+            <a:r>
+              <a:rPr sz="2700" b="0" i="0">
+                <a:solidFill>
+                  <a:srgbClr val="1D2433"/>
+                </a:solidFill>
+                <a:latin typeface="Noto Sans"/>
+              </a:rPr>
+              <a:t>I came for a ladder and left with </a:t>
+            </a:r>
+            <a:r>
+              <a:rPr sz="2700" b="1" i="0">
+                <a:solidFill>
+                  <a:srgbClr val="5B4BD6"/>
+                </a:solidFill>
+                <a:latin typeface="Noto Sans"/>
+              </a:rPr>
+              <a:t>the confidence</a:t>
+            </a:r>
+            <a:r>
+              <a:rPr sz="2700" b="0" i="0">
+                <a:solidFill>
+                  <a:srgbClr val="1D2433"/>
+                </a:solidFill>
+                <a:latin typeface="Noto Sans"/>
+              </a:rPr>
+              <a:t> to ask for a second tool next week.</a:t>
+            </a:r>
+          </a:p>
+        </p:txBody>
+      </p:sp>
+      <p:sp>
+        <p:nvSpPr>
+          <p:cNvPr id="7" name="Text"/>
+          <p:cNvSpPr txBox="1"/>
+          <p:nvPr/>
+        </p:nvSpPr>
+        <p:spPr>
+          <a:xfrm>
+            <a:off x="1168400" y="3292242"/>
             <a:ext cx="10569448" cy="242164"/>
           </a:xfrm>
           <a:prstGeom prst="rect">
@@ -5164,7 +5329,7 @@
       </p:sp>
       <p:sp>
         <p:nvSpPr>
-          <p:cNvPr id="7" name="Box"/>
+          <p:cNvPr id="8" name="Box"/>
           <p:cNvSpPr/>
           <p:nvPr/>
         </p:nvSpPr>
@@ -5194,7 +5359,7 @@
       </p:sp>
       <p:sp>
         <p:nvSpPr>
-          <p:cNvPr id="8" name="Text"/>
+          <p:cNvPr id="9" name="Text"/>
           <p:cNvSpPr txBox="1"/>
           <p:nvPr/>
         </p:nvSpPr>
@@ -5248,7 +5413,7 @@
       </p:sp>
       <p:sp>
         <p:nvSpPr>
-          <p:cNvPr id="9" name="Text"/>
+          <p:cNvPr id="10" name="Text"/>
           <p:cNvSpPr txBox="1"/>
           <p:nvPr/>
         </p:nvSpPr>
@@ -5884,7 +6049,7 @@
             <a:r>
               <a:rPr sz="850" b="1" i="0">
                 <a:solidFill>
-                  <a:srgbClr val="4A5163"/>
+                  <a:srgbClr val="8F93AD"/>
                 </a:solidFill>
                 <a:latin typeface="Noto Sans"/>
               </a:rPr>
@@ -7831,13 +7996,58 @@
       </p:sp>
       <p:sp>
         <p:nvSpPr>
-          <p:cNvPr id="4" name="Box"/>
+          <p:cNvPr id="4" name="Text"/>
+          <p:cNvSpPr txBox="1"/>
+          <p:nvPr/>
+        </p:nvSpPr>
+        <p:spPr>
+          <a:xfrm>
+            <a:off x="762000" y="1389757"/>
+            <a:ext cx="9810750" cy="269875"/>
+          </a:xfrm>
+          <a:prstGeom prst="rect">
+            <a:avLst/>
+          </a:prstGeom>
+          <a:noFill/>
+        </p:spPr>
+        <p:txBody>
+          <a:bodyPr wrap="square" lIns="0" rIns="0" tIns="0" bIns="0" anchor="t">
+            <a:noAutofit/>
+          </a:bodyPr>
+          <a:lstStyle/>
+          <a:p>
+            <a:pPr algn="l">
+              <a:lnSpc>
+                <a:spcPts val="2125"/>
+              </a:lnSpc>
+              <a:spcBef>
+                <a:spcPts val="0"/>
+              </a:spcBef>
+              <a:spcAft>
+                <a:spcPts val="0"/>
+              </a:spcAft>
+            </a:pPr>
+            <a:r>
+              <a:rPr sz="1700" b="0" i="0">
+                <a:solidFill>
+                  <a:srgbClr val="4A5163"/>
+                </a:solidFill>
+                <a:latin typeface="Noto Sans"/>
+              </a:rPr>
+              <a:t>Four ideas carry the whole deck.</a:t>
+            </a:r>
+          </a:p>
+        </p:txBody>
+      </p:sp>
+      <p:sp>
+        <p:nvSpPr>
+          <p:cNvPr id="5" name="Box"/>
           <p:cNvSpPr/>
           <p:nvPr/>
         </p:nvSpPr>
         <p:spPr>
           <a:xfrm>
-            <a:off x="787400" y="2012950"/>
+            <a:off x="787400" y="2203450"/>
             <a:ext cx="101600" cy="101600"/>
           </a:xfrm>
           <a:prstGeom prst="roundRect">
@@ -7863,13 +8073,13 @@
       </p:sp>
       <p:sp>
         <p:nvSpPr>
-          <p:cNvPr id="5" name="Text"/>
+          <p:cNvPr id="6" name="Text"/>
           <p:cNvSpPr txBox="1"/>
           <p:nvPr/>
         </p:nvSpPr>
         <p:spPr>
           <a:xfrm>
-            <a:off x="1054100" y="1900873"/>
+            <a:off x="1054100" y="2091373"/>
             <a:ext cx="9902317" cy="325755"/>
           </a:xfrm>
           <a:prstGeom prst="rect">
@@ -7926,13 +8136,13 @@
       </p:sp>
       <p:sp>
         <p:nvSpPr>
-          <p:cNvPr id="6" name="Box"/>
+          <p:cNvPr id="7" name="Box"/>
           <p:cNvSpPr/>
           <p:nvPr/>
         </p:nvSpPr>
         <p:spPr>
           <a:xfrm>
-            <a:off x="787400" y="2503785"/>
+            <a:off x="787400" y="2694285"/>
             <a:ext cx="101600" cy="101600"/>
           </a:xfrm>
           <a:prstGeom prst="roundRect">
@@ -7958,13 +8168,13 @@
       </p:sp>
       <p:sp>
         <p:nvSpPr>
-          <p:cNvPr id="7" name="Text"/>
+          <p:cNvPr id="8" name="Text"/>
           <p:cNvSpPr txBox="1"/>
           <p:nvPr/>
         </p:nvSpPr>
         <p:spPr>
           <a:xfrm>
-            <a:off x="1054100" y="2391708"/>
+            <a:off x="1054100" y="2582208"/>
             <a:ext cx="9902317" cy="325755"/>
           </a:xfrm>
           <a:prstGeom prst="rect">
@@ -8021,13 +8231,13 @@
       </p:sp>
       <p:sp>
         <p:nvSpPr>
-          <p:cNvPr id="8" name="Box"/>
+          <p:cNvPr id="9" name="Box"/>
           <p:cNvSpPr/>
           <p:nvPr/>
         </p:nvSpPr>
         <p:spPr>
           <a:xfrm>
-            <a:off x="787400" y="2994620"/>
+            <a:off x="787400" y="3185120"/>
             <a:ext cx="101600" cy="101600"/>
           </a:xfrm>
           <a:prstGeom prst="roundRect">
@@ -8053,13 +8263,13 @@
       </p:sp>
       <p:sp>
         <p:nvSpPr>
-          <p:cNvPr id="9" name="Text"/>
+          <p:cNvPr id="10" name="Text"/>
           <p:cNvSpPr txBox="1"/>
           <p:nvPr/>
         </p:nvSpPr>
         <p:spPr>
           <a:xfrm>
-            <a:off x="1054100" y="2882543"/>
+            <a:off x="1054100" y="3073043"/>
             <a:ext cx="9902317" cy="325755"/>
           </a:xfrm>
           <a:prstGeom prst="rect">
@@ -8116,13 +8326,13 @@
       </p:sp>
       <p:sp>
         <p:nvSpPr>
-          <p:cNvPr id="10" name="Box"/>
+          <p:cNvPr id="11" name="Box"/>
           <p:cNvSpPr/>
           <p:nvPr/>
         </p:nvSpPr>
         <p:spPr>
           <a:xfrm>
-            <a:off x="787400" y="3485455"/>
+            <a:off x="787400" y="3675955"/>
             <a:ext cx="101600" cy="101600"/>
           </a:xfrm>
           <a:prstGeom prst="roundRect">
@@ -8148,13 +8358,13 @@
       </p:sp>
       <p:sp>
         <p:nvSpPr>
-          <p:cNvPr id="11" name="Text"/>
+          <p:cNvPr id="12" name="Text"/>
           <p:cNvSpPr txBox="1"/>
           <p:nvPr/>
         </p:nvSpPr>
         <p:spPr>
           <a:xfrm>
-            <a:off x="1054100" y="3373378"/>
+            <a:off x="1054100" y="3563878"/>
             <a:ext cx="9902317" cy="325755"/>
           </a:xfrm>
           <a:prstGeom prst="rect">
@@ -8211,13 +8421,13 @@
       </p:sp>
       <p:sp>
         <p:nvSpPr>
-          <p:cNvPr id="12" name="Box"/>
+          <p:cNvPr id="13" name="Box"/>
           <p:cNvSpPr/>
           <p:nvPr/>
         </p:nvSpPr>
         <p:spPr>
           <a:xfrm>
-            <a:off x="787400" y="3976291"/>
+            <a:off x="787400" y="4166791"/>
             <a:ext cx="101600" cy="101600"/>
           </a:xfrm>
           <a:prstGeom prst="roundRect">
@@ -8243,13 +8453,13 @@
       </p:sp>
       <p:sp>
         <p:nvSpPr>
-          <p:cNvPr id="13" name="Text"/>
+          <p:cNvPr id="14" name="Text"/>
           <p:cNvSpPr txBox="1"/>
           <p:nvPr/>
         </p:nvSpPr>
         <p:spPr>
           <a:xfrm>
-            <a:off x="1054100" y="3864213"/>
+            <a:off x="1054100" y="4054713"/>
             <a:ext cx="9902317" cy="325755"/>
           </a:xfrm>
           <a:prstGeom prst="rect">
@@ -8288,7 +8498,7 @@
       </p:sp>
       <p:sp>
         <p:nvSpPr>
-          <p:cNvPr id="14" name="Box"/>
+          <p:cNvPr id="15" name="Box"/>
           <p:cNvSpPr/>
           <p:nvPr/>
         </p:nvSpPr>
@@ -8318,7 +8528,7 @@
       </p:sp>
       <p:sp>
         <p:nvSpPr>
-          <p:cNvPr id="15" name="Text"/>
+          <p:cNvPr id="16" name="Text"/>
           <p:cNvSpPr txBox="1"/>
           <p:nvPr/>
         </p:nvSpPr>
@@ -8372,7 +8582,7 @@
       </p:sp>
       <p:sp>
         <p:nvSpPr>
-          <p:cNvPr id="16" name="Text"/>
+          <p:cNvPr id="17" name="Text"/>
           <p:cNvSpPr txBox="1"/>
           <p:nvPr/>
         </p:nvSpPr>
@@ -9277,7 +9487,7 @@
                 </a:solidFill>
                 <a:latin typeface="Noto Sans"/>
               </a:rPr>
-              <a:t>Three volunteers keep the shed open</a:t>
+              <a:t>Six jobs keep the shed open</a:t>
             </a:r>
           </a:p>
         </p:txBody>
@@ -9322,25 +9532,70 @@
                 </a:solidFill>
                 <a:latin typeface="Noto Sans"/>
               </a:rPr>
-              <a:t>THREE JOBS</a:t>
-            </a:r>
-          </a:p>
-        </p:txBody>
-      </p:sp>
-      <p:sp>
-        <p:nvSpPr>
-          <p:cNvPr id="4" name="Box"/>
+              <a:t>SIX JOBS</a:t>
+            </a:r>
+          </a:p>
+        </p:txBody>
+      </p:sp>
+      <p:sp>
+        <p:nvSpPr>
+          <p:cNvPr id="4" name="Text"/>
+          <p:cNvSpPr txBox="1"/>
+          <p:nvPr/>
+        </p:nvSpPr>
+        <p:spPr>
+          <a:xfrm>
+            <a:off x="762000" y="1389757"/>
+            <a:ext cx="9810750" cy="269875"/>
+          </a:xfrm>
+          <a:prstGeom prst="rect">
+            <a:avLst/>
+          </a:prstGeom>
+          <a:noFill/>
+        </p:spPr>
+        <p:txBody>
+          <a:bodyPr wrap="square" lIns="0" rIns="0" tIns="0" bIns="0" anchor="t">
+            <a:noAutofit/>
+          </a:bodyPr>
+          <a:lstStyle/>
+          <a:p>
+            <a:pPr algn="l">
+              <a:lnSpc>
+                <a:spcPts val="2125"/>
+              </a:lnSpc>
+              <a:spcBef>
+                <a:spcPts val="0"/>
+              </a:spcBef>
+              <a:spcAft>
+                <a:spcPts val="0"/>
+              </a:spcAft>
+            </a:pPr>
+            <a:r>
+              <a:rPr sz="1700" b="0" i="0">
+                <a:solidFill>
+                  <a:srgbClr val="4A5163"/>
+                </a:solidFill>
+                <a:latin typeface="Noto Sans"/>
+              </a:rPr>
+              <a:t>Each job is small and has one test.</a:t>
+            </a:r>
+          </a:p>
+        </p:txBody>
+      </p:sp>
+      <p:sp>
+        <p:nvSpPr>
+          <p:cNvPr id="5" name="Box"/>
           <p:cNvSpPr/>
           <p:nvPr/>
         </p:nvSpPr>
         <p:spPr>
           <a:xfrm>
-            <a:off x="762000" y="1778000"/>
-            <a:ext cx="3437434" cy="3492500"/>
+            <a:off x="762000" y="2159000"/>
+            <a:ext cx="3437434" cy="2126952"/>
           </a:xfrm>
           <a:prstGeom prst="roundRect">
             <a:avLst>
-              <a:gd name="adj" fmla="val 2955"/>
+              <a:gd name="adj" fmla="val 4776"/>
             </a:avLst>
           </a:prstGeom>
           <a:solidFill>
@@ -9361,18 +9616,18 @@
       </p:sp>
       <p:sp>
         <p:nvSpPr>
-          <p:cNvPr id="5" name="Box"/>
+          <p:cNvPr id="6" name="Box"/>
           <p:cNvSpPr/>
           <p:nvPr/>
         </p:nvSpPr>
         <p:spPr>
           <a:xfrm>
-            <a:off x="762000" y="1841500"/>
-            <a:ext cx="3437434" cy="3429000"/>
+            <a:off x="762000" y="2222500"/>
+            <a:ext cx="3437434" cy="2063452"/>
           </a:xfrm>
           <a:prstGeom prst="roundRect">
             <a:avLst>
-              <a:gd name="adj" fmla="val 1111"/>
+              <a:gd name="adj" fmla="val 1846"/>
             </a:avLst>
           </a:prstGeom>
           <a:solidFill>
@@ -9393,58 +9648,58 @@
       </p:sp>
       <p:sp>
         <p:nvSpPr>
-          <p:cNvPr id="6" name="Text"/>
-          <p:cNvSpPr txBox="1"/>
-          <p:nvPr/>
-        </p:nvSpPr>
-        <p:spPr>
-          <a:xfrm>
-            <a:off x="965200" y="2031022"/>
-            <a:ext cx="3121965" cy="294056"/>
-          </a:xfrm>
-          <a:prstGeom prst="rect">
-            <a:avLst/>
-          </a:prstGeom>
-          <a:noFill/>
-        </p:spPr>
-        <p:txBody>
-          <a:bodyPr wrap="square" lIns="0" rIns="0" tIns="0" bIns="0" anchor="t">
-            <a:noAutofit/>
-          </a:bodyPr>
-          <a:lstStyle/>
-          <a:p>
-            <a:pPr algn="l">
-              <a:lnSpc>
-                <a:spcPts val="2315"/>
-              </a:lnSpc>
-              <a:spcBef>
-                <a:spcPts val="0"/>
-              </a:spcBef>
-              <a:spcAft>
-                <a:spcPts val="0"/>
-              </a:spcAft>
-            </a:pPr>
-            <a:r>
-              <a:rPr sz="1700" b="1" i="0">
-                <a:solidFill>
-                  <a:srgbClr val="5B4BD6"/>
-                </a:solidFill>
-                <a:latin typeface="Noto Sans"/>
-              </a:rPr>
-              <a:t>The registrar</a:t>
-            </a:r>
-          </a:p>
-        </p:txBody>
-      </p:sp>
-      <p:sp>
-        <p:nvSpPr>
           <p:cNvPr id="7" name="Text"/>
           <p:cNvSpPr txBox="1"/>
           <p:nvPr/>
         </p:nvSpPr>
         <p:spPr>
           <a:xfrm>
-            <a:off x="965200" y="2399030"/>
+            <a:off x="965200" y="2412022"/>
+            <a:ext cx="3121965" cy="294056"/>
+          </a:xfrm>
+          <a:prstGeom prst="rect">
+            <a:avLst/>
+          </a:prstGeom>
+          <a:noFill/>
+        </p:spPr>
+        <p:txBody>
+          <a:bodyPr wrap="square" lIns="0" rIns="0" tIns="0" bIns="0" anchor="t">
+            <a:noAutofit/>
+          </a:bodyPr>
+          <a:lstStyle/>
+          <a:p>
+            <a:pPr algn="l">
+              <a:lnSpc>
+                <a:spcPts val="2315"/>
+              </a:lnSpc>
+              <a:spcBef>
+                <a:spcPts val="0"/>
+              </a:spcBef>
+              <a:spcAft>
+                <a:spcPts val="0"/>
+              </a:spcAft>
+            </a:pPr>
+            <a:r>
+              <a:rPr sz="1700" b="1" i="0">
+                <a:solidFill>
+                  <a:srgbClr val="5B4BD6"/>
+                </a:solidFill>
+                <a:latin typeface="Noto Sans"/>
+              </a:rPr>
+              <a:t>The registrar</a:t>
+            </a:r>
+          </a:p>
+        </p:txBody>
+      </p:sp>
+      <p:sp>
+        <p:nvSpPr>
+          <p:cNvPr id="8" name="Text"/>
+          <p:cNvSpPr txBox="1"/>
+          <p:nvPr/>
+        </p:nvSpPr>
+        <p:spPr>
+          <a:xfrm>
+            <a:off x="965200" y="2780030"/>
             <a:ext cx="3121965" cy="788551"/>
           </a:xfrm>
           <a:prstGeom prst="rect">
@@ -9483,18 +9738,18 @@
       </p:sp>
       <p:sp>
         <p:nvSpPr>
-          <p:cNvPr id="8" name="Box"/>
+          <p:cNvPr id="9" name="Box"/>
           <p:cNvSpPr/>
           <p:nvPr/>
         </p:nvSpPr>
         <p:spPr>
           <a:xfrm>
-            <a:off x="4377234" y="1778000"/>
-            <a:ext cx="3437434" cy="3492500"/>
+            <a:off x="4377234" y="2159000"/>
+            <a:ext cx="3437434" cy="2126952"/>
           </a:xfrm>
           <a:prstGeom prst="roundRect">
             <a:avLst>
-              <a:gd name="adj" fmla="val 2955"/>
+              <a:gd name="adj" fmla="val 4776"/>
             </a:avLst>
           </a:prstGeom>
           <a:solidFill>
@@ -9515,18 +9770,18 @@
       </p:sp>
       <p:sp>
         <p:nvSpPr>
-          <p:cNvPr id="9" name="Box"/>
+          <p:cNvPr id="10" name="Box"/>
           <p:cNvSpPr/>
           <p:nvPr/>
         </p:nvSpPr>
         <p:spPr>
           <a:xfrm>
-            <a:off x="4377234" y="1841500"/>
-            <a:ext cx="3437434" cy="3429000"/>
+            <a:off x="4377234" y="2222500"/>
+            <a:ext cx="3437434" cy="2063452"/>
           </a:xfrm>
           <a:prstGeom prst="roundRect">
             <a:avLst>
-              <a:gd name="adj" fmla="val 1111"/>
+              <a:gd name="adj" fmla="val 1846"/>
             </a:avLst>
           </a:prstGeom>
           <a:solidFill>
@@ -9547,58 +9802,58 @@
       </p:sp>
       <p:sp>
         <p:nvSpPr>
-          <p:cNvPr id="10" name="Text"/>
-          <p:cNvSpPr txBox="1"/>
-          <p:nvPr/>
-        </p:nvSpPr>
-        <p:spPr>
-          <a:xfrm>
-            <a:off x="4580434" y="2031022"/>
-            <a:ext cx="3121965" cy="294056"/>
-          </a:xfrm>
-          <a:prstGeom prst="rect">
-            <a:avLst/>
-          </a:prstGeom>
-          <a:noFill/>
-        </p:spPr>
-        <p:txBody>
-          <a:bodyPr wrap="square" lIns="0" rIns="0" tIns="0" bIns="0" anchor="t">
-            <a:noAutofit/>
-          </a:bodyPr>
-          <a:lstStyle/>
-          <a:p>
-            <a:pPr algn="l">
-              <a:lnSpc>
-                <a:spcPts val="2315"/>
-              </a:lnSpc>
-              <a:spcBef>
-                <a:spcPts val="0"/>
-              </a:spcBef>
-              <a:spcAft>
-                <a:spcPts val="0"/>
-              </a:spcAft>
-            </a:pPr>
-            <a:r>
-              <a:rPr sz="1700" b="1" i="0">
-                <a:solidFill>
-                  <a:srgbClr val="3F9FA6"/>
-                </a:solidFill>
-                <a:latin typeface="Noto Sans"/>
-              </a:rPr>
-              <a:t>The checker</a:t>
-            </a:r>
-          </a:p>
-        </p:txBody>
-      </p:sp>
-      <p:sp>
-        <p:nvSpPr>
           <p:cNvPr id="11" name="Text"/>
           <p:cNvSpPr txBox="1"/>
           <p:nvPr/>
         </p:nvSpPr>
         <p:spPr>
           <a:xfrm>
-            <a:off x="4580434" y="2399030"/>
+            <a:off x="4580434" y="2412022"/>
+            <a:ext cx="3121965" cy="294056"/>
+          </a:xfrm>
+          <a:prstGeom prst="rect">
+            <a:avLst/>
+          </a:prstGeom>
+          <a:noFill/>
+        </p:spPr>
+        <p:txBody>
+          <a:bodyPr wrap="square" lIns="0" rIns="0" tIns="0" bIns="0" anchor="t">
+            <a:noAutofit/>
+          </a:bodyPr>
+          <a:lstStyle/>
+          <a:p>
+            <a:pPr algn="l">
+              <a:lnSpc>
+                <a:spcPts val="2315"/>
+              </a:lnSpc>
+              <a:spcBef>
+                <a:spcPts val="0"/>
+              </a:spcBef>
+              <a:spcAft>
+                <a:spcPts val="0"/>
+              </a:spcAft>
+            </a:pPr>
+            <a:r>
+              <a:rPr sz="1700" b="1" i="0">
+                <a:solidFill>
+                  <a:srgbClr val="3F9FA6"/>
+                </a:solidFill>
+                <a:latin typeface="Noto Sans"/>
+              </a:rPr>
+              <a:t>The checker</a:t>
+            </a:r>
+          </a:p>
+        </p:txBody>
+      </p:sp>
+      <p:sp>
+        <p:nvSpPr>
+          <p:cNvPr id="12" name="Text"/>
+          <p:cNvSpPr txBox="1"/>
+          <p:nvPr/>
+        </p:nvSpPr>
+        <p:spPr>
+          <a:xfrm>
+            <a:off x="4580434" y="2780030"/>
             <a:ext cx="3121965" cy="1314212"/>
           </a:xfrm>
           <a:prstGeom prst="rect">
@@ -9637,18 +9892,18 @@
       </p:sp>
       <p:sp>
         <p:nvSpPr>
-          <p:cNvPr id="12" name="Box"/>
+          <p:cNvPr id="13" name="Box"/>
           <p:cNvSpPr/>
           <p:nvPr/>
         </p:nvSpPr>
         <p:spPr>
           <a:xfrm>
-            <a:off x="7992467" y="1778000"/>
-            <a:ext cx="3437434" cy="3492500"/>
+            <a:off x="7992467" y="2159000"/>
+            <a:ext cx="3437434" cy="2126952"/>
           </a:xfrm>
           <a:prstGeom prst="roundRect">
             <a:avLst>
-              <a:gd name="adj" fmla="val 2955"/>
+              <a:gd name="adj" fmla="val 4776"/>
             </a:avLst>
           </a:prstGeom>
           <a:solidFill>
@@ -9669,18 +9924,18 @@
       </p:sp>
       <p:sp>
         <p:nvSpPr>
-          <p:cNvPr id="13" name="Box"/>
+          <p:cNvPr id="14" name="Box"/>
           <p:cNvSpPr/>
           <p:nvPr/>
         </p:nvSpPr>
         <p:spPr>
           <a:xfrm>
-            <a:off x="7992467" y="1841500"/>
-            <a:ext cx="3437434" cy="3429000"/>
+            <a:off x="7992467" y="2222500"/>
+            <a:ext cx="3437434" cy="2063452"/>
           </a:xfrm>
           <a:prstGeom prst="roundRect">
             <a:avLst>
-              <a:gd name="adj" fmla="val 1111"/>
+              <a:gd name="adj" fmla="val 1846"/>
             </a:avLst>
           </a:prstGeom>
           <a:solidFill>
@@ -9701,58 +9956,58 @@
       </p:sp>
       <p:sp>
         <p:nvSpPr>
-          <p:cNvPr id="14" name="Text"/>
-          <p:cNvSpPr txBox="1"/>
-          <p:nvPr/>
-        </p:nvSpPr>
-        <p:spPr>
-          <a:xfrm>
-            <a:off x="8195667" y="2031022"/>
-            <a:ext cx="3121965" cy="294056"/>
-          </a:xfrm>
-          <a:prstGeom prst="rect">
-            <a:avLst/>
-          </a:prstGeom>
-          <a:noFill/>
-        </p:spPr>
-        <p:txBody>
-          <a:bodyPr wrap="square" lIns="0" rIns="0" tIns="0" bIns="0" anchor="t">
-            <a:noAutofit/>
-          </a:bodyPr>
-          <a:lstStyle/>
-          <a:p>
-            <a:pPr algn="l">
-              <a:lnSpc>
-                <a:spcPts val="2315"/>
-              </a:lnSpc>
-              <a:spcBef>
-                <a:spcPts val="0"/>
-              </a:spcBef>
-              <a:spcAft>
-                <a:spcPts val="0"/>
-              </a:spcAft>
-            </a:pPr>
-            <a:r>
-              <a:rPr sz="1700" b="1" i="0">
-                <a:solidFill>
-                  <a:srgbClr val="2E9E6B"/>
-                </a:solidFill>
-                <a:latin typeface="Noto Sans"/>
-              </a:rPr>
-              <a:t>The host</a:t>
-            </a:r>
-          </a:p>
-        </p:txBody>
-      </p:sp>
-      <p:sp>
-        <p:nvSpPr>
           <p:cNvPr id="15" name="Text"/>
           <p:cNvSpPr txBox="1"/>
           <p:nvPr/>
         </p:nvSpPr>
         <p:spPr>
           <a:xfrm>
-            <a:off x="8195667" y="2399030"/>
+            <a:off x="8195667" y="2412022"/>
+            <a:ext cx="3121965" cy="294056"/>
+          </a:xfrm>
+          <a:prstGeom prst="rect">
+            <a:avLst/>
+          </a:prstGeom>
+          <a:noFill/>
+        </p:spPr>
+        <p:txBody>
+          <a:bodyPr wrap="square" lIns="0" rIns="0" tIns="0" bIns="0" anchor="t">
+            <a:noAutofit/>
+          </a:bodyPr>
+          <a:lstStyle/>
+          <a:p>
+            <a:pPr algn="l">
+              <a:lnSpc>
+                <a:spcPts val="2315"/>
+              </a:lnSpc>
+              <a:spcBef>
+                <a:spcPts val="0"/>
+              </a:spcBef>
+              <a:spcAft>
+                <a:spcPts val="0"/>
+              </a:spcAft>
+            </a:pPr>
+            <a:r>
+              <a:rPr sz="1700" b="1" i="0">
+                <a:solidFill>
+                  <a:srgbClr val="2E9E6B"/>
+                </a:solidFill>
+                <a:latin typeface="Noto Sans"/>
+              </a:rPr>
+              <a:t>The host</a:t>
+            </a:r>
+          </a:p>
+        </p:txBody>
+      </p:sp>
+      <p:sp>
+        <p:nvSpPr>
+          <p:cNvPr id="16" name="Text"/>
+          <p:cNvSpPr txBox="1"/>
+          <p:nvPr/>
+        </p:nvSpPr>
+        <p:spPr>
+          <a:xfrm>
+            <a:off x="8195667" y="2780030"/>
             <a:ext cx="3121965" cy="1051381"/>
           </a:xfrm>
           <a:prstGeom prst="rect">
@@ -9791,18 +10046,18 @@
       </p:sp>
       <p:sp>
         <p:nvSpPr>
-          <p:cNvPr id="16" name="Box"/>
+          <p:cNvPr id="17" name="Box"/>
           <p:cNvSpPr/>
           <p:nvPr/>
         </p:nvSpPr>
         <p:spPr>
           <a:xfrm>
-            <a:off x="762000" y="5461000"/>
-            <a:ext cx="10668000" cy="635000"/>
+            <a:off x="762000" y="4463752"/>
+            <a:ext cx="3437434" cy="1601291"/>
           </a:xfrm>
           <a:prstGeom prst="roundRect">
             <a:avLst>
-              <a:gd name="adj" fmla="val 16000"/>
+              <a:gd name="adj" fmla="val 6344"/>
             </a:avLst>
           </a:prstGeom>
           <a:solidFill>
@@ -9823,59 +10078,91 @@
       </p:sp>
       <p:sp>
         <p:nvSpPr>
-          <p:cNvPr id="17" name="Text"/>
+          <p:cNvPr id="18" name="Box"/>
+          <p:cNvSpPr/>
+          <p:nvPr/>
+        </p:nvSpPr>
+        <p:spPr>
+          <a:xfrm>
+            <a:off x="762000" y="4527252"/>
+            <a:ext cx="3437434" cy="1537791"/>
+          </a:xfrm>
+          <a:prstGeom prst="roundRect">
+            <a:avLst>
+              <a:gd name="adj" fmla="val 2477"/>
+            </a:avLst>
+          </a:prstGeom>
+          <a:solidFill>
+            <a:srgbClr val="FFFFFF"/>
+          </a:solidFill>
+          <a:ln>
+            <a:noFill/>
+          </a:ln>
+          <a:effectLst/>
+        </p:spPr>
+        <p:txBody>
+          <a:bodyPr rtlCol="0" anchor="ctr"/>
+          <a:lstStyle/>
+          <a:p>
+            <a:pPr algn="ctr"/>
+          </a:p>
+        </p:txBody>
+      </p:sp>
+      <p:sp>
+        <p:nvSpPr>
+          <p:cNvPr id="19" name="Text"/>
           <p:cNvSpPr txBox="1"/>
           <p:nvPr/>
         </p:nvSpPr>
         <p:spPr>
           <a:xfrm>
-            <a:off x="990600" y="5700662"/>
-            <a:ext cx="1042988" cy="155677"/>
-          </a:xfrm>
-          <a:prstGeom prst="rect">
-            <a:avLst/>
-          </a:prstGeom>
-          <a:noFill/>
-        </p:spPr>
-        <p:txBody>
-          <a:bodyPr wrap="none" lIns="0" rIns="0" tIns="0" bIns="0" anchor="t">
+            <a:off x="965200" y="4716774"/>
+            <a:ext cx="3121965" cy="294056"/>
+          </a:xfrm>
+          <a:prstGeom prst="rect">
+            <a:avLst/>
+          </a:prstGeom>
+          <a:noFill/>
+        </p:spPr>
+        <p:txBody>
+          <a:bodyPr wrap="square" lIns="0" rIns="0" tIns="0" bIns="0" anchor="t">
             <a:noAutofit/>
           </a:bodyPr>
           <a:lstStyle/>
           <a:p>
             <a:pPr algn="l">
               <a:lnSpc>
-                <a:spcPts val="1225"/>
-              </a:lnSpc>
-              <a:spcBef>
-                <a:spcPts val="0"/>
-              </a:spcBef>
-              <a:spcAft>
-                <a:spcPts val="0"/>
-              </a:spcAft>
-            </a:pPr>
-            <a:r>
-              <a:rPr sz="900" b="1" i="0" spc="126">
-                <a:solidFill>
-                  <a:srgbClr val="B3A9FF"/>
-                </a:solidFill>
-                <a:latin typeface="Noto Sans"/>
-              </a:rPr>
-              <a:t>WHY IT WORKS</a:t>
-            </a:r>
-          </a:p>
-        </p:txBody>
-      </p:sp>
-      <p:sp>
-        <p:nvSpPr>
-          <p:cNvPr id="18" name="Text"/>
+                <a:spcPts val="2315"/>
+              </a:lnSpc>
+              <a:spcBef>
+                <a:spcPts val="0"/>
+              </a:spcBef>
+              <a:spcAft>
+                <a:spcPts val="0"/>
+              </a:spcAft>
+            </a:pPr>
+            <a:r>
+              <a:rPr sz="1700" b="1" i="0">
+                <a:solidFill>
+                  <a:srgbClr val="1D2433"/>
+                </a:solidFill>
+                <a:latin typeface="Noto Sans"/>
+              </a:rPr>
+              <a:t>The mender</a:t>
+            </a:r>
+          </a:p>
+        </p:txBody>
+      </p:sp>
+      <p:sp>
+        <p:nvSpPr>
+          <p:cNvPr id="20" name="Text"/>
           <p:cNvSpPr txBox="1"/>
           <p:nvPr/>
         </p:nvSpPr>
         <p:spPr>
           <a:xfrm>
-            <a:off x="2211388" y="5648770"/>
-            <a:ext cx="6854444" cy="259461"/>
+            <a:off x="965200" y="5084782"/>
+            <a:ext cx="3121965" cy="788551"/>
           </a:xfrm>
           <a:prstGeom prst="rect">
             <a:avLst/>
@@ -9890,7 +10177,7 @@
           <a:p>
             <a:pPr algn="l">
               <a:lnSpc>
-                <a:spcPts val="2043"/>
+                <a:spcPts val="2070"/>
               </a:lnSpc>
               <a:spcBef>
                 <a:spcPts val="0"/>
@@ -9902,18 +10189,326 @@
             <a:r>
               <a:rPr sz="1500" b="0" i="0">
                 <a:solidFill>
-                  <a:srgbClr val="FFFFFF"/>
-                </a:solidFill>
-                <a:latin typeface="Noto Sans"/>
-              </a:rPr>
-              <a:t>Each job is small and has one test, so a new volunteer can start in an hour.</a:t>
-            </a:r>
-          </a:p>
-        </p:txBody>
-      </p:sp>
-      <p:sp>
-        <p:nvSpPr>
-          <p:cNvPr id="19" name="Box"/>
+                  <a:srgbClr val="4A5163"/>
+                </a:solidFill>
+                <a:latin typeface="Noto Sans"/>
+              </a:rPr>
+              <a:t>Sharpens, oils and fixes at the repair bench, and signs the ledger line when a tool is fit.</a:t>
+            </a:r>
+          </a:p>
+        </p:txBody>
+      </p:sp>
+      <p:sp>
+        <p:nvSpPr>
+          <p:cNvPr id="21" name="Box"/>
+          <p:cNvSpPr/>
+          <p:nvPr/>
+        </p:nvSpPr>
+        <p:spPr>
+          <a:xfrm>
+            <a:off x="4377234" y="4463752"/>
+            <a:ext cx="3437434" cy="1601291"/>
+          </a:xfrm>
+          <a:prstGeom prst="roundRect">
+            <a:avLst>
+              <a:gd name="adj" fmla="val 6344"/>
+            </a:avLst>
+          </a:prstGeom>
+          <a:solidFill>
+            <a:srgbClr val="E3A33B"/>
+          </a:solidFill>
+          <a:ln>
+            <a:noFill/>
+          </a:ln>
+          <a:effectLst/>
+        </p:spPr>
+        <p:txBody>
+          <a:bodyPr rtlCol="0" anchor="ctr"/>
+          <a:lstStyle/>
+          <a:p>
+            <a:pPr algn="ctr"/>
+          </a:p>
+        </p:txBody>
+      </p:sp>
+      <p:sp>
+        <p:nvSpPr>
+          <p:cNvPr id="22" name="Box"/>
+          <p:cNvSpPr/>
+          <p:nvPr/>
+        </p:nvSpPr>
+        <p:spPr>
+          <a:xfrm>
+            <a:off x="4377234" y="4527252"/>
+            <a:ext cx="3437434" cy="1537791"/>
+          </a:xfrm>
+          <a:prstGeom prst="roundRect">
+            <a:avLst>
+              <a:gd name="adj" fmla="val 2477"/>
+            </a:avLst>
+          </a:prstGeom>
+          <a:solidFill>
+            <a:srgbClr val="FFFFFF"/>
+          </a:solidFill>
+          <a:ln>
+            <a:noFill/>
+          </a:ln>
+          <a:effectLst/>
+        </p:spPr>
+        <p:txBody>
+          <a:bodyPr rtlCol="0" anchor="ctr"/>
+          <a:lstStyle/>
+          <a:p>
+            <a:pPr algn="ctr"/>
+          </a:p>
+        </p:txBody>
+      </p:sp>
+      <p:sp>
+        <p:nvSpPr>
+          <p:cNvPr id="23" name="Text"/>
+          <p:cNvSpPr txBox="1"/>
+          <p:nvPr/>
+        </p:nvSpPr>
+        <p:spPr>
+          <a:xfrm>
+            <a:off x="4580434" y="4716774"/>
+            <a:ext cx="3121965" cy="294056"/>
+          </a:xfrm>
+          <a:prstGeom prst="rect">
+            <a:avLst/>
+          </a:prstGeom>
+          <a:noFill/>
+        </p:spPr>
+        <p:txBody>
+          <a:bodyPr wrap="square" lIns="0" rIns="0" tIns="0" bIns="0" anchor="t">
+            <a:noAutofit/>
+          </a:bodyPr>
+          <a:lstStyle/>
+          <a:p>
+            <a:pPr algn="l">
+              <a:lnSpc>
+                <a:spcPts val="2315"/>
+              </a:lnSpc>
+              <a:spcBef>
+                <a:spcPts val="0"/>
+              </a:spcBef>
+              <a:spcAft>
+                <a:spcPts val="0"/>
+              </a:spcAft>
+            </a:pPr>
+            <a:r>
+              <a:rPr sz="1700" b="1" i="0">
+                <a:solidFill>
+                  <a:srgbClr val="E3A33B"/>
+                </a:solidFill>
+                <a:latin typeface="Noto Sans"/>
+              </a:rPr>
+              <a:t>The stocker</a:t>
+            </a:r>
+          </a:p>
+        </p:txBody>
+      </p:sp>
+      <p:sp>
+        <p:nvSpPr>
+          <p:cNvPr id="24" name="Text"/>
+          <p:cNvSpPr txBox="1"/>
+          <p:nvPr/>
+        </p:nvSpPr>
+        <p:spPr>
+          <a:xfrm>
+            <a:off x="4580434" y="5084782"/>
+            <a:ext cx="3121965" cy="788551"/>
+          </a:xfrm>
+          <a:prstGeom prst="rect">
+            <a:avLst/>
+          </a:prstGeom>
+          <a:noFill/>
+        </p:spPr>
+        <p:txBody>
+          <a:bodyPr wrap="square" lIns="0" rIns="0" tIns="0" bIns="0" anchor="t">
+            <a:noAutofit/>
+          </a:bodyPr>
+          <a:lstStyle/>
+          <a:p>
+            <a:pPr algn="l">
+              <a:lnSpc>
+                <a:spcPts val="2070"/>
+              </a:lnSpc>
+              <a:spcBef>
+                <a:spcPts val="0"/>
+              </a:spcBef>
+              <a:spcAft>
+                <a:spcPts val="0"/>
+              </a:spcAft>
+            </a:pPr>
+            <a:r>
+              <a:rPr sz="1500" b="0" i="0">
+                <a:solidFill>
+                  <a:srgbClr val="4A5163"/>
+                </a:solidFill>
+                <a:latin typeface="Noto Sans"/>
+              </a:rPr>
+              <a:t>Watches the gaps on the hooks and asks neighbours for the tools the shed is missing.</a:t>
+            </a:r>
+          </a:p>
+        </p:txBody>
+      </p:sp>
+      <p:sp>
+        <p:nvSpPr>
+          <p:cNvPr id="25" name="Box"/>
+          <p:cNvSpPr/>
+          <p:nvPr/>
+        </p:nvSpPr>
+        <p:spPr>
+          <a:xfrm>
+            <a:off x="7992467" y="4463752"/>
+            <a:ext cx="3437434" cy="1601291"/>
+          </a:xfrm>
+          <a:prstGeom prst="roundRect">
+            <a:avLst>
+              <a:gd name="adj" fmla="val 6344"/>
+            </a:avLst>
+          </a:prstGeom>
+          <a:solidFill>
+            <a:srgbClr val="B9BEC8"/>
+          </a:solidFill>
+          <a:ln>
+            <a:noFill/>
+          </a:ln>
+          <a:effectLst/>
+        </p:spPr>
+        <p:txBody>
+          <a:bodyPr rtlCol="0" anchor="ctr"/>
+          <a:lstStyle/>
+          <a:p>
+            <a:pPr algn="ctr"/>
+          </a:p>
+        </p:txBody>
+      </p:sp>
+      <p:sp>
+        <p:nvSpPr>
+          <p:cNvPr id="26" name="Box"/>
+          <p:cNvSpPr/>
+          <p:nvPr/>
+        </p:nvSpPr>
+        <p:spPr>
+          <a:xfrm>
+            <a:off x="7992467" y="4527252"/>
+            <a:ext cx="3437434" cy="1537791"/>
+          </a:xfrm>
+          <a:prstGeom prst="roundRect">
+            <a:avLst>
+              <a:gd name="adj" fmla="val 2477"/>
+            </a:avLst>
+          </a:prstGeom>
+          <a:solidFill>
+            <a:srgbClr val="FFFFFF"/>
+          </a:solidFill>
+          <a:ln>
+            <a:noFill/>
+          </a:ln>
+          <a:effectLst/>
+        </p:spPr>
+        <p:txBody>
+          <a:bodyPr rtlCol="0" anchor="ctr"/>
+          <a:lstStyle/>
+          <a:p>
+            <a:pPr algn="ctr"/>
+          </a:p>
+        </p:txBody>
+      </p:sp>
+      <p:sp>
+        <p:nvSpPr>
+          <p:cNvPr id="27" name="Text"/>
+          <p:cNvSpPr txBox="1"/>
+          <p:nvPr/>
+        </p:nvSpPr>
+        <p:spPr>
+          <a:xfrm>
+            <a:off x="8195667" y="4716774"/>
+            <a:ext cx="3121965" cy="294056"/>
+          </a:xfrm>
+          <a:prstGeom prst="rect">
+            <a:avLst/>
+          </a:prstGeom>
+          <a:noFill/>
+        </p:spPr>
+        <p:txBody>
+          <a:bodyPr wrap="square" lIns="0" rIns="0" tIns="0" bIns="0" anchor="t">
+            <a:noAutofit/>
+          </a:bodyPr>
+          <a:lstStyle/>
+          <a:p>
+            <a:pPr algn="l">
+              <a:lnSpc>
+                <a:spcPts val="2315"/>
+              </a:lnSpc>
+              <a:spcBef>
+                <a:spcPts val="0"/>
+              </a:spcBef>
+              <a:spcAft>
+                <a:spcPts val="0"/>
+              </a:spcAft>
+            </a:pPr>
+            <a:r>
+              <a:rPr sz="1700" b="1" i="0">
+                <a:solidFill>
+                  <a:srgbClr val="B9BEC8"/>
+                </a:solidFill>
+                <a:latin typeface="Noto Sans"/>
+              </a:rPr>
+              <a:t>The spare hands</a:t>
+            </a:r>
+          </a:p>
+        </p:txBody>
+      </p:sp>
+      <p:sp>
+        <p:nvSpPr>
+          <p:cNvPr id="28" name="Text"/>
+          <p:cNvSpPr txBox="1"/>
+          <p:nvPr/>
+        </p:nvSpPr>
+        <p:spPr>
+          <a:xfrm>
+            <a:off x="8195667" y="5084782"/>
+            <a:ext cx="3121965" cy="788551"/>
+          </a:xfrm>
+          <a:prstGeom prst="rect">
+            <a:avLst/>
+          </a:prstGeom>
+          <a:noFill/>
+        </p:spPr>
+        <p:txBody>
+          <a:bodyPr wrap="square" lIns="0" rIns="0" tIns="0" bIns="0" anchor="t">
+            <a:noAutofit/>
+          </a:bodyPr>
+          <a:lstStyle/>
+          <a:p>
+            <a:pPr algn="l">
+              <a:lnSpc>
+                <a:spcPts val="2070"/>
+              </a:lnSpc>
+              <a:spcBef>
+                <a:spcPts val="0"/>
+              </a:spcBef>
+              <a:spcAft>
+                <a:spcPts val="0"/>
+              </a:spcAft>
+            </a:pPr>
+            <a:r>
+              <a:rPr sz="1500" b="0" i="0">
+                <a:solidFill>
+                  <a:srgbClr val="4A5163"/>
+                </a:solidFill>
+                <a:latin typeface="Noto Sans"/>
+              </a:rPr>
+              <a:t>Not a job yet: anyone who helps on a Saturday and may take a job later.</a:t>
+            </a:r>
+          </a:p>
+        </p:txBody>
+      </p:sp>
+      <p:sp>
+        <p:nvSpPr>
+          <p:cNvPr id="29" name="Box"/>
           <p:cNvSpPr/>
           <p:nvPr/>
         </p:nvSpPr>
@@ -9943,7 +10538,7 @@
       </p:sp>
       <p:sp>
         <p:nvSpPr>
-          <p:cNvPr id="20" name="Text"/>
+          <p:cNvPr id="30" name="Text"/>
           <p:cNvSpPr txBox="1"/>
           <p:nvPr/>
         </p:nvSpPr>
@@ -9997,7 +10592,7 @@
       </p:sp>
       <p:sp>
         <p:nvSpPr>
-          <p:cNvPr id="21" name="Text"/>
+          <p:cNvPr id="31" name="Text"/>
           <p:cNvSpPr txBox="1"/>
           <p:nvPr/>
         </p:nvSpPr>
@@ -10210,11 +10805,11 @@
         <p:spPr>
           <a:xfrm>
             <a:off x="762000" y="2095500"/>
-            <a:ext cx="3437434" cy="3175000"/>
+            <a:ext cx="3437434" cy="1627981"/>
           </a:xfrm>
           <a:prstGeom prst="roundRect">
             <a:avLst>
-              <a:gd name="adj" fmla="val 3200"/>
+              <a:gd name="adj" fmla="val 6240"/>
             </a:avLst>
           </a:prstGeom>
           <a:solidFill>
@@ -10334,11 +10929,11 @@
         <p:spPr>
           <a:xfrm>
             <a:off x="4377234" y="2095500"/>
-            <a:ext cx="3437434" cy="3175000"/>
+            <a:ext cx="3437434" cy="1627981"/>
           </a:xfrm>
           <a:prstGeom prst="roundRect">
             <a:avLst>
-              <a:gd name="adj" fmla="val 3200"/>
+              <a:gd name="adj" fmla="val 6240"/>
             </a:avLst>
           </a:prstGeom>
           <a:solidFill>
@@ -10458,11 +11053,11 @@
         <p:spPr>
           <a:xfrm>
             <a:off x="7992467" y="2095500"/>
-            <a:ext cx="3437434" cy="3175000"/>
+            <a:ext cx="3437434" cy="1627981"/>
           </a:xfrm>
           <a:prstGeom prst="roundRect">
             <a:avLst>
-              <a:gd name="adj" fmla="val 3200"/>
+              <a:gd name="adj" fmla="val 6240"/>
             </a:avLst>
           </a:prstGeom>
           <a:solidFill>
@@ -14203,18 +14798,63 @@
       </p:sp>
       <p:sp>
         <p:nvSpPr>
-          <p:cNvPr id="4" name="Box"/>
+          <p:cNvPr id="4" name="Text"/>
+          <p:cNvSpPr txBox="1"/>
+          <p:nvPr/>
+        </p:nvSpPr>
+        <p:spPr>
+          <a:xfrm>
+            <a:off x="762000" y="1389757"/>
+            <a:ext cx="9810750" cy="269875"/>
+          </a:xfrm>
+          <a:prstGeom prst="rect">
+            <a:avLst/>
+          </a:prstGeom>
+          <a:noFill/>
+        </p:spPr>
+        <p:txBody>
+          <a:bodyPr wrap="square" lIns="0" rIns="0" tIns="0" bIns="0" anchor="t">
+            <a:noAutofit/>
+          </a:bodyPr>
+          <a:lstStyle/>
+          <a:p>
+            <a:pPr algn="l">
+              <a:lnSpc>
+                <a:spcPts val="2125"/>
+              </a:lnSpc>
+              <a:spcBef>
+                <a:spcPts val="0"/>
+              </a:spcBef>
+              <a:spcAft>
+                <a:spcPts val="0"/>
+              </a:spcAft>
+            </a:pPr>
+            <a:r>
+              <a:rPr sz="1700" b="0" i="0">
+                <a:solidFill>
+                  <a:srgbClr val="4A5163"/>
+                </a:solidFill>
+                <a:latin typeface="Noto Sans"/>
+              </a:rPr>
+              <a:t>Two lists, four short lines each.</a:t>
+            </a:r>
+          </a:p>
+        </p:txBody>
+      </p:sp>
+      <p:sp>
+        <p:nvSpPr>
+          <p:cNvPr id="5" name="Box"/>
           <p:cNvSpPr/>
           <p:nvPr/>
         </p:nvSpPr>
         <p:spPr>
           <a:xfrm>
-            <a:off x="762000" y="1905000"/>
-            <a:ext cx="5245100" cy="4191000"/>
+            <a:off x="762000" y="2159000"/>
+            <a:ext cx="5245100" cy="2384822"/>
           </a:xfrm>
           <a:prstGeom prst="roundRect">
             <a:avLst>
-              <a:gd name="adj" fmla="val 2424"/>
+              <a:gd name="adj" fmla="val 4260"/>
             </a:avLst>
           </a:prstGeom>
           <a:solidFill>
@@ -14235,18 +14875,18 @@
       </p:sp>
       <p:sp>
         <p:nvSpPr>
-          <p:cNvPr id="5" name="Box"/>
+          <p:cNvPr id="6" name="Box"/>
           <p:cNvSpPr/>
           <p:nvPr/>
         </p:nvSpPr>
         <p:spPr>
           <a:xfrm>
-            <a:off x="762000" y="1968500"/>
-            <a:ext cx="5245100" cy="4127500"/>
+            <a:off x="762000" y="2222500"/>
+            <a:ext cx="5245100" cy="2321322"/>
           </a:xfrm>
           <a:prstGeom prst="roundRect">
             <a:avLst>
-              <a:gd name="adj" fmla="val 923"/>
+              <a:gd name="adj" fmla="val 1641"/>
             </a:avLst>
           </a:prstGeom>
           <a:solidFill>
@@ -14267,13 +14907,13 @@
       </p:sp>
       <p:sp>
         <p:nvSpPr>
-          <p:cNvPr id="6" name="Text"/>
+          <p:cNvPr id="7" name="Text"/>
           <p:cNvSpPr txBox="1"/>
           <p:nvPr/>
         </p:nvSpPr>
         <p:spPr>
           <a:xfrm>
-            <a:off x="965200" y="2158022"/>
+            <a:off x="965200" y="2412022"/>
             <a:ext cx="4983861" cy="294056"/>
           </a:xfrm>
           <a:prstGeom prst="rect">
@@ -14312,13 +14952,13 @@
       </p:sp>
       <p:sp>
         <p:nvSpPr>
-          <p:cNvPr id="7" name="Box"/>
+          <p:cNvPr id="8" name="Box"/>
           <p:cNvSpPr/>
           <p:nvPr/>
         </p:nvSpPr>
         <p:spPr>
           <a:xfrm>
-            <a:off x="990600" y="2616200"/>
+            <a:off x="990600" y="2870200"/>
             <a:ext cx="101600" cy="101600"/>
           </a:xfrm>
           <a:prstGeom prst="roundRect">
@@ -14344,13 +14984,13 @@
       </p:sp>
       <p:sp>
         <p:nvSpPr>
-          <p:cNvPr id="8" name="Text"/>
+          <p:cNvPr id="9" name="Text"/>
           <p:cNvSpPr txBox="1"/>
           <p:nvPr/>
         </p:nvSpPr>
         <p:spPr>
           <a:xfrm>
-            <a:off x="1257300" y="2521268"/>
+            <a:off x="1257300" y="2775268"/>
             <a:ext cx="4682998" cy="291465"/>
           </a:xfrm>
           <a:prstGeom prst="rect">
@@ -14389,13 +15029,13 @@
       </p:sp>
       <p:sp>
         <p:nvSpPr>
-          <p:cNvPr id="9" name="Box"/>
+          <p:cNvPr id="10" name="Box"/>
           <p:cNvSpPr/>
           <p:nvPr/>
         </p:nvSpPr>
         <p:spPr>
           <a:xfrm>
-            <a:off x="990600" y="3009205"/>
+            <a:off x="990600" y="3263205"/>
             <a:ext cx="101600" cy="101600"/>
           </a:xfrm>
           <a:prstGeom prst="roundRect">
@@ -14421,13 +15061,13 @@
       </p:sp>
       <p:sp>
         <p:nvSpPr>
-          <p:cNvPr id="10" name="Text"/>
+          <p:cNvPr id="11" name="Text"/>
           <p:cNvSpPr txBox="1"/>
           <p:nvPr/>
         </p:nvSpPr>
         <p:spPr>
           <a:xfrm>
-            <a:off x="1257300" y="2914273"/>
+            <a:off x="1257300" y="3168273"/>
             <a:ext cx="4682998" cy="291465"/>
           </a:xfrm>
           <a:prstGeom prst="rect">
@@ -14466,13 +15106,13 @@
       </p:sp>
       <p:sp>
         <p:nvSpPr>
-          <p:cNvPr id="11" name="Box"/>
+          <p:cNvPr id="12" name="Box"/>
           <p:cNvSpPr/>
           <p:nvPr/>
         </p:nvSpPr>
         <p:spPr>
           <a:xfrm>
-            <a:off x="990600" y="3402211"/>
+            <a:off x="990600" y="3656211"/>
             <a:ext cx="101600" cy="101600"/>
           </a:xfrm>
           <a:prstGeom prst="roundRect">
@@ -14498,13 +15138,13 @@
       </p:sp>
       <p:sp>
         <p:nvSpPr>
-          <p:cNvPr id="12" name="Text"/>
+          <p:cNvPr id="13" name="Text"/>
           <p:cNvSpPr txBox="1"/>
           <p:nvPr/>
         </p:nvSpPr>
         <p:spPr>
           <a:xfrm>
-            <a:off x="1257300" y="3307278"/>
+            <a:off x="1257300" y="3561278"/>
             <a:ext cx="4682998" cy="291465"/>
           </a:xfrm>
           <a:prstGeom prst="rect">
@@ -14543,13 +15183,13 @@
       </p:sp>
       <p:sp>
         <p:nvSpPr>
-          <p:cNvPr id="13" name="Box"/>
+          <p:cNvPr id="14" name="Box"/>
           <p:cNvSpPr/>
           <p:nvPr/>
         </p:nvSpPr>
         <p:spPr>
           <a:xfrm>
-            <a:off x="990600" y="3795216"/>
+            <a:off x="990600" y="4049216"/>
             <a:ext cx="101600" cy="101600"/>
           </a:xfrm>
           <a:prstGeom prst="roundRect">
@@ -14575,13 +15215,13 @@
       </p:sp>
       <p:sp>
         <p:nvSpPr>
-          <p:cNvPr id="14" name="Text"/>
+          <p:cNvPr id="15" name="Text"/>
           <p:cNvSpPr txBox="1"/>
           <p:nvPr/>
         </p:nvSpPr>
         <p:spPr>
           <a:xfrm>
-            <a:off x="1257300" y="3700284"/>
+            <a:off x="1257300" y="3954284"/>
             <a:ext cx="4682998" cy="291465"/>
           </a:xfrm>
           <a:prstGeom prst="rect">
@@ -14620,18 +15260,18 @@
       </p:sp>
       <p:sp>
         <p:nvSpPr>
-          <p:cNvPr id="15" name="Box"/>
+          <p:cNvPr id="16" name="Box"/>
           <p:cNvSpPr/>
           <p:nvPr/>
         </p:nvSpPr>
         <p:spPr>
           <a:xfrm>
-            <a:off x="6184900" y="1905000"/>
-            <a:ext cx="5245100" cy="4191000"/>
+            <a:off x="6184900" y="2159000"/>
+            <a:ext cx="5245100" cy="2384822"/>
           </a:xfrm>
           <a:prstGeom prst="roundRect">
             <a:avLst>
-              <a:gd name="adj" fmla="val 2424"/>
+              <a:gd name="adj" fmla="val 4260"/>
             </a:avLst>
           </a:prstGeom>
           <a:solidFill>
@@ -14652,18 +15292,18 @@
       </p:sp>
       <p:sp>
         <p:nvSpPr>
-          <p:cNvPr id="16" name="Box"/>
+          <p:cNvPr id="17" name="Box"/>
           <p:cNvSpPr/>
           <p:nvPr/>
         </p:nvSpPr>
         <p:spPr>
           <a:xfrm>
-            <a:off x="6184900" y="1968500"/>
-            <a:ext cx="5245100" cy="4127500"/>
+            <a:off x="6184900" y="2222500"/>
+            <a:ext cx="5245100" cy="2321322"/>
           </a:xfrm>
           <a:prstGeom prst="roundRect">
             <a:avLst>
-              <a:gd name="adj" fmla="val 923"/>
+              <a:gd name="adj" fmla="val 1641"/>
             </a:avLst>
           </a:prstGeom>
           <a:solidFill>
@@ -14684,13 +15324,13 @@
       </p:sp>
       <p:sp>
         <p:nvSpPr>
-          <p:cNvPr id="17" name="Text"/>
+          <p:cNvPr id="18" name="Text"/>
           <p:cNvSpPr txBox="1"/>
           <p:nvPr/>
         </p:nvSpPr>
         <p:spPr>
           <a:xfrm>
-            <a:off x="6388100" y="2158022"/>
+            <a:off x="6388100" y="2412022"/>
             <a:ext cx="4983861" cy="294056"/>
           </a:xfrm>
           <a:prstGeom prst="rect">
@@ -14729,13 +15369,13 @@
       </p:sp>
       <p:sp>
         <p:nvSpPr>
-          <p:cNvPr id="18" name="Box"/>
+          <p:cNvPr id="19" name="Box"/>
           <p:cNvSpPr/>
           <p:nvPr/>
         </p:nvSpPr>
         <p:spPr>
           <a:xfrm>
-            <a:off x="6413500" y="2616200"/>
+            <a:off x="6413500" y="2870200"/>
             <a:ext cx="101600" cy="101600"/>
           </a:xfrm>
           <a:prstGeom prst="roundRect">
@@ -14761,13 +15401,13 @@
       </p:sp>
       <p:sp>
         <p:nvSpPr>
-          <p:cNvPr id="19" name="Text"/>
+          <p:cNvPr id="20" name="Text"/>
           <p:cNvSpPr txBox="1"/>
           <p:nvPr/>
         </p:nvSpPr>
         <p:spPr>
           <a:xfrm>
-            <a:off x="6680200" y="2521268"/>
+            <a:off x="6680200" y="2775268"/>
             <a:ext cx="4682998" cy="291465"/>
           </a:xfrm>
           <a:prstGeom prst="rect">
@@ -14806,13 +15446,13 @@
       </p:sp>
       <p:sp>
         <p:nvSpPr>
-          <p:cNvPr id="20" name="Box"/>
+          <p:cNvPr id="21" name="Box"/>
           <p:cNvSpPr/>
           <p:nvPr/>
         </p:nvSpPr>
         <p:spPr>
           <a:xfrm>
-            <a:off x="6413500" y="3009205"/>
+            <a:off x="6413500" y="3263205"/>
             <a:ext cx="101600" cy="101600"/>
           </a:xfrm>
           <a:prstGeom prst="roundRect">
@@ -14838,13 +15478,13 @@
       </p:sp>
       <p:sp>
         <p:nvSpPr>
-          <p:cNvPr id="21" name="Text"/>
+          <p:cNvPr id="22" name="Text"/>
           <p:cNvSpPr txBox="1"/>
           <p:nvPr/>
         </p:nvSpPr>
         <p:spPr>
           <a:xfrm>
-            <a:off x="6680200" y="2914273"/>
+            <a:off x="6680200" y="3168273"/>
             <a:ext cx="4682998" cy="291465"/>
           </a:xfrm>
           <a:prstGeom prst="rect">
@@ -14883,13 +15523,13 @@
       </p:sp>
       <p:sp>
         <p:nvSpPr>
-          <p:cNvPr id="22" name="Box"/>
+          <p:cNvPr id="23" name="Box"/>
           <p:cNvSpPr/>
           <p:nvPr/>
         </p:nvSpPr>
         <p:spPr>
           <a:xfrm>
-            <a:off x="6413500" y="3402211"/>
+            <a:off x="6413500" y="3656211"/>
             <a:ext cx="101600" cy="101600"/>
           </a:xfrm>
           <a:prstGeom prst="roundRect">
@@ -14915,13 +15555,13 @@
       </p:sp>
       <p:sp>
         <p:nvSpPr>
-          <p:cNvPr id="23" name="Text"/>
+          <p:cNvPr id="24" name="Text"/>
           <p:cNvSpPr txBox="1"/>
           <p:nvPr/>
         </p:nvSpPr>
         <p:spPr>
           <a:xfrm>
-            <a:off x="6680200" y="3307278"/>
+            <a:off x="6680200" y="3561278"/>
             <a:ext cx="4682998" cy="291465"/>
           </a:xfrm>
           <a:prstGeom prst="rect">
@@ -14960,13 +15600,13 @@
       </p:sp>
       <p:sp>
         <p:nvSpPr>
-          <p:cNvPr id="24" name="Box"/>
+          <p:cNvPr id="25" name="Box"/>
           <p:cNvSpPr/>
           <p:nvPr/>
         </p:nvSpPr>
         <p:spPr>
           <a:xfrm>
-            <a:off x="6413500" y="3795216"/>
+            <a:off x="6413500" y="4049216"/>
             <a:ext cx="101600" cy="101600"/>
           </a:xfrm>
           <a:prstGeom prst="roundRect">
@@ -14992,13 +15632,13 @@
       </p:sp>
       <p:sp>
         <p:nvSpPr>
-          <p:cNvPr id="25" name="Text"/>
+          <p:cNvPr id="26" name="Text"/>
           <p:cNvSpPr txBox="1"/>
           <p:nvPr/>
         </p:nvSpPr>
         <p:spPr>
           <a:xfrm>
-            <a:off x="6680200" y="3700284"/>
+            <a:off x="6680200" y="3954284"/>
             <a:ext cx="4682998" cy="291465"/>
           </a:xfrm>
           <a:prstGeom prst="rect">
@@ -15037,7 +15677,7 @@
       </p:sp>
       <p:sp>
         <p:nvSpPr>
-          <p:cNvPr id="26" name="Box"/>
+          <p:cNvPr id="27" name="Box"/>
           <p:cNvSpPr/>
           <p:nvPr/>
         </p:nvSpPr>
@@ -15067,7 +15707,7 @@
       </p:sp>
       <p:sp>
         <p:nvSpPr>
-          <p:cNvPr id="27" name="Text"/>
+          <p:cNvPr id="28" name="Text"/>
           <p:cNvSpPr txBox="1"/>
           <p:nvPr/>
         </p:nvSpPr>
@@ -15121,7 +15761,7 @@
       </p:sp>
       <p:sp>
         <p:nvSpPr>
-          <p:cNvPr id="28" name="Text"/>
+          <p:cNvPr id="29" name="Text"/>
           <p:cNvSpPr txBox="1"/>
           <p:nvPr/>
         </p:nvSpPr>

</xml_diff>

<commit_message>
Sample deck: callout, heat-map, outline panels; v0.17.0 (#46)
</commit_message>
<xml_diff>
--- a/docs/samples/house-style-explainer-v1.pptx
+++ b/docs/samples/house-style-explainer-v1.pptx
@@ -17,6 +17,7 @@
     <p:sldId id="265" r:id="rId17"/>
     <p:sldId id="266" r:id="rId18"/>
     <p:sldId id="267" r:id="rId19"/>
+    <p:sldId id="268" r:id="rId20"/>
   </p:sldIdLst>
   <p:sldSz cx="12192000" cy="6858000" type="screen4x3"/>
   <p:notesSz cx="6858000" cy="9144000"/>
@@ -589,7 +590,7 @@
           <a:lstStyle/>
           <a:p>
             <a:r>
-              <a:t>A section slide marks a change of subject. Say what comes next in one sentence.</a:t>
+              <a:t>Two columns, one for what works and one for what does not. Keep each list to four short lines.</a:t>
             </a:r>
           </a:p>
           <a:p/>
@@ -665,13 +666,13 @@
           <a:lstStyle/>
           <a:p>
             <a:r>
-              <a:t>A quote slide: read it slowly, then say why it matters. This quote is invented.</a:t>
+              <a:t>A section slide marks a change of subject. Say what comes next in one sentence.</a:t>
             </a:r>
           </a:p>
           <a:p/>
           <a:p>
             <a:r>
-              <a:t>Source: Invented example; no real person</a:t>
+              <a:t>Source: Invented example</a:t>
             </a:r>
           </a:p>
         </p:txBody>
@@ -741,6 +742,82 @@
           <a:lstStyle/>
           <a:p>
             <a:r>
+              <a:t>A quote slide: read it slowly, then say why it matters. This quote is invented.</a:t>
+            </a:r>
+          </a:p>
+          <a:p/>
+          <a:p>
+            <a:r>
+              <a:t>Source: Invented example; no real person</a:t>
+            </a:r>
+          </a:p>
+        </p:txBody>
+      </p:sp>
+      <p:sp>
+        <p:nvSpPr>
+          <p:cNvPr id="4" name="Slide Number Placeholder 3"/>
+          <p:cNvSpPr>
+            <a:spLocks noGrp="1"/>
+          </p:cNvSpPr>
+          <p:nvPr>
+            <p:ph type="sldNum" idx="5" sz="quarter"/>
+          </p:nvPr>
+        </p:nvSpPr>
+        <p:spPr/>
+      </p:sp>
+    </p:spTree>
+  </p:cSld>
+  <p:clrMapOvr>
+    <a:masterClrMapping/>
+  </p:clrMapOvr>
+</p:notes>
+</file>
+
+<file path=ppt/notesSlides/notesSlide13.xml><?xml version="1.0" encoding="utf-8"?>
+<p:notes xmlns:a="http://schemas.openxmlformats.org/drawingml/2006/main" xmlns:p="http://schemas.openxmlformats.org/presentationml/2006/main" xmlns:r="http://schemas.openxmlformats.org/officeDocument/2006/relationships">
+  <p:cSld>
+    <p:spTree>
+      <p:nvGrpSpPr>
+        <p:cNvPr id="1" name=""/>
+        <p:cNvGrpSpPr/>
+        <p:nvPr/>
+      </p:nvGrpSpPr>
+      <p:grpSpPr>
+        <a:xfrm>
+          <a:off x="0" y="0"/>
+          <a:ext cx="0" cy="0"/>
+          <a:chOff x="0" y="0"/>
+          <a:chExt cx="0" cy="0"/>
+        </a:xfrm>
+      </p:grpSpPr>
+      <p:sp>
+        <p:nvSpPr>
+          <p:cNvPr id="2" name="Slide Image Placeholder 1"/>
+          <p:cNvSpPr>
+            <a:spLocks noGrp="1"/>
+          </p:cNvSpPr>
+          <p:nvPr>
+            <p:ph type="sldImg" idx="2"/>
+          </p:nvPr>
+        </p:nvSpPr>
+        <p:spPr/>
+      </p:sp>
+      <p:sp>
+        <p:nvSpPr>
+          <p:cNvPr id="3" name="Notes Placeholder 2"/>
+          <p:cNvSpPr>
+            <a:spLocks noGrp="1"/>
+          </p:cNvSpPr>
+          <p:nvPr>
+            <p:ph type="body" idx="3" sz="quarter"/>
+          </p:nvPr>
+        </p:nvSpPr>
+        <p:spPr/>
+        <p:txBody>
+          <a:bodyPr/>
+          <a:lstStyle/>
+          <a:p>
+            <a:r>
               <a:t>Close on the three figures. They are invented: forty tools, three hundred and twelve loans, and one hour to learn a job.</a:t>
             </a:r>
           </a:p>
@@ -1273,13 +1350,13 @@
           <a:lstStyle/>
           <a:p>
             <a:r>
-              <a:t>The contrast has two cards, then three small examples of the change in practice. Say the before in one breath, the now in one breath, and let the examples carry the detail.</a:t>
+              <a:t>A heat-map shades each cell by its value and outlines the best one in its row. The figures are invented; read across a row to see the habit settle in.</a:t>
             </a:r>
           </a:p>
           <a:p/>
           <a:p>
             <a:r>
-              <a:t>Source: Invented example</a:t>
+              <a:t>Source: Invented example; the figures are made up</a:t>
             </a:r>
           </a:p>
         </p:txBody>
@@ -1349,7 +1426,7 @@
           <a:lstStyle/>
           <a:p>
             <a:r>
-              <a:t>Two columns, one for what works and one for what does not. Keep each list to four short lines.</a:t>
+              <a:t>The contrast has two cards, then three small examples of the change in practice. Say the before in one breath, the now in one breath, and let the examples carry the detail.</a:t>
             </a:r>
           </a:p>
           <a:p/>
@@ -4673,7 +4750,7 @@
                 </a:solidFill>
                 <a:latin typeface="Noto Sans"/>
               </a:rPr>
-              <a:t>1 / 12</a:t>
+              <a:t>1 / 13</a:t>
             </a:r>
           </a:p>
         </p:txBody>
@@ -4687,6 +4764,1070 @@
 </file>
 
 <file path=ppt/slides/slide10.xml><?xml version="1.0" encoding="utf-8"?>
+<p:sld xmlns:a="http://schemas.openxmlformats.org/drawingml/2006/main" xmlns:p="http://schemas.openxmlformats.org/presentationml/2006/main" xmlns:r="http://schemas.openxmlformats.org/officeDocument/2006/relationships">
+  <p:cSld>
+    <p:bg>
+      <p:bgPr>
+        <a:solidFill>
+          <a:srgbClr val="F7F6F2"/>
+        </a:solidFill>
+        <a:effectLst/>
+      </p:bgPr>
+    </p:bg>
+    <p:spTree>
+      <p:nvGrpSpPr>
+        <p:cNvPr id="1" name=""/>
+        <p:cNvGrpSpPr/>
+        <p:nvPr/>
+      </p:nvGrpSpPr>
+      <p:grpSpPr/>
+      <p:sp>
+        <p:nvSpPr>
+          <p:cNvPr id="2" name="Title 1"/>
+          <p:cNvSpPr>
+            <a:spLocks noGrp="1"/>
+          </p:cNvSpPr>
+          <p:nvPr>
+            <p:ph type="title"/>
+          </p:nvPr>
+        </p:nvSpPr>
+        <p:spPr>
+          <a:xfrm>
+            <a:off x="762000" y="837819"/>
+            <a:ext cx="10988040" cy="438912"/>
+          </a:xfrm>
+        </p:spPr>
+        <p:txBody>
+          <a:bodyPr wrap="square" lIns="0" rIns="0" tIns="0" bIns="0" anchor="t">
+            <a:noAutofit/>
+          </a:bodyPr>
+          <a:lstStyle/>
+          <a:p>
+            <a:pPr algn="l">
+              <a:lnSpc>
+                <a:spcPts val="3456"/>
+              </a:lnSpc>
+              <a:spcBef>
+                <a:spcPts val="0"/>
+              </a:spcBef>
+              <a:spcAft>
+                <a:spcPts val="0"/>
+              </a:spcAft>
+            </a:pPr>
+            <a:r>
+              <a:rPr sz="3200" b="1" i="0" spc="-32">
+                <a:solidFill>
+                  <a:srgbClr val="1D2433"/>
+                </a:solidFill>
+                <a:latin typeface="Noto Sans"/>
+              </a:rPr>
+              <a:t>Keep the rules few and the hooks labelled</a:t>
+            </a:r>
+          </a:p>
+        </p:txBody>
+      </p:sp>
+      <p:sp>
+        <p:nvSpPr>
+          <p:cNvPr id="3" name="Text"/>
+          <p:cNvSpPr txBox="1"/>
+          <p:nvPr/>
+        </p:nvSpPr>
+        <p:spPr>
+          <a:xfrm>
+            <a:off x="762000" y="558914"/>
+            <a:ext cx="10988040" cy="190271"/>
+          </a:xfrm>
+          <a:prstGeom prst="rect">
+            <a:avLst/>
+          </a:prstGeom>
+          <a:noFill/>
+        </p:spPr>
+        <p:txBody>
+          <a:bodyPr wrap="square" lIns="0" rIns="0" tIns="0" bIns="0" anchor="t">
+            <a:noAutofit/>
+          </a:bodyPr>
+          <a:lstStyle/>
+          <a:p>
+            <a:pPr algn="l">
+              <a:lnSpc>
+                <a:spcPts val="1498"/>
+              </a:lnSpc>
+              <a:spcBef>
+                <a:spcPts val="0"/>
+              </a:spcBef>
+              <a:spcAft>
+                <a:spcPts val="0"/>
+              </a:spcAft>
+            </a:pPr>
+            <a:r>
+              <a:rPr sz="1100" b="1" i="0" spc="154">
+                <a:solidFill>
+                  <a:srgbClr val="5B4BD6"/>
+                </a:solidFill>
+                <a:latin typeface="Noto Sans"/>
+              </a:rPr>
+              <a:t>WHAT WORKS, WHAT DOES NOT</a:t>
+            </a:r>
+          </a:p>
+        </p:txBody>
+      </p:sp>
+      <p:sp>
+        <p:nvSpPr>
+          <p:cNvPr id="4" name="Text"/>
+          <p:cNvSpPr txBox="1"/>
+          <p:nvPr/>
+        </p:nvSpPr>
+        <p:spPr>
+          <a:xfrm>
+            <a:off x="762000" y="1389757"/>
+            <a:ext cx="9810750" cy="269875"/>
+          </a:xfrm>
+          <a:prstGeom prst="rect">
+            <a:avLst/>
+          </a:prstGeom>
+          <a:noFill/>
+        </p:spPr>
+        <p:txBody>
+          <a:bodyPr wrap="square" lIns="0" rIns="0" tIns="0" bIns="0" anchor="t">
+            <a:noAutofit/>
+          </a:bodyPr>
+          <a:lstStyle/>
+          <a:p>
+            <a:pPr algn="l">
+              <a:lnSpc>
+                <a:spcPts val="2125"/>
+              </a:lnSpc>
+              <a:spcBef>
+                <a:spcPts val="0"/>
+              </a:spcBef>
+              <a:spcAft>
+                <a:spcPts val="0"/>
+              </a:spcAft>
+            </a:pPr>
+            <a:r>
+              <a:rPr sz="1700" b="0" i="0">
+                <a:solidFill>
+                  <a:srgbClr val="4A5163"/>
+                </a:solidFill>
+                <a:latin typeface="Noto Sans"/>
+              </a:rPr>
+              <a:t>Two lists, four short lines each.</a:t>
+            </a:r>
+          </a:p>
+        </p:txBody>
+      </p:sp>
+      <p:sp>
+        <p:nvSpPr>
+          <p:cNvPr id="5" name="Box"/>
+          <p:cNvSpPr/>
+          <p:nvPr/>
+        </p:nvSpPr>
+        <p:spPr>
+          <a:xfrm>
+            <a:off x="762000" y="2159000"/>
+            <a:ext cx="5245100" cy="2372122"/>
+          </a:xfrm>
+          <a:prstGeom prst="roundRect">
+            <a:avLst>
+              <a:gd name="adj" fmla="val 4283"/>
+            </a:avLst>
+          </a:prstGeom>
+          <a:solidFill>
+            <a:srgbClr val="FFFFFF"/>
+          </a:solidFill>
+          <a:ln w="25400">
+            <a:solidFill>
+              <a:srgbClr val="2E9E6B"/>
+            </a:solidFill>
+          </a:ln>
+          <a:effectLst/>
+        </p:spPr>
+        <p:txBody>
+          <a:bodyPr rtlCol="0" anchor="ctr"/>
+          <a:lstStyle/>
+          <a:p>
+            <a:pPr algn="ctr"/>
+          </a:p>
+        </p:txBody>
+      </p:sp>
+      <p:sp>
+        <p:nvSpPr>
+          <p:cNvPr id="6" name="Text"/>
+          <p:cNvSpPr txBox="1"/>
+          <p:nvPr/>
+        </p:nvSpPr>
+        <p:spPr>
+          <a:xfrm>
+            <a:off x="990600" y="2373922"/>
+            <a:ext cx="4931537" cy="294056"/>
+          </a:xfrm>
+          <a:prstGeom prst="rect">
+            <a:avLst/>
+          </a:prstGeom>
+          <a:noFill/>
+        </p:spPr>
+        <p:txBody>
+          <a:bodyPr wrap="square" lIns="0" rIns="0" tIns="0" bIns="0" anchor="t">
+            <a:noAutofit/>
+          </a:bodyPr>
+          <a:lstStyle/>
+          <a:p>
+            <a:pPr algn="l">
+              <a:lnSpc>
+                <a:spcPts val="2315"/>
+              </a:lnSpc>
+              <a:spcBef>
+                <a:spcPts val="0"/>
+              </a:spcBef>
+              <a:spcAft>
+                <a:spcPts val="0"/>
+              </a:spcAft>
+            </a:pPr>
+            <a:r>
+              <a:rPr sz="1700" b="1" i="0">
+                <a:solidFill>
+                  <a:srgbClr val="2E9E6B"/>
+                </a:solidFill>
+                <a:latin typeface="Noto Sans"/>
+              </a:rPr>
+              <a:t>What works</a:t>
+            </a:r>
+          </a:p>
+        </p:txBody>
+      </p:sp>
+      <p:sp>
+        <p:nvSpPr>
+          <p:cNvPr id="7" name="Box"/>
+          <p:cNvSpPr/>
+          <p:nvPr/>
+        </p:nvSpPr>
+        <p:spPr>
+          <a:xfrm>
+            <a:off x="1016000" y="2832100"/>
+            <a:ext cx="101600" cy="101600"/>
+          </a:xfrm>
+          <a:prstGeom prst="roundRect">
+            <a:avLst>
+              <a:gd name="adj" fmla="val 25000"/>
+            </a:avLst>
+          </a:prstGeom>
+          <a:solidFill>
+            <a:srgbClr val="5B4BD6"/>
+          </a:solidFill>
+          <a:ln>
+            <a:noFill/>
+          </a:ln>
+          <a:effectLst/>
+        </p:spPr>
+        <p:txBody>
+          <a:bodyPr rtlCol="0" anchor="ctr"/>
+          <a:lstStyle/>
+          <a:p>
+            <a:pPr algn="ctr"/>
+          </a:p>
+        </p:txBody>
+      </p:sp>
+      <p:sp>
+        <p:nvSpPr>
+          <p:cNvPr id="8" name="Text"/>
+          <p:cNvSpPr txBox="1"/>
+          <p:nvPr/>
+        </p:nvSpPr>
+        <p:spPr>
+          <a:xfrm>
+            <a:off x="1282700" y="2737168"/>
+            <a:ext cx="4630674" cy="291465"/>
+          </a:xfrm>
+          <a:prstGeom prst="rect">
+            <a:avLst/>
+          </a:prstGeom>
+          <a:noFill/>
+        </p:spPr>
+        <p:txBody>
+          <a:bodyPr wrap="square" lIns="0" rIns="0" tIns="0" bIns="0" anchor="t">
+            <a:noAutofit/>
+          </a:bodyPr>
+          <a:lstStyle/>
+          <a:p>
+            <a:pPr algn="l">
+              <a:lnSpc>
+                <a:spcPts val="2295"/>
+              </a:lnSpc>
+              <a:spcBef>
+                <a:spcPts val="0"/>
+              </a:spcBef>
+              <a:spcAft>
+                <a:spcPts val="0"/>
+              </a:spcAft>
+            </a:pPr>
+            <a:r>
+              <a:rPr sz="1700" b="0" i="0">
+                <a:solidFill>
+                  <a:srgbClr val="1D2433"/>
+                </a:solidFill>
+                <a:latin typeface="Noto Sans"/>
+              </a:rPr>
+              <a:t>A hook for every tool</a:t>
+            </a:r>
+          </a:p>
+        </p:txBody>
+      </p:sp>
+      <p:sp>
+        <p:nvSpPr>
+          <p:cNvPr id="9" name="Box"/>
+          <p:cNvSpPr/>
+          <p:nvPr/>
+        </p:nvSpPr>
+        <p:spPr>
+          <a:xfrm>
+            <a:off x="1016000" y="3225105"/>
+            <a:ext cx="101600" cy="101600"/>
+          </a:xfrm>
+          <a:prstGeom prst="roundRect">
+            <a:avLst>
+              <a:gd name="adj" fmla="val 25000"/>
+            </a:avLst>
+          </a:prstGeom>
+          <a:solidFill>
+            <a:srgbClr val="5B4BD6"/>
+          </a:solidFill>
+          <a:ln>
+            <a:noFill/>
+          </a:ln>
+          <a:effectLst/>
+        </p:spPr>
+        <p:txBody>
+          <a:bodyPr rtlCol="0" anchor="ctr"/>
+          <a:lstStyle/>
+          <a:p>
+            <a:pPr algn="ctr"/>
+          </a:p>
+        </p:txBody>
+      </p:sp>
+      <p:sp>
+        <p:nvSpPr>
+          <p:cNvPr id="10" name="Text"/>
+          <p:cNvSpPr txBox="1"/>
+          <p:nvPr/>
+        </p:nvSpPr>
+        <p:spPr>
+          <a:xfrm>
+            <a:off x="1282700" y="3130173"/>
+            <a:ext cx="4630674" cy="291465"/>
+          </a:xfrm>
+          <a:prstGeom prst="rect">
+            <a:avLst/>
+          </a:prstGeom>
+          <a:noFill/>
+        </p:spPr>
+        <p:txBody>
+          <a:bodyPr wrap="square" lIns="0" rIns="0" tIns="0" bIns="0" anchor="t">
+            <a:noAutofit/>
+          </a:bodyPr>
+          <a:lstStyle/>
+          <a:p>
+            <a:pPr algn="l">
+              <a:lnSpc>
+                <a:spcPts val="2295"/>
+              </a:lnSpc>
+              <a:spcBef>
+                <a:spcPts val="0"/>
+              </a:spcBef>
+              <a:spcAft>
+                <a:spcPts val="0"/>
+              </a:spcAft>
+            </a:pPr>
+            <a:r>
+              <a:rPr sz="1700" b="0" i="0">
+                <a:solidFill>
+                  <a:srgbClr val="1D2433"/>
+                </a:solidFill>
+                <a:latin typeface="Noto Sans"/>
+              </a:rPr>
+              <a:t>A ledger line for every hook</a:t>
+            </a:r>
+          </a:p>
+        </p:txBody>
+      </p:sp>
+      <p:sp>
+        <p:nvSpPr>
+          <p:cNvPr id="11" name="Box"/>
+          <p:cNvSpPr/>
+          <p:nvPr/>
+        </p:nvSpPr>
+        <p:spPr>
+          <a:xfrm>
+            <a:off x="1016000" y="3618111"/>
+            <a:ext cx="101600" cy="101600"/>
+          </a:xfrm>
+          <a:prstGeom prst="roundRect">
+            <a:avLst>
+              <a:gd name="adj" fmla="val 25000"/>
+            </a:avLst>
+          </a:prstGeom>
+          <a:solidFill>
+            <a:srgbClr val="5B4BD6"/>
+          </a:solidFill>
+          <a:ln>
+            <a:noFill/>
+          </a:ln>
+          <a:effectLst/>
+        </p:spPr>
+        <p:txBody>
+          <a:bodyPr rtlCol="0" anchor="ctr"/>
+          <a:lstStyle/>
+          <a:p>
+            <a:pPr algn="ctr"/>
+          </a:p>
+        </p:txBody>
+      </p:sp>
+      <p:sp>
+        <p:nvSpPr>
+          <p:cNvPr id="12" name="Text"/>
+          <p:cNvSpPr txBox="1"/>
+          <p:nvPr/>
+        </p:nvSpPr>
+        <p:spPr>
+          <a:xfrm>
+            <a:off x="1282700" y="3523178"/>
+            <a:ext cx="4630674" cy="291465"/>
+          </a:xfrm>
+          <a:prstGeom prst="rect">
+            <a:avLst/>
+          </a:prstGeom>
+          <a:noFill/>
+        </p:spPr>
+        <p:txBody>
+          <a:bodyPr wrap="square" lIns="0" rIns="0" tIns="0" bIns="0" anchor="t">
+            <a:noAutofit/>
+          </a:bodyPr>
+          <a:lstStyle/>
+          <a:p>
+            <a:pPr algn="l">
+              <a:lnSpc>
+                <a:spcPts val="2295"/>
+              </a:lnSpc>
+              <a:spcBef>
+                <a:spcPts val="0"/>
+              </a:spcBef>
+              <a:spcAft>
+                <a:spcPts val="0"/>
+              </a:spcAft>
+            </a:pPr>
+            <a:r>
+              <a:rPr sz="1700" b="0" i="0">
+                <a:solidFill>
+                  <a:srgbClr val="1D2433"/>
+                </a:solidFill>
+                <a:latin typeface="Noto Sans"/>
+              </a:rPr>
+              <a:t>One rule said out loud</a:t>
+            </a:r>
+          </a:p>
+        </p:txBody>
+      </p:sp>
+      <p:sp>
+        <p:nvSpPr>
+          <p:cNvPr id="13" name="Box"/>
+          <p:cNvSpPr/>
+          <p:nvPr/>
+        </p:nvSpPr>
+        <p:spPr>
+          <a:xfrm>
+            <a:off x="1016000" y="4011116"/>
+            <a:ext cx="101600" cy="101600"/>
+          </a:xfrm>
+          <a:prstGeom prst="roundRect">
+            <a:avLst>
+              <a:gd name="adj" fmla="val 25000"/>
+            </a:avLst>
+          </a:prstGeom>
+          <a:solidFill>
+            <a:srgbClr val="5B4BD6"/>
+          </a:solidFill>
+          <a:ln>
+            <a:noFill/>
+          </a:ln>
+          <a:effectLst/>
+        </p:spPr>
+        <p:txBody>
+          <a:bodyPr rtlCol="0" anchor="ctr"/>
+          <a:lstStyle/>
+          <a:p>
+            <a:pPr algn="ctr"/>
+          </a:p>
+        </p:txBody>
+      </p:sp>
+      <p:sp>
+        <p:nvSpPr>
+          <p:cNvPr id="14" name="Text"/>
+          <p:cNvSpPr txBox="1"/>
+          <p:nvPr/>
+        </p:nvSpPr>
+        <p:spPr>
+          <a:xfrm>
+            <a:off x="1282700" y="3916184"/>
+            <a:ext cx="4630674" cy="291465"/>
+          </a:xfrm>
+          <a:prstGeom prst="rect">
+            <a:avLst/>
+          </a:prstGeom>
+          <a:noFill/>
+        </p:spPr>
+        <p:txBody>
+          <a:bodyPr wrap="square" lIns="0" rIns="0" tIns="0" bIns="0" anchor="t">
+            <a:noAutofit/>
+          </a:bodyPr>
+          <a:lstStyle/>
+          <a:p>
+            <a:pPr algn="l">
+              <a:lnSpc>
+                <a:spcPts val="2295"/>
+              </a:lnSpc>
+              <a:spcBef>
+                <a:spcPts val="0"/>
+              </a:spcBef>
+              <a:spcAft>
+                <a:spcPts val="0"/>
+              </a:spcAft>
+            </a:pPr>
+            <a:r>
+              <a:rPr sz="1700" b="0" i="0">
+                <a:solidFill>
+                  <a:srgbClr val="1D2433"/>
+                </a:solidFill>
+                <a:latin typeface="Noto Sans"/>
+              </a:rPr>
+              <a:t>Saturday mornings, always</a:t>
+            </a:r>
+          </a:p>
+        </p:txBody>
+      </p:sp>
+      <p:sp>
+        <p:nvSpPr>
+          <p:cNvPr id="15" name="Box"/>
+          <p:cNvSpPr/>
+          <p:nvPr/>
+        </p:nvSpPr>
+        <p:spPr>
+          <a:xfrm>
+            <a:off x="6184900" y="2159000"/>
+            <a:ext cx="5245100" cy="2372122"/>
+          </a:xfrm>
+          <a:prstGeom prst="roundRect">
+            <a:avLst>
+              <a:gd name="adj" fmla="val 4283"/>
+            </a:avLst>
+          </a:prstGeom>
+          <a:solidFill>
+            <a:srgbClr val="FFFFFF"/>
+          </a:solidFill>
+          <a:ln w="25400">
+            <a:solidFill>
+              <a:srgbClr val="D0453D"/>
+            </a:solidFill>
+          </a:ln>
+          <a:effectLst/>
+        </p:spPr>
+        <p:txBody>
+          <a:bodyPr rtlCol="0" anchor="ctr"/>
+          <a:lstStyle/>
+          <a:p>
+            <a:pPr algn="ctr"/>
+          </a:p>
+        </p:txBody>
+      </p:sp>
+      <p:sp>
+        <p:nvSpPr>
+          <p:cNvPr id="16" name="Text"/>
+          <p:cNvSpPr txBox="1"/>
+          <p:nvPr/>
+        </p:nvSpPr>
+        <p:spPr>
+          <a:xfrm>
+            <a:off x="6413500" y="2373922"/>
+            <a:ext cx="4931537" cy="294056"/>
+          </a:xfrm>
+          <a:prstGeom prst="rect">
+            <a:avLst/>
+          </a:prstGeom>
+          <a:noFill/>
+        </p:spPr>
+        <p:txBody>
+          <a:bodyPr wrap="square" lIns="0" rIns="0" tIns="0" bIns="0" anchor="t">
+            <a:noAutofit/>
+          </a:bodyPr>
+          <a:lstStyle/>
+          <a:p>
+            <a:pPr algn="l">
+              <a:lnSpc>
+                <a:spcPts val="2315"/>
+              </a:lnSpc>
+              <a:spcBef>
+                <a:spcPts val="0"/>
+              </a:spcBef>
+              <a:spcAft>
+                <a:spcPts val="0"/>
+              </a:spcAft>
+            </a:pPr>
+            <a:r>
+              <a:rPr sz="1700" b="1" i="0">
+                <a:solidFill>
+                  <a:srgbClr val="D0453D"/>
+                </a:solidFill>
+                <a:latin typeface="Noto Sans"/>
+              </a:rPr>
+              <a:t>What does not</a:t>
+            </a:r>
+          </a:p>
+        </p:txBody>
+      </p:sp>
+      <p:sp>
+        <p:nvSpPr>
+          <p:cNvPr id="17" name="Box"/>
+          <p:cNvSpPr/>
+          <p:nvPr/>
+        </p:nvSpPr>
+        <p:spPr>
+          <a:xfrm>
+            <a:off x="6438900" y="2832100"/>
+            <a:ext cx="101600" cy="101600"/>
+          </a:xfrm>
+          <a:prstGeom prst="roundRect">
+            <a:avLst>
+              <a:gd name="adj" fmla="val 25000"/>
+            </a:avLst>
+          </a:prstGeom>
+          <a:solidFill>
+            <a:srgbClr val="5B4BD6"/>
+          </a:solidFill>
+          <a:ln>
+            <a:noFill/>
+          </a:ln>
+          <a:effectLst/>
+        </p:spPr>
+        <p:txBody>
+          <a:bodyPr rtlCol="0" anchor="ctr"/>
+          <a:lstStyle/>
+          <a:p>
+            <a:pPr algn="ctr"/>
+          </a:p>
+        </p:txBody>
+      </p:sp>
+      <p:sp>
+        <p:nvSpPr>
+          <p:cNvPr id="18" name="Text"/>
+          <p:cNvSpPr txBox="1"/>
+          <p:nvPr/>
+        </p:nvSpPr>
+        <p:spPr>
+          <a:xfrm>
+            <a:off x="6705600" y="2737168"/>
+            <a:ext cx="4630674" cy="291465"/>
+          </a:xfrm>
+          <a:prstGeom prst="rect">
+            <a:avLst/>
+          </a:prstGeom>
+          <a:noFill/>
+        </p:spPr>
+        <p:txBody>
+          <a:bodyPr wrap="square" lIns="0" rIns="0" tIns="0" bIns="0" anchor="t">
+            <a:noAutofit/>
+          </a:bodyPr>
+          <a:lstStyle/>
+          <a:p>
+            <a:pPr algn="l">
+              <a:lnSpc>
+                <a:spcPts val="2295"/>
+              </a:lnSpc>
+              <a:spcBef>
+                <a:spcPts val="0"/>
+              </a:spcBef>
+              <a:spcAft>
+                <a:spcPts val="0"/>
+              </a:spcAft>
+            </a:pPr>
+            <a:r>
+              <a:rPr sz="1700" b="0" i="0">
+                <a:solidFill>
+                  <a:srgbClr val="1D2433"/>
+                </a:solidFill>
+                <a:latin typeface="Noto Sans"/>
+              </a:rPr>
+              <a:t>Tools with no home</a:t>
+            </a:r>
+          </a:p>
+        </p:txBody>
+      </p:sp>
+      <p:sp>
+        <p:nvSpPr>
+          <p:cNvPr id="19" name="Box"/>
+          <p:cNvSpPr/>
+          <p:nvPr/>
+        </p:nvSpPr>
+        <p:spPr>
+          <a:xfrm>
+            <a:off x="6438900" y="3225105"/>
+            <a:ext cx="101600" cy="101600"/>
+          </a:xfrm>
+          <a:prstGeom prst="roundRect">
+            <a:avLst>
+              <a:gd name="adj" fmla="val 25000"/>
+            </a:avLst>
+          </a:prstGeom>
+          <a:solidFill>
+            <a:srgbClr val="5B4BD6"/>
+          </a:solidFill>
+          <a:ln>
+            <a:noFill/>
+          </a:ln>
+          <a:effectLst/>
+        </p:spPr>
+        <p:txBody>
+          <a:bodyPr rtlCol="0" anchor="ctr"/>
+          <a:lstStyle/>
+          <a:p>
+            <a:pPr algn="ctr"/>
+          </a:p>
+        </p:txBody>
+      </p:sp>
+      <p:sp>
+        <p:nvSpPr>
+          <p:cNvPr id="20" name="Text"/>
+          <p:cNvSpPr txBox="1"/>
+          <p:nvPr/>
+        </p:nvSpPr>
+        <p:spPr>
+          <a:xfrm>
+            <a:off x="6705600" y="3130173"/>
+            <a:ext cx="4630674" cy="291465"/>
+          </a:xfrm>
+          <a:prstGeom prst="rect">
+            <a:avLst/>
+          </a:prstGeom>
+          <a:noFill/>
+        </p:spPr>
+        <p:txBody>
+          <a:bodyPr wrap="square" lIns="0" rIns="0" tIns="0" bIns="0" anchor="t">
+            <a:noAutofit/>
+          </a:bodyPr>
+          <a:lstStyle/>
+          <a:p>
+            <a:pPr algn="l">
+              <a:lnSpc>
+                <a:spcPts val="2295"/>
+              </a:lnSpc>
+              <a:spcBef>
+                <a:spcPts val="0"/>
+              </a:spcBef>
+              <a:spcAft>
+                <a:spcPts val="0"/>
+              </a:spcAft>
+            </a:pPr>
+            <a:r>
+              <a:rPr sz="1700" b="0" i="0">
+                <a:solidFill>
+                  <a:srgbClr val="1D2433"/>
+                </a:solidFill>
+                <a:latin typeface="Noto Sans"/>
+              </a:rPr>
+              <a:t>Rules on a long notice board</a:t>
+            </a:r>
+          </a:p>
+        </p:txBody>
+      </p:sp>
+      <p:sp>
+        <p:nvSpPr>
+          <p:cNvPr id="21" name="Box"/>
+          <p:cNvSpPr/>
+          <p:nvPr/>
+        </p:nvSpPr>
+        <p:spPr>
+          <a:xfrm>
+            <a:off x="6438900" y="3618111"/>
+            <a:ext cx="101600" cy="101600"/>
+          </a:xfrm>
+          <a:prstGeom prst="roundRect">
+            <a:avLst>
+              <a:gd name="adj" fmla="val 25000"/>
+            </a:avLst>
+          </a:prstGeom>
+          <a:solidFill>
+            <a:srgbClr val="5B4BD6"/>
+          </a:solidFill>
+          <a:ln>
+            <a:noFill/>
+          </a:ln>
+          <a:effectLst/>
+        </p:spPr>
+        <p:txBody>
+          <a:bodyPr rtlCol="0" anchor="ctr"/>
+          <a:lstStyle/>
+          <a:p>
+            <a:pPr algn="ctr"/>
+          </a:p>
+        </p:txBody>
+      </p:sp>
+      <p:sp>
+        <p:nvSpPr>
+          <p:cNvPr id="22" name="Text"/>
+          <p:cNvSpPr txBox="1"/>
+          <p:nvPr/>
+        </p:nvSpPr>
+        <p:spPr>
+          <a:xfrm>
+            <a:off x="6705600" y="3523178"/>
+            <a:ext cx="4630674" cy="291465"/>
+          </a:xfrm>
+          <a:prstGeom prst="rect">
+            <a:avLst/>
+          </a:prstGeom>
+          <a:noFill/>
+        </p:spPr>
+        <p:txBody>
+          <a:bodyPr wrap="square" lIns="0" rIns="0" tIns="0" bIns="0" anchor="t">
+            <a:noAutofit/>
+          </a:bodyPr>
+          <a:lstStyle/>
+          <a:p>
+            <a:pPr algn="l">
+              <a:lnSpc>
+                <a:spcPts val="2295"/>
+              </a:lnSpc>
+              <a:spcBef>
+                <a:spcPts val="0"/>
+              </a:spcBef>
+              <a:spcAft>
+                <a:spcPts val="0"/>
+              </a:spcAft>
+            </a:pPr>
+            <a:r>
+              <a:rPr sz="1700" b="0" i="0">
+                <a:solidFill>
+                  <a:srgbClr val="1D2433"/>
+                </a:solidFill>
+                <a:latin typeface="Noto Sans"/>
+              </a:rPr>
+              <a:t>Fines nobody collects</a:t>
+            </a:r>
+          </a:p>
+        </p:txBody>
+      </p:sp>
+      <p:sp>
+        <p:nvSpPr>
+          <p:cNvPr id="23" name="Box"/>
+          <p:cNvSpPr/>
+          <p:nvPr/>
+        </p:nvSpPr>
+        <p:spPr>
+          <a:xfrm>
+            <a:off x="6438900" y="4011116"/>
+            <a:ext cx="101600" cy="101600"/>
+          </a:xfrm>
+          <a:prstGeom prst="roundRect">
+            <a:avLst>
+              <a:gd name="adj" fmla="val 25000"/>
+            </a:avLst>
+          </a:prstGeom>
+          <a:solidFill>
+            <a:srgbClr val="5B4BD6"/>
+          </a:solidFill>
+          <a:ln>
+            <a:noFill/>
+          </a:ln>
+          <a:effectLst/>
+        </p:spPr>
+        <p:txBody>
+          <a:bodyPr rtlCol="0" anchor="ctr"/>
+          <a:lstStyle/>
+          <a:p>
+            <a:pPr algn="ctr"/>
+          </a:p>
+        </p:txBody>
+      </p:sp>
+      <p:sp>
+        <p:nvSpPr>
+          <p:cNvPr id="24" name="Text"/>
+          <p:cNvSpPr txBox="1"/>
+          <p:nvPr/>
+        </p:nvSpPr>
+        <p:spPr>
+          <a:xfrm>
+            <a:off x="6705600" y="3916184"/>
+            <a:ext cx="4630674" cy="291465"/>
+          </a:xfrm>
+          <a:prstGeom prst="rect">
+            <a:avLst/>
+          </a:prstGeom>
+          <a:noFill/>
+        </p:spPr>
+        <p:txBody>
+          <a:bodyPr wrap="square" lIns="0" rIns="0" tIns="0" bIns="0" anchor="t">
+            <a:noAutofit/>
+          </a:bodyPr>
+          <a:lstStyle/>
+          <a:p>
+            <a:pPr algn="l">
+              <a:lnSpc>
+                <a:spcPts val="2295"/>
+              </a:lnSpc>
+              <a:spcBef>
+                <a:spcPts val="0"/>
+              </a:spcBef>
+              <a:spcAft>
+                <a:spcPts val="0"/>
+              </a:spcAft>
+            </a:pPr>
+            <a:r>
+              <a:rPr sz="1700" b="0" i="0">
+                <a:solidFill>
+                  <a:srgbClr val="1D2433"/>
+                </a:solidFill>
+                <a:latin typeface="Noto Sans"/>
+              </a:rPr>
+              <a:t>Opening whenever someone is free</a:t>
+            </a:r>
+          </a:p>
+        </p:txBody>
+      </p:sp>
+      <p:sp>
+        <p:nvSpPr>
+          <p:cNvPr id="25" name="Box"/>
+          <p:cNvSpPr/>
+          <p:nvPr/>
+        </p:nvSpPr>
+        <p:spPr>
+          <a:xfrm>
+            <a:off x="762000" y="6369050"/>
+            <a:ext cx="10668000" cy="6350"/>
+          </a:xfrm>
+          <a:prstGeom prst="rect">
+            <a:avLst/>
+          </a:prstGeom>
+          <a:solidFill>
+            <a:srgbClr val="DCD9D0"/>
+          </a:solidFill>
+          <a:ln>
+            <a:noFill/>
+          </a:ln>
+          <a:effectLst/>
+        </p:spPr>
+        <p:txBody>
+          <a:bodyPr rtlCol="0" anchor="ctr"/>
+          <a:lstStyle/>
+          <a:p>
+            <a:pPr algn="ctr"/>
+          </a:p>
+        </p:txBody>
+      </p:sp>
+      <p:sp>
+        <p:nvSpPr>
+          <p:cNvPr id="26" name="Text"/>
+          <p:cNvSpPr txBox="1"/>
+          <p:nvPr/>
+        </p:nvSpPr>
+        <p:spPr>
+          <a:xfrm>
+            <a:off x="762000" y="6495561"/>
+            <a:ext cx="1339850" cy="147028"/>
+          </a:xfrm>
+          <a:prstGeom prst="rect">
+            <a:avLst/>
+          </a:prstGeom>
+          <a:noFill/>
+        </p:spPr>
+        <p:txBody>
+          <a:bodyPr wrap="none" lIns="0" rIns="0" tIns="0" bIns="0" anchor="t">
+            <a:noAutofit/>
+          </a:bodyPr>
+          <a:lstStyle/>
+          <a:p>
+            <a:pPr algn="l">
+              <a:lnSpc>
+                <a:spcPts val="1157"/>
+              </a:lnSpc>
+              <a:spcBef>
+                <a:spcPts val="0"/>
+              </a:spcBef>
+              <a:spcAft>
+                <a:spcPts val="0"/>
+              </a:spcAft>
+            </a:pPr>
+            <a:r>
+              <a:rPr sz="850" b="1" i="0">
+                <a:solidFill>
+                  <a:srgbClr val="4A5163"/>
+                </a:solidFill>
+                <a:latin typeface="Noto Sans"/>
+              </a:rPr>
+              <a:t>Source:</a:t>
+            </a:r>
+            <a:r>
+              <a:rPr sz="850" b="0" i="0">
+                <a:solidFill>
+                  <a:srgbClr val="8A8F9C"/>
+                </a:solidFill>
+                <a:latin typeface="Noto Sans"/>
+              </a:rPr>
+              <a:t> Invented example</a:t>
+            </a:r>
+          </a:p>
+        </p:txBody>
+      </p:sp>
+      <p:sp>
+        <p:nvSpPr>
+          <p:cNvPr id="27" name="Text"/>
+          <p:cNvSpPr txBox="1"/>
+          <p:nvPr/>
+        </p:nvSpPr>
+        <p:spPr>
+          <a:xfrm>
+            <a:off x="11087100" y="6495561"/>
+            <a:ext cx="353187" cy="147028"/>
+          </a:xfrm>
+          <a:prstGeom prst="rect">
+            <a:avLst/>
+          </a:prstGeom>
+          <a:noFill/>
+        </p:spPr>
+        <p:txBody>
+          <a:bodyPr wrap="square" lIns="0" rIns="0" tIns="0" bIns="0" anchor="t">
+            <a:noAutofit/>
+          </a:bodyPr>
+          <a:lstStyle/>
+          <a:p>
+            <a:pPr algn="l">
+              <a:lnSpc>
+                <a:spcPts val="1157"/>
+              </a:lnSpc>
+              <a:spcBef>
+                <a:spcPts val="0"/>
+              </a:spcBef>
+              <a:spcAft>
+                <a:spcPts val="0"/>
+              </a:spcAft>
+            </a:pPr>
+            <a:r>
+              <a:rPr sz="850" b="0" i="0">
+                <a:solidFill>
+                  <a:srgbClr val="8A8F9C"/>
+                </a:solidFill>
+                <a:latin typeface="Noto Sans"/>
+              </a:rPr>
+              <a:t>10 / 13</a:t>
+            </a:r>
+          </a:p>
+        </p:txBody>
+      </p:sp>
+    </p:spTree>
+  </p:cSld>
+  <p:clrMapOvr>
+    <a:masterClrMapping/>
+  </p:clrMapOvr>
+</p:sld>
+</file>
+
+<file path=ppt/slides/slide11.xml><?xml version="1.0" encoding="utf-8"?>
 <p:sld xmlns:a="http://schemas.openxmlformats.org/drawingml/2006/main" xmlns:p="http://schemas.openxmlformats.org/presentationml/2006/main" xmlns:r="http://schemas.openxmlformats.org/officeDocument/2006/relationships">
   <p:cSld>
     <p:bg>
@@ -4757,8 +5898,8 @@
         </p:nvSpPr>
         <p:spPr>
           <a:xfrm>
-            <a:off x="10356850" y="762000"/>
-            <a:ext cx="974534" cy="1651000"/>
+            <a:off x="10350500" y="762000"/>
+            <a:ext cx="981075" cy="1651000"/>
           </a:xfrm>
           <a:prstGeom prst="rect">
             <a:avLst/>
@@ -5008,7 +6149,7 @@
                 </a:solidFill>
                 <a:latin typeface="Noto Sans"/>
               </a:rPr>
-              <a:t>10 / 12</a:t>
+              <a:t>11 / 13</a:t>
             </a:r>
           </a:p>
         </p:txBody>
@@ -5021,7 +6162,7 @@
 </p:sld>
 </file>
 
-<file path=ppt/slides/slide11.xml><?xml version="1.0" encoding="utf-8"?>
+<file path=ppt/slides/slide12.xml><?xml version="1.0" encoding="utf-8"?>
 <p:sld xmlns:a="http://schemas.openxmlformats.org/drawingml/2006/main" xmlns:p="http://schemas.openxmlformats.org/presentationml/2006/main" xmlns:r="http://schemas.openxmlformats.org/officeDocument/2006/relationships">
   <p:cSld>
     <p:bg>
@@ -5451,7 +6592,7 @@
                 </a:solidFill>
                 <a:latin typeface="Noto Sans"/>
               </a:rPr>
-              <a:t>11 / 12</a:t>
+              <a:t>12 / 13</a:t>
             </a:r>
           </a:p>
         </p:txBody>
@@ -5464,7 +6605,7 @@
 </p:sld>
 </file>
 
-<file path=ppt/slides/slide12.xml><?xml version="1.0" encoding="utf-8"?>
+<file path=ppt/slides/slide13.xml><?xml version="1.0" encoding="utf-8"?>
 <p:sld xmlns:a="http://schemas.openxmlformats.org/drawingml/2006/main" xmlns:p="http://schemas.openxmlformats.org/presentationml/2006/main" xmlns:r="http://schemas.openxmlformats.org/officeDocument/2006/relationships">
   <p:cSld>
     <p:bg>
@@ -6107,7 +7248,7 @@
                 </a:solidFill>
                 <a:latin typeface="Noto Sans"/>
               </a:rPr>
-              <a:t>12 / 12</a:t>
+              <a:t>13 / 13</a:t>
             </a:r>
           </a:p>
         </p:txBody>
@@ -7873,7 +9014,7 @@
                 </a:solidFill>
                 <a:latin typeface="Noto Sans"/>
               </a:rPr>
-              <a:t>2 / 12</a:t>
+              <a:t>2 / 13</a:t>
             </a:r>
           </a:p>
         </p:txBody>
@@ -8620,7 +9761,7 @@
                 </a:solidFill>
                 <a:latin typeface="Noto Sans"/>
               </a:rPr>
-              <a:t>3 / 12</a:t>
+              <a:t>3 / 13</a:t>
             </a:r>
           </a:p>
         </p:txBody>
@@ -8758,7 +9899,7 @@
         <p:spPr>
           <a:xfrm>
             <a:off x="508000" y="1587500"/>
-            <a:ext cx="11176000" cy="3683000"/>
+            <a:ext cx="11176000" cy="3276600"/>
           </a:xfrm>
           <a:prstGeom prst="rect">
             <a:avLst/>
@@ -8773,7 +9914,7 @@
         </p:nvSpPr>
         <p:spPr>
           <a:xfrm>
-            <a:off x="1631950" y="3765550"/>
+            <a:off x="1631950" y="3562350"/>
             <a:ext cx="1117600" cy="260350"/>
           </a:xfrm>
           <a:prstGeom prst="rect">
@@ -8818,7 +9959,7 @@
         </p:nvSpPr>
         <p:spPr>
           <a:xfrm>
-            <a:off x="1670050" y="4070350"/>
+            <a:off x="1670050" y="3867150"/>
             <a:ext cx="1041400" cy="190500"/>
           </a:xfrm>
           <a:prstGeom prst="rect">
@@ -8863,7 +10004,7 @@
         </p:nvSpPr>
         <p:spPr>
           <a:xfrm>
-            <a:off x="4289425" y="3765550"/>
+            <a:off x="4289425" y="3562350"/>
             <a:ext cx="1016000" cy="260350"/>
           </a:xfrm>
           <a:prstGeom prst="rect">
@@ -8908,7 +10049,7 @@
         </p:nvSpPr>
         <p:spPr>
           <a:xfrm>
-            <a:off x="4254500" y="4070350"/>
+            <a:off x="4254500" y="3867150"/>
             <a:ext cx="1079500" cy="190500"/>
           </a:xfrm>
           <a:prstGeom prst="rect">
@@ -8953,7 +10094,7 @@
         </p:nvSpPr>
         <p:spPr>
           <a:xfrm>
-            <a:off x="6969125" y="3765550"/>
+            <a:off x="6969125" y="3562350"/>
             <a:ext cx="857250" cy="260350"/>
           </a:xfrm>
           <a:prstGeom prst="rect">
@@ -8998,7 +10139,7 @@
         </p:nvSpPr>
         <p:spPr>
           <a:xfrm>
-            <a:off x="6435725" y="4070350"/>
+            <a:off x="6435725" y="3867150"/>
             <a:ext cx="1924050" cy="190500"/>
           </a:xfrm>
           <a:prstGeom prst="rect">
@@ -9043,7 +10184,7 @@
         </p:nvSpPr>
         <p:spPr>
           <a:xfrm>
-            <a:off x="9512300" y="3765550"/>
+            <a:off x="9512300" y="3562350"/>
             <a:ext cx="977900" cy="260350"/>
           </a:xfrm>
           <a:prstGeom prst="rect">
@@ -9088,7 +10229,7 @@
         </p:nvSpPr>
         <p:spPr>
           <a:xfrm>
-            <a:off x="9232900" y="4070350"/>
+            <a:off x="9232900" y="3867150"/>
             <a:ext cx="1536700" cy="190500"/>
           </a:xfrm>
           <a:prstGeom prst="rect">
@@ -9133,7 +10274,7 @@
         </p:nvSpPr>
         <p:spPr>
           <a:xfrm>
-            <a:off x="4752975" y="2794000"/>
+            <a:off x="4752975" y="2590800"/>
             <a:ext cx="2940050" cy="209550"/>
           </a:xfrm>
           <a:prstGeom prst="rect">
@@ -9173,6 +10314,83 @@
       <p:sp>
         <p:nvSpPr>
           <p:cNvPr id="14" name="Box"/>
+          <p:cNvSpPr/>
+          <p:nvPr/>
+        </p:nvSpPr>
+        <p:spPr>
+          <a:xfrm>
+            <a:off x="762000" y="5054600"/>
+            <a:ext cx="10668000" cy="279400"/>
+          </a:xfrm>
+          <a:prstGeom prst="roundRect">
+            <a:avLst>
+              <a:gd name="adj" fmla="val 27272"/>
+            </a:avLst>
+          </a:prstGeom>
+          <a:solidFill>
+            <a:srgbClr val="ECE9FB"/>
+          </a:solidFill>
+          <a:ln>
+            <a:noFill/>
+          </a:ln>
+          <a:effectLst/>
+        </p:spPr>
+        <p:txBody>
+          <a:bodyPr rtlCol="0" anchor="ctr"/>
+          <a:lstStyle/>
+          <a:p>
+            <a:pPr algn="ctr"/>
+          </a:p>
+        </p:txBody>
+      </p:sp>
+      <p:sp>
+        <p:nvSpPr>
+          <p:cNvPr id="15" name="Text"/>
+          <p:cNvSpPr txBox="1"/>
+          <p:nvPr/>
+        </p:nvSpPr>
+        <p:spPr>
+          <a:xfrm>
+            <a:off x="914400" y="5054600"/>
+            <a:ext cx="10363200" cy="279400"/>
+          </a:xfrm>
+          <a:prstGeom prst="rect">
+            <a:avLst/>
+          </a:prstGeom>
+          <a:noFill/>
+        </p:spPr>
+        <p:txBody>
+          <a:bodyPr wrap="none" lIns="0" rIns="0" tIns="0" bIns="0" anchor="t">
+            <a:noAutofit/>
+          </a:bodyPr>
+          <a:lstStyle/>
+          <a:p>
+            <a:pPr algn="l">
+              <a:lnSpc>
+                <a:spcPts val="2200"/>
+              </a:lnSpc>
+              <a:spcBef>
+                <a:spcPts val="0"/>
+              </a:spcBef>
+              <a:spcAft>
+                <a:spcPts val="0"/>
+              </a:spcAft>
+            </a:pPr>
+            <a:r>
+              <a:rPr sz="1400" b="1" i="0">
+                <a:solidFill>
+                  <a:srgbClr val="5B4BD6"/>
+                </a:solidFill>
+                <a:latin typeface="Noto Sans"/>
+              </a:rPr>
+              <a:t>Return: hang it back clean, and write the date in the ledger.</a:t>
+            </a:r>
+          </a:p>
+        </p:txBody>
+      </p:sp>
+      <p:sp>
+        <p:nvSpPr>
+          <p:cNvPr id="16" name="Box"/>
           <p:cNvSpPr/>
           <p:nvPr/>
         </p:nvSpPr>
@@ -9204,7 +10422,7 @@
       </p:sp>
       <p:sp>
         <p:nvSpPr>
-          <p:cNvPr id="15" name="Text"/>
+          <p:cNvPr id="17" name="Text"/>
           <p:cNvSpPr txBox="1"/>
           <p:nvPr/>
         </p:nvSpPr>
@@ -9249,7 +10467,7 @@
       </p:sp>
       <p:sp>
         <p:nvSpPr>
-          <p:cNvPr id="16" name="Text"/>
+          <p:cNvPr id="18" name="Text"/>
           <p:cNvSpPr txBox="1"/>
           <p:nvPr/>
         </p:nvSpPr>
@@ -9294,7 +10512,7 @@
       </p:sp>
       <p:sp>
         <p:nvSpPr>
-          <p:cNvPr id="17" name="Box"/>
+          <p:cNvPr id="19" name="Box"/>
           <p:cNvSpPr/>
           <p:nvPr/>
         </p:nvSpPr>
@@ -9324,7 +10542,7 @@
       </p:sp>
       <p:sp>
         <p:nvSpPr>
-          <p:cNvPr id="18" name="Text"/>
+          <p:cNvPr id="20" name="Text"/>
           <p:cNvSpPr txBox="1"/>
           <p:nvPr/>
         </p:nvSpPr>
@@ -9378,7 +10596,7 @@
       </p:sp>
       <p:sp>
         <p:nvSpPr>
-          <p:cNvPr id="19" name="Text"/>
+          <p:cNvPr id="21" name="Text"/>
           <p:cNvSpPr txBox="1"/>
           <p:nvPr/>
         </p:nvSpPr>
@@ -9416,7 +10634,7 @@
                 </a:solidFill>
                 <a:latin typeface="Noto Sans"/>
               </a:rPr>
-              <a:t>4 / 12</a:t>
+              <a:t>4 / 13</a:t>
             </a:r>
           </a:p>
         </p:txBody>
@@ -10630,7 +11848,7 @@
                 </a:solidFill>
                 <a:latin typeface="Noto Sans"/>
               </a:rPr>
-              <a:t>5 / 12</a:t>
+              <a:t>5 / 13</a:t>
             </a:r>
           </a:p>
         </p:txBody>
@@ -11414,7 +12632,7 @@
                 </a:solidFill>
                 <a:latin typeface="Noto Sans"/>
               </a:rPr>
-              <a:t>6 / 12</a:t>
+              <a:t>6 / 13</a:t>
             </a:r>
           </a:p>
         </p:txBody>
@@ -13786,7 +15004,7 @@
                 </a:solidFill>
                 <a:latin typeface="Noto Sans"/>
               </a:rPr>
-              <a:t>7 / 12</a:t>
+              <a:t>7 / 13</a:t>
             </a:r>
           </a:p>
         </p:txBody>
@@ -13857,7 +15075,7 @@
                 </a:solidFill>
                 <a:latin typeface="Noto Sans"/>
               </a:rPr>
-              <a:t>From a shared garage to a labelled shed</a:t>
+              <a:t>Most tools come back, and on time</a:t>
             </a:r>
           </a:p>
         </p:txBody>
@@ -13902,33 +15120,260 @@
                 </a:solidFill>
                 <a:latin typeface="Noto Sans"/>
               </a:rPr>
-              <a:t>BEFORE AND AFTER</a:t>
-            </a:r>
-          </a:p>
-        </p:txBody>
-      </p:sp>
-      <p:sp>
-        <p:nvSpPr>
-          <p:cNvPr id="4" name="Box"/>
+              <a:t>THE NUMBERS</a:t>
+            </a:r>
+          </a:p>
+        </p:txBody>
+      </p:sp>
+      <p:sp>
+        <p:nvSpPr>
+          <p:cNvPr id="4" name="Text"/>
+          <p:cNvSpPr txBox="1"/>
+          <p:nvPr/>
+        </p:nvSpPr>
+        <p:spPr>
+          <a:xfrm>
+            <a:off x="2930018" y="1974361"/>
+            <a:ext cx="2869031" cy="147028"/>
+          </a:xfrm>
+          <a:prstGeom prst="rect">
+            <a:avLst/>
+          </a:prstGeom>
+          <a:noFill/>
+        </p:spPr>
+        <p:txBody>
+          <a:bodyPr wrap="square" lIns="0" rIns="0" tIns="0" bIns="0" anchor="t">
+            <a:noAutofit/>
+          </a:bodyPr>
+          <a:lstStyle/>
+          <a:p>
+            <a:pPr algn="ctr">
+              <a:lnSpc>
+                <a:spcPts val="1157"/>
+              </a:lnSpc>
+              <a:spcBef>
+                <a:spcPts val="0"/>
+              </a:spcBef>
+              <a:spcAft>
+                <a:spcPts val="0"/>
+              </a:spcAft>
+            </a:pPr>
+            <a:r>
+              <a:rPr sz="850" b="1" i="0" spc="102">
+                <a:solidFill>
+                  <a:srgbClr val="8A8F9C"/>
+                </a:solidFill>
+                <a:latin typeface="Noto Sans"/>
+              </a:rPr>
+              <a:t>WEEK 1</a:t>
+            </a:r>
+          </a:p>
+        </p:txBody>
+      </p:sp>
+      <p:sp>
+        <p:nvSpPr>
+          <p:cNvPr id="5" name="Text"/>
+          <p:cNvSpPr txBox="1"/>
+          <p:nvPr/>
+        </p:nvSpPr>
+        <p:spPr>
+          <a:xfrm>
+            <a:off x="5766284" y="1974361"/>
+            <a:ext cx="2869133" cy="147028"/>
+          </a:xfrm>
+          <a:prstGeom prst="rect">
+            <a:avLst/>
+          </a:prstGeom>
+          <a:noFill/>
+        </p:spPr>
+        <p:txBody>
+          <a:bodyPr wrap="square" lIns="0" rIns="0" tIns="0" bIns="0" anchor="t">
+            <a:noAutofit/>
+          </a:bodyPr>
+          <a:lstStyle/>
+          <a:p>
+            <a:pPr algn="ctr">
+              <a:lnSpc>
+                <a:spcPts val="1157"/>
+              </a:lnSpc>
+              <a:spcBef>
+                <a:spcPts val="0"/>
+              </a:spcBef>
+              <a:spcAft>
+                <a:spcPts val="0"/>
+              </a:spcAft>
+            </a:pPr>
+            <a:r>
+              <a:rPr sz="850" b="1" i="0" spc="102">
+                <a:solidFill>
+                  <a:srgbClr val="8A8F9C"/>
+                </a:solidFill>
+                <a:latin typeface="Noto Sans"/>
+              </a:rPr>
+              <a:t>WEEK 4</a:t>
+            </a:r>
+          </a:p>
+        </p:txBody>
+      </p:sp>
+      <p:sp>
+        <p:nvSpPr>
+          <p:cNvPr id="6" name="Text"/>
+          <p:cNvSpPr txBox="1"/>
+          <p:nvPr/>
+        </p:nvSpPr>
+        <p:spPr>
+          <a:xfrm>
+            <a:off x="8602652" y="1974361"/>
+            <a:ext cx="2869031" cy="147028"/>
+          </a:xfrm>
+          <a:prstGeom prst="rect">
+            <a:avLst/>
+          </a:prstGeom>
+          <a:noFill/>
+        </p:spPr>
+        <p:txBody>
+          <a:bodyPr wrap="square" lIns="0" rIns="0" tIns="0" bIns="0" anchor="t">
+            <a:noAutofit/>
+          </a:bodyPr>
+          <a:lstStyle/>
+          <a:p>
+            <a:pPr algn="ctr">
+              <a:lnSpc>
+                <a:spcPts val="1157"/>
+              </a:lnSpc>
+              <a:spcBef>
+                <a:spcPts val="0"/>
+              </a:spcBef>
+              <a:spcAft>
+                <a:spcPts val="0"/>
+              </a:spcAft>
+            </a:pPr>
+            <a:r>
+              <a:rPr sz="850" b="1" i="0" spc="102">
+                <a:solidFill>
+                  <a:srgbClr val="5B4BD6"/>
+                </a:solidFill>
+                <a:latin typeface="Noto Sans"/>
+              </a:rPr>
+              <a:t>WEEK 12</a:t>
+            </a:r>
+          </a:p>
+        </p:txBody>
+      </p:sp>
+      <p:sp>
+        <p:nvSpPr>
+          <p:cNvPr id="7" name="Text"/>
+          <p:cNvSpPr txBox="1"/>
+          <p:nvPr/>
+        </p:nvSpPr>
+        <p:spPr>
+          <a:xfrm>
+            <a:off x="762000" y="2239050"/>
+            <a:ext cx="2119122" cy="181610"/>
+          </a:xfrm>
+          <a:prstGeom prst="rect">
+            <a:avLst/>
+          </a:prstGeom>
+          <a:noFill/>
+        </p:spPr>
+        <p:txBody>
+          <a:bodyPr wrap="square" lIns="0" rIns="0" tIns="0" bIns="0" anchor="t">
+            <a:noAutofit/>
+          </a:bodyPr>
+          <a:lstStyle/>
+          <a:p>
+            <a:pPr algn="l">
+              <a:lnSpc>
+                <a:spcPts val="1430"/>
+              </a:lnSpc>
+              <a:spcBef>
+                <a:spcPts val="0"/>
+              </a:spcBef>
+              <a:spcAft>
+                <a:spcPts val="0"/>
+              </a:spcAft>
+            </a:pPr>
+            <a:r>
+              <a:rPr sz="1300" b="1" i="0">
+                <a:solidFill>
+                  <a:srgbClr val="1D2433"/>
+                </a:solidFill>
+                <a:latin typeface="Noto Sans"/>
+              </a:rPr>
+              <a:t>Returned</a:t>
+            </a:r>
+          </a:p>
+        </p:txBody>
+      </p:sp>
+      <p:sp>
+        <p:nvSpPr>
+          <p:cNvPr id="8" name="Text"/>
+          <p:cNvSpPr txBox="1"/>
+          <p:nvPr/>
+        </p:nvSpPr>
+        <p:spPr>
+          <a:xfrm>
+            <a:off x="762000" y="2417445"/>
+            <a:ext cx="2119122" cy="137160"/>
+          </a:xfrm>
+          <a:prstGeom prst="rect">
+            <a:avLst/>
+          </a:prstGeom>
+          <a:noFill/>
+        </p:spPr>
+        <p:txBody>
+          <a:bodyPr wrap="square" lIns="0" rIns="0" tIns="0" bIns="0" anchor="t">
+            <a:noAutofit/>
+          </a:bodyPr>
+          <a:lstStyle/>
+          <a:p>
+            <a:pPr algn="l">
+              <a:lnSpc>
+                <a:spcPts val="1080"/>
+              </a:lnSpc>
+              <a:spcBef>
+                <a:spcPts val="0"/>
+              </a:spcBef>
+              <a:spcAft>
+                <a:spcPts val="0"/>
+              </a:spcAft>
+            </a:pPr>
+            <a:r>
+              <a:rPr sz="900" b="0" i="0">
+                <a:solidFill>
+                  <a:srgbClr val="8A8F9C"/>
+                </a:solidFill>
+                <a:latin typeface="Noto Sans"/>
+              </a:rPr>
+              <a:t>share of tools out</a:t>
+            </a:r>
+          </a:p>
+        </p:txBody>
+      </p:sp>
+      <p:sp>
+        <p:nvSpPr>
+          <p:cNvPr id="9" name="Box"/>
           <p:cNvSpPr/>
           <p:nvPr/>
         </p:nvSpPr>
         <p:spPr>
           <a:xfrm>
-            <a:off x="762000" y="1905000"/>
-            <a:ext cx="4662289" cy="2159000"/>
+            <a:off x="2971800" y="2209800"/>
+            <a:ext cx="2785467" cy="381000"/>
           </a:xfrm>
           <a:prstGeom prst="roundRect">
             <a:avLst>
-              <a:gd name="adj" fmla="val 4705"/>
+              <a:gd name="adj" fmla="val 16666"/>
             </a:avLst>
           </a:prstGeom>
           <a:solidFill>
-            <a:srgbClr val="FFFFFF"/>
+            <a:srgbClr val="74BE9C"/>
           </a:solidFill>
-          <a:ln w="6350">
+          <a:ln w="19050">
             <a:solidFill>
-              <a:srgbClr val="DCD9D0"/>
+              <a:srgbClr val="000000">
+                <a:alpha val="0"/>
+              </a:srgbClr>
             </a:solidFill>
           </a:ln>
           <a:effectLst/>
@@ -13943,14 +15388,14 @@
       </p:sp>
       <p:sp>
         <p:nvSpPr>
-          <p:cNvPr id="5" name="Text"/>
-          <p:cNvSpPr txBox="1"/>
-          <p:nvPr/>
-        </p:nvSpPr>
-        <p:spPr>
-          <a:xfrm>
-            <a:off x="965200" y="2093862"/>
-            <a:ext cx="4383566" cy="155677"/>
+          <p:cNvPr id="10" name="Text"/>
+          <p:cNvSpPr txBox="1"/>
+          <p:nvPr/>
+        </p:nvSpPr>
+        <p:spPr>
+          <a:xfrm>
+            <a:off x="4196259" y="2287867"/>
+            <a:ext cx="346646" cy="224866"/>
           </a:xfrm>
           <a:prstGeom prst="rect">
             <a:avLst/>
@@ -13965,93 +15410,52 @@
           <a:p>
             <a:pPr algn="l">
               <a:lnSpc>
-                <a:spcPts val="1225"/>
-              </a:lnSpc>
-              <a:spcBef>
-                <a:spcPts val="0"/>
-              </a:spcBef>
-              <a:spcAft>
-                <a:spcPts val="0"/>
-              </a:spcAft>
-            </a:pPr>
-            <a:r>
-              <a:rPr sz="900" b="1" i="0" spc="108">
-                <a:solidFill>
-                  <a:srgbClr val="8A8F9C"/>
-                </a:solidFill>
-                <a:latin typeface="Noto Sans"/>
-              </a:rPr>
-              <a:t>BEFORE</a:t>
-            </a:r>
-          </a:p>
-        </p:txBody>
-      </p:sp>
-      <p:sp>
-        <p:nvSpPr>
-          <p:cNvPr id="6" name="Text"/>
-          <p:cNvSpPr txBox="1"/>
-          <p:nvPr/>
-        </p:nvSpPr>
-        <p:spPr>
-          <a:xfrm>
-            <a:off x="965200" y="2321560"/>
-            <a:ext cx="4383566" cy="720050"/>
-          </a:xfrm>
-          <a:prstGeom prst="rect">
-            <a:avLst/>
-          </a:prstGeom>
-          <a:noFill/>
-        </p:spPr>
-        <p:txBody>
-          <a:bodyPr wrap="square" lIns="0" rIns="0" tIns="0" bIns="0" anchor="t">
-            <a:noAutofit/>
-          </a:bodyPr>
-          <a:lstStyle/>
-          <a:p>
-            <a:pPr algn="l">
-              <a:lnSpc>
-                <a:spcPts val="1889"/>
-              </a:lnSpc>
-              <a:spcBef>
-                <a:spcPts val="0"/>
-              </a:spcBef>
-              <a:spcAft>
-                <a:spcPts val="0"/>
-              </a:spcAft>
-            </a:pPr>
-            <a:r>
-              <a:rPr sz="1350" b="0" i="0">
-                <a:solidFill>
-                  <a:srgbClr val="4A5163"/>
-                </a:solidFill>
-                <a:latin typeface="Noto Sans"/>
-              </a:rPr>
-              <a:t>Tools lived in one garage. Nobody knew what was there, so people bought a second drill and the first went missing.</a:t>
-            </a:r>
-          </a:p>
-        </p:txBody>
-      </p:sp>
-      <p:sp>
-        <p:nvSpPr>
-          <p:cNvPr id="7" name="Box"/>
+                <a:spcPts val="1770"/>
+              </a:lnSpc>
+              <a:spcBef>
+                <a:spcPts val="0"/>
+              </a:spcBef>
+              <a:spcAft>
+                <a:spcPts val="0"/>
+              </a:spcAft>
+            </a:pPr>
+            <a:r>
+              <a:rPr sz="1300" b="1" i="0">
+                <a:solidFill>
+                  <a:srgbClr val="FFFFFF"/>
+                </a:solidFill>
+                <a:latin typeface="Noto Sans"/>
+              </a:rPr>
+              <a:t>62%</a:t>
+            </a:r>
+          </a:p>
+        </p:txBody>
+      </p:sp>
+      <p:sp>
+        <p:nvSpPr>
+          <p:cNvPr id="11" name="Box"/>
           <p:cNvSpPr/>
           <p:nvPr/>
         </p:nvSpPr>
         <p:spPr>
           <a:xfrm>
-            <a:off x="5602089" y="1905000"/>
-            <a:ext cx="5827911" cy="2159000"/>
+            <a:off x="5808067" y="2209800"/>
+            <a:ext cx="2785566" cy="381000"/>
           </a:xfrm>
           <a:prstGeom prst="roundRect">
             <a:avLst>
-              <a:gd name="adj" fmla="val 4705"/>
+              <a:gd name="adj" fmla="val 16666"/>
             </a:avLst>
           </a:prstGeom>
           <a:solidFill>
-            <a:srgbClr val="5B4BD6"/>
+            <a:srgbClr val="51AE84"/>
           </a:solidFill>
-          <a:ln>
-            <a:noFill/>
+          <a:ln w="19050">
+            <a:solidFill>
+              <a:srgbClr val="000000">
+                <a:alpha val="0"/>
+              </a:srgbClr>
+            </a:solidFill>
           </a:ln>
           <a:effectLst/>
         </p:spPr>
@@ -14065,25 +15469,72 @@
       </p:sp>
       <p:sp>
         <p:nvSpPr>
-          <p:cNvPr id="8" name="Box"/>
+          <p:cNvPr id="12" name="Text"/>
+          <p:cNvSpPr txBox="1"/>
+          <p:nvPr/>
+        </p:nvSpPr>
+        <p:spPr>
+          <a:xfrm>
+            <a:off x="7032526" y="2287867"/>
+            <a:ext cx="346646" cy="224866"/>
+          </a:xfrm>
+          <a:prstGeom prst="rect">
+            <a:avLst/>
+          </a:prstGeom>
+          <a:noFill/>
+        </p:spPr>
+        <p:txBody>
+          <a:bodyPr wrap="square" lIns="0" rIns="0" tIns="0" bIns="0" anchor="t">
+            <a:noAutofit/>
+          </a:bodyPr>
+          <a:lstStyle/>
+          <a:p>
+            <a:pPr algn="l">
+              <a:lnSpc>
+                <a:spcPts val="1770"/>
+              </a:lnSpc>
+              <a:spcBef>
+                <a:spcPts val="0"/>
+              </a:spcBef>
+              <a:spcAft>
+                <a:spcPts val="0"/>
+              </a:spcAft>
+            </a:pPr>
+            <a:r>
+              <a:rPr sz="1300" b="1" i="0">
+                <a:solidFill>
+                  <a:srgbClr val="FFFFFF"/>
+                </a:solidFill>
+                <a:latin typeface="Noto Sans"/>
+              </a:rPr>
+              <a:t>81%</a:t>
+            </a:r>
+          </a:p>
+        </p:txBody>
+      </p:sp>
+      <p:sp>
+        <p:nvSpPr>
+          <p:cNvPr id="13" name="Box"/>
           <p:cNvSpPr/>
           <p:nvPr/>
         </p:nvSpPr>
         <p:spPr>
           <a:xfrm>
-            <a:off x="5665589" y="1905000"/>
-            <a:ext cx="5764411" cy="2159000"/>
+            <a:off x="8644434" y="2209800"/>
+            <a:ext cx="2785467" cy="381000"/>
           </a:xfrm>
           <a:prstGeom prst="roundRect">
             <a:avLst>
-              <a:gd name="adj" fmla="val 1764"/>
+              <a:gd name="adj" fmla="val 16666"/>
             </a:avLst>
           </a:prstGeom>
           <a:solidFill>
-            <a:srgbClr val="FFFFFF"/>
+            <a:srgbClr val="39A373"/>
           </a:solidFill>
-          <a:ln>
-            <a:noFill/>
+          <a:ln w="19050">
+            <a:solidFill>
+              <a:srgbClr val="1D2433"/>
+            </a:solidFill>
           </a:ln>
           <a:effectLst/>
         </p:spPr>
@@ -14097,14 +15548,14 @@
       </p:sp>
       <p:sp>
         <p:nvSpPr>
-          <p:cNvPr id="9" name="Text"/>
-          <p:cNvSpPr txBox="1"/>
-          <p:nvPr/>
-        </p:nvSpPr>
-        <p:spPr>
-          <a:xfrm>
-            <a:off x="5868789" y="2093862"/>
-            <a:ext cx="5518751" cy="155677"/>
+          <p:cNvPr id="14" name="Text"/>
+          <p:cNvSpPr txBox="1"/>
+          <p:nvPr/>
+        </p:nvSpPr>
+        <p:spPr>
+          <a:xfrm>
+            <a:off x="9865717" y="2287867"/>
+            <a:ext cx="353187" cy="224866"/>
           </a:xfrm>
           <a:prstGeom prst="rect">
             <a:avLst/>
@@ -14119,37 +15570,37 @@
           <a:p>
             <a:pPr algn="l">
               <a:lnSpc>
-                <a:spcPts val="1225"/>
-              </a:lnSpc>
-              <a:spcBef>
-                <a:spcPts val="0"/>
-              </a:spcBef>
-              <a:spcAft>
-                <a:spcPts val="0"/>
-              </a:spcAft>
-            </a:pPr>
-            <a:r>
-              <a:rPr sz="900" b="1" i="0" spc="108">
-                <a:solidFill>
-                  <a:srgbClr val="5B4BD6"/>
-                </a:solidFill>
-                <a:latin typeface="Noto Sans"/>
-              </a:rPr>
-              <a:t>NOW</a:t>
-            </a:r>
-          </a:p>
-        </p:txBody>
-      </p:sp>
-      <p:sp>
-        <p:nvSpPr>
-          <p:cNvPr id="10" name="Text"/>
-          <p:cNvSpPr txBox="1"/>
-          <p:nvPr/>
-        </p:nvSpPr>
-        <p:spPr>
-          <a:xfrm>
-            <a:off x="5868789" y="2321560"/>
-            <a:ext cx="5518751" cy="480040"/>
+                <a:spcPts val="1770"/>
+              </a:lnSpc>
+              <a:spcBef>
+                <a:spcPts val="0"/>
+              </a:spcBef>
+              <a:spcAft>
+                <a:spcPts val="0"/>
+              </a:spcAft>
+            </a:pPr>
+            <a:r>
+              <a:rPr sz="1300" b="1" i="0">
+                <a:solidFill>
+                  <a:srgbClr val="FFFFFF"/>
+                </a:solidFill>
+                <a:latin typeface="Noto Sans"/>
+              </a:rPr>
+              <a:t>94%</a:t>
+            </a:r>
+          </a:p>
+        </p:txBody>
+      </p:sp>
+      <p:sp>
+        <p:nvSpPr>
+          <p:cNvPr id="15" name="Text"/>
+          <p:cNvSpPr txBox="1"/>
+          <p:nvPr/>
+        </p:nvSpPr>
+        <p:spPr>
+          <a:xfrm>
+            <a:off x="762000" y="2670850"/>
+            <a:ext cx="2119122" cy="181610"/>
           </a:xfrm>
           <a:prstGeom prst="rect">
             <a:avLst/>
@@ -14164,48 +15615,97 @@
           <a:p>
             <a:pPr algn="l">
               <a:lnSpc>
-                <a:spcPts val="1889"/>
-              </a:lnSpc>
-              <a:spcBef>
-                <a:spcPts val="0"/>
-              </a:spcBef>
-              <a:spcAft>
-                <a:spcPts val="0"/>
-              </a:spcAft>
-            </a:pPr>
-            <a:r>
-              <a:rPr sz="1350" b="0" i="0">
+                <a:spcPts val="1430"/>
+              </a:lnSpc>
+              <a:spcBef>
+                <a:spcPts val="0"/>
+              </a:spcBef>
+              <a:spcAft>
+                <a:spcPts val="0"/>
+              </a:spcAft>
+            </a:pPr>
+            <a:r>
+              <a:rPr sz="1300" b="1" i="0">
                 <a:solidFill>
                   <a:srgbClr val="1D2433"/>
                 </a:solidFill>
                 <a:latin typeface="Noto Sans"/>
               </a:rPr>
-              <a:t>Every tool has a hook, a ledger line and a Friday deadline, so anyone can see what is in and what is out.</a:t>
-            </a:r>
-          </a:p>
-        </p:txBody>
-      </p:sp>
-      <p:sp>
-        <p:nvSpPr>
-          <p:cNvPr id="11" name="Box"/>
+              <a:t>On time</a:t>
+            </a:r>
+          </a:p>
+        </p:txBody>
+      </p:sp>
+      <p:sp>
+        <p:nvSpPr>
+          <p:cNvPr id="16" name="Text"/>
+          <p:cNvSpPr txBox="1"/>
+          <p:nvPr/>
+        </p:nvSpPr>
+        <p:spPr>
+          <a:xfrm>
+            <a:off x="762000" y="2849245"/>
+            <a:ext cx="2119122" cy="137160"/>
+          </a:xfrm>
+          <a:prstGeom prst="rect">
+            <a:avLst/>
+          </a:prstGeom>
+          <a:noFill/>
+        </p:spPr>
+        <p:txBody>
+          <a:bodyPr wrap="square" lIns="0" rIns="0" tIns="0" bIns="0" anchor="t">
+            <a:noAutofit/>
+          </a:bodyPr>
+          <a:lstStyle/>
+          <a:p>
+            <a:pPr algn="l">
+              <a:lnSpc>
+                <a:spcPts val="1080"/>
+              </a:lnSpc>
+              <a:spcBef>
+                <a:spcPts val="0"/>
+              </a:spcBef>
+              <a:spcAft>
+                <a:spcPts val="0"/>
+              </a:spcAft>
+            </a:pPr>
+            <a:r>
+              <a:rPr sz="900" b="0" i="0">
+                <a:solidFill>
+                  <a:srgbClr val="8A8F9C"/>
+                </a:solidFill>
+                <a:latin typeface="Noto Sans"/>
+              </a:rPr>
+              <a:t>by the Friday deadline</a:t>
+            </a:r>
+          </a:p>
+        </p:txBody>
+      </p:sp>
+      <p:sp>
+        <p:nvSpPr>
+          <p:cNvPr id="17" name="Box"/>
           <p:cNvSpPr/>
           <p:nvPr/>
         </p:nvSpPr>
         <p:spPr>
           <a:xfrm>
-            <a:off x="762000" y="4241800"/>
-            <a:ext cx="3462834" cy="1460500"/>
+            <a:off x="2971800" y="2641600"/>
+            <a:ext cx="2785467" cy="381000"/>
           </a:xfrm>
           <a:prstGeom prst="roundRect">
             <a:avLst>
-              <a:gd name="adj" fmla="val 6086"/>
+              <a:gd name="adj" fmla="val 16666"/>
             </a:avLst>
           </a:prstGeom>
           <a:solidFill>
-            <a:srgbClr val="ECE9FB"/>
+            <a:srgbClr val="8ECAAF"/>
           </a:solidFill>
-          <a:ln>
-            <a:noFill/>
+          <a:ln w="19050">
+            <a:solidFill>
+              <a:srgbClr val="000000">
+                <a:alpha val="0"/>
+              </a:srgbClr>
+            </a:solidFill>
           </a:ln>
           <a:effectLst/>
         </p:spPr>
@@ -14219,14 +15719,14 @@
       </p:sp>
       <p:sp>
         <p:nvSpPr>
-          <p:cNvPr id="12" name="Text"/>
-          <p:cNvSpPr txBox="1"/>
-          <p:nvPr/>
-        </p:nvSpPr>
-        <p:spPr>
-          <a:xfrm>
-            <a:off x="914400" y="4379862"/>
-            <a:ext cx="3252775" cy="155677"/>
+          <p:cNvPr id="18" name="Text"/>
+          <p:cNvSpPr txBox="1"/>
+          <p:nvPr/>
+        </p:nvSpPr>
+        <p:spPr>
+          <a:xfrm>
+            <a:off x="4196259" y="2719667"/>
+            <a:ext cx="346646" cy="224866"/>
           </a:xfrm>
           <a:prstGeom prst="rect">
             <a:avLst/>
@@ -14241,93 +15741,52 @@
           <a:p>
             <a:pPr algn="l">
               <a:lnSpc>
-                <a:spcPts val="1225"/>
-              </a:lnSpc>
-              <a:spcBef>
-                <a:spcPts val="0"/>
-              </a:spcBef>
-              <a:spcAft>
-                <a:spcPts val="0"/>
-              </a:spcAft>
-            </a:pPr>
-            <a:r>
-              <a:rPr sz="900" b="1" i="0" spc="90">
-                <a:solidFill>
-                  <a:srgbClr val="5B4BD6"/>
-                </a:solidFill>
-                <a:latin typeface="Noto Sans"/>
-              </a:rPr>
-              <a:t>FINDING</a:t>
-            </a:r>
-          </a:p>
-        </p:txBody>
-      </p:sp>
-      <p:sp>
-        <p:nvSpPr>
-          <p:cNvPr id="13" name="Text"/>
-          <p:cNvSpPr txBox="1"/>
-          <p:nvPr/>
-        </p:nvSpPr>
-        <p:spPr>
-          <a:xfrm>
-            <a:off x="914400" y="4583112"/>
-            <a:ext cx="3252775" cy="438150"/>
-          </a:xfrm>
-          <a:prstGeom prst="rect">
-            <a:avLst/>
-          </a:prstGeom>
-          <a:noFill/>
-        </p:spPr>
-        <p:txBody>
-          <a:bodyPr wrap="square" lIns="0" rIns="0" tIns="0" bIns="0" anchor="t">
-            <a:noAutofit/>
-          </a:bodyPr>
-          <a:lstStyle/>
-          <a:p>
-            <a:pPr algn="l">
-              <a:lnSpc>
-                <a:spcPts val="1725"/>
-              </a:lnSpc>
-              <a:spcBef>
-                <a:spcPts val="0"/>
-              </a:spcBef>
-              <a:spcAft>
-                <a:spcPts val="0"/>
-              </a:spcAft>
-            </a:pPr>
-            <a:r>
-              <a:rPr sz="1250" b="0" i="0">
+                <a:spcPts val="1770"/>
+              </a:lnSpc>
+              <a:spcBef>
+                <a:spcPts val="0"/>
+              </a:spcBef>
+              <a:spcAft>
+                <a:spcPts val="0"/>
+              </a:spcAft>
+            </a:pPr>
+            <a:r>
+              <a:rPr sz="1300" b="1" i="0">
                 <a:solidFill>
                   <a:srgbClr val="1D2433"/>
                 </a:solidFill>
                 <a:latin typeface="Noto Sans"/>
               </a:rPr>
-              <a:t>A shelf of hooks, each labelled with the tool's name.</a:t>
-            </a:r>
-          </a:p>
-        </p:txBody>
-      </p:sp>
-      <p:sp>
-        <p:nvSpPr>
-          <p:cNvPr id="14" name="Box"/>
+              <a:t>48%</a:t>
+            </a:r>
+          </a:p>
+        </p:txBody>
+      </p:sp>
+      <p:sp>
+        <p:nvSpPr>
+          <p:cNvPr id="19" name="Box"/>
           <p:cNvSpPr/>
           <p:nvPr/>
         </p:nvSpPr>
         <p:spPr>
           <a:xfrm>
-            <a:off x="4364534" y="4241800"/>
-            <a:ext cx="3462834" cy="1460500"/>
+            <a:off x="5808067" y="2641600"/>
+            <a:ext cx="2785566" cy="381000"/>
           </a:xfrm>
           <a:prstGeom prst="roundRect">
             <a:avLst>
-              <a:gd name="adj" fmla="val 6086"/>
+              <a:gd name="adj" fmla="val 16666"/>
             </a:avLst>
           </a:prstGeom>
           <a:solidFill>
-            <a:srgbClr val="ECE9FB"/>
+            <a:srgbClr val="65B892"/>
           </a:solidFill>
-          <a:ln>
-            <a:noFill/>
+          <a:ln w="19050">
+            <a:solidFill>
+              <a:srgbClr val="000000">
+                <a:alpha val="0"/>
+              </a:srgbClr>
+            </a:solidFill>
           </a:ln>
           <a:effectLst/>
         </p:spPr>
@@ -14341,14 +15800,14 @@
       </p:sp>
       <p:sp>
         <p:nvSpPr>
-          <p:cNvPr id="15" name="Text"/>
-          <p:cNvSpPr txBox="1"/>
-          <p:nvPr/>
-        </p:nvSpPr>
-        <p:spPr>
-          <a:xfrm>
-            <a:off x="4516934" y="4379862"/>
-            <a:ext cx="3252775" cy="155677"/>
+          <p:cNvPr id="20" name="Text"/>
+          <p:cNvSpPr txBox="1"/>
+          <p:nvPr/>
+        </p:nvSpPr>
+        <p:spPr>
+          <a:xfrm>
+            <a:off x="7032526" y="2719667"/>
+            <a:ext cx="346646" cy="224866"/>
           </a:xfrm>
           <a:prstGeom prst="rect">
             <a:avLst/>
@@ -14363,93 +15822,50 @@
           <a:p>
             <a:pPr algn="l">
               <a:lnSpc>
-                <a:spcPts val="1225"/>
-              </a:lnSpc>
-              <a:spcBef>
-                <a:spcPts val="0"/>
-              </a:spcBef>
-              <a:spcAft>
-                <a:spcPts val="0"/>
-              </a:spcAft>
-            </a:pPr>
-            <a:r>
-              <a:rPr sz="900" b="1" i="0" spc="90">
-                <a:solidFill>
-                  <a:srgbClr val="5B4BD6"/>
-                </a:solidFill>
-                <a:latin typeface="Noto Sans"/>
-              </a:rPr>
-              <a:t>TRUSTING</a:t>
-            </a:r>
-          </a:p>
-        </p:txBody>
-      </p:sp>
-      <p:sp>
-        <p:nvSpPr>
-          <p:cNvPr id="16" name="Text"/>
-          <p:cNvSpPr txBox="1"/>
-          <p:nvPr/>
-        </p:nvSpPr>
-        <p:spPr>
-          <a:xfrm>
-            <a:off x="4516934" y="4583112"/>
-            <a:ext cx="3252775" cy="438150"/>
-          </a:xfrm>
-          <a:prstGeom prst="rect">
-            <a:avLst/>
-          </a:prstGeom>
-          <a:noFill/>
-        </p:spPr>
-        <p:txBody>
-          <a:bodyPr wrap="square" lIns="0" rIns="0" tIns="0" bIns="0" anchor="t">
-            <a:noAutofit/>
-          </a:bodyPr>
-          <a:lstStyle/>
-          <a:p>
-            <a:pPr algn="l">
-              <a:lnSpc>
-                <a:spcPts val="1725"/>
-              </a:lnSpc>
-              <a:spcBef>
-                <a:spcPts val="0"/>
-              </a:spcBef>
-              <a:spcAft>
-                <a:spcPts val="0"/>
-              </a:spcAft>
-            </a:pPr>
-            <a:r>
-              <a:rPr sz="1250" b="0" i="0">
-                <a:solidFill>
-                  <a:srgbClr val="1D2433"/>
-                </a:solidFill>
-                <a:latin typeface="Noto Sans"/>
-              </a:rPr>
-              <a:t>A ledger line says its condition and who checked it last.</a:t>
-            </a:r>
-          </a:p>
-        </p:txBody>
-      </p:sp>
-      <p:sp>
-        <p:nvSpPr>
-          <p:cNvPr id="17" name="Box"/>
+                <a:spcPts val="1770"/>
+              </a:lnSpc>
+              <a:spcBef>
+                <a:spcPts val="0"/>
+              </a:spcBef>
+              <a:spcAft>
+                <a:spcPts val="0"/>
+              </a:spcAft>
+            </a:pPr>
+            <a:r>
+              <a:rPr sz="1300" b="1" i="0">
+                <a:solidFill>
+                  <a:srgbClr val="FFFFFF"/>
+                </a:solidFill>
+                <a:latin typeface="Noto Sans"/>
+              </a:rPr>
+              <a:t>70%</a:t>
+            </a:r>
+          </a:p>
+        </p:txBody>
+      </p:sp>
+      <p:sp>
+        <p:nvSpPr>
+          <p:cNvPr id="21" name="Box"/>
           <p:cNvSpPr/>
           <p:nvPr/>
         </p:nvSpPr>
         <p:spPr>
           <a:xfrm>
-            <a:off x="7967067" y="4241800"/>
-            <a:ext cx="3462834" cy="1460500"/>
+            <a:off x="8644434" y="2641600"/>
+            <a:ext cx="2785467" cy="381000"/>
           </a:xfrm>
           <a:prstGeom prst="roundRect">
             <a:avLst>
-              <a:gd name="adj" fmla="val 6086"/>
+              <a:gd name="adj" fmla="val 16666"/>
             </a:avLst>
           </a:prstGeom>
           <a:solidFill>
-            <a:srgbClr val="ECE9FB"/>
+            <a:srgbClr val="42A779"/>
           </a:solidFill>
-          <a:ln>
-            <a:noFill/>
+          <a:ln w="19050">
+            <a:solidFill>
+              <a:srgbClr val="1D2433"/>
+            </a:solidFill>
           </a:ln>
           <a:effectLst/>
         </p:spPr>
@@ -14463,14 +15879,14 @@
       </p:sp>
       <p:sp>
         <p:nvSpPr>
-          <p:cNvPr id="18" name="Text"/>
-          <p:cNvSpPr txBox="1"/>
-          <p:nvPr/>
-        </p:nvSpPr>
-        <p:spPr>
-          <a:xfrm>
-            <a:off x="8119467" y="4379862"/>
-            <a:ext cx="3252775" cy="155677"/>
+          <p:cNvPr id="22" name="Text"/>
+          <p:cNvSpPr txBox="1"/>
+          <p:nvPr/>
+        </p:nvSpPr>
+        <p:spPr>
+          <a:xfrm>
+            <a:off x="9865717" y="2719667"/>
+            <a:ext cx="353187" cy="224866"/>
           </a:xfrm>
           <a:prstGeom prst="rect">
             <a:avLst/>
@@ -14485,37 +15901,37 @@
           <a:p>
             <a:pPr algn="l">
               <a:lnSpc>
-                <a:spcPts val="1225"/>
-              </a:lnSpc>
-              <a:spcBef>
-                <a:spcPts val="0"/>
-              </a:spcBef>
-              <a:spcAft>
-                <a:spcPts val="0"/>
-              </a:spcAft>
-            </a:pPr>
-            <a:r>
-              <a:rPr sz="900" b="1" i="0" spc="90">
-                <a:solidFill>
-                  <a:srgbClr val="5B4BD6"/>
-                </a:solidFill>
-                <a:latin typeface="Noto Sans"/>
-              </a:rPr>
-              <a:t>RETURNING</a:t>
-            </a:r>
-          </a:p>
-        </p:txBody>
-      </p:sp>
-      <p:sp>
-        <p:nvSpPr>
-          <p:cNvPr id="19" name="Text"/>
-          <p:cNvSpPr txBox="1"/>
-          <p:nvPr/>
-        </p:nvSpPr>
-        <p:spPr>
-          <a:xfrm>
-            <a:off x="8119467" y="4583112"/>
-            <a:ext cx="3252775" cy="438150"/>
+                <a:spcPts val="1770"/>
+              </a:lnSpc>
+              <a:spcBef>
+                <a:spcPts val="0"/>
+              </a:spcBef>
+              <a:spcAft>
+                <a:spcPts val="0"/>
+              </a:spcAft>
+            </a:pPr>
+            <a:r>
+              <a:rPr sz="1300" b="1" i="0">
+                <a:solidFill>
+                  <a:srgbClr val="FFFFFF"/>
+                </a:solidFill>
+                <a:latin typeface="Noto Sans"/>
+              </a:rPr>
+              <a:t>89%</a:t>
+            </a:r>
+          </a:p>
+        </p:txBody>
+      </p:sp>
+      <p:sp>
+        <p:nvSpPr>
+          <p:cNvPr id="23" name="Text"/>
+          <p:cNvSpPr txBox="1"/>
+          <p:nvPr/>
+        </p:nvSpPr>
+        <p:spPr>
+          <a:xfrm>
+            <a:off x="762000" y="3102650"/>
+            <a:ext cx="2119122" cy="181610"/>
           </a:xfrm>
           <a:prstGeom prst="rect">
             <a:avLst/>
@@ -14530,30 +15946,316 @@
           <a:p>
             <a:pPr algn="l">
               <a:lnSpc>
-                <a:spcPts val="1725"/>
-              </a:lnSpc>
-              <a:spcBef>
-                <a:spcPts val="0"/>
-              </a:spcBef>
-              <a:spcAft>
-                <a:spcPts val="0"/>
-              </a:spcAft>
-            </a:pPr>
-            <a:r>
-              <a:rPr sz="1250" b="0" i="0">
+                <a:spcPts val="1430"/>
+              </a:lnSpc>
+              <a:spcBef>
+                <a:spcPts val="0"/>
+              </a:spcBef>
+              <a:spcAft>
+                <a:spcPts val="0"/>
+              </a:spcAft>
+            </a:pPr>
+            <a:r>
+              <a:rPr sz="1300" b="1" i="0">
                 <a:solidFill>
                   <a:srgbClr val="1D2433"/>
                 </a:solidFill>
                 <a:latin typeface="Noto Sans"/>
               </a:rPr>
-              <a:t>A tool hung back clean is the only sign-off it needs.</a:t>
-            </a:r>
-          </a:p>
-        </p:txBody>
-      </p:sp>
-      <p:sp>
-        <p:nvSpPr>
-          <p:cNvPr id="20" name="Box"/>
+              <a:t>Clean</a:t>
+            </a:r>
+          </a:p>
+        </p:txBody>
+      </p:sp>
+      <p:sp>
+        <p:nvSpPr>
+          <p:cNvPr id="24" name="Text"/>
+          <p:cNvSpPr txBox="1"/>
+          <p:nvPr/>
+        </p:nvSpPr>
+        <p:spPr>
+          <a:xfrm>
+            <a:off x="762000" y="3281045"/>
+            <a:ext cx="2119122" cy="137160"/>
+          </a:xfrm>
+          <a:prstGeom prst="rect">
+            <a:avLst/>
+          </a:prstGeom>
+          <a:noFill/>
+        </p:spPr>
+        <p:txBody>
+          <a:bodyPr wrap="square" lIns="0" rIns="0" tIns="0" bIns="0" anchor="t">
+            <a:noAutofit/>
+          </a:bodyPr>
+          <a:lstStyle/>
+          <a:p>
+            <a:pPr algn="l">
+              <a:lnSpc>
+                <a:spcPts val="1080"/>
+              </a:lnSpc>
+              <a:spcBef>
+                <a:spcPts val="0"/>
+              </a:spcBef>
+              <a:spcAft>
+                <a:spcPts val="0"/>
+              </a:spcAft>
+            </a:pPr>
+            <a:r>
+              <a:rPr sz="900" b="0" i="0">
+                <a:solidFill>
+                  <a:srgbClr val="8A8F9C"/>
+                </a:solidFill>
+                <a:latin typeface="Noto Sans"/>
+              </a:rPr>
+              <a:t>hung back without a note</a:t>
+            </a:r>
+          </a:p>
+        </p:txBody>
+      </p:sp>
+      <p:sp>
+        <p:nvSpPr>
+          <p:cNvPr id="25" name="Box"/>
+          <p:cNvSpPr/>
+          <p:nvPr/>
+        </p:nvSpPr>
+        <p:spPr>
+          <a:xfrm>
+            <a:off x="2971800" y="3073400"/>
+            <a:ext cx="2785467" cy="381000"/>
+          </a:xfrm>
+          <a:prstGeom prst="roundRect">
+            <a:avLst>
+              <a:gd name="adj" fmla="val 16666"/>
+            </a:avLst>
+          </a:prstGeom>
+          <a:solidFill>
+            <a:srgbClr val="81C4A6"/>
+          </a:solidFill>
+          <a:ln w="19050">
+            <a:solidFill>
+              <a:srgbClr val="000000">
+                <a:alpha val="0"/>
+              </a:srgbClr>
+            </a:solidFill>
+          </a:ln>
+          <a:effectLst/>
+        </p:spPr>
+        <p:txBody>
+          <a:bodyPr rtlCol="0" anchor="ctr"/>
+          <a:lstStyle/>
+          <a:p>
+            <a:pPr algn="ctr"/>
+          </a:p>
+        </p:txBody>
+      </p:sp>
+      <p:sp>
+        <p:nvSpPr>
+          <p:cNvPr id="26" name="Text"/>
+          <p:cNvSpPr txBox="1"/>
+          <p:nvPr/>
+        </p:nvSpPr>
+        <p:spPr>
+          <a:xfrm>
+            <a:off x="4196259" y="3151467"/>
+            <a:ext cx="346646" cy="224866"/>
+          </a:xfrm>
+          <a:prstGeom prst="rect">
+            <a:avLst/>
+          </a:prstGeom>
+          <a:noFill/>
+        </p:spPr>
+        <p:txBody>
+          <a:bodyPr wrap="square" lIns="0" rIns="0" tIns="0" bIns="0" anchor="t">
+            <a:noAutofit/>
+          </a:bodyPr>
+          <a:lstStyle/>
+          <a:p>
+            <a:pPr algn="l">
+              <a:lnSpc>
+                <a:spcPts val="1770"/>
+              </a:lnSpc>
+              <a:spcBef>
+                <a:spcPts val="0"/>
+              </a:spcBef>
+              <a:spcAft>
+                <a:spcPts val="0"/>
+              </a:spcAft>
+            </a:pPr>
+            <a:r>
+              <a:rPr sz="1300" b="1" i="0">
+                <a:solidFill>
+                  <a:srgbClr val="1D2433"/>
+                </a:solidFill>
+                <a:latin typeface="Noto Sans"/>
+              </a:rPr>
+              <a:t>55%</a:t>
+            </a:r>
+          </a:p>
+        </p:txBody>
+      </p:sp>
+      <p:sp>
+        <p:nvSpPr>
+          <p:cNvPr id="27" name="Box"/>
+          <p:cNvSpPr/>
+          <p:nvPr/>
+        </p:nvSpPr>
+        <p:spPr>
+          <a:xfrm>
+            <a:off x="5808067" y="3073400"/>
+            <a:ext cx="2785566" cy="381000"/>
+          </a:xfrm>
+          <a:prstGeom prst="roundRect">
+            <a:avLst>
+              <a:gd name="adj" fmla="val 16666"/>
+            </a:avLst>
+          </a:prstGeom>
+          <a:solidFill>
+            <a:srgbClr val="58B289"/>
+          </a:solidFill>
+          <a:ln w="19050">
+            <a:solidFill>
+              <a:srgbClr val="000000">
+                <a:alpha val="0"/>
+              </a:srgbClr>
+            </a:solidFill>
+          </a:ln>
+          <a:effectLst/>
+        </p:spPr>
+        <p:txBody>
+          <a:bodyPr rtlCol="0" anchor="ctr"/>
+          <a:lstStyle/>
+          <a:p>
+            <a:pPr algn="ctr"/>
+          </a:p>
+        </p:txBody>
+      </p:sp>
+      <p:sp>
+        <p:nvSpPr>
+          <p:cNvPr id="28" name="Text"/>
+          <p:cNvSpPr txBox="1"/>
+          <p:nvPr/>
+        </p:nvSpPr>
+        <p:spPr>
+          <a:xfrm>
+            <a:off x="7032526" y="3151467"/>
+            <a:ext cx="346646" cy="224866"/>
+          </a:xfrm>
+          <a:prstGeom prst="rect">
+            <a:avLst/>
+          </a:prstGeom>
+          <a:noFill/>
+        </p:spPr>
+        <p:txBody>
+          <a:bodyPr wrap="square" lIns="0" rIns="0" tIns="0" bIns="0" anchor="t">
+            <a:noAutofit/>
+          </a:bodyPr>
+          <a:lstStyle/>
+          <a:p>
+            <a:pPr algn="l">
+              <a:lnSpc>
+                <a:spcPts val="1770"/>
+              </a:lnSpc>
+              <a:spcBef>
+                <a:spcPts val="0"/>
+              </a:spcBef>
+              <a:spcAft>
+                <a:spcPts val="0"/>
+              </a:spcAft>
+            </a:pPr>
+            <a:r>
+              <a:rPr sz="1300" b="1" i="0">
+                <a:solidFill>
+                  <a:srgbClr val="FFFFFF"/>
+                </a:solidFill>
+                <a:latin typeface="Noto Sans"/>
+              </a:rPr>
+              <a:t>77%</a:t>
+            </a:r>
+          </a:p>
+        </p:txBody>
+      </p:sp>
+      <p:sp>
+        <p:nvSpPr>
+          <p:cNvPr id="29" name="Box"/>
+          <p:cNvSpPr/>
+          <p:nvPr/>
+        </p:nvSpPr>
+        <p:spPr>
+          <a:xfrm>
+            <a:off x="8644434" y="3073400"/>
+            <a:ext cx="2785467" cy="381000"/>
+          </a:xfrm>
+          <a:prstGeom prst="roundRect">
+            <a:avLst>
+              <a:gd name="adj" fmla="val 16666"/>
+            </a:avLst>
+          </a:prstGeom>
+          <a:solidFill>
+            <a:srgbClr val="3FA677"/>
+          </a:solidFill>
+          <a:ln w="19050">
+            <a:solidFill>
+              <a:srgbClr val="1D2433"/>
+            </a:solidFill>
+          </a:ln>
+          <a:effectLst/>
+        </p:spPr>
+        <p:txBody>
+          <a:bodyPr rtlCol="0" anchor="ctr"/>
+          <a:lstStyle/>
+          <a:p>
+            <a:pPr algn="ctr"/>
+          </a:p>
+        </p:txBody>
+      </p:sp>
+      <p:sp>
+        <p:nvSpPr>
+          <p:cNvPr id="30" name="Text"/>
+          <p:cNvSpPr txBox="1"/>
+          <p:nvPr/>
+        </p:nvSpPr>
+        <p:spPr>
+          <a:xfrm>
+            <a:off x="9865717" y="3151467"/>
+            <a:ext cx="353187" cy="224866"/>
+          </a:xfrm>
+          <a:prstGeom prst="rect">
+            <a:avLst/>
+          </a:prstGeom>
+          <a:noFill/>
+        </p:spPr>
+        <p:txBody>
+          <a:bodyPr wrap="square" lIns="0" rIns="0" tIns="0" bIns="0" anchor="t">
+            <a:noAutofit/>
+          </a:bodyPr>
+          <a:lstStyle/>
+          <a:p>
+            <a:pPr algn="l">
+              <a:lnSpc>
+                <a:spcPts val="1770"/>
+              </a:lnSpc>
+              <a:spcBef>
+                <a:spcPts val="0"/>
+              </a:spcBef>
+              <a:spcAft>
+                <a:spcPts val="0"/>
+              </a:spcAft>
+            </a:pPr>
+            <a:r>
+              <a:rPr sz="1300" b="1" i="0">
+                <a:solidFill>
+                  <a:srgbClr val="FFFFFF"/>
+                </a:solidFill>
+                <a:latin typeface="Noto Sans"/>
+              </a:rPr>
+              <a:t>91%</a:t>
+            </a:r>
+          </a:p>
+        </p:txBody>
+      </p:sp>
+      <p:sp>
+        <p:nvSpPr>
+          <p:cNvPr id="31" name="Box"/>
           <p:cNvSpPr/>
           <p:nvPr/>
         </p:nvSpPr>
@@ -14583,14 +16285,14 @@
       </p:sp>
       <p:sp>
         <p:nvSpPr>
-          <p:cNvPr id="21" name="Text"/>
+          <p:cNvPr id="32" name="Text"/>
           <p:cNvSpPr txBox="1"/>
           <p:nvPr/>
         </p:nvSpPr>
         <p:spPr>
           <a:xfrm>
             <a:off x="762000" y="6495561"/>
-            <a:ext cx="1339850" cy="147028"/>
+            <a:ext cx="2622550" cy="147028"/>
           </a:xfrm>
           <a:prstGeom prst="rect">
             <a:avLst/>
@@ -14630,14 +16332,14 @@
                 </a:solidFill>
                 <a:latin typeface="Noto Sans"/>
               </a:rPr>
-              <a:t> Invented example</a:t>
-            </a:r>
-          </a:p>
-        </p:txBody>
-      </p:sp>
-      <p:sp>
-        <p:nvSpPr>
-          <p:cNvPr id="22" name="Text"/>
+              <a:t> Invented example; the figures are made up</a:t>
+            </a:r>
+          </a:p>
+        </p:txBody>
+      </p:sp>
+      <p:sp>
+        <p:nvSpPr>
+          <p:cNvPr id="33" name="Text"/>
           <p:cNvSpPr txBox="1"/>
           <p:nvPr/>
         </p:nvSpPr>
@@ -14675,7 +16377,7 @@
                 </a:solidFill>
                 <a:latin typeface="Noto Sans"/>
               </a:rPr>
-              <a:t>8 / 12</a:t>
+              <a:t>8 / 13</a:t>
             </a:r>
           </a:p>
         </p:txBody>
@@ -14746,7 +16448,7 @@
                 </a:solidFill>
                 <a:latin typeface="Noto Sans"/>
               </a:rPr>
-              <a:t>Keep the rules few and the hooks labelled</a:t>
+              <a:t>From a shared garage to a labelled shed</a:t>
             </a:r>
           </a:p>
         </p:txBody>
@@ -14791,74 +16493,153 @@
                 </a:solidFill>
                 <a:latin typeface="Noto Sans"/>
               </a:rPr>
-              <a:t>WHAT WORKS, WHAT DOES NOT</a:t>
-            </a:r>
-          </a:p>
-        </p:txBody>
-      </p:sp>
-      <p:sp>
-        <p:nvSpPr>
-          <p:cNvPr id="4" name="Text"/>
-          <p:cNvSpPr txBox="1"/>
-          <p:nvPr/>
-        </p:nvSpPr>
-        <p:spPr>
-          <a:xfrm>
-            <a:off x="762000" y="1389757"/>
-            <a:ext cx="9810750" cy="269875"/>
-          </a:xfrm>
-          <a:prstGeom prst="rect">
-            <a:avLst/>
-          </a:prstGeom>
-          <a:noFill/>
-        </p:spPr>
-        <p:txBody>
-          <a:bodyPr wrap="square" lIns="0" rIns="0" tIns="0" bIns="0" anchor="t">
-            <a:noAutofit/>
-          </a:bodyPr>
-          <a:lstStyle/>
-          <a:p>
-            <a:pPr algn="l">
-              <a:lnSpc>
-                <a:spcPts val="2125"/>
-              </a:lnSpc>
-              <a:spcBef>
-                <a:spcPts val="0"/>
-              </a:spcBef>
-              <a:spcAft>
-                <a:spcPts val="0"/>
-              </a:spcAft>
-            </a:pPr>
-            <a:r>
-              <a:rPr sz="1700" b="0" i="0">
-                <a:solidFill>
-                  <a:srgbClr val="4A5163"/>
-                </a:solidFill>
-                <a:latin typeface="Noto Sans"/>
-              </a:rPr>
-              <a:t>Two lists, four short lines each.</a:t>
-            </a:r>
-          </a:p>
-        </p:txBody>
-      </p:sp>
-      <p:sp>
-        <p:nvSpPr>
-          <p:cNvPr id="5" name="Box"/>
+              <a:t>BEFORE AND AFTER</a:t>
+            </a:r>
+          </a:p>
+        </p:txBody>
+      </p:sp>
+      <p:sp>
+        <p:nvSpPr>
+          <p:cNvPr id="4" name="Box"/>
           <p:cNvSpPr/>
           <p:nvPr/>
         </p:nvSpPr>
         <p:spPr>
           <a:xfrm>
-            <a:off x="762000" y="2159000"/>
-            <a:ext cx="5245100" cy="2384822"/>
+            <a:off x="762000" y="1905000"/>
+            <a:ext cx="4662289" cy="2159000"/>
           </a:xfrm>
           <a:prstGeom prst="roundRect">
             <a:avLst>
-              <a:gd name="adj" fmla="val 4260"/>
+              <a:gd name="adj" fmla="val 4705"/>
             </a:avLst>
           </a:prstGeom>
           <a:solidFill>
-            <a:srgbClr val="2E9E6B"/>
+            <a:srgbClr val="FFFFFF"/>
+          </a:solidFill>
+          <a:ln w="6350">
+            <a:solidFill>
+              <a:srgbClr val="DCD9D0"/>
+            </a:solidFill>
+          </a:ln>
+          <a:effectLst/>
+        </p:spPr>
+        <p:txBody>
+          <a:bodyPr rtlCol="0" anchor="ctr"/>
+          <a:lstStyle/>
+          <a:p>
+            <a:pPr algn="ctr"/>
+          </a:p>
+        </p:txBody>
+      </p:sp>
+      <p:sp>
+        <p:nvSpPr>
+          <p:cNvPr id="5" name="Text"/>
+          <p:cNvSpPr txBox="1"/>
+          <p:nvPr/>
+        </p:nvSpPr>
+        <p:spPr>
+          <a:xfrm>
+            <a:off x="965200" y="2093862"/>
+            <a:ext cx="4383566" cy="155677"/>
+          </a:xfrm>
+          <a:prstGeom prst="rect">
+            <a:avLst/>
+          </a:prstGeom>
+          <a:noFill/>
+        </p:spPr>
+        <p:txBody>
+          <a:bodyPr wrap="square" lIns="0" rIns="0" tIns="0" bIns="0" anchor="t">
+            <a:noAutofit/>
+          </a:bodyPr>
+          <a:lstStyle/>
+          <a:p>
+            <a:pPr algn="l">
+              <a:lnSpc>
+                <a:spcPts val="1225"/>
+              </a:lnSpc>
+              <a:spcBef>
+                <a:spcPts val="0"/>
+              </a:spcBef>
+              <a:spcAft>
+                <a:spcPts val="0"/>
+              </a:spcAft>
+            </a:pPr>
+            <a:r>
+              <a:rPr sz="900" b="1" i="0" spc="108">
+                <a:solidFill>
+                  <a:srgbClr val="8A8F9C"/>
+                </a:solidFill>
+                <a:latin typeface="Noto Sans"/>
+              </a:rPr>
+              <a:t>BEFORE</a:t>
+            </a:r>
+          </a:p>
+        </p:txBody>
+      </p:sp>
+      <p:sp>
+        <p:nvSpPr>
+          <p:cNvPr id="6" name="Text"/>
+          <p:cNvSpPr txBox="1"/>
+          <p:nvPr/>
+        </p:nvSpPr>
+        <p:spPr>
+          <a:xfrm>
+            <a:off x="965200" y="2321560"/>
+            <a:ext cx="4383566" cy="720050"/>
+          </a:xfrm>
+          <a:prstGeom prst="rect">
+            <a:avLst/>
+          </a:prstGeom>
+          <a:noFill/>
+        </p:spPr>
+        <p:txBody>
+          <a:bodyPr wrap="square" lIns="0" rIns="0" tIns="0" bIns="0" anchor="t">
+            <a:noAutofit/>
+          </a:bodyPr>
+          <a:lstStyle/>
+          <a:p>
+            <a:pPr algn="l">
+              <a:lnSpc>
+                <a:spcPts val="1889"/>
+              </a:lnSpc>
+              <a:spcBef>
+                <a:spcPts val="0"/>
+              </a:spcBef>
+              <a:spcAft>
+                <a:spcPts val="0"/>
+              </a:spcAft>
+            </a:pPr>
+            <a:r>
+              <a:rPr sz="1350" b="0" i="0">
+                <a:solidFill>
+                  <a:srgbClr val="4A5163"/>
+                </a:solidFill>
+                <a:latin typeface="Noto Sans"/>
+              </a:rPr>
+              <a:t>Tools lived in one garage. Nobody knew what was there, so people bought a second drill and the first went missing.</a:t>
+            </a:r>
+          </a:p>
+        </p:txBody>
+      </p:sp>
+      <p:sp>
+        <p:nvSpPr>
+          <p:cNvPr id="7" name="Box"/>
+          <p:cNvSpPr/>
+          <p:nvPr/>
+        </p:nvSpPr>
+        <p:spPr>
+          <a:xfrm>
+            <a:off x="5602089" y="1905000"/>
+            <a:ext cx="5827911" cy="2159000"/>
+          </a:xfrm>
+          <a:prstGeom prst="roundRect">
+            <a:avLst>
+              <a:gd name="adj" fmla="val 4705"/>
+            </a:avLst>
+          </a:prstGeom>
+          <a:solidFill>
+            <a:srgbClr val="5B4BD6"/>
           </a:solidFill>
           <a:ln>
             <a:noFill/>
@@ -14875,18 +16656,18 @@
       </p:sp>
       <p:sp>
         <p:nvSpPr>
-          <p:cNvPr id="6" name="Box"/>
+          <p:cNvPr id="8" name="Box"/>
           <p:cNvSpPr/>
           <p:nvPr/>
         </p:nvSpPr>
         <p:spPr>
           <a:xfrm>
-            <a:off x="762000" y="2222500"/>
-            <a:ext cx="5245100" cy="2321322"/>
+            <a:off x="5665589" y="1905000"/>
+            <a:ext cx="5764411" cy="2159000"/>
           </a:xfrm>
           <a:prstGeom prst="roundRect">
             <a:avLst>
-              <a:gd name="adj" fmla="val 1641"/>
+              <a:gd name="adj" fmla="val 1764"/>
             </a:avLst>
           </a:prstGeom>
           <a:solidFill>
@@ -14907,14 +16688,14 @@
       </p:sp>
       <p:sp>
         <p:nvSpPr>
-          <p:cNvPr id="7" name="Text"/>
-          <p:cNvSpPr txBox="1"/>
-          <p:nvPr/>
-        </p:nvSpPr>
-        <p:spPr>
-          <a:xfrm>
-            <a:off x="965200" y="2412022"/>
-            <a:ext cx="4983861" cy="294056"/>
+          <p:cNvPr id="9" name="Text"/>
+          <p:cNvSpPr txBox="1"/>
+          <p:nvPr/>
+        </p:nvSpPr>
+        <p:spPr>
+          <a:xfrm>
+            <a:off x="5868789" y="2093862"/>
+            <a:ext cx="5518751" cy="155677"/>
           </a:xfrm>
           <a:prstGeom prst="rect">
             <a:avLst/>
@@ -14929,45 +16710,90 @@
           <a:p>
             <a:pPr algn="l">
               <a:lnSpc>
-                <a:spcPts val="2315"/>
-              </a:lnSpc>
-              <a:spcBef>
-                <a:spcPts val="0"/>
-              </a:spcBef>
-              <a:spcAft>
-                <a:spcPts val="0"/>
-              </a:spcAft>
-            </a:pPr>
-            <a:r>
-              <a:rPr sz="1700" b="1" i="0">
-                <a:solidFill>
-                  <a:srgbClr val="2E9E6B"/>
-                </a:solidFill>
-                <a:latin typeface="Noto Sans"/>
-              </a:rPr>
-              <a:t>What works</a:t>
-            </a:r>
-          </a:p>
-        </p:txBody>
-      </p:sp>
-      <p:sp>
-        <p:nvSpPr>
-          <p:cNvPr id="8" name="Box"/>
+                <a:spcPts val="1225"/>
+              </a:lnSpc>
+              <a:spcBef>
+                <a:spcPts val="0"/>
+              </a:spcBef>
+              <a:spcAft>
+                <a:spcPts val="0"/>
+              </a:spcAft>
+            </a:pPr>
+            <a:r>
+              <a:rPr sz="900" b="1" i="0" spc="108">
+                <a:solidFill>
+                  <a:srgbClr val="5B4BD6"/>
+                </a:solidFill>
+                <a:latin typeface="Noto Sans"/>
+              </a:rPr>
+              <a:t>NOW</a:t>
+            </a:r>
+          </a:p>
+        </p:txBody>
+      </p:sp>
+      <p:sp>
+        <p:nvSpPr>
+          <p:cNvPr id="10" name="Text"/>
+          <p:cNvSpPr txBox="1"/>
+          <p:nvPr/>
+        </p:nvSpPr>
+        <p:spPr>
+          <a:xfrm>
+            <a:off x="5868789" y="2321560"/>
+            <a:ext cx="5518751" cy="480040"/>
+          </a:xfrm>
+          <a:prstGeom prst="rect">
+            <a:avLst/>
+          </a:prstGeom>
+          <a:noFill/>
+        </p:spPr>
+        <p:txBody>
+          <a:bodyPr wrap="square" lIns="0" rIns="0" tIns="0" bIns="0" anchor="t">
+            <a:noAutofit/>
+          </a:bodyPr>
+          <a:lstStyle/>
+          <a:p>
+            <a:pPr algn="l">
+              <a:lnSpc>
+                <a:spcPts val="1889"/>
+              </a:lnSpc>
+              <a:spcBef>
+                <a:spcPts val="0"/>
+              </a:spcBef>
+              <a:spcAft>
+                <a:spcPts val="0"/>
+              </a:spcAft>
+            </a:pPr>
+            <a:r>
+              <a:rPr sz="1350" b="0" i="0">
+                <a:solidFill>
+                  <a:srgbClr val="1D2433"/>
+                </a:solidFill>
+                <a:latin typeface="Noto Sans"/>
+              </a:rPr>
+              <a:t>Every tool has a hook, a ledger line and a Friday deadline, so anyone can see what is in and what is out.</a:t>
+            </a:r>
+          </a:p>
+        </p:txBody>
+      </p:sp>
+      <p:sp>
+        <p:nvSpPr>
+          <p:cNvPr id="11" name="Box"/>
           <p:cNvSpPr/>
           <p:nvPr/>
         </p:nvSpPr>
         <p:spPr>
           <a:xfrm>
-            <a:off x="990600" y="2870200"/>
-            <a:ext cx="101600" cy="101600"/>
+            <a:off x="762000" y="4241800"/>
+            <a:ext cx="3462834" cy="1460500"/>
           </a:xfrm>
           <a:prstGeom prst="roundRect">
             <a:avLst>
-              <a:gd name="adj" fmla="val 25000"/>
+              <a:gd name="adj" fmla="val 6086"/>
             </a:avLst>
           </a:prstGeom>
           <a:solidFill>
-            <a:srgbClr val="5B4BD6"/>
+            <a:srgbClr val="ECE9FB"/>
           </a:solidFill>
           <a:ln>
             <a:noFill/>
@@ -14984,14 +16810,14 @@
       </p:sp>
       <p:sp>
         <p:nvSpPr>
-          <p:cNvPr id="9" name="Text"/>
-          <p:cNvSpPr txBox="1"/>
-          <p:nvPr/>
-        </p:nvSpPr>
-        <p:spPr>
-          <a:xfrm>
-            <a:off x="1257300" y="2775268"/>
-            <a:ext cx="4682998" cy="291465"/>
+          <p:cNvPr id="12" name="Text"/>
+          <p:cNvSpPr txBox="1"/>
+          <p:nvPr/>
+        </p:nvSpPr>
+        <p:spPr>
+          <a:xfrm>
+            <a:off x="914400" y="4379862"/>
+            <a:ext cx="3252775" cy="155677"/>
           </a:xfrm>
           <a:prstGeom prst="rect">
             <a:avLst/>
@@ -15006,45 +16832,90 @@
           <a:p>
             <a:pPr algn="l">
               <a:lnSpc>
-                <a:spcPts val="2295"/>
-              </a:lnSpc>
-              <a:spcBef>
-                <a:spcPts val="0"/>
-              </a:spcBef>
-              <a:spcAft>
-                <a:spcPts val="0"/>
-              </a:spcAft>
-            </a:pPr>
-            <a:r>
-              <a:rPr sz="1700" b="0" i="0">
+                <a:spcPts val="1225"/>
+              </a:lnSpc>
+              <a:spcBef>
+                <a:spcPts val="0"/>
+              </a:spcBef>
+              <a:spcAft>
+                <a:spcPts val="0"/>
+              </a:spcAft>
+            </a:pPr>
+            <a:r>
+              <a:rPr sz="900" b="1" i="0" spc="90">
+                <a:solidFill>
+                  <a:srgbClr val="5B4BD6"/>
+                </a:solidFill>
+                <a:latin typeface="Noto Sans"/>
+              </a:rPr>
+              <a:t>FINDING</a:t>
+            </a:r>
+          </a:p>
+        </p:txBody>
+      </p:sp>
+      <p:sp>
+        <p:nvSpPr>
+          <p:cNvPr id="13" name="Text"/>
+          <p:cNvSpPr txBox="1"/>
+          <p:nvPr/>
+        </p:nvSpPr>
+        <p:spPr>
+          <a:xfrm>
+            <a:off x="914400" y="4583112"/>
+            <a:ext cx="3252775" cy="438150"/>
+          </a:xfrm>
+          <a:prstGeom prst="rect">
+            <a:avLst/>
+          </a:prstGeom>
+          <a:noFill/>
+        </p:spPr>
+        <p:txBody>
+          <a:bodyPr wrap="square" lIns="0" rIns="0" tIns="0" bIns="0" anchor="t">
+            <a:noAutofit/>
+          </a:bodyPr>
+          <a:lstStyle/>
+          <a:p>
+            <a:pPr algn="l">
+              <a:lnSpc>
+                <a:spcPts val="1725"/>
+              </a:lnSpc>
+              <a:spcBef>
+                <a:spcPts val="0"/>
+              </a:spcBef>
+              <a:spcAft>
+                <a:spcPts val="0"/>
+              </a:spcAft>
+            </a:pPr>
+            <a:r>
+              <a:rPr sz="1250" b="0" i="0">
                 <a:solidFill>
                   <a:srgbClr val="1D2433"/>
                 </a:solidFill>
                 <a:latin typeface="Noto Sans"/>
               </a:rPr>
-              <a:t>A hook for every tool</a:t>
-            </a:r>
-          </a:p>
-        </p:txBody>
-      </p:sp>
-      <p:sp>
-        <p:nvSpPr>
-          <p:cNvPr id="10" name="Box"/>
+              <a:t>A shelf of hooks, each labelled with the tool's name.</a:t>
+            </a:r>
+          </a:p>
+        </p:txBody>
+      </p:sp>
+      <p:sp>
+        <p:nvSpPr>
+          <p:cNvPr id="14" name="Box"/>
           <p:cNvSpPr/>
           <p:nvPr/>
         </p:nvSpPr>
         <p:spPr>
           <a:xfrm>
-            <a:off x="990600" y="3263205"/>
-            <a:ext cx="101600" cy="101600"/>
+            <a:off x="4364534" y="4241800"/>
+            <a:ext cx="3462834" cy="1460500"/>
           </a:xfrm>
           <a:prstGeom prst="roundRect">
             <a:avLst>
-              <a:gd name="adj" fmla="val 25000"/>
+              <a:gd name="adj" fmla="val 6086"/>
             </a:avLst>
           </a:prstGeom>
           <a:solidFill>
-            <a:srgbClr val="5B4BD6"/>
+            <a:srgbClr val="ECE9FB"/>
           </a:solidFill>
           <a:ln>
             <a:noFill/>
@@ -15061,14 +16932,14 @@
       </p:sp>
       <p:sp>
         <p:nvSpPr>
-          <p:cNvPr id="11" name="Text"/>
-          <p:cNvSpPr txBox="1"/>
-          <p:nvPr/>
-        </p:nvSpPr>
-        <p:spPr>
-          <a:xfrm>
-            <a:off x="1257300" y="3168273"/>
-            <a:ext cx="4682998" cy="291465"/>
+          <p:cNvPr id="15" name="Text"/>
+          <p:cNvSpPr txBox="1"/>
+          <p:nvPr/>
+        </p:nvSpPr>
+        <p:spPr>
+          <a:xfrm>
+            <a:off x="4516934" y="4379862"/>
+            <a:ext cx="3252775" cy="155677"/>
           </a:xfrm>
           <a:prstGeom prst="rect">
             <a:avLst/>
@@ -15083,45 +16954,90 @@
           <a:p>
             <a:pPr algn="l">
               <a:lnSpc>
-                <a:spcPts val="2295"/>
-              </a:lnSpc>
-              <a:spcBef>
-                <a:spcPts val="0"/>
-              </a:spcBef>
-              <a:spcAft>
-                <a:spcPts val="0"/>
-              </a:spcAft>
-            </a:pPr>
-            <a:r>
-              <a:rPr sz="1700" b="0" i="0">
+                <a:spcPts val="1225"/>
+              </a:lnSpc>
+              <a:spcBef>
+                <a:spcPts val="0"/>
+              </a:spcBef>
+              <a:spcAft>
+                <a:spcPts val="0"/>
+              </a:spcAft>
+            </a:pPr>
+            <a:r>
+              <a:rPr sz="900" b="1" i="0" spc="90">
+                <a:solidFill>
+                  <a:srgbClr val="5B4BD6"/>
+                </a:solidFill>
+                <a:latin typeface="Noto Sans"/>
+              </a:rPr>
+              <a:t>TRUSTING</a:t>
+            </a:r>
+          </a:p>
+        </p:txBody>
+      </p:sp>
+      <p:sp>
+        <p:nvSpPr>
+          <p:cNvPr id="16" name="Text"/>
+          <p:cNvSpPr txBox="1"/>
+          <p:nvPr/>
+        </p:nvSpPr>
+        <p:spPr>
+          <a:xfrm>
+            <a:off x="4516934" y="4583112"/>
+            <a:ext cx="3252775" cy="438150"/>
+          </a:xfrm>
+          <a:prstGeom prst="rect">
+            <a:avLst/>
+          </a:prstGeom>
+          <a:noFill/>
+        </p:spPr>
+        <p:txBody>
+          <a:bodyPr wrap="square" lIns="0" rIns="0" tIns="0" bIns="0" anchor="t">
+            <a:noAutofit/>
+          </a:bodyPr>
+          <a:lstStyle/>
+          <a:p>
+            <a:pPr algn="l">
+              <a:lnSpc>
+                <a:spcPts val="1725"/>
+              </a:lnSpc>
+              <a:spcBef>
+                <a:spcPts val="0"/>
+              </a:spcBef>
+              <a:spcAft>
+                <a:spcPts val="0"/>
+              </a:spcAft>
+            </a:pPr>
+            <a:r>
+              <a:rPr sz="1250" b="0" i="0">
                 <a:solidFill>
                   <a:srgbClr val="1D2433"/>
                 </a:solidFill>
                 <a:latin typeface="Noto Sans"/>
               </a:rPr>
-              <a:t>A ledger line for every hook</a:t>
-            </a:r>
-          </a:p>
-        </p:txBody>
-      </p:sp>
-      <p:sp>
-        <p:nvSpPr>
-          <p:cNvPr id="12" name="Box"/>
+              <a:t>A ledger line says its condition and who checked it last.</a:t>
+            </a:r>
+          </a:p>
+        </p:txBody>
+      </p:sp>
+      <p:sp>
+        <p:nvSpPr>
+          <p:cNvPr id="17" name="Box"/>
           <p:cNvSpPr/>
           <p:nvPr/>
         </p:nvSpPr>
         <p:spPr>
           <a:xfrm>
-            <a:off x="990600" y="3656211"/>
-            <a:ext cx="101600" cy="101600"/>
+            <a:off x="7967067" y="4241800"/>
+            <a:ext cx="3462834" cy="1460500"/>
           </a:xfrm>
           <a:prstGeom prst="roundRect">
             <a:avLst>
-              <a:gd name="adj" fmla="val 25000"/>
+              <a:gd name="adj" fmla="val 6086"/>
             </a:avLst>
           </a:prstGeom>
           <a:solidFill>
-            <a:srgbClr val="5B4BD6"/>
+            <a:srgbClr val="ECE9FB"/>
           </a:solidFill>
           <a:ln>
             <a:noFill/>
@@ -15138,14 +17054,14 @@
       </p:sp>
       <p:sp>
         <p:nvSpPr>
-          <p:cNvPr id="13" name="Text"/>
-          <p:cNvSpPr txBox="1"/>
-          <p:nvPr/>
-        </p:nvSpPr>
-        <p:spPr>
-          <a:xfrm>
-            <a:off x="1257300" y="3561278"/>
-            <a:ext cx="4682998" cy="291465"/>
+          <p:cNvPr id="18" name="Text"/>
+          <p:cNvSpPr txBox="1"/>
+          <p:nvPr/>
+        </p:nvSpPr>
+        <p:spPr>
+          <a:xfrm>
+            <a:off x="8119467" y="4379862"/>
+            <a:ext cx="3252775" cy="155677"/>
           </a:xfrm>
           <a:prstGeom prst="rect">
             <a:avLst/>
@@ -15160,524 +17076,75 @@
           <a:p>
             <a:pPr algn="l">
               <a:lnSpc>
-                <a:spcPts val="2295"/>
-              </a:lnSpc>
-              <a:spcBef>
-                <a:spcPts val="0"/>
-              </a:spcBef>
-              <a:spcAft>
-                <a:spcPts val="0"/>
-              </a:spcAft>
-            </a:pPr>
-            <a:r>
-              <a:rPr sz="1700" b="0" i="0">
+                <a:spcPts val="1225"/>
+              </a:lnSpc>
+              <a:spcBef>
+                <a:spcPts val="0"/>
+              </a:spcBef>
+              <a:spcAft>
+                <a:spcPts val="0"/>
+              </a:spcAft>
+            </a:pPr>
+            <a:r>
+              <a:rPr sz="900" b="1" i="0" spc="90">
+                <a:solidFill>
+                  <a:srgbClr val="5B4BD6"/>
+                </a:solidFill>
+                <a:latin typeface="Noto Sans"/>
+              </a:rPr>
+              <a:t>RETURNING</a:t>
+            </a:r>
+          </a:p>
+        </p:txBody>
+      </p:sp>
+      <p:sp>
+        <p:nvSpPr>
+          <p:cNvPr id="19" name="Text"/>
+          <p:cNvSpPr txBox="1"/>
+          <p:nvPr/>
+        </p:nvSpPr>
+        <p:spPr>
+          <a:xfrm>
+            <a:off x="8119467" y="4583112"/>
+            <a:ext cx="3252775" cy="438150"/>
+          </a:xfrm>
+          <a:prstGeom prst="rect">
+            <a:avLst/>
+          </a:prstGeom>
+          <a:noFill/>
+        </p:spPr>
+        <p:txBody>
+          <a:bodyPr wrap="square" lIns="0" rIns="0" tIns="0" bIns="0" anchor="t">
+            <a:noAutofit/>
+          </a:bodyPr>
+          <a:lstStyle/>
+          <a:p>
+            <a:pPr algn="l">
+              <a:lnSpc>
+                <a:spcPts val="1725"/>
+              </a:lnSpc>
+              <a:spcBef>
+                <a:spcPts val="0"/>
+              </a:spcBef>
+              <a:spcAft>
+                <a:spcPts val="0"/>
+              </a:spcAft>
+            </a:pPr>
+            <a:r>
+              <a:rPr sz="1250" b="0" i="0">
                 <a:solidFill>
                   <a:srgbClr val="1D2433"/>
                 </a:solidFill>
                 <a:latin typeface="Noto Sans"/>
               </a:rPr>
-              <a:t>One rule said out loud</a:t>
-            </a:r>
-          </a:p>
-        </p:txBody>
-      </p:sp>
-      <p:sp>
-        <p:nvSpPr>
-          <p:cNvPr id="14" name="Box"/>
-          <p:cNvSpPr/>
-          <p:nvPr/>
-        </p:nvSpPr>
-        <p:spPr>
-          <a:xfrm>
-            <a:off x="990600" y="4049216"/>
-            <a:ext cx="101600" cy="101600"/>
-          </a:xfrm>
-          <a:prstGeom prst="roundRect">
-            <a:avLst>
-              <a:gd name="adj" fmla="val 25000"/>
-            </a:avLst>
-          </a:prstGeom>
-          <a:solidFill>
-            <a:srgbClr val="5B4BD6"/>
-          </a:solidFill>
-          <a:ln>
-            <a:noFill/>
-          </a:ln>
-          <a:effectLst/>
-        </p:spPr>
-        <p:txBody>
-          <a:bodyPr rtlCol="0" anchor="ctr"/>
-          <a:lstStyle/>
-          <a:p>
-            <a:pPr algn="ctr"/>
-          </a:p>
-        </p:txBody>
-      </p:sp>
-      <p:sp>
-        <p:nvSpPr>
-          <p:cNvPr id="15" name="Text"/>
-          <p:cNvSpPr txBox="1"/>
-          <p:nvPr/>
-        </p:nvSpPr>
-        <p:spPr>
-          <a:xfrm>
-            <a:off x="1257300" y="3954284"/>
-            <a:ext cx="4682998" cy="291465"/>
-          </a:xfrm>
-          <a:prstGeom prst="rect">
-            <a:avLst/>
-          </a:prstGeom>
-          <a:noFill/>
-        </p:spPr>
-        <p:txBody>
-          <a:bodyPr wrap="square" lIns="0" rIns="0" tIns="0" bIns="0" anchor="t">
-            <a:noAutofit/>
-          </a:bodyPr>
-          <a:lstStyle/>
-          <a:p>
-            <a:pPr algn="l">
-              <a:lnSpc>
-                <a:spcPts val="2295"/>
-              </a:lnSpc>
-              <a:spcBef>
-                <a:spcPts val="0"/>
-              </a:spcBef>
-              <a:spcAft>
-                <a:spcPts val="0"/>
-              </a:spcAft>
-            </a:pPr>
-            <a:r>
-              <a:rPr sz="1700" b="0" i="0">
-                <a:solidFill>
-                  <a:srgbClr val="1D2433"/>
-                </a:solidFill>
-                <a:latin typeface="Noto Sans"/>
-              </a:rPr>
-              <a:t>Saturday mornings, always</a:t>
-            </a:r>
-          </a:p>
-        </p:txBody>
-      </p:sp>
-      <p:sp>
-        <p:nvSpPr>
-          <p:cNvPr id="16" name="Box"/>
-          <p:cNvSpPr/>
-          <p:nvPr/>
-        </p:nvSpPr>
-        <p:spPr>
-          <a:xfrm>
-            <a:off x="6184900" y="2159000"/>
-            <a:ext cx="5245100" cy="2384822"/>
-          </a:xfrm>
-          <a:prstGeom prst="roundRect">
-            <a:avLst>
-              <a:gd name="adj" fmla="val 4260"/>
-            </a:avLst>
-          </a:prstGeom>
-          <a:solidFill>
-            <a:srgbClr val="D0453D"/>
-          </a:solidFill>
-          <a:ln>
-            <a:noFill/>
-          </a:ln>
-          <a:effectLst/>
-        </p:spPr>
-        <p:txBody>
-          <a:bodyPr rtlCol="0" anchor="ctr"/>
-          <a:lstStyle/>
-          <a:p>
-            <a:pPr algn="ctr"/>
-          </a:p>
-        </p:txBody>
-      </p:sp>
-      <p:sp>
-        <p:nvSpPr>
-          <p:cNvPr id="17" name="Box"/>
-          <p:cNvSpPr/>
-          <p:nvPr/>
-        </p:nvSpPr>
-        <p:spPr>
-          <a:xfrm>
-            <a:off x="6184900" y="2222500"/>
-            <a:ext cx="5245100" cy="2321322"/>
-          </a:xfrm>
-          <a:prstGeom prst="roundRect">
-            <a:avLst>
-              <a:gd name="adj" fmla="val 1641"/>
-            </a:avLst>
-          </a:prstGeom>
-          <a:solidFill>
-            <a:srgbClr val="FFFFFF"/>
-          </a:solidFill>
-          <a:ln>
-            <a:noFill/>
-          </a:ln>
-          <a:effectLst/>
-        </p:spPr>
-        <p:txBody>
-          <a:bodyPr rtlCol="0" anchor="ctr"/>
-          <a:lstStyle/>
-          <a:p>
-            <a:pPr algn="ctr"/>
-          </a:p>
-        </p:txBody>
-      </p:sp>
-      <p:sp>
-        <p:nvSpPr>
-          <p:cNvPr id="18" name="Text"/>
-          <p:cNvSpPr txBox="1"/>
-          <p:nvPr/>
-        </p:nvSpPr>
-        <p:spPr>
-          <a:xfrm>
-            <a:off x="6388100" y="2412022"/>
-            <a:ext cx="4983861" cy="294056"/>
-          </a:xfrm>
-          <a:prstGeom prst="rect">
-            <a:avLst/>
-          </a:prstGeom>
-          <a:noFill/>
-        </p:spPr>
-        <p:txBody>
-          <a:bodyPr wrap="square" lIns="0" rIns="0" tIns="0" bIns="0" anchor="t">
-            <a:noAutofit/>
-          </a:bodyPr>
-          <a:lstStyle/>
-          <a:p>
-            <a:pPr algn="l">
-              <a:lnSpc>
-                <a:spcPts val="2315"/>
-              </a:lnSpc>
-              <a:spcBef>
-                <a:spcPts val="0"/>
-              </a:spcBef>
-              <a:spcAft>
-                <a:spcPts val="0"/>
-              </a:spcAft>
-            </a:pPr>
-            <a:r>
-              <a:rPr sz="1700" b="1" i="0">
-                <a:solidFill>
-                  <a:srgbClr val="D0453D"/>
-                </a:solidFill>
-                <a:latin typeface="Noto Sans"/>
-              </a:rPr>
-              <a:t>What does not</a:t>
-            </a:r>
-          </a:p>
-        </p:txBody>
-      </p:sp>
-      <p:sp>
-        <p:nvSpPr>
-          <p:cNvPr id="19" name="Box"/>
-          <p:cNvSpPr/>
-          <p:nvPr/>
-        </p:nvSpPr>
-        <p:spPr>
-          <a:xfrm>
-            <a:off x="6413500" y="2870200"/>
-            <a:ext cx="101600" cy="101600"/>
-          </a:xfrm>
-          <a:prstGeom prst="roundRect">
-            <a:avLst>
-              <a:gd name="adj" fmla="val 25000"/>
-            </a:avLst>
-          </a:prstGeom>
-          <a:solidFill>
-            <a:srgbClr val="5B4BD6"/>
-          </a:solidFill>
-          <a:ln>
-            <a:noFill/>
-          </a:ln>
-          <a:effectLst/>
-        </p:spPr>
-        <p:txBody>
-          <a:bodyPr rtlCol="0" anchor="ctr"/>
-          <a:lstStyle/>
-          <a:p>
-            <a:pPr algn="ctr"/>
-          </a:p>
-        </p:txBody>
-      </p:sp>
-      <p:sp>
-        <p:nvSpPr>
-          <p:cNvPr id="20" name="Text"/>
-          <p:cNvSpPr txBox="1"/>
-          <p:nvPr/>
-        </p:nvSpPr>
-        <p:spPr>
-          <a:xfrm>
-            <a:off x="6680200" y="2775268"/>
-            <a:ext cx="4682998" cy="291465"/>
-          </a:xfrm>
-          <a:prstGeom prst="rect">
-            <a:avLst/>
-          </a:prstGeom>
-          <a:noFill/>
-        </p:spPr>
-        <p:txBody>
-          <a:bodyPr wrap="square" lIns="0" rIns="0" tIns="0" bIns="0" anchor="t">
-            <a:noAutofit/>
-          </a:bodyPr>
-          <a:lstStyle/>
-          <a:p>
-            <a:pPr algn="l">
-              <a:lnSpc>
-                <a:spcPts val="2295"/>
-              </a:lnSpc>
-              <a:spcBef>
-                <a:spcPts val="0"/>
-              </a:spcBef>
-              <a:spcAft>
-                <a:spcPts val="0"/>
-              </a:spcAft>
-            </a:pPr>
-            <a:r>
-              <a:rPr sz="1700" b="0" i="0">
-                <a:solidFill>
-                  <a:srgbClr val="1D2433"/>
-                </a:solidFill>
-                <a:latin typeface="Noto Sans"/>
-              </a:rPr>
-              <a:t>Tools with no home</a:t>
-            </a:r>
-          </a:p>
-        </p:txBody>
-      </p:sp>
-      <p:sp>
-        <p:nvSpPr>
-          <p:cNvPr id="21" name="Box"/>
-          <p:cNvSpPr/>
-          <p:nvPr/>
-        </p:nvSpPr>
-        <p:spPr>
-          <a:xfrm>
-            <a:off x="6413500" y="3263205"/>
-            <a:ext cx="101600" cy="101600"/>
-          </a:xfrm>
-          <a:prstGeom prst="roundRect">
-            <a:avLst>
-              <a:gd name="adj" fmla="val 25000"/>
-            </a:avLst>
-          </a:prstGeom>
-          <a:solidFill>
-            <a:srgbClr val="5B4BD6"/>
-          </a:solidFill>
-          <a:ln>
-            <a:noFill/>
-          </a:ln>
-          <a:effectLst/>
-        </p:spPr>
-        <p:txBody>
-          <a:bodyPr rtlCol="0" anchor="ctr"/>
-          <a:lstStyle/>
-          <a:p>
-            <a:pPr algn="ctr"/>
-          </a:p>
-        </p:txBody>
-      </p:sp>
-      <p:sp>
-        <p:nvSpPr>
-          <p:cNvPr id="22" name="Text"/>
-          <p:cNvSpPr txBox="1"/>
-          <p:nvPr/>
-        </p:nvSpPr>
-        <p:spPr>
-          <a:xfrm>
-            <a:off x="6680200" y="3168273"/>
-            <a:ext cx="4682998" cy="291465"/>
-          </a:xfrm>
-          <a:prstGeom prst="rect">
-            <a:avLst/>
-          </a:prstGeom>
-          <a:noFill/>
-        </p:spPr>
-        <p:txBody>
-          <a:bodyPr wrap="square" lIns="0" rIns="0" tIns="0" bIns="0" anchor="t">
-            <a:noAutofit/>
-          </a:bodyPr>
-          <a:lstStyle/>
-          <a:p>
-            <a:pPr algn="l">
-              <a:lnSpc>
-                <a:spcPts val="2295"/>
-              </a:lnSpc>
-              <a:spcBef>
-                <a:spcPts val="0"/>
-              </a:spcBef>
-              <a:spcAft>
-                <a:spcPts val="0"/>
-              </a:spcAft>
-            </a:pPr>
-            <a:r>
-              <a:rPr sz="1700" b="0" i="0">
-                <a:solidFill>
-                  <a:srgbClr val="1D2433"/>
-                </a:solidFill>
-                <a:latin typeface="Noto Sans"/>
-              </a:rPr>
-              <a:t>Rules on a long notice board</a:t>
-            </a:r>
-          </a:p>
-        </p:txBody>
-      </p:sp>
-      <p:sp>
-        <p:nvSpPr>
-          <p:cNvPr id="23" name="Box"/>
-          <p:cNvSpPr/>
-          <p:nvPr/>
-        </p:nvSpPr>
-        <p:spPr>
-          <a:xfrm>
-            <a:off x="6413500" y="3656211"/>
-            <a:ext cx="101600" cy="101600"/>
-          </a:xfrm>
-          <a:prstGeom prst="roundRect">
-            <a:avLst>
-              <a:gd name="adj" fmla="val 25000"/>
-            </a:avLst>
-          </a:prstGeom>
-          <a:solidFill>
-            <a:srgbClr val="5B4BD6"/>
-          </a:solidFill>
-          <a:ln>
-            <a:noFill/>
-          </a:ln>
-          <a:effectLst/>
-        </p:spPr>
-        <p:txBody>
-          <a:bodyPr rtlCol="0" anchor="ctr"/>
-          <a:lstStyle/>
-          <a:p>
-            <a:pPr algn="ctr"/>
-          </a:p>
-        </p:txBody>
-      </p:sp>
-      <p:sp>
-        <p:nvSpPr>
-          <p:cNvPr id="24" name="Text"/>
-          <p:cNvSpPr txBox="1"/>
-          <p:nvPr/>
-        </p:nvSpPr>
-        <p:spPr>
-          <a:xfrm>
-            <a:off x="6680200" y="3561278"/>
-            <a:ext cx="4682998" cy="291465"/>
-          </a:xfrm>
-          <a:prstGeom prst="rect">
-            <a:avLst/>
-          </a:prstGeom>
-          <a:noFill/>
-        </p:spPr>
-        <p:txBody>
-          <a:bodyPr wrap="square" lIns="0" rIns="0" tIns="0" bIns="0" anchor="t">
-            <a:noAutofit/>
-          </a:bodyPr>
-          <a:lstStyle/>
-          <a:p>
-            <a:pPr algn="l">
-              <a:lnSpc>
-                <a:spcPts val="2295"/>
-              </a:lnSpc>
-              <a:spcBef>
-                <a:spcPts val="0"/>
-              </a:spcBef>
-              <a:spcAft>
-                <a:spcPts val="0"/>
-              </a:spcAft>
-            </a:pPr>
-            <a:r>
-              <a:rPr sz="1700" b="0" i="0">
-                <a:solidFill>
-                  <a:srgbClr val="1D2433"/>
-                </a:solidFill>
-                <a:latin typeface="Noto Sans"/>
-              </a:rPr>
-              <a:t>Fines nobody collects</a:t>
-            </a:r>
-          </a:p>
-        </p:txBody>
-      </p:sp>
-      <p:sp>
-        <p:nvSpPr>
-          <p:cNvPr id="25" name="Box"/>
-          <p:cNvSpPr/>
-          <p:nvPr/>
-        </p:nvSpPr>
-        <p:spPr>
-          <a:xfrm>
-            <a:off x="6413500" y="4049216"/>
-            <a:ext cx="101600" cy="101600"/>
-          </a:xfrm>
-          <a:prstGeom prst="roundRect">
-            <a:avLst>
-              <a:gd name="adj" fmla="val 25000"/>
-            </a:avLst>
-          </a:prstGeom>
-          <a:solidFill>
-            <a:srgbClr val="5B4BD6"/>
-          </a:solidFill>
-          <a:ln>
-            <a:noFill/>
-          </a:ln>
-          <a:effectLst/>
-        </p:spPr>
-        <p:txBody>
-          <a:bodyPr rtlCol="0" anchor="ctr"/>
-          <a:lstStyle/>
-          <a:p>
-            <a:pPr algn="ctr"/>
-          </a:p>
-        </p:txBody>
-      </p:sp>
-      <p:sp>
-        <p:nvSpPr>
-          <p:cNvPr id="26" name="Text"/>
-          <p:cNvSpPr txBox="1"/>
-          <p:nvPr/>
-        </p:nvSpPr>
-        <p:spPr>
-          <a:xfrm>
-            <a:off x="6680200" y="3954284"/>
-            <a:ext cx="4682998" cy="291465"/>
-          </a:xfrm>
-          <a:prstGeom prst="rect">
-            <a:avLst/>
-          </a:prstGeom>
-          <a:noFill/>
-        </p:spPr>
-        <p:txBody>
-          <a:bodyPr wrap="square" lIns="0" rIns="0" tIns="0" bIns="0" anchor="t">
-            <a:noAutofit/>
-          </a:bodyPr>
-          <a:lstStyle/>
-          <a:p>
-            <a:pPr algn="l">
-              <a:lnSpc>
-                <a:spcPts val="2295"/>
-              </a:lnSpc>
-              <a:spcBef>
-                <a:spcPts val="0"/>
-              </a:spcBef>
-              <a:spcAft>
-                <a:spcPts val="0"/>
-              </a:spcAft>
-            </a:pPr>
-            <a:r>
-              <a:rPr sz="1700" b="0" i="0">
-                <a:solidFill>
-                  <a:srgbClr val="1D2433"/>
-                </a:solidFill>
-                <a:latin typeface="Noto Sans"/>
-              </a:rPr>
-              <a:t>Opening whenever someone is free</a:t>
-            </a:r>
-          </a:p>
-        </p:txBody>
-      </p:sp>
-      <p:sp>
-        <p:nvSpPr>
-          <p:cNvPr id="27" name="Box"/>
+              <a:t>A tool hung back clean is the only sign-off it needs.</a:t>
+            </a:r>
+          </a:p>
+        </p:txBody>
+      </p:sp>
+      <p:sp>
+        <p:nvSpPr>
+          <p:cNvPr id="20" name="Box"/>
           <p:cNvSpPr/>
           <p:nvPr/>
         </p:nvSpPr>
@@ -15707,7 +17174,7 @@
       </p:sp>
       <p:sp>
         <p:nvSpPr>
-          <p:cNvPr id="28" name="Text"/>
+          <p:cNvPr id="21" name="Text"/>
           <p:cNvSpPr txBox="1"/>
           <p:nvPr/>
         </p:nvSpPr>
@@ -15761,7 +17228,7 @@
       </p:sp>
       <p:sp>
         <p:nvSpPr>
-          <p:cNvPr id="29" name="Text"/>
+          <p:cNvPr id="22" name="Text"/>
           <p:cNvSpPr txBox="1"/>
           <p:nvPr/>
         </p:nvSpPr>
@@ -15799,7 +17266,7 @@
                 </a:solidFill>
                 <a:latin typeface="Noto Sans"/>
               </a:rPr>
-              <a:t>9 / 12</a:t>
+              <a:t>9 / 13</a:t>
             </a:r>
           </a:p>
         </p:txBody>

</xml_diff>

<commit_message>
Explainer parity: ExtraBold, diagram callout band, heat-map, outline panels; v0.17.0 (#46) (#55)
* Vendor NotoSans ExtraBold for the 800-weight numerals (#46, item 23)

* Explainer diagram callout band (#46, item 7)

* Explainer heatmap kind and outline two-column panels (#46, items 16, 18)

* Sample deck: callout, heat-map, outline panels; v0.17.0 (#46)

* Test: sample deck now has 13 slides and a heatmap (#46)
</commit_message>
<xml_diff>
--- a/docs/samples/house-style-explainer-v1.pptx
+++ b/docs/samples/house-style-explainer-v1.pptx
@@ -17,6 +17,7 @@
     <p:sldId id="265" r:id="rId17"/>
     <p:sldId id="266" r:id="rId18"/>
     <p:sldId id="267" r:id="rId19"/>
+    <p:sldId id="268" r:id="rId20"/>
   </p:sldIdLst>
   <p:sldSz cx="12192000" cy="6858000" type="screen4x3"/>
   <p:notesSz cx="6858000" cy="9144000"/>
@@ -589,7 +590,7 @@
           <a:lstStyle/>
           <a:p>
             <a:r>
-              <a:t>A section slide marks a change of subject. Say what comes next in one sentence.</a:t>
+              <a:t>Two columns, one for what works and one for what does not. Keep each list to four short lines.</a:t>
             </a:r>
           </a:p>
           <a:p/>
@@ -665,13 +666,13 @@
           <a:lstStyle/>
           <a:p>
             <a:r>
-              <a:t>A quote slide: read it slowly, then say why it matters. This quote is invented.</a:t>
+              <a:t>A section slide marks a change of subject. Say what comes next in one sentence.</a:t>
             </a:r>
           </a:p>
           <a:p/>
           <a:p>
             <a:r>
-              <a:t>Source: Invented example; no real person</a:t>
+              <a:t>Source: Invented example</a:t>
             </a:r>
           </a:p>
         </p:txBody>
@@ -741,6 +742,82 @@
           <a:lstStyle/>
           <a:p>
             <a:r>
+              <a:t>A quote slide: read it slowly, then say why it matters. This quote is invented.</a:t>
+            </a:r>
+          </a:p>
+          <a:p/>
+          <a:p>
+            <a:r>
+              <a:t>Source: Invented example; no real person</a:t>
+            </a:r>
+          </a:p>
+        </p:txBody>
+      </p:sp>
+      <p:sp>
+        <p:nvSpPr>
+          <p:cNvPr id="4" name="Slide Number Placeholder 3"/>
+          <p:cNvSpPr>
+            <a:spLocks noGrp="1"/>
+          </p:cNvSpPr>
+          <p:nvPr>
+            <p:ph type="sldNum" idx="5" sz="quarter"/>
+          </p:nvPr>
+        </p:nvSpPr>
+        <p:spPr/>
+      </p:sp>
+    </p:spTree>
+  </p:cSld>
+  <p:clrMapOvr>
+    <a:masterClrMapping/>
+  </p:clrMapOvr>
+</p:notes>
+</file>
+
+<file path=ppt/notesSlides/notesSlide13.xml><?xml version="1.0" encoding="utf-8"?>
+<p:notes xmlns:a="http://schemas.openxmlformats.org/drawingml/2006/main" xmlns:p="http://schemas.openxmlformats.org/presentationml/2006/main" xmlns:r="http://schemas.openxmlformats.org/officeDocument/2006/relationships">
+  <p:cSld>
+    <p:spTree>
+      <p:nvGrpSpPr>
+        <p:cNvPr id="1" name=""/>
+        <p:cNvGrpSpPr/>
+        <p:nvPr/>
+      </p:nvGrpSpPr>
+      <p:grpSpPr>
+        <a:xfrm>
+          <a:off x="0" y="0"/>
+          <a:ext cx="0" cy="0"/>
+          <a:chOff x="0" y="0"/>
+          <a:chExt cx="0" cy="0"/>
+        </a:xfrm>
+      </p:grpSpPr>
+      <p:sp>
+        <p:nvSpPr>
+          <p:cNvPr id="2" name="Slide Image Placeholder 1"/>
+          <p:cNvSpPr>
+            <a:spLocks noGrp="1"/>
+          </p:cNvSpPr>
+          <p:nvPr>
+            <p:ph type="sldImg" idx="2"/>
+          </p:nvPr>
+        </p:nvSpPr>
+        <p:spPr/>
+      </p:sp>
+      <p:sp>
+        <p:nvSpPr>
+          <p:cNvPr id="3" name="Notes Placeholder 2"/>
+          <p:cNvSpPr>
+            <a:spLocks noGrp="1"/>
+          </p:cNvSpPr>
+          <p:nvPr>
+            <p:ph type="body" idx="3" sz="quarter"/>
+          </p:nvPr>
+        </p:nvSpPr>
+        <p:spPr/>
+        <p:txBody>
+          <a:bodyPr/>
+          <a:lstStyle/>
+          <a:p>
+            <a:r>
               <a:t>Close on the three figures. They are invented: forty tools, three hundred and twelve loans, and one hour to learn a job.</a:t>
             </a:r>
           </a:p>
@@ -1273,13 +1350,13 @@
           <a:lstStyle/>
           <a:p>
             <a:r>
-              <a:t>The contrast has two cards, then three small examples of the change in practice. Say the before in one breath, the now in one breath, and let the examples carry the detail.</a:t>
+              <a:t>A heat-map shades each cell by its value and outlines the best one in its row. The figures are invented; read across a row to see the habit settle in.</a:t>
             </a:r>
           </a:p>
           <a:p/>
           <a:p>
             <a:r>
-              <a:t>Source: Invented example</a:t>
+              <a:t>Source: Invented example; the figures are made up</a:t>
             </a:r>
           </a:p>
         </p:txBody>
@@ -1349,7 +1426,7 @@
           <a:lstStyle/>
           <a:p>
             <a:r>
-              <a:t>Two columns, one for what works and one for what does not. Keep each list to four short lines.</a:t>
+              <a:t>The contrast has two cards, then three small examples of the change in practice. Say the before in one breath, the now in one breath, and let the examples carry the detail.</a:t>
             </a:r>
           </a:p>
           <a:p/>
@@ -4673,7 +4750,7 @@
                 </a:solidFill>
                 <a:latin typeface="Noto Sans"/>
               </a:rPr>
-              <a:t>1 / 12</a:t>
+              <a:t>1 / 13</a:t>
             </a:r>
           </a:p>
         </p:txBody>
@@ -4687,6 +4764,1070 @@
 </file>
 
 <file path=ppt/slides/slide10.xml><?xml version="1.0" encoding="utf-8"?>
+<p:sld xmlns:a="http://schemas.openxmlformats.org/drawingml/2006/main" xmlns:p="http://schemas.openxmlformats.org/presentationml/2006/main" xmlns:r="http://schemas.openxmlformats.org/officeDocument/2006/relationships">
+  <p:cSld>
+    <p:bg>
+      <p:bgPr>
+        <a:solidFill>
+          <a:srgbClr val="F7F6F2"/>
+        </a:solidFill>
+        <a:effectLst/>
+      </p:bgPr>
+    </p:bg>
+    <p:spTree>
+      <p:nvGrpSpPr>
+        <p:cNvPr id="1" name=""/>
+        <p:cNvGrpSpPr/>
+        <p:nvPr/>
+      </p:nvGrpSpPr>
+      <p:grpSpPr/>
+      <p:sp>
+        <p:nvSpPr>
+          <p:cNvPr id="2" name="Title 1"/>
+          <p:cNvSpPr>
+            <a:spLocks noGrp="1"/>
+          </p:cNvSpPr>
+          <p:nvPr>
+            <p:ph type="title"/>
+          </p:nvPr>
+        </p:nvSpPr>
+        <p:spPr>
+          <a:xfrm>
+            <a:off x="762000" y="837819"/>
+            <a:ext cx="10988040" cy="438912"/>
+          </a:xfrm>
+        </p:spPr>
+        <p:txBody>
+          <a:bodyPr wrap="square" lIns="0" rIns="0" tIns="0" bIns="0" anchor="t">
+            <a:noAutofit/>
+          </a:bodyPr>
+          <a:lstStyle/>
+          <a:p>
+            <a:pPr algn="l">
+              <a:lnSpc>
+                <a:spcPts val="3456"/>
+              </a:lnSpc>
+              <a:spcBef>
+                <a:spcPts val="0"/>
+              </a:spcBef>
+              <a:spcAft>
+                <a:spcPts val="0"/>
+              </a:spcAft>
+            </a:pPr>
+            <a:r>
+              <a:rPr sz="3200" b="1" i="0" spc="-32">
+                <a:solidFill>
+                  <a:srgbClr val="1D2433"/>
+                </a:solidFill>
+                <a:latin typeface="Noto Sans"/>
+              </a:rPr>
+              <a:t>Keep the rules few and the hooks labelled</a:t>
+            </a:r>
+          </a:p>
+        </p:txBody>
+      </p:sp>
+      <p:sp>
+        <p:nvSpPr>
+          <p:cNvPr id="3" name="Text"/>
+          <p:cNvSpPr txBox="1"/>
+          <p:nvPr/>
+        </p:nvSpPr>
+        <p:spPr>
+          <a:xfrm>
+            <a:off x="762000" y="558914"/>
+            <a:ext cx="10988040" cy="190271"/>
+          </a:xfrm>
+          <a:prstGeom prst="rect">
+            <a:avLst/>
+          </a:prstGeom>
+          <a:noFill/>
+        </p:spPr>
+        <p:txBody>
+          <a:bodyPr wrap="square" lIns="0" rIns="0" tIns="0" bIns="0" anchor="t">
+            <a:noAutofit/>
+          </a:bodyPr>
+          <a:lstStyle/>
+          <a:p>
+            <a:pPr algn="l">
+              <a:lnSpc>
+                <a:spcPts val="1498"/>
+              </a:lnSpc>
+              <a:spcBef>
+                <a:spcPts val="0"/>
+              </a:spcBef>
+              <a:spcAft>
+                <a:spcPts val="0"/>
+              </a:spcAft>
+            </a:pPr>
+            <a:r>
+              <a:rPr sz="1100" b="1" i="0" spc="154">
+                <a:solidFill>
+                  <a:srgbClr val="5B4BD6"/>
+                </a:solidFill>
+                <a:latin typeface="Noto Sans"/>
+              </a:rPr>
+              <a:t>WHAT WORKS, WHAT DOES NOT</a:t>
+            </a:r>
+          </a:p>
+        </p:txBody>
+      </p:sp>
+      <p:sp>
+        <p:nvSpPr>
+          <p:cNvPr id="4" name="Text"/>
+          <p:cNvSpPr txBox="1"/>
+          <p:nvPr/>
+        </p:nvSpPr>
+        <p:spPr>
+          <a:xfrm>
+            <a:off x="762000" y="1389757"/>
+            <a:ext cx="9810750" cy="269875"/>
+          </a:xfrm>
+          <a:prstGeom prst="rect">
+            <a:avLst/>
+          </a:prstGeom>
+          <a:noFill/>
+        </p:spPr>
+        <p:txBody>
+          <a:bodyPr wrap="square" lIns="0" rIns="0" tIns="0" bIns="0" anchor="t">
+            <a:noAutofit/>
+          </a:bodyPr>
+          <a:lstStyle/>
+          <a:p>
+            <a:pPr algn="l">
+              <a:lnSpc>
+                <a:spcPts val="2125"/>
+              </a:lnSpc>
+              <a:spcBef>
+                <a:spcPts val="0"/>
+              </a:spcBef>
+              <a:spcAft>
+                <a:spcPts val="0"/>
+              </a:spcAft>
+            </a:pPr>
+            <a:r>
+              <a:rPr sz="1700" b="0" i="0">
+                <a:solidFill>
+                  <a:srgbClr val="4A5163"/>
+                </a:solidFill>
+                <a:latin typeface="Noto Sans"/>
+              </a:rPr>
+              <a:t>Two lists, four short lines each.</a:t>
+            </a:r>
+          </a:p>
+        </p:txBody>
+      </p:sp>
+      <p:sp>
+        <p:nvSpPr>
+          <p:cNvPr id="5" name="Box"/>
+          <p:cNvSpPr/>
+          <p:nvPr/>
+        </p:nvSpPr>
+        <p:spPr>
+          <a:xfrm>
+            <a:off x="762000" y="2159000"/>
+            <a:ext cx="5245100" cy="2372122"/>
+          </a:xfrm>
+          <a:prstGeom prst="roundRect">
+            <a:avLst>
+              <a:gd name="adj" fmla="val 4283"/>
+            </a:avLst>
+          </a:prstGeom>
+          <a:solidFill>
+            <a:srgbClr val="FFFFFF"/>
+          </a:solidFill>
+          <a:ln w="25400">
+            <a:solidFill>
+              <a:srgbClr val="2E9E6B"/>
+            </a:solidFill>
+          </a:ln>
+          <a:effectLst/>
+        </p:spPr>
+        <p:txBody>
+          <a:bodyPr rtlCol="0" anchor="ctr"/>
+          <a:lstStyle/>
+          <a:p>
+            <a:pPr algn="ctr"/>
+          </a:p>
+        </p:txBody>
+      </p:sp>
+      <p:sp>
+        <p:nvSpPr>
+          <p:cNvPr id="6" name="Text"/>
+          <p:cNvSpPr txBox="1"/>
+          <p:nvPr/>
+        </p:nvSpPr>
+        <p:spPr>
+          <a:xfrm>
+            <a:off x="990600" y="2373922"/>
+            <a:ext cx="4931537" cy="294056"/>
+          </a:xfrm>
+          <a:prstGeom prst="rect">
+            <a:avLst/>
+          </a:prstGeom>
+          <a:noFill/>
+        </p:spPr>
+        <p:txBody>
+          <a:bodyPr wrap="square" lIns="0" rIns="0" tIns="0" bIns="0" anchor="t">
+            <a:noAutofit/>
+          </a:bodyPr>
+          <a:lstStyle/>
+          <a:p>
+            <a:pPr algn="l">
+              <a:lnSpc>
+                <a:spcPts val="2315"/>
+              </a:lnSpc>
+              <a:spcBef>
+                <a:spcPts val="0"/>
+              </a:spcBef>
+              <a:spcAft>
+                <a:spcPts val="0"/>
+              </a:spcAft>
+            </a:pPr>
+            <a:r>
+              <a:rPr sz="1700" b="1" i="0">
+                <a:solidFill>
+                  <a:srgbClr val="2E9E6B"/>
+                </a:solidFill>
+                <a:latin typeface="Noto Sans"/>
+              </a:rPr>
+              <a:t>What works</a:t>
+            </a:r>
+          </a:p>
+        </p:txBody>
+      </p:sp>
+      <p:sp>
+        <p:nvSpPr>
+          <p:cNvPr id="7" name="Box"/>
+          <p:cNvSpPr/>
+          <p:nvPr/>
+        </p:nvSpPr>
+        <p:spPr>
+          <a:xfrm>
+            <a:off x="1016000" y="2832100"/>
+            <a:ext cx="101600" cy="101600"/>
+          </a:xfrm>
+          <a:prstGeom prst="roundRect">
+            <a:avLst>
+              <a:gd name="adj" fmla="val 25000"/>
+            </a:avLst>
+          </a:prstGeom>
+          <a:solidFill>
+            <a:srgbClr val="5B4BD6"/>
+          </a:solidFill>
+          <a:ln>
+            <a:noFill/>
+          </a:ln>
+          <a:effectLst/>
+        </p:spPr>
+        <p:txBody>
+          <a:bodyPr rtlCol="0" anchor="ctr"/>
+          <a:lstStyle/>
+          <a:p>
+            <a:pPr algn="ctr"/>
+          </a:p>
+        </p:txBody>
+      </p:sp>
+      <p:sp>
+        <p:nvSpPr>
+          <p:cNvPr id="8" name="Text"/>
+          <p:cNvSpPr txBox="1"/>
+          <p:nvPr/>
+        </p:nvSpPr>
+        <p:spPr>
+          <a:xfrm>
+            <a:off x="1282700" y="2737168"/>
+            <a:ext cx="4630674" cy="291465"/>
+          </a:xfrm>
+          <a:prstGeom prst="rect">
+            <a:avLst/>
+          </a:prstGeom>
+          <a:noFill/>
+        </p:spPr>
+        <p:txBody>
+          <a:bodyPr wrap="square" lIns="0" rIns="0" tIns="0" bIns="0" anchor="t">
+            <a:noAutofit/>
+          </a:bodyPr>
+          <a:lstStyle/>
+          <a:p>
+            <a:pPr algn="l">
+              <a:lnSpc>
+                <a:spcPts val="2295"/>
+              </a:lnSpc>
+              <a:spcBef>
+                <a:spcPts val="0"/>
+              </a:spcBef>
+              <a:spcAft>
+                <a:spcPts val="0"/>
+              </a:spcAft>
+            </a:pPr>
+            <a:r>
+              <a:rPr sz="1700" b="0" i="0">
+                <a:solidFill>
+                  <a:srgbClr val="1D2433"/>
+                </a:solidFill>
+                <a:latin typeface="Noto Sans"/>
+              </a:rPr>
+              <a:t>A hook for every tool</a:t>
+            </a:r>
+          </a:p>
+        </p:txBody>
+      </p:sp>
+      <p:sp>
+        <p:nvSpPr>
+          <p:cNvPr id="9" name="Box"/>
+          <p:cNvSpPr/>
+          <p:nvPr/>
+        </p:nvSpPr>
+        <p:spPr>
+          <a:xfrm>
+            <a:off x="1016000" y="3225105"/>
+            <a:ext cx="101600" cy="101600"/>
+          </a:xfrm>
+          <a:prstGeom prst="roundRect">
+            <a:avLst>
+              <a:gd name="adj" fmla="val 25000"/>
+            </a:avLst>
+          </a:prstGeom>
+          <a:solidFill>
+            <a:srgbClr val="5B4BD6"/>
+          </a:solidFill>
+          <a:ln>
+            <a:noFill/>
+          </a:ln>
+          <a:effectLst/>
+        </p:spPr>
+        <p:txBody>
+          <a:bodyPr rtlCol="0" anchor="ctr"/>
+          <a:lstStyle/>
+          <a:p>
+            <a:pPr algn="ctr"/>
+          </a:p>
+        </p:txBody>
+      </p:sp>
+      <p:sp>
+        <p:nvSpPr>
+          <p:cNvPr id="10" name="Text"/>
+          <p:cNvSpPr txBox="1"/>
+          <p:nvPr/>
+        </p:nvSpPr>
+        <p:spPr>
+          <a:xfrm>
+            <a:off x="1282700" y="3130173"/>
+            <a:ext cx="4630674" cy="291465"/>
+          </a:xfrm>
+          <a:prstGeom prst="rect">
+            <a:avLst/>
+          </a:prstGeom>
+          <a:noFill/>
+        </p:spPr>
+        <p:txBody>
+          <a:bodyPr wrap="square" lIns="0" rIns="0" tIns="0" bIns="0" anchor="t">
+            <a:noAutofit/>
+          </a:bodyPr>
+          <a:lstStyle/>
+          <a:p>
+            <a:pPr algn="l">
+              <a:lnSpc>
+                <a:spcPts val="2295"/>
+              </a:lnSpc>
+              <a:spcBef>
+                <a:spcPts val="0"/>
+              </a:spcBef>
+              <a:spcAft>
+                <a:spcPts val="0"/>
+              </a:spcAft>
+            </a:pPr>
+            <a:r>
+              <a:rPr sz="1700" b="0" i="0">
+                <a:solidFill>
+                  <a:srgbClr val="1D2433"/>
+                </a:solidFill>
+                <a:latin typeface="Noto Sans"/>
+              </a:rPr>
+              <a:t>A ledger line for every hook</a:t>
+            </a:r>
+          </a:p>
+        </p:txBody>
+      </p:sp>
+      <p:sp>
+        <p:nvSpPr>
+          <p:cNvPr id="11" name="Box"/>
+          <p:cNvSpPr/>
+          <p:nvPr/>
+        </p:nvSpPr>
+        <p:spPr>
+          <a:xfrm>
+            <a:off x="1016000" y="3618111"/>
+            <a:ext cx="101600" cy="101600"/>
+          </a:xfrm>
+          <a:prstGeom prst="roundRect">
+            <a:avLst>
+              <a:gd name="adj" fmla="val 25000"/>
+            </a:avLst>
+          </a:prstGeom>
+          <a:solidFill>
+            <a:srgbClr val="5B4BD6"/>
+          </a:solidFill>
+          <a:ln>
+            <a:noFill/>
+          </a:ln>
+          <a:effectLst/>
+        </p:spPr>
+        <p:txBody>
+          <a:bodyPr rtlCol="0" anchor="ctr"/>
+          <a:lstStyle/>
+          <a:p>
+            <a:pPr algn="ctr"/>
+          </a:p>
+        </p:txBody>
+      </p:sp>
+      <p:sp>
+        <p:nvSpPr>
+          <p:cNvPr id="12" name="Text"/>
+          <p:cNvSpPr txBox="1"/>
+          <p:nvPr/>
+        </p:nvSpPr>
+        <p:spPr>
+          <a:xfrm>
+            <a:off x="1282700" y="3523178"/>
+            <a:ext cx="4630674" cy="291465"/>
+          </a:xfrm>
+          <a:prstGeom prst="rect">
+            <a:avLst/>
+          </a:prstGeom>
+          <a:noFill/>
+        </p:spPr>
+        <p:txBody>
+          <a:bodyPr wrap="square" lIns="0" rIns="0" tIns="0" bIns="0" anchor="t">
+            <a:noAutofit/>
+          </a:bodyPr>
+          <a:lstStyle/>
+          <a:p>
+            <a:pPr algn="l">
+              <a:lnSpc>
+                <a:spcPts val="2295"/>
+              </a:lnSpc>
+              <a:spcBef>
+                <a:spcPts val="0"/>
+              </a:spcBef>
+              <a:spcAft>
+                <a:spcPts val="0"/>
+              </a:spcAft>
+            </a:pPr>
+            <a:r>
+              <a:rPr sz="1700" b="0" i="0">
+                <a:solidFill>
+                  <a:srgbClr val="1D2433"/>
+                </a:solidFill>
+                <a:latin typeface="Noto Sans"/>
+              </a:rPr>
+              <a:t>One rule said out loud</a:t>
+            </a:r>
+          </a:p>
+        </p:txBody>
+      </p:sp>
+      <p:sp>
+        <p:nvSpPr>
+          <p:cNvPr id="13" name="Box"/>
+          <p:cNvSpPr/>
+          <p:nvPr/>
+        </p:nvSpPr>
+        <p:spPr>
+          <a:xfrm>
+            <a:off x="1016000" y="4011116"/>
+            <a:ext cx="101600" cy="101600"/>
+          </a:xfrm>
+          <a:prstGeom prst="roundRect">
+            <a:avLst>
+              <a:gd name="adj" fmla="val 25000"/>
+            </a:avLst>
+          </a:prstGeom>
+          <a:solidFill>
+            <a:srgbClr val="5B4BD6"/>
+          </a:solidFill>
+          <a:ln>
+            <a:noFill/>
+          </a:ln>
+          <a:effectLst/>
+        </p:spPr>
+        <p:txBody>
+          <a:bodyPr rtlCol="0" anchor="ctr"/>
+          <a:lstStyle/>
+          <a:p>
+            <a:pPr algn="ctr"/>
+          </a:p>
+        </p:txBody>
+      </p:sp>
+      <p:sp>
+        <p:nvSpPr>
+          <p:cNvPr id="14" name="Text"/>
+          <p:cNvSpPr txBox="1"/>
+          <p:nvPr/>
+        </p:nvSpPr>
+        <p:spPr>
+          <a:xfrm>
+            <a:off x="1282700" y="3916184"/>
+            <a:ext cx="4630674" cy="291465"/>
+          </a:xfrm>
+          <a:prstGeom prst="rect">
+            <a:avLst/>
+          </a:prstGeom>
+          <a:noFill/>
+        </p:spPr>
+        <p:txBody>
+          <a:bodyPr wrap="square" lIns="0" rIns="0" tIns="0" bIns="0" anchor="t">
+            <a:noAutofit/>
+          </a:bodyPr>
+          <a:lstStyle/>
+          <a:p>
+            <a:pPr algn="l">
+              <a:lnSpc>
+                <a:spcPts val="2295"/>
+              </a:lnSpc>
+              <a:spcBef>
+                <a:spcPts val="0"/>
+              </a:spcBef>
+              <a:spcAft>
+                <a:spcPts val="0"/>
+              </a:spcAft>
+            </a:pPr>
+            <a:r>
+              <a:rPr sz="1700" b="0" i="0">
+                <a:solidFill>
+                  <a:srgbClr val="1D2433"/>
+                </a:solidFill>
+                <a:latin typeface="Noto Sans"/>
+              </a:rPr>
+              <a:t>Saturday mornings, always</a:t>
+            </a:r>
+          </a:p>
+        </p:txBody>
+      </p:sp>
+      <p:sp>
+        <p:nvSpPr>
+          <p:cNvPr id="15" name="Box"/>
+          <p:cNvSpPr/>
+          <p:nvPr/>
+        </p:nvSpPr>
+        <p:spPr>
+          <a:xfrm>
+            <a:off x="6184900" y="2159000"/>
+            <a:ext cx="5245100" cy="2372122"/>
+          </a:xfrm>
+          <a:prstGeom prst="roundRect">
+            <a:avLst>
+              <a:gd name="adj" fmla="val 4283"/>
+            </a:avLst>
+          </a:prstGeom>
+          <a:solidFill>
+            <a:srgbClr val="FFFFFF"/>
+          </a:solidFill>
+          <a:ln w="25400">
+            <a:solidFill>
+              <a:srgbClr val="D0453D"/>
+            </a:solidFill>
+          </a:ln>
+          <a:effectLst/>
+        </p:spPr>
+        <p:txBody>
+          <a:bodyPr rtlCol="0" anchor="ctr"/>
+          <a:lstStyle/>
+          <a:p>
+            <a:pPr algn="ctr"/>
+          </a:p>
+        </p:txBody>
+      </p:sp>
+      <p:sp>
+        <p:nvSpPr>
+          <p:cNvPr id="16" name="Text"/>
+          <p:cNvSpPr txBox="1"/>
+          <p:nvPr/>
+        </p:nvSpPr>
+        <p:spPr>
+          <a:xfrm>
+            <a:off x="6413500" y="2373922"/>
+            <a:ext cx="4931537" cy="294056"/>
+          </a:xfrm>
+          <a:prstGeom prst="rect">
+            <a:avLst/>
+          </a:prstGeom>
+          <a:noFill/>
+        </p:spPr>
+        <p:txBody>
+          <a:bodyPr wrap="square" lIns="0" rIns="0" tIns="0" bIns="0" anchor="t">
+            <a:noAutofit/>
+          </a:bodyPr>
+          <a:lstStyle/>
+          <a:p>
+            <a:pPr algn="l">
+              <a:lnSpc>
+                <a:spcPts val="2315"/>
+              </a:lnSpc>
+              <a:spcBef>
+                <a:spcPts val="0"/>
+              </a:spcBef>
+              <a:spcAft>
+                <a:spcPts val="0"/>
+              </a:spcAft>
+            </a:pPr>
+            <a:r>
+              <a:rPr sz="1700" b="1" i="0">
+                <a:solidFill>
+                  <a:srgbClr val="D0453D"/>
+                </a:solidFill>
+                <a:latin typeface="Noto Sans"/>
+              </a:rPr>
+              <a:t>What does not</a:t>
+            </a:r>
+          </a:p>
+        </p:txBody>
+      </p:sp>
+      <p:sp>
+        <p:nvSpPr>
+          <p:cNvPr id="17" name="Box"/>
+          <p:cNvSpPr/>
+          <p:nvPr/>
+        </p:nvSpPr>
+        <p:spPr>
+          <a:xfrm>
+            <a:off x="6438900" y="2832100"/>
+            <a:ext cx="101600" cy="101600"/>
+          </a:xfrm>
+          <a:prstGeom prst="roundRect">
+            <a:avLst>
+              <a:gd name="adj" fmla="val 25000"/>
+            </a:avLst>
+          </a:prstGeom>
+          <a:solidFill>
+            <a:srgbClr val="5B4BD6"/>
+          </a:solidFill>
+          <a:ln>
+            <a:noFill/>
+          </a:ln>
+          <a:effectLst/>
+        </p:spPr>
+        <p:txBody>
+          <a:bodyPr rtlCol="0" anchor="ctr"/>
+          <a:lstStyle/>
+          <a:p>
+            <a:pPr algn="ctr"/>
+          </a:p>
+        </p:txBody>
+      </p:sp>
+      <p:sp>
+        <p:nvSpPr>
+          <p:cNvPr id="18" name="Text"/>
+          <p:cNvSpPr txBox="1"/>
+          <p:nvPr/>
+        </p:nvSpPr>
+        <p:spPr>
+          <a:xfrm>
+            <a:off x="6705600" y="2737168"/>
+            <a:ext cx="4630674" cy="291465"/>
+          </a:xfrm>
+          <a:prstGeom prst="rect">
+            <a:avLst/>
+          </a:prstGeom>
+          <a:noFill/>
+        </p:spPr>
+        <p:txBody>
+          <a:bodyPr wrap="square" lIns="0" rIns="0" tIns="0" bIns="0" anchor="t">
+            <a:noAutofit/>
+          </a:bodyPr>
+          <a:lstStyle/>
+          <a:p>
+            <a:pPr algn="l">
+              <a:lnSpc>
+                <a:spcPts val="2295"/>
+              </a:lnSpc>
+              <a:spcBef>
+                <a:spcPts val="0"/>
+              </a:spcBef>
+              <a:spcAft>
+                <a:spcPts val="0"/>
+              </a:spcAft>
+            </a:pPr>
+            <a:r>
+              <a:rPr sz="1700" b="0" i="0">
+                <a:solidFill>
+                  <a:srgbClr val="1D2433"/>
+                </a:solidFill>
+                <a:latin typeface="Noto Sans"/>
+              </a:rPr>
+              <a:t>Tools with no home</a:t>
+            </a:r>
+          </a:p>
+        </p:txBody>
+      </p:sp>
+      <p:sp>
+        <p:nvSpPr>
+          <p:cNvPr id="19" name="Box"/>
+          <p:cNvSpPr/>
+          <p:nvPr/>
+        </p:nvSpPr>
+        <p:spPr>
+          <a:xfrm>
+            <a:off x="6438900" y="3225105"/>
+            <a:ext cx="101600" cy="101600"/>
+          </a:xfrm>
+          <a:prstGeom prst="roundRect">
+            <a:avLst>
+              <a:gd name="adj" fmla="val 25000"/>
+            </a:avLst>
+          </a:prstGeom>
+          <a:solidFill>
+            <a:srgbClr val="5B4BD6"/>
+          </a:solidFill>
+          <a:ln>
+            <a:noFill/>
+          </a:ln>
+          <a:effectLst/>
+        </p:spPr>
+        <p:txBody>
+          <a:bodyPr rtlCol="0" anchor="ctr"/>
+          <a:lstStyle/>
+          <a:p>
+            <a:pPr algn="ctr"/>
+          </a:p>
+        </p:txBody>
+      </p:sp>
+      <p:sp>
+        <p:nvSpPr>
+          <p:cNvPr id="20" name="Text"/>
+          <p:cNvSpPr txBox="1"/>
+          <p:nvPr/>
+        </p:nvSpPr>
+        <p:spPr>
+          <a:xfrm>
+            <a:off x="6705600" y="3130173"/>
+            <a:ext cx="4630674" cy="291465"/>
+          </a:xfrm>
+          <a:prstGeom prst="rect">
+            <a:avLst/>
+          </a:prstGeom>
+          <a:noFill/>
+        </p:spPr>
+        <p:txBody>
+          <a:bodyPr wrap="square" lIns="0" rIns="0" tIns="0" bIns="0" anchor="t">
+            <a:noAutofit/>
+          </a:bodyPr>
+          <a:lstStyle/>
+          <a:p>
+            <a:pPr algn="l">
+              <a:lnSpc>
+                <a:spcPts val="2295"/>
+              </a:lnSpc>
+              <a:spcBef>
+                <a:spcPts val="0"/>
+              </a:spcBef>
+              <a:spcAft>
+                <a:spcPts val="0"/>
+              </a:spcAft>
+            </a:pPr>
+            <a:r>
+              <a:rPr sz="1700" b="0" i="0">
+                <a:solidFill>
+                  <a:srgbClr val="1D2433"/>
+                </a:solidFill>
+                <a:latin typeface="Noto Sans"/>
+              </a:rPr>
+              <a:t>Rules on a long notice board</a:t>
+            </a:r>
+          </a:p>
+        </p:txBody>
+      </p:sp>
+      <p:sp>
+        <p:nvSpPr>
+          <p:cNvPr id="21" name="Box"/>
+          <p:cNvSpPr/>
+          <p:nvPr/>
+        </p:nvSpPr>
+        <p:spPr>
+          <a:xfrm>
+            <a:off x="6438900" y="3618111"/>
+            <a:ext cx="101600" cy="101600"/>
+          </a:xfrm>
+          <a:prstGeom prst="roundRect">
+            <a:avLst>
+              <a:gd name="adj" fmla="val 25000"/>
+            </a:avLst>
+          </a:prstGeom>
+          <a:solidFill>
+            <a:srgbClr val="5B4BD6"/>
+          </a:solidFill>
+          <a:ln>
+            <a:noFill/>
+          </a:ln>
+          <a:effectLst/>
+        </p:spPr>
+        <p:txBody>
+          <a:bodyPr rtlCol="0" anchor="ctr"/>
+          <a:lstStyle/>
+          <a:p>
+            <a:pPr algn="ctr"/>
+          </a:p>
+        </p:txBody>
+      </p:sp>
+      <p:sp>
+        <p:nvSpPr>
+          <p:cNvPr id="22" name="Text"/>
+          <p:cNvSpPr txBox="1"/>
+          <p:nvPr/>
+        </p:nvSpPr>
+        <p:spPr>
+          <a:xfrm>
+            <a:off x="6705600" y="3523178"/>
+            <a:ext cx="4630674" cy="291465"/>
+          </a:xfrm>
+          <a:prstGeom prst="rect">
+            <a:avLst/>
+          </a:prstGeom>
+          <a:noFill/>
+        </p:spPr>
+        <p:txBody>
+          <a:bodyPr wrap="square" lIns="0" rIns="0" tIns="0" bIns="0" anchor="t">
+            <a:noAutofit/>
+          </a:bodyPr>
+          <a:lstStyle/>
+          <a:p>
+            <a:pPr algn="l">
+              <a:lnSpc>
+                <a:spcPts val="2295"/>
+              </a:lnSpc>
+              <a:spcBef>
+                <a:spcPts val="0"/>
+              </a:spcBef>
+              <a:spcAft>
+                <a:spcPts val="0"/>
+              </a:spcAft>
+            </a:pPr>
+            <a:r>
+              <a:rPr sz="1700" b="0" i="0">
+                <a:solidFill>
+                  <a:srgbClr val="1D2433"/>
+                </a:solidFill>
+                <a:latin typeface="Noto Sans"/>
+              </a:rPr>
+              <a:t>Fines nobody collects</a:t>
+            </a:r>
+          </a:p>
+        </p:txBody>
+      </p:sp>
+      <p:sp>
+        <p:nvSpPr>
+          <p:cNvPr id="23" name="Box"/>
+          <p:cNvSpPr/>
+          <p:nvPr/>
+        </p:nvSpPr>
+        <p:spPr>
+          <a:xfrm>
+            <a:off x="6438900" y="4011116"/>
+            <a:ext cx="101600" cy="101600"/>
+          </a:xfrm>
+          <a:prstGeom prst="roundRect">
+            <a:avLst>
+              <a:gd name="adj" fmla="val 25000"/>
+            </a:avLst>
+          </a:prstGeom>
+          <a:solidFill>
+            <a:srgbClr val="5B4BD6"/>
+          </a:solidFill>
+          <a:ln>
+            <a:noFill/>
+          </a:ln>
+          <a:effectLst/>
+        </p:spPr>
+        <p:txBody>
+          <a:bodyPr rtlCol="0" anchor="ctr"/>
+          <a:lstStyle/>
+          <a:p>
+            <a:pPr algn="ctr"/>
+          </a:p>
+        </p:txBody>
+      </p:sp>
+      <p:sp>
+        <p:nvSpPr>
+          <p:cNvPr id="24" name="Text"/>
+          <p:cNvSpPr txBox="1"/>
+          <p:nvPr/>
+        </p:nvSpPr>
+        <p:spPr>
+          <a:xfrm>
+            <a:off x="6705600" y="3916184"/>
+            <a:ext cx="4630674" cy="291465"/>
+          </a:xfrm>
+          <a:prstGeom prst="rect">
+            <a:avLst/>
+          </a:prstGeom>
+          <a:noFill/>
+        </p:spPr>
+        <p:txBody>
+          <a:bodyPr wrap="square" lIns="0" rIns="0" tIns="0" bIns="0" anchor="t">
+            <a:noAutofit/>
+          </a:bodyPr>
+          <a:lstStyle/>
+          <a:p>
+            <a:pPr algn="l">
+              <a:lnSpc>
+                <a:spcPts val="2295"/>
+              </a:lnSpc>
+              <a:spcBef>
+                <a:spcPts val="0"/>
+              </a:spcBef>
+              <a:spcAft>
+                <a:spcPts val="0"/>
+              </a:spcAft>
+            </a:pPr>
+            <a:r>
+              <a:rPr sz="1700" b="0" i="0">
+                <a:solidFill>
+                  <a:srgbClr val="1D2433"/>
+                </a:solidFill>
+                <a:latin typeface="Noto Sans"/>
+              </a:rPr>
+              <a:t>Opening whenever someone is free</a:t>
+            </a:r>
+          </a:p>
+        </p:txBody>
+      </p:sp>
+      <p:sp>
+        <p:nvSpPr>
+          <p:cNvPr id="25" name="Box"/>
+          <p:cNvSpPr/>
+          <p:nvPr/>
+        </p:nvSpPr>
+        <p:spPr>
+          <a:xfrm>
+            <a:off x="762000" y="6369050"/>
+            <a:ext cx="10668000" cy="6350"/>
+          </a:xfrm>
+          <a:prstGeom prst="rect">
+            <a:avLst/>
+          </a:prstGeom>
+          <a:solidFill>
+            <a:srgbClr val="DCD9D0"/>
+          </a:solidFill>
+          <a:ln>
+            <a:noFill/>
+          </a:ln>
+          <a:effectLst/>
+        </p:spPr>
+        <p:txBody>
+          <a:bodyPr rtlCol="0" anchor="ctr"/>
+          <a:lstStyle/>
+          <a:p>
+            <a:pPr algn="ctr"/>
+          </a:p>
+        </p:txBody>
+      </p:sp>
+      <p:sp>
+        <p:nvSpPr>
+          <p:cNvPr id="26" name="Text"/>
+          <p:cNvSpPr txBox="1"/>
+          <p:nvPr/>
+        </p:nvSpPr>
+        <p:spPr>
+          <a:xfrm>
+            <a:off x="762000" y="6495561"/>
+            <a:ext cx="1339850" cy="147028"/>
+          </a:xfrm>
+          <a:prstGeom prst="rect">
+            <a:avLst/>
+          </a:prstGeom>
+          <a:noFill/>
+        </p:spPr>
+        <p:txBody>
+          <a:bodyPr wrap="none" lIns="0" rIns="0" tIns="0" bIns="0" anchor="t">
+            <a:noAutofit/>
+          </a:bodyPr>
+          <a:lstStyle/>
+          <a:p>
+            <a:pPr algn="l">
+              <a:lnSpc>
+                <a:spcPts val="1157"/>
+              </a:lnSpc>
+              <a:spcBef>
+                <a:spcPts val="0"/>
+              </a:spcBef>
+              <a:spcAft>
+                <a:spcPts val="0"/>
+              </a:spcAft>
+            </a:pPr>
+            <a:r>
+              <a:rPr sz="850" b="1" i="0">
+                <a:solidFill>
+                  <a:srgbClr val="4A5163"/>
+                </a:solidFill>
+                <a:latin typeface="Noto Sans"/>
+              </a:rPr>
+              <a:t>Source:</a:t>
+            </a:r>
+            <a:r>
+              <a:rPr sz="850" b="0" i="0">
+                <a:solidFill>
+                  <a:srgbClr val="8A8F9C"/>
+                </a:solidFill>
+                <a:latin typeface="Noto Sans"/>
+              </a:rPr>
+              <a:t> Invented example</a:t>
+            </a:r>
+          </a:p>
+        </p:txBody>
+      </p:sp>
+      <p:sp>
+        <p:nvSpPr>
+          <p:cNvPr id="27" name="Text"/>
+          <p:cNvSpPr txBox="1"/>
+          <p:nvPr/>
+        </p:nvSpPr>
+        <p:spPr>
+          <a:xfrm>
+            <a:off x="11087100" y="6495561"/>
+            <a:ext cx="353187" cy="147028"/>
+          </a:xfrm>
+          <a:prstGeom prst="rect">
+            <a:avLst/>
+          </a:prstGeom>
+          <a:noFill/>
+        </p:spPr>
+        <p:txBody>
+          <a:bodyPr wrap="square" lIns="0" rIns="0" tIns="0" bIns="0" anchor="t">
+            <a:noAutofit/>
+          </a:bodyPr>
+          <a:lstStyle/>
+          <a:p>
+            <a:pPr algn="l">
+              <a:lnSpc>
+                <a:spcPts val="1157"/>
+              </a:lnSpc>
+              <a:spcBef>
+                <a:spcPts val="0"/>
+              </a:spcBef>
+              <a:spcAft>
+                <a:spcPts val="0"/>
+              </a:spcAft>
+            </a:pPr>
+            <a:r>
+              <a:rPr sz="850" b="0" i="0">
+                <a:solidFill>
+                  <a:srgbClr val="8A8F9C"/>
+                </a:solidFill>
+                <a:latin typeface="Noto Sans"/>
+              </a:rPr>
+              <a:t>10 / 13</a:t>
+            </a:r>
+          </a:p>
+        </p:txBody>
+      </p:sp>
+    </p:spTree>
+  </p:cSld>
+  <p:clrMapOvr>
+    <a:masterClrMapping/>
+  </p:clrMapOvr>
+</p:sld>
+</file>
+
+<file path=ppt/slides/slide11.xml><?xml version="1.0" encoding="utf-8"?>
 <p:sld xmlns:a="http://schemas.openxmlformats.org/drawingml/2006/main" xmlns:p="http://schemas.openxmlformats.org/presentationml/2006/main" xmlns:r="http://schemas.openxmlformats.org/officeDocument/2006/relationships">
   <p:cSld>
     <p:bg>
@@ -4757,8 +5898,8 @@
         </p:nvSpPr>
         <p:spPr>
           <a:xfrm>
-            <a:off x="10356850" y="762000"/>
-            <a:ext cx="974534" cy="1651000"/>
+            <a:off x="10350500" y="762000"/>
+            <a:ext cx="981075" cy="1651000"/>
           </a:xfrm>
           <a:prstGeom prst="rect">
             <a:avLst/>
@@ -5008,7 +6149,7 @@
                 </a:solidFill>
                 <a:latin typeface="Noto Sans"/>
               </a:rPr>
-              <a:t>10 / 12</a:t>
+              <a:t>11 / 13</a:t>
             </a:r>
           </a:p>
         </p:txBody>
@@ -5021,7 +6162,7 @@
 </p:sld>
 </file>
 
-<file path=ppt/slides/slide11.xml><?xml version="1.0" encoding="utf-8"?>
+<file path=ppt/slides/slide12.xml><?xml version="1.0" encoding="utf-8"?>
 <p:sld xmlns:a="http://schemas.openxmlformats.org/drawingml/2006/main" xmlns:p="http://schemas.openxmlformats.org/presentationml/2006/main" xmlns:r="http://schemas.openxmlformats.org/officeDocument/2006/relationships">
   <p:cSld>
     <p:bg>
@@ -5451,7 +6592,7 @@
                 </a:solidFill>
                 <a:latin typeface="Noto Sans"/>
               </a:rPr>
-              <a:t>11 / 12</a:t>
+              <a:t>12 / 13</a:t>
             </a:r>
           </a:p>
         </p:txBody>
@@ -5464,7 +6605,7 @@
 </p:sld>
 </file>
 
-<file path=ppt/slides/slide12.xml><?xml version="1.0" encoding="utf-8"?>
+<file path=ppt/slides/slide13.xml><?xml version="1.0" encoding="utf-8"?>
 <p:sld xmlns:a="http://schemas.openxmlformats.org/drawingml/2006/main" xmlns:p="http://schemas.openxmlformats.org/presentationml/2006/main" xmlns:r="http://schemas.openxmlformats.org/officeDocument/2006/relationships">
   <p:cSld>
     <p:bg>
@@ -6107,7 +7248,7 @@
                 </a:solidFill>
                 <a:latin typeface="Noto Sans"/>
               </a:rPr>
-              <a:t>12 / 12</a:t>
+              <a:t>13 / 13</a:t>
             </a:r>
           </a:p>
         </p:txBody>
@@ -7873,7 +9014,7 @@
                 </a:solidFill>
                 <a:latin typeface="Noto Sans"/>
               </a:rPr>
-              <a:t>2 / 12</a:t>
+              <a:t>2 / 13</a:t>
             </a:r>
           </a:p>
         </p:txBody>
@@ -8620,7 +9761,7 @@
                 </a:solidFill>
                 <a:latin typeface="Noto Sans"/>
               </a:rPr>
-              <a:t>3 / 12</a:t>
+              <a:t>3 / 13</a:t>
             </a:r>
           </a:p>
         </p:txBody>
@@ -8758,7 +9899,7 @@
         <p:spPr>
           <a:xfrm>
             <a:off x="508000" y="1587500"/>
-            <a:ext cx="11176000" cy="3683000"/>
+            <a:ext cx="11176000" cy="3276600"/>
           </a:xfrm>
           <a:prstGeom prst="rect">
             <a:avLst/>
@@ -8773,7 +9914,7 @@
         </p:nvSpPr>
         <p:spPr>
           <a:xfrm>
-            <a:off x="1631950" y="3765550"/>
+            <a:off x="1631950" y="3562350"/>
             <a:ext cx="1117600" cy="260350"/>
           </a:xfrm>
           <a:prstGeom prst="rect">
@@ -8818,7 +9959,7 @@
         </p:nvSpPr>
         <p:spPr>
           <a:xfrm>
-            <a:off x="1670050" y="4070350"/>
+            <a:off x="1670050" y="3867150"/>
             <a:ext cx="1041400" cy="190500"/>
           </a:xfrm>
           <a:prstGeom prst="rect">
@@ -8863,7 +10004,7 @@
         </p:nvSpPr>
         <p:spPr>
           <a:xfrm>
-            <a:off x="4289425" y="3765550"/>
+            <a:off x="4289425" y="3562350"/>
             <a:ext cx="1016000" cy="260350"/>
           </a:xfrm>
           <a:prstGeom prst="rect">
@@ -8908,7 +10049,7 @@
         </p:nvSpPr>
         <p:spPr>
           <a:xfrm>
-            <a:off x="4254500" y="4070350"/>
+            <a:off x="4254500" y="3867150"/>
             <a:ext cx="1079500" cy="190500"/>
           </a:xfrm>
           <a:prstGeom prst="rect">
@@ -8953,7 +10094,7 @@
         </p:nvSpPr>
         <p:spPr>
           <a:xfrm>
-            <a:off x="6969125" y="3765550"/>
+            <a:off x="6969125" y="3562350"/>
             <a:ext cx="857250" cy="260350"/>
           </a:xfrm>
           <a:prstGeom prst="rect">
@@ -8998,7 +10139,7 @@
         </p:nvSpPr>
         <p:spPr>
           <a:xfrm>
-            <a:off x="6435725" y="4070350"/>
+            <a:off x="6435725" y="3867150"/>
             <a:ext cx="1924050" cy="190500"/>
           </a:xfrm>
           <a:prstGeom prst="rect">
@@ -9043,7 +10184,7 @@
         </p:nvSpPr>
         <p:spPr>
           <a:xfrm>
-            <a:off x="9512300" y="3765550"/>
+            <a:off x="9512300" y="3562350"/>
             <a:ext cx="977900" cy="260350"/>
           </a:xfrm>
           <a:prstGeom prst="rect">
@@ -9088,7 +10229,7 @@
         </p:nvSpPr>
         <p:spPr>
           <a:xfrm>
-            <a:off x="9232900" y="4070350"/>
+            <a:off x="9232900" y="3867150"/>
             <a:ext cx="1536700" cy="190500"/>
           </a:xfrm>
           <a:prstGeom prst="rect">
@@ -9133,7 +10274,7 @@
         </p:nvSpPr>
         <p:spPr>
           <a:xfrm>
-            <a:off x="4752975" y="2794000"/>
+            <a:off x="4752975" y="2590800"/>
             <a:ext cx="2940050" cy="209550"/>
           </a:xfrm>
           <a:prstGeom prst="rect">
@@ -9173,6 +10314,83 @@
       <p:sp>
         <p:nvSpPr>
           <p:cNvPr id="14" name="Box"/>
+          <p:cNvSpPr/>
+          <p:nvPr/>
+        </p:nvSpPr>
+        <p:spPr>
+          <a:xfrm>
+            <a:off x="762000" y="5054600"/>
+            <a:ext cx="10668000" cy="279400"/>
+          </a:xfrm>
+          <a:prstGeom prst="roundRect">
+            <a:avLst>
+              <a:gd name="adj" fmla="val 27272"/>
+            </a:avLst>
+          </a:prstGeom>
+          <a:solidFill>
+            <a:srgbClr val="ECE9FB"/>
+          </a:solidFill>
+          <a:ln>
+            <a:noFill/>
+          </a:ln>
+          <a:effectLst/>
+        </p:spPr>
+        <p:txBody>
+          <a:bodyPr rtlCol="0" anchor="ctr"/>
+          <a:lstStyle/>
+          <a:p>
+            <a:pPr algn="ctr"/>
+          </a:p>
+        </p:txBody>
+      </p:sp>
+      <p:sp>
+        <p:nvSpPr>
+          <p:cNvPr id="15" name="Text"/>
+          <p:cNvSpPr txBox="1"/>
+          <p:nvPr/>
+        </p:nvSpPr>
+        <p:spPr>
+          <a:xfrm>
+            <a:off x="914400" y="5054600"/>
+            <a:ext cx="10363200" cy="279400"/>
+          </a:xfrm>
+          <a:prstGeom prst="rect">
+            <a:avLst/>
+          </a:prstGeom>
+          <a:noFill/>
+        </p:spPr>
+        <p:txBody>
+          <a:bodyPr wrap="none" lIns="0" rIns="0" tIns="0" bIns="0" anchor="t">
+            <a:noAutofit/>
+          </a:bodyPr>
+          <a:lstStyle/>
+          <a:p>
+            <a:pPr algn="l">
+              <a:lnSpc>
+                <a:spcPts val="2200"/>
+              </a:lnSpc>
+              <a:spcBef>
+                <a:spcPts val="0"/>
+              </a:spcBef>
+              <a:spcAft>
+                <a:spcPts val="0"/>
+              </a:spcAft>
+            </a:pPr>
+            <a:r>
+              <a:rPr sz="1400" b="1" i="0">
+                <a:solidFill>
+                  <a:srgbClr val="5B4BD6"/>
+                </a:solidFill>
+                <a:latin typeface="Noto Sans"/>
+              </a:rPr>
+              <a:t>Return: hang it back clean, and write the date in the ledger.</a:t>
+            </a:r>
+          </a:p>
+        </p:txBody>
+      </p:sp>
+      <p:sp>
+        <p:nvSpPr>
+          <p:cNvPr id="16" name="Box"/>
           <p:cNvSpPr/>
           <p:nvPr/>
         </p:nvSpPr>
@@ -9204,7 +10422,7 @@
       </p:sp>
       <p:sp>
         <p:nvSpPr>
-          <p:cNvPr id="15" name="Text"/>
+          <p:cNvPr id="17" name="Text"/>
           <p:cNvSpPr txBox="1"/>
           <p:nvPr/>
         </p:nvSpPr>
@@ -9249,7 +10467,7 @@
       </p:sp>
       <p:sp>
         <p:nvSpPr>
-          <p:cNvPr id="16" name="Text"/>
+          <p:cNvPr id="18" name="Text"/>
           <p:cNvSpPr txBox="1"/>
           <p:nvPr/>
         </p:nvSpPr>
@@ -9294,7 +10512,7 @@
       </p:sp>
       <p:sp>
         <p:nvSpPr>
-          <p:cNvPr id="17" name="Box"/>
+          <p:cNvPr id="19" name="Box"/>
           <p:cNvSpPr/>
           <p:nvPr/>
         </p:nvSpPr>
@@ -9324,7 +10542,7 @@
       </p:sp>
       <p:sp>
         <p:nvSpPr>
-          <p:cNvPr id="18" name="Text"/>
+          <p:cNvPr id="20" name="Text"/>
           <p:cNvSpPr txBox="1"/>
           <p:nvPr/>
         </p:nvSpPr>
@@ -9378,7 +10596,7 @@
       </p:sp>
       <p:sp>
         <p:nvSpPr>
-          <p:cNvPr id="19" name="Text"/>
+          <p:cNvPr id="21" name="Text"/>
           <p:cNvSpPr txBox="1"/>
           <p:nvPr/>
         </p:nvSpPr>
@@ -9416,7 +10634,7 @@
                 </a:solidFill>
                 <a:latin typeface="Noto Sans"/>
               </a:rPr>
-              <a:t>4 / 12</a:t>
+              <a:t>4 / 13</a:t>
             </a:r>
           </a:p>
         </p:txBody>
@@ -10630,7 +11848,7 @@
                 </a:solidFill>
                 <a:latin typeface="Noto Sans"/>
               </a:rPr>
-              <a:t>5 / 12</a:t>
+              <a:t>5 / 13</a:t>
             </a:r>
           </a:p>
         </p:txBody>
@@ -11414,7 +12632,7 @@
                 </a:solidFill>
                 <a:latin typeface="Noto Sans"/>
               </a:rPr>
-              <a:t>6 / 12</a:t>
+              <a:t>6 / 13</a:t>
             </a:r>
           </a:p>
         </p:txBody>
@@ -13786,7 +15004,7 @@
                 </a:solidFill>
                 <a:latin typeface="Noto Sans"/>
               </a:rPr>
-              <a:t>7 / 12</a:t>
+              <a:t>7 / 13</a:t>
             </a:r>
           </a:p>
         </p:txBody>
@@ -13857,7 +15075,7 @@
                 </a:solidFill>
                 <a:latin typeface="Noto Sans"/>
               </a:rPr>
-              <a:t>From a shared garage to a labelled shed</a:t>
+              <a:t>Most tools come back, and on time</a:t>
             </a:r>
           </a:p>
         </p:txBody>
@@ -13902,33 +15120,260 @@
                 </a:solidFill>
                 <a:latin typeface="Noto Sans"/>
               </a:rPr>
-              <a:t>BEFORE AND AFTER</a:t>
-            </a:r>
-          </a:p>
-        </p:txBody>
-      </p:sp>
-      <p:sp>
-        <p:nvSpPr>
-          <p:cNvPr id="4" name="Box"/>
+              <a:t>THE NUMBERS</a:t>
+            </a:r>
+          </a:p>
+        </p:txBody>
+      </p:sp>
+      <p:sp>
+        <p:nvSpPr>
+          <p:cNvPr id="4" name="Text"/>
+          <p:cNvSpPr txBox="1"/>
+          <p:nvPr/>
+        </p:nvSpPr>
+        <p:spPr>
+          <a:xfrm>
+            <a:off x="2930018" y="1974361"/>
+            <a:ext cx="2869031" cy="147028"/>
+          </a:xfrm>
+          <a:prstGeom prst="rect">
+            <a:avLst/>
+          </a:prstGeom>
+          <a:noFill/>
+        </p:spPr>
+        <p:txBody>
+          <a:bodyPr wrap="square" lIns="0" rIns="0" tIns="0" bIns="0" anchor="t">
+            <a:noAutofit/>
+          </a:bodyPr>
+          <a:lstStyle/>
+          <a:p>
+            <a:pPr algn="ctr">
+              <a:lnSpc>
+                <a:spcPts val="1157"/>
+              </a:lnSpc>
+              <a:spcBef>
+                <a:spcPts val="0"/>
+              </a:spcBef>
+              <a:spcAft>
+                <a:spcPts val="0"/>
+              </a:spcAft>
+            </a:pPr>
+            <a:r>
+              <a:rPr sz="850" b="1" i="0" spc="102">
+                <a:solidFill>
+                  <a:srgbClr val="8A8F9C"/>
+                </a:solidFill>
+                <a:latin typeface="Noto Sans"/>
+              </a:rPr>
+              <a:t>WEEK 1</a:t>
+            </a:r>
+          </a:p>
+        </p:txBody>
+      </p:sp>
+      <p:sp>
+        <p:nvSpPr>
+          <p:cNvPr id="5" name="Text"/>
+          <p:cNvSpPr txBox="1"/>
+          <p:nvPr/>
+        </p:nvSpPr>
+        <p:spPr>
+          <a:xfrm>
+            <a:off x="5766284" y="1974361"/>
+            <a:ext cx="2869133" cy="147028"/>
+          </a:xfrm>
+          <a:prstGeom prst="rect">
+            <a:avLst/>
+          </a:prstGeom>
+          <a:noFill/>
+        </p:spPr>
+        <p:txBody>
+          <a:bodyPr wrap="square" lIns="0" rIns="0" tIns="0" bIns="0" anchor="t">
+            <a:noAutofit/>
+          </a:bodyPr>
+          <a:lstStyle/>
+          <a:p>
+            <a:pPr algn="ctr">
+              <a:lnSpc>
+                <a:spcPts val="1157"/>
+              </a:lnSpc>
+              <a:spcBef>
+                <a:spcPts val="0"/>
+              </a:spcBef>
+              <a:spcAft>
+                <a:spcPts val="0"/>
+              </a:spcAft>
+            </a:pPr>
+            <a:r>
+              <a:rPr sz="850" b="1" i="0" spc="102">
+                <a:solidFill>
+                  <a:srgbClr val="8A8F9C"/>
+                </a:solidFill>
+                <a:latin typeface="Noto Sans"/>
+              </a:rPr>
+              <a:t>WEEK 4</a:t>
+            </a:r>
+          </a:p>
+        </p:txBody>
+      </p:sp>
+      <p:sp>
+        <p:nvSpPr>
+          <p:cNvPr id="6" name="Text"/>
+          <p:cNvSpPr txBox="1"/>
+          <p:nvPr/>
+        </p:nvSpPr>
+        <p:spPr>
+          <a:xfrm>
+            <a:off x="8602652" y="1974361"/>
+            <a:ext cx="2869031" cy="147028"/>
+          </a:xfrm>
+          <a:prstGeom prst="rect">
+            <a:avLst/>
+          </a:prstGeom>
+          <a:noFill/>
+        </p:spPr>
+        <p:txBody>
+          <a:bodyPr wrap="square" lIns="0" rIns="0" tIns="0" bIns="0" anchor="t">
+            <a:noAutofit/>
+          </a:bodyPr>
+          <a:lstStyle/>
+          <a:p>
+            <a:pPr algn="ctr">
+              <a:lnSpc>
+                <a:spcPts val="1157"/>
+              </a:lnSpc>
+              <a:spcBef>
+                <a:spcPts val="0"/>
+              </a:spcBef>
+              <a:spcAft>
+                <a:spcPts val="0"/>
+              </a:spcAft>
+            </a:pPr>
+            <a:r>
+              <a:rPr sz="850" b="1" i="0" spc="102">
+                <a:solidFill>
+                  <a:srgbClr val="5B4BD6"/>
+                </a:solidFill>
+                <a:latin typeface="Noto Sans"/>
+              </a:rPr>
+              <a:t>WEEK 12</a:t>
+            </a:r>
+          </a:p>
+        </p:txBody>
+      </p:sp>
+      <p:sp>
+        <p:nvSpPr>
+          <p:cNvPr id="7" name="Text"/>
+          <p:cNvSpPr txBox="1"/>
+          <p:nvPr/>
+        </p:nvSpPr>
+        <p:spPr>
+          <a:xfrm>
+            <a:off x="762000" y="2239050"/>
+            <a:ext cx="2119122" cy="181610"/>
+          </a:xfrm>
+          <a:prstGeom prst="rect">
+            <a:avLst/>
+          </a:prstGeom>
+          <a:noFill/>
+        </p:spPr>
+        <p:txBody>
+          <a:bodyPr wrap="square" lIns="0" rIns="0" tIns="0" bIns="0" anchor="t">
+            <a:noAutofit/>
+          </a:bodyPr>
+          <a:lstStyle/>
+          <a:p>
+            <a:pPr algn="l">
+              <a:lnSpc>
+                <a:spcPts val="1430"/>
+              </a:lnSpc>
+              <a:spcBef>
+                <a:spcPts val="0"/>
+              </a:spcBef>
+              <a:spcAft>
+                <a:spcPts val="0"/>
+              </a:spcAft>
+            </a:pPr>
+            <a:r>
+              <a:rPr sz="1300" b="1" i="0">
+                <a:solidFill>
+                  <a:srgbClr val="1D2433"/>
+                </a:solidFill>
+                <a:latin typeface="Noto Sans"/>
+              </a:rPr>
+              <a:t>Returned</a:t>
+            </a:r>
+          </a:p>
+        </p:txBody>
+      </p:sp>
+      <p:sp>
+        <p:nvSpPr>
+          <p:cNvPr id="8" name="Text"/>
+          <p:cNvSpPr txBox="1"/>
+          <p:nvPr/>
+        </p:nvSpPr>
+        <p:spPr>
+          <a:xfrm>
+            <a:off x="762000" y="2417445"/>
+            <a:ext cx="2119122" cy="137160"/>
+          </a:xfrm>
+          <a:prstGeom prst="rect">
+            <a:avLst/>
+          </a:prstGeom>
+          <a:noFill/>
+        </p:spPr>
+        <p:txBody>
+          <a:bodyPr wrap="square" lIns="0" rIns="0" tIns="0" bIns="0" anchor="t">
+            <a:noAutofit/>
+          </a:bodyPr>
+          <a:lstStyle/>
+          <a:p>
+            <a:pPr algn="l">
+              <a:lnSpc>
+                <a:spcPts val="1080"/>
+              </a:lnSpc>
+              <a:spcBef>
+                <a:spcPts val="0"/>
+              </a:spcBef>
+              <a:spcAft>
+                <a:spcPts val="0"/>
+              </a:spcAft>
+            </a:pPr>
+            <a:r>
+              <a:rPr sz="900" b="0" i="0">
+                <a:solidFill>
+                  <a:srgbClr val="8A8F9C"/>
+                </a:solidFill>
+                <a:latin typeface="Noto Sans"/>
+              </a:rPr>
+              <a:t>share of tools out</a:t>
+            </a:r>
+          </a:p>
+        </p:txBody>
+      </p:sp>
+      <p:sp>
+        <p:nvSpPr>
+          <p:cNvPr id="9" name="Box"/>
           <p:cNvSpPr/>
           <p:nvPr/>
         </p:nvSpPr>
         <p:spPr>
           <a:xfrm>
-            <a:off x="762000" y="1905000"/>
-            <a:ext cx="4662289" cy="2159000"/>
+            <a:off x="2971800" y="2209800"/>
+            <a:ext cx="2785467" cy="381000"/>
           </a:xfrm>
           <a:prstGeom prst="roundRect">
             <a:avLst>
-              <a:gd name="adj" fmla="val 4705"/>
+              <a:gd name="adj" fmla="val 16666"/>
             </a:avLst>
           </a:prstGeom>
           <a:solidFill>
-            <a:srgbClr val="FFFFFF"/>
+            <a:srgbClr val="74BE9C"/>
           </a:solidFill>
-          <a:ln w="6350">
+          <a:ln w="19050">
             <a:solidFill>
-              <a:srgbClr val="DCD9D0"/>
+              <a:srgbClr val="000000">
+                <a:alpha val="0"/>
+              </a:srgbClr>
             </a:solidFill>
           </a:ln>
           <a:effectLst/>
@@ -13943,14 +15388,14 @@
       </p:sp>
       <p:sp>
         <p:nvSpPr>
-          <p:cNvPr id="5" name="Text"/>
-          <p:cNvSpPr txBox="1"/>
-          <p:nvPr/>
-        </p:nvSpPr>
-        <p:spPr>
-          <a:xfrm>
-            <a:off x="965200" y="2093862"/>
-            <a:ext cx="4383566" cy="155677"/>
+          <p:cNvPr id="10" name="Text"/>
+          <p:cNvSpPr txBox="1"/>
+          <p:nvPr/>
+        </p:nvSpPr>
+        <p:spPr>
+          <a:xfrm>
+            <a:off x="4196259" y="2287867"/>
+            <a:ext cx="346646" cy="224866"/>
           </a:xfrm>
           <a:prstGeom prst="rect">
             <a:avLst/>
@@ -13965,93 +15410,52 @@
           <a:p>
             <a:pPr algn="l">
               <a:lnSpc>
-                <a:spcPts val="1225"/>
-              </a:lnSpc>
-              <a:spcBef>
-                <a:spcPts val="0"/>
-              </a:spcBef>
-              <a:spcAft>
-                <a:spcPts val="0"/>
-              </a:spcAft>
-            </a:pPr>
-            <a:r>
-              <a:rPr sz="900" b="1" i="0" spc="108">
-                <a:solidFill>
-                  <a:srgbClr val="8A8F9C"/>
-                </a:solidFill>
-                <a:latin typeface="Noto Sans"/>
-              </a:rPr>
-              <a:t>BEFORE</a:t>
-            </a:r>
-          </a:p>
-        </p:txBody>
-      </p:sp>
-      <p:sp>
-        <p:nvSpPr>
-          <p:cNvPr id="6" name="Text"/>
-          <p:cNvSpPr txBox="1"/>
-          <p:nvPr/>
-        </p:nvSpPr>
-        <p:spPr>
-          <a:xfrm>
-            <a:off x="965200" y="2321560"/>
-            <a:ext cx="4383566" cy="720050"/>
-          </a:xfrm>
-          <a:prstGeom prst="rect">
-            <a:avLst/>
-          </a:prstGeom>
-          <a:noFill/>
-        </p:spPr>
-        <p:txBody>
-          <a:bodyPr wrap="square" lIns="0" rIns="0" tIns="0" bIns="0" anchor="t">
-            <a:noAutofit/>
-          </a:bodyPr>
-          <a:lstStyle/>
-          <a:p>
-            <a:pPr algn="l">
-              <a:lnSpc>
-                <a:spcPts val="1889"/>
-              </a:lnSpc>
-              <a:spcBef>
-                <a:spcPts val="0"/>
-              </a:spcBef>
-              <a:spcAft>
-                <a:spcPts val="0"/>
-              </a:spcAft>
-            </a:pPr>
-            <a:r>
-              <a:rPr sz="1350" b="0" i="0">
-                <a:solidFill>
-                  <a:srgbClr val="4A5163"/>
-                </a:solidFill>
-                <a:latin typeface="Noto Sans"/>
-              </a:rPr>
-              <a:t>Tools lived in one garage. Nobody knew what was there, so people bought a second drill and the first went missing.</a:t>
-            </a:r>
-          </a:p>
-        </p:txBody>
-      </p:sp>
-      <p:sp>
-        <p:nvSpPr>
-          <p:cNvPr id="7" name="Box"/>
+                <a:spcPts val="1770"/>
+              </a:lnSpc>
+              <a:spcBef>
+                <a:spcPts val="0"/>
+              </a:spcBef>
+              <a:spcAft>
+                <a:spcPts val="0"/>
+              </a:spcAft>
+            </a:pPr>
+            <a:r>
+              <a:rPr sz="1300" b="1" i="0">
+                <a:solidFill>
+                  <a:srgbClr val="FFFFFF"/>
+                </a:solidFill>
+                <a:latin typeface="Noto Sans"/>
+              </a:rPr>
+              <a:t>62%</a:t>
+            </a:r>
+          </a:p>
+        </p:txBody>
+      </p:sp>
+      <p:sp>
+        <p:nvSpPr>
+          <p:cNvPr id="11" name="Box"/>
           <p:cNvSpPr/>
           <p:nvPr/>
         </p:nvSpPr>
         <p:spPr>
           <a:xfrm>
-            <a:off x="5602089" y="1905000"/>
-            <a:ext cx="5827911" cy="2159000"/>
+            <a:off x="5808067" y="2209800"/>
+            <a:ext cx="2785566" cy="381000"/>
           </a:xfrm>
           <a:prstGeom prst="roundRect">
             <a:avLst>
-              <a:gd name="adj" fmla="val 4705"/>
+              <a:gd name="adj" fmla="val 16666"/>
             </a:avLst>
           </a:prstGeom>
           <a:solidFill>
-            <a:srgbClr val="5B4BD6"/>
+            <a:srgbClr val="51AE84"/>
           </a:solidFill>
-          <a:ln>
-            <a:noFill/>
+          <a:ln w="19050">
+            <a:solidFill>
+              <a:srgbClr val="000000">
+                <a:alpha val="0"/>
+              </a:srgbClr>
+            </a:solidFill>
           </a:ln>
           <a:effectLst/>
         </p:spPr>
@@ -14065,25 +15469,72 @@
       </p:sp>
       <p:sp>
         <p:nvSpPr>
-          <p:cNvPr id="8" name="Box"/>
+          <p:cNvPr id="12" name="Text"/>
+          <p:cNvSpPr txBox="1"/>
+          <p:nvPr/>
+        </p:nvSpPr>
+        <p:spPr>
+          <a:xfrm>
+            <a:off x="7032526" y="2287867"/>
+            <a:ext cx="346646" cy="224866"/>
+          </a:xfrm>
+          <a:prstGeom prst="rect">
+            <a:avLst/>
+          </a:prstGeom>
+          <a:noFill/>
+        </p:spPr>
+        <p:txBody>
+          <a:bodyPr wrap="square" lIns="0" rIns="0" tIns="0" bIns="0" anchor="t">
+            <a:noAutofit/>
+          </a:bodyPr>
+          <a:lstStyle/>
+          <a:p>
+            <a:pPr algn="l">
+              <a:lnSpc>
+                <a:spcPts val="1770"/>
+              </a:lnSpc>
+              <a:spcBef>
+                <a:spcPts val="0"/>
+              </a:spcBef>
+              <a:spcAft>
+                <a:spcPts val="0"/>
+              </a:spcAft>
+            </a:pPr>
+            <a:r>
+              <a:rPr sz="1300" b="1" i="0">
+                <a:solidFill>
+                  <a:srgbClr val="FFFFFF"/>
+                </a:solidFill>
+                <a:latin typeface="Noto Sans"/>
+              </a:rPr>
+              <a:t>81%</a:t>
+            </a:r>
+          </a:p>
+        </p:txBody>
+      </p:sp>
+      <p:sp>
+        <p:nvSpPr>
+          <p:cNvPr id="13" name="Box"/>
           <p:cNvSpPr/>
           <p:nvPr/>
         </p:nvSpPr>
         <p:spPr>
           <a:xfrm>
-            <a:off x="5665589" y="1905000"/>
-            <a:ext cx="5764411" cy="2159000"/>
+            <a:off x="8644434" y="2209800"/>
+            <a:ext cx="2785467" cy="381000"/>
           </a:xfrm>
           <a:prstGeom prst="roundRect">
             <a:avLst>
-              <a:gd name="adj" fmla="val 1764"/>
+              <a:gd name="adj" fmla="val 16666"/>
             </a:avLst>
           </a:prstGeom>
           <a:solidFill>
-            <a:srgbClr val="FFFFFF"/>
+            <a:srgbClr val="39A373"/>
           </a:solidFill>
-          <a:ln>
-            <a:noFill/>
+          <a:ln w="19050">
+            <a:solidFill>
+              <a:srgbClr val="1D2433"/>
+            </a:solidFill>
           </a:ln>
           <a:effectLst/>
         </p:spPr>
@@ -14097,14 +15548,14 @@
       </p:sp>
       <p:sp>
         <p:nvSpPr>
-          <p:cNvPr id="9" name="Text"/>
-          <p:cNvSpPr txBox="1"/>
-          <p:nvPr/>
-        </p:nvSpPr>
-        <p:spPr>
-          <a:xfrm>
-            <a:off x="5868789" y="2093862"/>
-            <a:ext cx="5518751" cy="155677"/>
+          <p:cNvPr id="14" name="Text"/>
+          <p:cNvSpPr txBox="1"/>
+          <p:nvPr/>
+        </p:nvSpPr>
+        <p:spPr>
+          <a:xfrm>
+            <a:off x="9865717" y="2287867"/>
+            <a:ext cx="353187" cy="224866"/>
           </a:xfrm>
           <a:prstGeom prst="rect">
             <a:avLst/>
@@ -14119,37 +15570,37 @@
           <a:p>
             <a:pPr algn="l">
               <a:lnSpc>
-                <a:spcPts val="1225"/>
-              </a:lnSpc>
-              <a:spcBef>
-                <a:spcPts val="0"/>
-              </a:spcBef>
-              <a:spcAft>
-                <a:spcPts val="0"/>
-              </a:spcAft>
-            </a:pPr>
-            <a:r>
-              <a:rPr sz="900" b="1" i="0" spc="108">
-                <a:solidFill>
-                  <a:srgbClr val="5B4BD6"/>
-                </a:solidFill>
-                <a:latin typeface="Noto Sans"/>
-              </a:rPr>
-              <a:t>NOW</a:t>
-            </a:r>
-          </a:p>
-        </p:txBody>
-      </p:sp>
-      <p:sp>
-        <p:nvSpPr>
-          <p:cNvPr id="10" name="Text"/>
-          <p:cNvSpPr txBox="1"/>
-          <p:nvPr/>
-        </p:nvSpPr>
-        <p:spPr>
-          <a:xfrm>
-            <a:off x="5868789" y="2321560"/>
-            <a:ext cx="5518751" cy="480040"/>
+                <a:spcPts val="1770"/>
+              </a:lnSpc>
+              <a:spcBef>
+                <a:spcPts val="0"/>
+              </a:spcBef>
+              <a:spcAft>
+                <a:spcPts val="0"/>
+              </a:spcAft>
+            </a:pPr>
+            <a:r>
+              <a:rPr sz="1300" b="1" i="0">
+                <a:solidFill>
+                  <a:srgbClr val="FFFFFF"/>
+                </a:solidFill>
+                <a:latin typeface="Noto Sans"/>
+              </a:rPr>
+              <a:t>94%</a:t>
+            </a:r>
+          </a:p>
+        </p:txBody>
+      </p:sp>
+      <p:sp>
+        <p:nvSpPr>
+          <p:cNvPr id="15" name="Text"/>
+          <p:cNvSpPr txBox="1"/>
+          <p:nvPr/>
+        </p:nvSpPr>
+        <p:spPr>
+          <a:xfrm>
+            <a:off x="762000" y="2670850"/>
+            <a:ext cx="2119122" cy="181610"/>
           </a:xfrm>
           <a:prstGeom prst="rect">
             <a:avLst/>
@@ -14164,48 +15615,97 @@
           <a:p>
             <a:pPr algn="l">
               <a:lnSpc>
-                <a:spcPts val="1889"/>
-              </a:lnSpc>
-              <a:spcBef>
-                <a:spcPts val="0"/>
-              </a:spcBef>
-              <a:spcAft>
-                <a:spcPts val="0"/>
-              </a:spcAft>
-            </a:pPr>
-            <a:r>
-              <a:rPr sz="1350" b="0" i="0">
+                <a:spcPts val="1430"/>
+              </a:lnSpc>
+              <a:spcBef>
+                <a:spcPts val="0"/>
+              </a:spcBef>
+              <a:spcAft>
+                <a:spcPts val="0"/>
+              </a:spcAft>
+            </a:pPr>
+            <a:r>
+              <a:rPr sz="1300" b="1" i="0">
                 <a:solidFill>
                   <a:srgbClr val="1D2433"/>
                 </a:solidFill>
                 <a:latin typeface="Noto Sans"/>
               </a:rPr>
-              <a:t>Every tool has a hook, a ledger line and a Friday deadline, so anyone can see what is in and what is out.</a:t>
-            </a:r>
-          </a:p>
-        </p:txBody>
-      </p:sp>
-      <p:sp>
-        <p:nvSpPr>
-          <p:cNvPr id="11" name="Box"/>
+              <a:t>On time</a:t>
+            </a:r>
+          </a:p>
+        </p:txBody>
+      </p:sp>
+      <p:sp>
+        <p:nvSpPr>
+          <p:cNvPr id="16" name="Text"/>
+          <p:cNvSpPr txBox="1"/>
+          <p:nvPr/>
+        </p:nvSpPr>
+        <p:spPr>
+          <a:xfrm>
+            <a:off x="762000" y="2849245"/>
+            <a:ext cx="2119122" cy="137160"/>
+          </a:xfrm>
+          <a:prstGeom prst="rect">
+            <a:avLst/>
+          </a:prstGeom>
+          <a:noFill/>
+        </p:spPr>
+        <p:txBody>
+          <a:bodyPr wrap="square" lIns="0" rIns="0" tIns="0" bIns="0" anchor="t">
+            <a:noAutofit/>
+          </a:bodyPr>
+          <a:lstStyle/>
+          <a:p>
+            <a:pPr algn="l">
+              <a:lnSpc>
+                <a:spcPts val="1080"/>
+              </a:lnSpc>
+              <a:spcBef>
+                <a:spcPts val="0"/>
+              </a:spcBef>
+              <a:spcAft>
+                <a:spcPts val="0"/>
+              </a:spcAft>
+            </a:pPr>
+            <a:r>
+              <a:rPr sz="900" b="0" i="0">
+                <a:solidFill>
+                  <a:srgbClr val="8A8F9C"/>
+                </a:solidFill>
+                <a:latin typeface="Noto Sans"/>
+              </a:rPr>
+              <a:t>by the Friday deadline</a:t>
+            </a:r>
+          </a:p>
+        </p:txBody>
+      </p:sp>
+      <p:sp>
+        <p:nvSpPr>
+          <p:cNvPr id="17" name="Box"/>
           <p:cNvSpPr/>
           <p:nvPr/>
         </p:nvSpPr>
         <p:spPr>
           <a:xfrm>
-            <a:off x="762000" y="4241800"/>
-            <a:ext cx="3462834" cy="1460500"/>
+            <a:off x="2971800" y="2641600"/>
+            <a:ext cx="2785467" cy="381000"/>
           </a:xfrm>
           <a:prstGeom prst="roundRect">
             <a:avLst>
-              <a:gd name="adj" fmla="val 6086"/>
+              <a:gd name="adj" fmla="val 16666"/>
             </a:avLst>
           </a:prstGeom>
           <a:solidFill>
-            <a:srgbClr val="ECE9FB"/>
+            <a:srgbClr val="8ECAAF"/>
           </a:solidFill>
-          <a:ln>
-            <a:noFill/>
+          <a:ln w="19050">
+            <a:solidFill>
+              <a:srgbClr val="000000">
+                <a:alpha val="0"/>
+              </a:srgbClr>
+            </a:solidFill>
           </a:ln>
           <a:effectLst/>
         </p:spPr>
@@ -14219,14 +15719,14 @@
       </p:sp>
       <p:sp>
         <p:nvSpPr>
-          <p:cNvPr id="12" name="Text"/>
-          <p:cNvSpPr txBox="1"/>
-          <p:nvPr/>
-        </p:nvSpPr>
-        <p:spPr>
-          <a:xfrm>
-            <a:off x="914400" y="4379862"/>
-            <a:ext cx="3252775" cy="155677"/>
+          <p:cNvPr id="18" name="Text"/>
+          <p:cNvSpPr txBox="1"/>
+          <p:nvPr/>
+        </p:nvSpPr>
+        <p:spPr>
+          <a:xfrm>
+            <a:off x="4196259" y="2719667"/>
+            <a:ext cx="346646" cy="224866"/>
           </a:xfrm>
           <a:prstGeom prst="rect">
             <a:avLst/>
@@ -14241,93 +15741,52 @@
           <a:p>
             <a:pPr algn="l">
               <a:lnSpc>
-                <a:spcPts val="1225"/>
-              </a:lnSpc>
-              <a:spcBef>
-                <a:spcPts val="0"/>
-              </a:spcBef>
-              <a:spcAft>
-                <a:spcPts val="0"/>
-              </a:spcAft>
-            </a:pPr>
-            <a:r>
-              <a:rPr sz="900" b="1" i="0" spc="90">
-                <a:solidFill>
-                  <a:srgbClr val="5B4BD6"/>
-                </a:solidFill>
-                <a:latin typeface="Noto Sans"/>
-              </a:rPr>
-              <a:t>FINDING</a:t>
-            </a:r>
-          </a:p>
-        </p:txBody>
-      </p:sp>
-      <p:sp>
-        <p:nvSpPr>
-          <p:cNvPr id="13" name="Text"/>
-          <p:cNvSpPr txBox="1"/>
-          <p:nvPr/>
-        </p:nvSpPr>
-        <p:spPr>
-          <a:xfrm>
-            <a:off x="914400" y="4583112"/>
-            <a:ext cx="3252775" cy="438150"/>
-          </a:xfrm>
-          <a:prstGeom prst="rect">
-            <a:avLst/>
-          </a:prstGeom>
-          <a:noFill/>
-        </p:spPr>
-        <p:txBody>
-          <a:bodyPr wrap="square" lIns="0" rIns="0" tIns="0" bIns="0" anchor="t">
-            <a:noAutofit/>
-          </a:bodyPr>
-          <a:lstStyle/>
-          <a:p>
-            <a:pPr algn="l">
-              <a:lnSpc>
-                <a:spcPts val="1725"/>
-              </a:lnSpc>
-              <a:spcBef>
-                <a:spcPts val="0"/>
-              </a:spcBef>
-              <a:spcAft>
-                <a:spcPts val="0"/>
-              </a:spcAft>
-            </a:pPr>
-            <a:r>
-              <a:rPr sz="1250" b="0" i="0">
+                <a:spcPts val="1770"/>
+              </a:lnSpc>
+              <a:spcBef>
+                <a:spcPts val="0"/>
+              </a:spcBef>
+              <a:spcAft>
+                <a:spcPts val="0"/>
+              </a:spcAft>
+            </a:pPr>
+            <a:r>
+              <a:rPr sz="1300" b="1" i="0">
                 <a:solidFill>
                   <a:srgbClr val="1D2433"/>
                 </a:solidFill>
                 <a:latin typeface="Noto Sans"/>
               </a:rPr>
-              <a:t>A shelf of hooks, each labelled with the tool's name.</a:t>
-            </a:r>
-          </a:p>
-        </p:txBody>
-      </p:sp>
-      <p:sp>
-        <p:nvSpPr>
-          <p:cNvPr id="14" name="Box"/>
+              <a:t>48%</a:t>
+            </a:r>
+          </a:p>
+        </p:txBody>
+      </p:sp>
+      <p:sp>
+        <p:nvSpPr>
+          <p:cNvPr id="19" name="Box"/>
           <p:cNvSpPr/>
           <p:nvPr/>
         </p:nvSpPr>
         <p:spPr>
           <a:xfrm>
-            <a:off x="4364534" y="4241800"/>
-            <a:ext cx="3462834" cy="1460500"/>
+            <a:off x="5808067" y="2641600"/>
+            <a:ext cx="2785566" cy="381000"/>
           </a:xfrm>
           <a:prstGeom prst="roundRect">
             <a:avLst>
-              <a:gd name="adj" fmla="val 6086"/>
+              <a:gd name="adj" fmla="val 16666"/>
             </a:avLst>
           </a:prstGeom>
           <a:solidFill>
-            <a:srgbClr val="ECE9FB"/>
+            <a:srgbClr val="65B892"/>
           </a:solidFill>
-          <a:ln>
-            <a:noFill/>
+          <a:ln w="19050">
+            <a:solidFill>
+              <a:srgbClr val="000000">
+                <a:alpha val="0"/>
+              </a:srgbClr>
+            </a:solidFill>
           </a:ln>
           <a:effectLst/>
         </p:spPr>
@@ -14341,14 +15800,14 @@
       </p:sp>
       <p:sp>
         <p:nvSpPr>
-          <p:cNvPr id="15" name="Text"/>
-          <p:cNvSpPr txBox="1"/>
-          <p:nvPr/>
-        </p:nvSpPr>
-        <p:spPr>
-          <a:xfrm>
-            <a:off x="4516934" y="4379862"/>
-            <a:ext cx="3252775" cy="155677"/>
+          <p:cNvPr id="20" name="Text"/>
+          <p:cNvSpPr txBox="1"/>
+          <p:nvPr/>
+        </p:nvSpPr>
+        <p:spPr>
+          <a:xfrm>
+            <a:off x="7032526" y="2719667"/>
+            <a:ext cx="346646" cy="224866"/>
           </a:xfrm>
           <a:prstGeom prst="rect">
             <a:avLst/>
@@ -14363,93 +15822,50 @@
           <a:p>
             <a:pPr algn="l">
               <a:lnSpc>
-                <a:spcPts val="1225"/>
-              </a:lnSpc>
-              <a:spcBef>
-                <a:spcPts val="0"/>
-              </a:spcBef>
-              <a:spcAft>
-                <a:spcPts val="0"/>
-              </a:spcAft>
-            </a:pPr>
-            <a:r>
-              <a:rPr sz="900" b="1" i="0" spc="90">
-                <a:solidFill>
-                  <a:srgbClr val="5B4BD6"/>
-                </a:solidFill>
-                <a:latin typeface="Noto Sans"/>
-              </a:rPr>
-              <a:t>TRUSTING</a:t>
-            </a:r>
-          </a:p>
-        </p:txBody>
-      </p:sp>
-      <p:sp>
-        <p:nvSpPr>
-          <p:cNvPr id="16" name="Text"/>
-          <p:cNvSpPr txBox="1"/>
-          <p:nvPr/>
-        </p:nvSpPr>
-        <p:spPr>
-          <a:xfrm>
-            <a:off x="4516934" y="4583112"/>
-            <a:ext cx="3252775" cy="438150"/>
-          </a:xfrm>
-          <a:prstGeom prst="rect">
-            <a:avLst/>
-          </a:prstGeom>
-          <a:noFill/>
-        </p:spPr>
-        <p:txBody>
-          <a:bodyPr wrap="square" lIns="0" rIns="0" tIns="0" bIns="0" anchor="t">
-            <a:noAutofit/>
-          </a:bodyPr>
-          <a:lstStyle/>
-          <a:p>
-            <a:pPr algn="l">
-              <a:lnSpc>
-                <a:spcPts val="1725"/>
-              </a:lnSpc>
-              <a:spcBef>
-                <a:spcPts val="0"/>
-              </a:spcBef>
-              <a:spcAft>
-                <a:spcPts val="0"/>
-              </a:spcAft>
-            </a:pPr>
-            <a:r>
-              <a:rPr sz="1250" b="0" i="0">
-                <a:solidFill>
-                  <a:srgbClr val="1D2433"/>
-                </a:solidFill>
-                <a:latin typeface="Noto Sans"/>
-              </a:rPr>
-              <a:t>A ledger line says its condition and who checked it last.</a:t>
-            </a:r>
-          </a:p>
-        </p:txBody>
-      </p:sp>
-      <p:sp>
-        <p:nvSpPr>
-          <p:cNvPr id="17" name="Box"/>
+                <a:spcPts val="1770"/>
+              </a:lnSpc>
+              <a:spcBef>
+                <a:spcPts val="0"/>
+              </a:spcBef>
+              <a:spcAft>
+                <a:spcPts val="0"/>
+              </a:spcAft>
+            </a:pPr>
+            <a:r>
+              <a:rPr sz="1300" b="1" i="0">
+                <a:solidFill>
+                  <a:srgbClr val="FFFFFF"/>
+                </a:solidFill>
+                <a:latin typeface="Noto Sans"/>
+              </a:rPr>
+              <a:t>70%</a:t>
+            </a:r>
+          </a:p>
+        </p:txBody>
+      </p:sp>
+      <p:sp>
+        <p:nvSpPr>
+          <p:cNvPr id="21" name="Box"/>
           <p:cNvSpPr/>
           <p:nvPr/>
         </p:nvSpPr>
         <p:spPr>
           <a:xfrm>
-            <a:off x="7967067" y="4241800"/>
-            <a:ext cx="3462834" cy="1460500"/>
+            <a:off x="8644434" y="2641600"/>
+            <a:ext cx="2785467" cy="381000"/>
           </a:xfrm>
           <a:prstGeom prst="roundRect">
             <a:avLst>
-              <a:gd name="adj" fmla="val 6086"/>
+              <a:gd name="adj" fmla="val 16666"/>
             </a:avLst>
           </a:prstGeom>
           <a:solidFill>
-            <a:srgbClr val="ECE9FB"/>
+            <a:srgbClr val="42A779"/>
           </a:solidFill>
-          <a:ln>
-            <a:noFill/>
+          <a:ln w="19050">
+            <a:solidFill>
+              <a:srgbClr val="1D2433"/>
+            </a:solidFill>
           </a:ln>
           <a:effectLst/>
         </p:spPr>
@@ -14463,14 +15879,14 @@
       </p:sp>
       <p:sp>
         <p:nvSpPr>
-          <p:cNvPr id="18" name="Text"/>
-          <p:cNvSpPr txBox="1"/>
-          <p:nvPr/>
-        </p:nvSpPr>
-        <p:spPr>
-          <a:xfrm>
-            <a:off x="8119467" y="4379862"/>
-            <a:ext cx="3252775" cy="155677"/>
+          <p:cNvPr id="22" name="Text"/>
+          <p:cNvSpPr txBox="1"/>
+          <p:nvPr/>
+        </p:nvSpPr>
+        <p:spPr>
+          <a:xfrm>
+            <a:off x="9865717" y="2719667"/>
+            <a:ext cx="353187" cy="224866"/>
           </a:xfrm>
           <a:prstGeom prst="rect">
             <a:avLst/>
@@ -14485,37 +15901,37 @@
           <a:p>
             <a:pPr algn="l">
               <a:lnSpc>
-                <a:spcPts val="1225"/>
-              </a:lnSpc>
-              <a:spcBef>
-                <a:spcPts val="0"/>
-              </a:spcBef>
-              <a:spcAft>
-                <a:spcPts val="0"/>
-              </a:spcAft>
-            </a:pPr>
-            <a:r>
-              <a:rPr sz="900" b="1" i="0" spc="90">
-                <a:solidFill>
-                  <a:srgbClr val="5B4BD6"/>
-                </a:solidFill>
-                <a:latin typeface="Noto Sans"/>
-              </a:rPr>
-              <a:t>RETURNING</a:t>
-            </a:r>
-          </a:p>
-        </p:txBody>
-      </p:sp>
-      <p:sp>
-        <p:nvSpPr>
-          <p:cNvPr id="19" name="Text"/>
-          <p:cNvSpPr txBox="1"/>
-          <p:nvPr/>
-        </p:nvSpPr>
-        <p:spPr>
-          <a:xfrm>
-            <a:off x="8119467" y="4583112"/>
-            <a:ext cx="3252775" cy="438150"/>
+                <a:spcPts val="1770"/>
+              </a:lnSpc>
+              <a:spcBef>
+                <a:spcPts val="0"/>
+              </a:spcBef>
+              <a:spcAft>
+                <a:spcPts val="0"/>
+              </a:spcAft>
+            </a:pPr>
+            <a:r>
+              <a:rPr sz="1300" b="1" i="0">
+                <a:solidFill>
+                  <a:srgbClr val="FFFFFF"/>
+                </a:solidFill>
+                <a:latin typeface="Noto Sans"/>
+              </a:rPr>
+              <a:t>89%</a:t>
+            </a:r>
+          </a:p>
+        </p:txBody>
+      </p:sp>
+      <p:sp>
+        <p:nvSpPr>
+          <p:cNvPr id="23" name="Text"/>
+          <p:cNvSpPr txBox="1"/>
+          <p:nvPr/>
+        </p:nvSpPr>
+        <p:spPr>
+          <a:xfrm>
+            <a:off x="762000" y="3102650"/>
+            <a:ext cx="2119122" cy="181610"/>
           </a:xfrm>
           <a:prstGeom prst="rect">
             <a:avLst/>
@@ -14530,30 +15946,316 @@
           <a:p>
             <a:pPr algn="l">
               <a:lnSpc>
-                <a:spcPts val="1725"/>
-              </a:lnSpc>
-              <a:spcBef>
-                <a:spcPts val="0"/>
-              </a:spcBef>
-              <a:spcAft>
-                <a:spcPts val="0"/>
-              </a:spcAft>
-            </a:pPr>
-            <a:r>
-              <a:rPr sz="1250" b="0" i="0">
+                <a:spcPts val="1430"/>
+              </a:lnSpc>
+              <a:spcBef>
+                <a:spcPts val="0"/>
+              </a:spcBef>
+              <a:spcAft>
+                <a:spcPts val="0"/>
+              </a:spcAft>
+            </a:pPr>
+            <a:r>
+              <a:rPr sz="1300" b="1" i="0">
                 <a:solidFill>
                   <a:srgbClr val="1D2433"/>
                 </a:solidFill>
                 <a:latin typeface="Noto Sans"/>
               </a:rPr>
-              <a:t>A tool hung back clean is the only sign-off it needs.</a:t>
-            </a:r>
-          </a:p>
-        </p:txBody>
-      </p:sp>
-      <p:sp>
-        <p:nvSpPr>
-          <p:cNvPr id="20" name="Box"/>
+              <a:t>Clean</a:t>
+            </a:r>
+          </a:p>
+        </p:txBody>
+      </p:sp>
+      <p:sp>
+        <p:nvSpPr>
+          <p:cNvPr id="24" name="Text"/>
+          <p:cNvSpPr txBox="1"/>
+          <p:nvPr/>
+        </p:nvSpPr>
+        <p:spPr>
+          <a:xfrm>
+            <a:off x="762000" y="3281045"/>
+            <a:ext cx="2119122" cy="137160"/>
+          </a:xfrm>
+          <a:prstGeom prst="rect">
+            <a:avLst/>
+          </a:prstGeom>
+          <a:noFill/>
+        </p:spPr>
+        <p:txBody>
+          <a:bodyPr wrap="square" lIns="0" rIns="0" tIns="0" bIns="0" anchor="t">
+            <a:noAutofit/>
+          </a:bodyPr>
+          <a:lstStyle/>
+          <a:p>
+            <a:pPr algn="l">
+              <a:lnSpc>
+                <a:spcPts val="1080"/>
+              </a:lnSpc>
+              <a:spcBef>
+                <a:spcPts val="0"/>
+              </a:spcBef>
+              <a:spcAft>
+                <a:spcPts val="0"/>
+              </a:spcAft>
+            </a:pPr>
+            <a:r>
+              <a:rPr sz="900" b="0" i="0">
+                <a:solidFill>
+                  <a:srgbClr val="8A8F9C"/>
+                </a:solidFill>
+                <a:latin typeface="Noto Sans"/>
+              </a:rPr>
+              <a:t>hung back without a note</a:t>
+            </a:r>
+          </a:p>
+        </p:txBody>
+      </p:sp>
+      <p:sp>
+        <p:nvSpPr>
+          <p:cNvPr id="25" name="Box"/>
+          <p:cNvSpPr/>
+          <p:nvPr/>
+        </p:nvSpPr>
+        <p:spPr>
+          <a:xfrm>
+            <a:off x="2971800" y="3073400"/>
+            <a:ext cx="2785467" cy="381000"/>
+          </a:xfrm>
+          <a:prstGeom prst="roundRect">
+            <a:avLst>
+              <a:gd name="adj" fmla="val 16666"/>
+            </a:avLst>
+          </a:prstGeom>
+          <a:solidFill>
+            <a:srgbClr val="81C4A6"/>
+          </a:solidFill>
+          <a:ln w="19050">
+            <a:solidFill>
+              <a:srgbClr val="000000">
+                <a:alpha val="0"/>
+              </a:srgbClr>
+            </a:solidFill>
+          </a:ln>
+          <a:effectLst/>
+        </p:spPr>
+        <p:txBody>
+          <a:bodyPr rtlCol="0" anchor="ctr"/>
+          <a:lstStyle/>
+          <a:p>
+            <a:pPr algn="ctr"/>
+          </a:p>
+        </p:txBody>
+      </p:sp>
+      <p:sp>
+        <p:nvSpPr>
+          <p:cNvPr id="26" name="Text"/>
+          <p:cNvSpPr txBox="1"/>
+          <p:nvPr/>
+        </p:nvSpPr>
+        <p:spPr>
+          <a:xfrm>
+            <a:off x="4196259" y="3151467"/>
+            <a:ext cx="346646" cy="224866"/>
+          </a:xfrm>
+          <a:prstGeom prst="rect">
+            <a:avLst/>
+          </a:prstGeom>
+          <a:noFill/>
+        </p:spPr>
+        <p:txBody>
+          <a:bodyPr wrap="square" lIns="0" rIns="0" tIns="0" bIns="0" anchor="t">
+            <a:noAutofit/>
+          </a:bodyPr>
+          <a:lstStyle/>
+          <a:p>
+            <a:pPr algn="l">
+              <a:lnSpc>
+                <a:spcPts val="1770"/>
+              </a:lnSpc>
+              <a:spcBef>
+                <a:spcPts val="0"/>
+              </a:spcBef>
+              <a:spcAft>
+                <a:spcPts val="0"/>
+              </a:spcAft>
+            </a:pPr>
+            <a:r>
+              <a:rPr sz="1300" b="1" i="0">
+                <a:solidFill>
+                  <a:srgbClr val="1D2433"/>
+                </a:solidFill>
+                <a:latin typeface="Noto Sans"/>
+              </a:rPr>
+              <a:t>55%</a:t>
+            </a:r>
+          </a:p>
+        </p:txBody>
+      </p:sp>
+      <p:sp>
+        <p:nvSpPr>
+          <p:cNvPr id="27" name="Box"/>
+          <p:cNvSpPr/>
+          <p:nvPr/>
+        </p:nvSpPr>
+        <p:spPr>
+          <a:xfrm>
+            <a:off x="5808067" y="3073400"/>
+            <a:ext cx="2785566" cy="381000"/>
+          </a:xfrm>
+          <a:prstGeom prst="roundRect">
+            <a:avLst>
+              <a:gd name="adj" fmla="val 16666"/>
+            </a:avLst>
+          </a:prstGeom>
+          <a:solidFill>
+            <a:srgbClr val="58B289"/>
+          </a:solidFill>
+          <a:ln w="19050">
+            <a:solidFill>
+              <a:srgbClr val="000000">
+                <a:alpha val="0"/>
+              </a:srgbClr>
+            </a:solidFill>
+          </a:ln>
+          <a:effectLst/>
+        </p:spPr>
+        <p:txBody>
+          <a:bodyPr rtlCol="0" anchor="ctr"/>
+          <a:lstStyle/>
+          <a:p>
+            <a:pPr algn="ctr"/>
+          </a:p>
+        </p:txBody>
+      </p:sp>
+      <p:sp>
+        <p:nvSpPr>
+          <p:cNvPr id="28" name="Text"/>
+          <p:cNvSpPr txBox="1"/>
+          <p:nvPr/>
+        </p:nvSpPr>
+        <p:spPr>
+          <a:xfrm>
+            <a:off x="7032526" y="3151467"/>
+            <a:ext cx="346646" cy="224866"/>
+          </a:xfrm>
+          <a:prstGeom prst="rect">
+            <a:avLst/>
+          </a:prstGeom>
+          <a:noFill/>
+        </p:spPr>
+        <p:txBody>
+          <a:bodyPr wrap="square" lIns="0" rIns="0" tIns="0" bIns="0" anchor="t">
+            <a:noAutofit/>
+          </a:bodyPr>
+          <a:lstStyle/>
+          <a:p>
+            <a:pPr algn="l">
+              <a:lnSpc>
+                <a:spcPts val="1770"/>
+              </a:lnSpc>
+              <a:spcBef>
+                <a:spcPts val="0"/>
+              </a:spcBef>
+              <a:spcAft>
+                <a:spcPts val="0"/>
+              </a:spcAft>
+            </a:pPr>
+            <a:r>
+              <a:rPr sz="1300" b="1" i="0">
+                <a:solidFill>
+                  <a:srgbClr val="FFFFFF"/>
+                </a:solidFill>
+                <a:latin typeface="Noto Sans"/>
+              </a:rPr>
+              <a:t>77%</a:t>
+            </a:r>
+          </a:p>
+        </p:txBody>
+      </p:sp>
+      <p:sp>
+        <p:nvSpPr>
+          <p:cNvPr id="29" name="Box"/>
+          <p:cNvSpPr/>
+          <p:nvPr/>
+        </p:nvSpPr>
+        <p:spPr>
+          <a:xfrm>
+            <a:off x="8644434" y="3073400"/>
+            <a:ext cx="2785467" cy="381000"/>
+          </a:xfrm>
+          <a:prstGeom prst="roundRect">
+            <a:avLst>
+              <a:gd name="adj" fmla="val 16666"/>
+            </a:avLst>
+          </a:prstGeom>
+          <a:solidFill>
+            <a:srgbClr val="3FA677"/>
+          </a:solidFill>
+          <a:ln w="19050">
+            <a:solidFill>
+              <a:srgbClr val="1D2433"/>
+            </a:solidFill>
+          </a:ln>
+          <a:effectLst/>
+        </p:spPr>
+        <p:txBody>
+          <a:bodyPr rtlCol="0" anchor="ctr"/>
+          <a:lstStyle/>
+          <a:p>
+            <a:pPr algn="ctr"/>
+          </a:p>
+        </p:txBody>
+      </p:sp>
+      <p:sp>
+        <p:nvSpPr>
+          <p:cNvPr id="30" name="Text"/>
+          <p:cNvSpPr txBox="1"/>
+          <p:nvPr/>
+        </p:nvSpPr>
+        <p:spPr>
+          <a:xfrm>
+            <a:off x="9865717" y="3151467"/>
+            <a:ext cx="353187" cy="224866"/>
+          </a:xfrm>
+          <a:prstGeom prst="rect">
+            <a:avLst/>
+          </a:prstGeom>
+          <a:noFill/>
+        </p:spPr>
+        <p:txBody>
+          <a:bodyPr wrap="square" lIns="0" rIns="0" tIns="0" bIns="0" anchor="t">
+            <a:noAutofit/>
+          </a:bodyPr>
+          <a:lstStyle/>
+          <a:p>
+            <a:pPr algn="l">
+              <a:lnSpc>
+                <a:spcPts val="1770"/>
+              </a:lnSpc>
+              <a:spcBef>
+                <a:spcPts val="0"/>
+              </a:spcBef>
+              <a:spcAft>
+                <a:spcPts val="0"/>
+              </a:spcAft>
+            </a:pPr>
+            <a:r>
+              <a:rPr sz="1300" b="1" i="0">
+                <a:solidFill>
+                  <a:srgbClr val="FFFFFF"/>
+                </a:solidFill>
+                <a:latin typeface="Noto Sans"/>
+              </a:rPr>
+              <a:t>91%</a:t>
+            </a:r>
+          </a:p>
+        </p:txBody>
+      </p:sp>
+      <p:sp>
+        <p:nvSpPr>
+          <p:cNvPr id="31" name="Box"/>
           <p:cNvSpPr/>
           <p:nvPr/>
         </p:nvSpPr>
@@ -14583,14 +16285,14 @@
       </p:sp>
       <p:sp>
         <p:nvSpPr>
-          <p:cNvPr id="21" name="Text"/>
+          <p:cNvPr id="32" name="Text"/>
           <p:cNvSpPr txBox="1"/>
           <p:nvPr/>
         </p:nvSpPr>
         <p:spPr>
           <a:xfrm>
             <a:off x="762000" y="6495561"/>
-            <a:ext cx="1339850" cy="147028"/>
+            <a:ext cx="2622550" cy="147028"/>
           </a:xfrm>
           <a:prstGeom prst="rect">
             <a:avLst/>
@@ -14630,14 +16332,14 @@
                 </a:solidFill>
                 <a:latin typeface="Noto Sans"/>
               </a:rPr>
-              <a:t> Invented example</a:t>
-            </a:r>
-          </a:p>
-        </p:txBody>
-      </p:sp>
-      <p:sp>
-        <p:nvSpPr>
-          <p:cNvPr id="22" name="Text"/>
+              <a:t> Invented example; the figures are made up</a:t>
+            </a:r>
+          </a:p>
+        </p:txBody>
+      </p:sp>
+      <p:sp>
+        <p:nvSpPr>
+          <p:cNvPr id="33" name="Text"/>
           <p:cNvSpPr txBox="1"/>
           <p:nvPr/>
         </p:nvSpPr>
@@ -14675,7 +16377,7 @@
                 </a:solidFill>
                 <a:latin typeface="Noto Sans"/>
               </a:rPr>
-              <a:t>8 / 12</a:t>
+              <a:t>8 / 13</a:t>
             </a:r>
           </a:p>
         </p:txBody>
@@ -14746,7 +16448,7 @@
                 </a:solidFill>
                 <a:latin typeface="Noto Sans"/>
               </a:rPr>
-              <a:t>Keep the rules few and the hooks labelled</a:t>
+              <a:t>From a shared garage to a labelled shed</a:t>
             </a:r>
           </a:p>
         </p:txBody>
@@ -14791,74 +16493,153 @@
                 </a:solidFill>
                 <a:latin typeface="Noto Sans"/>
               </a:rPr>
-              <a:t>WHAT WORKS, WHAT DOES NOT</a:t>
-            </a:r>
-          </a:p>
-        </p:txBody>
-      </p:sp>
-      <p:sp>
-        <p:nvSpPr>
-          <p:cNvPr id="4" name="Text"/>
-          <p:cNvSpPr txBox="1"/>
-          <p:nvPr/>
-        </p:nvSpPr>
-        <p:spPr>
-          <a:xfrm>
-            <a:off x="762000" y="1389757"/>
-            <a:ext cx="9810750" cy="269875"/>
-          </a:xfrm>
-          <a:prstGeom prst="rect">
-            <a:avLst/>
-          </a:prstGeom>
-          <a:noFill/>
-        </p:spPr>
-        <p:txBody>
-          <a:bodyPr wrap="square" lIns="0" rIns="0" tIns="0" bIns="0" anchor="t">
-            <a:noAutofit/>
-          </a:bodyPr>
-          <a:lstStyle/>
-          <a:p>
-            <a:pPr algn="l">
-              <a:lnSpc>
-                <a:spcPts val="2125"/>
-              </a:lnSpc>
-              <a:spcBef>
-                <a:spcPts val="0"/>
-              </a:spcBef>
-              <a:spcAft>
-                <a:spcPts val="0"/>
-              </a:spcAft>
-            </a:pPr>
-            <a:r>
-              <a:rPr sz="1700" b="0" i="0">
-                <a:solidFill>
-                  <a:srgbClr val="4A5163"/>
-                </a:solidFill>
-                <a:latin typeface="Noto Sans"/>
-              </a:rPr>
-              <a:t>Two lists, four short lines each.</a:t>
-            </a:r>
-          </a:p>
-        </p:txBody>
-      </p:sp>
-      <p:sp>
-        <p:nvSpPr>
-          <p:cNvPr id="5" name="Box"/>
+              <a:t>BEFORE AND AFTER</a:t>
+            </a:r>
+          </a:p>
+        </p:txBody>
+      </p:sp>
+      <p:sp>
+        <p:nvSpPr>
+          <p:cNvPr id="4" name="Box"/>
           <p:cNvSpPr/>
           <p:nvPr/>
         </p:nvSpPr>
         <p:spPr>
           <a:xfrm>
-            <a:off x="762000" y="2159000"/>
-            <a:ext cx="5245100" cy="2384822"/>
+            <a:off x="762000" y="1905000"/>
+            <a:ext cx="4662289" cy="2159000"/>
           </a:xfrm>
           <a:prstGeom prst="roundRect">
             <a:avLst>
-              <a:gd name="adj" fmla="val 4260"/>
+              <a:gd name="adj" fmla="val 4705"/>
             </a:avLst>
           </a:prstGeom>
           <a:solidFill>
-            <a:srgbClr val="2E9E6B"/>
+            <a:srgbClr val="FFFFFF"/>
+          </a:solidFill>
+          <a:ln w="6350">
+            <a:solidFill>
+              <a:srgbClr val="DCD9D0"/>
+            </a:solidFill>
+          </a:ln>
+          <a:effectLst/>
+        </p:spPr>
+        <p:txBody>
+          <a:bodyPr rtlCol="0" anchor="ctr"/>
+          <a:lstStyle/>
+          <a:p>
+            <a:pPr algn="ctr"/>
+          </a:p>
+        </p:txBody>
+      </p:sp>
+      <p:sp>
+        <p:nvSpPr>
+          <p:cNvPr id="5" name="Text"/>
+          <p:cNvSpPr txBox="1"/>
+          <p:nvPr/>
+        </p:nvSpPr>
+        <p:spPr>
+          <a:xfrm>
+            <a:off x="965200" y="2093862"/>
+            <a:ext cx="4383566" cy="155677"/>
+          </a:xfrm>
+          <a:prstGeom prst="rect">
+            <a:avLst/>
+          </a:prstGeom>
+          <a:noFill/>
+        </p:spPr>
+        <p:txBody>
+          <a:bodyPr wrap="square" lIns="0" rIns="0" tIns="0" bIns="0" anchor="t">
+            <a:noAutofit/>
+          </a:bodyPr>
+          <a:lstStyle/>
+          <a:p>
+            <a:pPr algn="l">
+              <a:lnSpc>
+                <a:spcPts val="1225"/>
+              </a:lnSpc>
+              <a:spcBef>
+                <a:spcPts val="0"/>
+              </a:spcBef>
+              <a:spcAft>
+                <a:spcPts val="0"/>
+              </a:spcAft>
+            </a:pPr>
+            <a:r>
+              <a:rPr sz="900" b="1" i="0" spc="108">
+                <a:solidFill>
+                  <a:srgbClr val="8A8F9C"/>
+                </a:solidFill>
+                <a:latin typeface="Noto Sans"/>
+              </a:rPr>
+              <a:t>BEFORE</a:t>
+            </a:r>
+          </a:p>
+        </p:txBody>
+      </p:sp>
+      <p:sp>
+        <p:nvSpPr>
+          <p:cNvPr id="6" name="Text"/>
+          <p:cNvSpPr txBox="1"/>
+          <p:nvPr/>
+        </p:nvSpPr>
+        <p:spPr>
+          <a:xfrm>
+            <a:off x="965200" y="2321560"/>
+            <a:ext cx="4383566" cy="720050"/>
+          </a:xfrm>
+          <a:prstGeom prst="rect">
+            <a:avLst/>
+          </a:prstGeom>
+          <a:noFill/>
+        </p:spPr>
+        <p:txBody>
+          <a:bodyPr wrap="square" lIns="0" rIns="0" tIns="0" bIns="0" anchor="t">
+            <a:noAutofit/>
+          </a:bodyPr>
+          <a:lstStyle/>
+          <a:p>
+            <a:pPr algn="l">
+              <a:lnSpc>
+                <a:spcPts val="1889"/>
+              </a:lnSpc>
+              <a:spcBef>
+                <a:spcPts val="0"/>
+              </a:spcBef>
+              <a:spcAft>
+                <a:spcPts val="0"/>
+              </a:spcAft>
+            </a:pPr>
+            <a:r>
+              <a:rPr sz="1350" b="0" i="0">
+                <a:solidFill>
+                  <a:srgbClr val="4A5163"/>
+                </a:solidFill>
+                <a:latin typeface="Noto Sans"/>
+              </a:rPr>
+              <a:t>Tools lived in one garage. Nobody knew what was there, so people bought a second drill and the first went missing.</a:t>
+            </a:r>
+          </a:p>
+        </p:txBody>
+      </p:sp>
+      <p:sp>
+        <p:nvSpPr>
+          <p:cNvPr id="7" name="Box"/>
+          <p:cNvSpPr/>
+          <p:nvPr/>
+        </p:nvSpPr>
+        <p:spPr>
+          <a:xfrm>
+            <a:off x="5602089" y="1905000"/>
+            <a:ext cx="5827911" cy="2159000"/>
+          </a:xfrm>
+          <a:prstGeom prst="roundRect">
+            <a:avLst>
+              <a:gd name="adj" fmla="val 4705"/>
+            </a:avLst>
+          </a:prstGeom>
+          <a:solidFill>
+            <a:srgbClr val="5B4BD6"/>
           </a:solidFill>
           <a:ln>
             <a:noFill/>
@@ -14875,18 +16656,18 @@
       </p:sp>
       <p:sp>
         <p:nvSpPr>
-          <p:cNvPr id="6" name="Box"/>
+          <p:cNvPr id="8" name="Box"/>
           <p:cNvSpPr/>
           <p:nvPr/>
         </p:nvSpPr>
         <p:spPr>
           <a:xfrm>
-            <a:off x="762000" y="2222500"/>
-            <a:ext cx="5245100" cy="2321322"/>
+            <a:off x="5665589" y="1905000"/>
+            <a:ext cx="5764411" cy="2159000"/>
           </a:xfrm>
           <a:prstGeom prst="roundRect">
             <a:avLst>
-              <a:gd name="adj" fmla="val 1641"/>
+              <a:gd name="adj" fmla="val 1764"/>
             </a:avLst>
           </a:prstGeom>
           <a:solidFill>
@@ -14907,14 +16688,14 @@
       </p:sp>
       <p:sp>
         <p:nvSpPr>
-          <p:cNvPr id="7" name="Text"/>
-          <p:cNvSpPr txBox="1"/>
-          <p:nvPr/>
-        </p:nvSpPr>
-        <p:spPr>
-          <a:xfrm>
-            <a:off x="965200" y="2412022"/>
-            <a:ext cx="4983861" cy="294056"/>
+          <p:cNvPr id="9" name="Text"/>
+          <p:cNvSpPr txBox="1"/>
+          <p:nvPr/>
+        </p:nvSpPr>
+        <p:spPr>
+          <a:xfrm>
+            <a:off x="5868789" y="2093862"/>
+            <a:ext cx="5518751" cy="155677"/>
           </a:xfrm>
           <a:prstGeom prst="rect">
             <a:avLst/>
@@ -14929,45 +16710,90 @@
           <a:p>
             <a:pPr algn="l">
               <a:lnSpc>
-                <a:spcPts val="2315"/>
-              </a:lnSpc>
-              <a:spcBef>
-                <a:spcPts val="0"/>
-              </a:spcBef>
-              <a:spcAft>
-                <a:spcPts val="0"/>
-              </a:spcAft>
-            </a:pPr>
-            <a:r>
-              <a:rPr sz="1700" b="1" i="0">
-                <a:solidFill>
-                  <a:srgbClr val="2E9E6B"/>
-                </a:solidFill>
-                <a:latin typeface="Noto Sans"/>
-              </a:rPr>
-              <a:t>What works</a:t>
-            </a:r>
-          </a:p>
-        </p:txBody>
-      </p:sp>
-      <p:sp>
-        <p:nvSpPr>
-          <p:cNvPr id="8" name="Box"/>
+                <a:spcPts val="1225"/>
+              </a:lnSpc>
+              <a:spcBef>
+                <a:spcPts val="0"/>
+              </a:spcBef>
+              <a:spcAft>
+                <a:spcPts val="0"/>
+              </a:spcAft>
+            </a:pPr>
+            <a:r>
+              <a:rPr sz="900" b="1" i="0" spc="108">
+                <a:solidFill>
+                  <a:srgbClr val="5B4BD6"/>
+                </a:solidFill>
+                <a:latin typeface="Noto Sans"/>
+              </a:rPr>
+              <a:t>NOW</a:t>
+            </a:r>
+          </a:p>
+        </p:txBody>
+      </p:sp>
+      <p:sp>
+        <p:nvSpPr>
+          <p:cNvPr id="10" name="Text"/>
+          <p:cNvSpPr txBox="1"/>
+          <p:nvPr/>
+        </p:nvSpPr>
+        <p:spPr>
+          <a:xfrm>
+            <a:off x="5868789" y="2321560"/>
+            <a:ext cx="5518751" cy="480040"/>
+          </a:xfrm>
+          <a:prstGeom prst="rect">
+            <a:avLst/>
+          </a:prstGeom>
+          <a:noFill/>
+        </p:spPr>
+        <p:txBody>
+          <a:bodyPr wrap="square" lIns="0" rIns="0" tIns="0" bIns="0" anchor="t">
+            <a:noAutofit/>
+          </a:bodyPr>
+          <a:lstStyle/>
+          <a:p>
+            <a:pPr algn="l">
+              <a:lnSpc>
+                <a:spcPts val="1889"/>
+              </a:lnSpc>
+              <a:spcBef>
+                <a:spcPts val="0"/>
+              </a:spcBef>
+              <a:spcAft>
+                <a:spcPts val="0"/>
+              </a:spcAft>
+            </a:pPr>
+            <a:r>
+              <a:rPr sz="1350" b="0" i="0">
+                <a:solidFill>
+                  <a:srgbClr val="1D2433"/>
+                </a:solidFill>
+                <a:latin typeface="Noto Sans"/>
+              </a:rPr>
+              <a:t>Every tool has a hook, a ledger line and a Friday deadline, so anyone can see what is in and what is out.</a:t>
+            </a:r>
+          </a:p>
+        </p:txBody>
+      </p:sp>
+      <p:sp>
+        <p:nvSpPr>
+          <p:cNvPr id="11" name="Box"/>
           <p:cNvSpPr/>
           <p:nvPr/>
         </p:nvSpPr>
         <p:spPr>
           <a:xfrm>
-            <a:off x="990600" y="2870200"/>
-            <a:ext cx="101600" cy="101600"/>
+            <a:off x="762000" y="4241800"/>
+            <a:ext cx="3462834" cy="1460500"/>
           </a:xfrm>
           <a:prstGeom prst="roundRect">
             <a:avLst>
-              <a:gd name="adj" fmla="val 25000"/>
+              <a:gd name="adj" fmla="val 6086"/>
             </a:avLst>
           </a:prstGeom>
           <a:solidFill>
-            <a:srgbClr val="5B4BD6"/>
+            <a:srgbClr val="ECE9FB"/>
           </a:solidFill>
           <a:ln>
             <a:noFill/>
@@ -14984,14 +16810,14 @@
       </p:sp>
       <p:sp>
         <p:nvSpPr>
-          <p:cNvPr id="9" name="Text"/>
-          <p:cNvSpPr txBox="1"/>
-          <p:nvPr/>
-        </p:nvSpPr>
-        <p:spPr>
-          <a:xfrm>
-            <a:off x="1257300" y="2775268"/>
-            <a:ext cx="4682998" cy="291465"/>
+          <p:cNvPr id="12" name="Text"/>
+          <p:cNvSpPr txBox="1"/>
+          <p:nvPr/>
+        </p:nvSpPr>
+        <p:spPr>
+          <a:xfrm>
+            <a:off x="914400" y="4379862"/>
+            <a:ext cx="3252775" cy="155677"/>
           </a:xfrm>
           <a:prstGeom prst="rect">
             <a:avLst/>
@@ -15006,45 +16832,90 @@
           <a:p>
             <a:pPr algn="l">
               <a:lnSpc>
-                <a:spcPts val="2295"/>
-              </a:lnSpc>
-              <a:spcBef>
-                <a:spcPts val="0"/>
-              </a:spcBef>
-              <a:spcAft>
-                <a:spcPts val="0"/>
-              </a:spcAft>
-            </a:pPr>
-            <a:r>
-              <a:rPr sz="1700" b="0" i="0">
+                <a:spcPts val="1225"/>
+              </a:lnSpc>
+              <a:spcBef>
+                <a:spcPts val="0"/>
+              </a:spcBef>
+              <a:spcAft>
+                <a:spcPts val="0"/>
+              </a:spcAft>
+            </a:pPr>
+            <a:r>
+              <a:rPr sz="900" b="1" i="0" spc="90">
+                <a:solidFill>
+                  <a:srgbClr val="5B4BD6"/>
+                </a:solidFill>
+                <a:latin typeface="Noto Sans"/>
+              </a:rPr>
+              <a:t>FINDING</a:t>
+            </a:r>
+          </a:p>
+        </p:txBody>
+      </p:sp>
+      <p:sp>
+        <p:nvSpPr>
+          <p:cNvPr id="13" name="Text"/>
+          <p:cNvSpPr txBox="1"/>
+          <p:nvPr/>
+        </p:nvSpPr>
+        <p:spPr>
+          <a:xfrm>
+            <a:off x="914400" y="4583112"/>
+            <a:ext cx="3252775" cy="438150"/>
+          </a:xfrm>
+          <a:prstGeom prst="rect">
+            <a:avLst/>
+          </a:prstGeom>
+          <a:noFill/>
+        </p:spPr>
+        <p:txBody>
+          <a:bodyPr wrap="square" lIns="0" rIns="0" tIns="0" bIns="0" anchor="t">
+            <a:noAutofit/>
+          </a:bodyPr>
+          <a:lstStyle/>
+          <a:p>
+            <a:pPr algn="l">
+              <a:lnSpc>
+                <a:spcPts val="1725"/>
+              </a:lnSpc>
+              <a:spcBef>
+                <a:spcPts val="0"/>
+              </a:spcBef>
+              <a:spcAft>
+                <a:spcPts val="0"/>
+              </a:spcAft>
+            </a:pPr>
+            <a:r>
+              <a:rPr sz="1250" b="0" i="0">
                 <a:solidFill>
                   <a:srgbClr val="1D2433"/>
                 </a:solidFill>
                 <a:latin typeface="Noto Sans"/>
               </a:rPr>
-              <a:t>A hook for every tool</a:t>
-            </a:r>
-          </a:p>
-        </p:txBody>
-      </p:sp>
-      <p:sp>
-        <p:nvSpPr>
-          <p:cNvPr id="10" name="Box"/>
+              <a:t>A shelf of hooks, each labelled with the tool's name.</a:t>
+            </a:r>
+          </a:p>
+        </p:txBody>
+      </p:sp>
+      <p:sp>
+        <p:nvSpPr>
+          <p:cNvPr id="14" name="Box"/>
           <p:cNvSpPr/>
           <p:nvPr/>
         </p:nvSpPr>
         <p:spPr>
           <a:xfrm>
-            <a:off x="990600" y="3263205"/>
-            <a:ext cx="101600" cy="101600"/>
+            <a:off x="4364534" y="4241800"/>
+            <a:ext cx="3462834" cy="1460500"/>
           </a:xfrm>
           <a:prstGeom prst="roundRect">
             <a:avLst>
-              <a:gd name="adj" fmla="val 25000"/>
+              <a:gd name="adj" fmla="val 6086"/>
             </a:avLst>
           </a:prstGeom>
           <a:solidFill>
-            <a:srgbClr val="5B4BD6"/>
+            <a:srgbClr val="ECE9FB"/>
           </a:solidFill>
           <a:ln>
             <a:noFill/>
@@ -15061,14 +16932,14 @@
       </p:sp>
       <p:sp>
         <p:nvSpPr>
-          <p:cNvPr id="11" name="Text"/>
-          <p:cNvSpPr txBox="1"/>
-          <p:nvPr/>
-        </p:nvSpPr>
-        <p:spPr>
-          <a:xfrm>
-            <a:off x="1257300" y="3168273"/>
-            <a:ext cx="4682998" cy="291465"/>
+          <p:cNvPr id="15" name="Text"/>
+          <p:cNvSpPr txBox="1"/>
+          <p:nvPr/>
+        </p:nvSpPr>
+        <p:spPr>
+          <a:xfrm>
+            <a:off x="4516934" y="4379862"/>
+            <a:ext cx="3252775" cy="155677"/>
           </a:xfrm>
           <a:prstGeom prst="rect">
             <a:avLst/>
@@ -15083,45 +16954,90 @@
           <a:p>
             <a:pPr algn="l">
               <a:lnSpc>
-                <a:spcPts val="2295"/>
-              </a:lnSpc>
-              <a:spcBef>
-                <a:spcPts val="0"/>
-              </a:spcBef>
-              <a:spcAft>
-                <a:spcPts val="0"/>
-              </a:spcAft>
-            </a:pPr>
-            <a:r>
-              <a:rPr sz="1700" b="0" i="0">
+                <a:spcPts val="1225"/>
+              </a:lnSpc>
+              <a:spcBef>
+                <a:spcPts val="0"/>
+              </a:spcBef>
+              <a:spcAft>
+                <a:spcPts val="0"/>
+              </a:spcAft>
+            </a:pPr>
+            <a:r>
+              <a:rPr sz="900" b="1" i="0" spc="90">
+                <a:solidFill>
+                  <a:srgbClr val="5B4BD6"/>
+                </a:solidFill>
+                <a:latin typeface="Noto Sans"/>
+              </a:rPr>
+              <a:t>TRUSTING</a:t>
+            </a:r>
+          </a:p>
+        </p:txBody>
+      </p:sp>
+      <p:sp>
+        <p:nvSpPr>
+          <p:cNvPr id="16" name="Text"/>
+          <p:cNvSpPr txBox="1"/>
+          <p:nvPr/>
+        </p:nvSpPr>
+        <p:spPr>
+          <a:xfrm>
+            <a:off x="4516934" y="4583112"/>
+            <a:ext cx="3252775" cy="438150"/>
+          </a:xfrm>
+          <a:prstGeom prst="rect">
+            <a:avLst/>
+          </a:prstGeom>
+          <a:noFill/>
+        </p:spPr>
+        <p:txBody>
+          <a:bodyPr wrap="square" lIns="0" rIns="0" tIns="0" bIns="0" anchor="t">
+            <a:noAutofit/>
+          </a:bodyPr>
+          <a:lstStyle/>
+          <a:p>
+            <a:pPr algn="l">
+              <a:lnSpc>
+                <a:spcPts val="1725"/>
+              </a:lnSpc>
+              <a:spcBef>
+                <a:spcPts val="0"/>
+              </a:spcBef>
+              <a:spcAft>
+                <a:spcPts val="0"/>
+              </a:spcAft>
+            </a:pPr>
+            <a:r>
+              <a:rPr sz="1250" b="0" i="0">
                 <a:solidFill>
                   <a:srgbClr val="1D2433"/>
                 </a:solidFill>
                 <a:latin typeface="Noto Sans"/>
               </a:rPr>
-              <a:t>A ledger line for every hook</a:t>
-            </a:r>
-          </a:p>
-        </p:txBody>
-      </p:sp>
-      <p:sp>
-        <p:nvSpPr>
-          <p:cNvPr id="12" name="Box"/>
+              <a:t>A ledger line says its condition and who checked it last.</a:t>
+            </a:r>
+          </a:p>
+        </p:txBody>
+      </p:sp>
+      <p:sp>
+        <p:nvSpPr>
+          <p:cNvPr id="17" name="Box"/>
           <p:cNvSpPr/>
           <p:nvPr/>
         </p:nvSpPr>
         <p:spPr>
           <a:xfrm>
-            <a:off x="990600" y="3656211"/>
-            <a:ext cx="101600" cy="101600"/>
+            <a:off x="7967067" y="4241800"/>
+            <a:ext cx="3462834" cy="1460500"/>
           </a:xfrm>
           <a:prstGeom prst="roundRect">
             <a:avLst>
-              <a:gd name="adj" fmla="val 25000"/>
+              <a:gd name="adj" fmla="val 6086"/>
             </a:avLst>
           </a:prstGeom>
           <a:solidFill>
-            <a:srgbClr val="5B4BD6"/>
+            <a:srgbClr val="ECE9FB"/>
           </a:solidFill>
           <a:ln>
             <a:noFill/>
@@ -15138,14 +17054,14 @@
       </p:sp>
       <p:sp>
         <p:nvSpPr>
-          <p:cNvPr id="13" name="Text"/>
-          <p:cNvSpPr txBox="1"/>
-          <p:nvPr/>
-        </p:nvSpPr>
-        <p:spPr>
-          <a:xfrm>
-            <a:off x="1257300" y="3561278"/>
-            <a:ext cx="4682998" cy="291465"/>
+          <p:cNvPr id="18" name="Text"/>
+          <p:cNvSpPr txBox="1"/>
+          <p:nvPr/>
+        </p:nvSpPr>
+        <p:spPr>
+          <a:xfrm>
+            <a:off x="8119467" y="4379862"/>
+            <a:ext cx="3252775" cy="155677"/>
           </a:xfrm>
           <a:prstGeom prst="rect">
             <a:avLst/>
@@ -15160,524 +17076,75 @@
           <a:p>
             <a:pPr algn="l">
               <a:lnSpc>
-                <a:spcPts val="2295"/>
-              </a:lnSpc>
-              <a:spcBef>
-                <a:spcPts val="0"/>
-              </a:spcBef>
-              <a:spcAft>
-                <a:spcPts val="0"/>
-              </a:spcAft>
-            </a:pPr>
-            <a:r>
-              <a:rPr sz="1700" b="0" i="0">
+                <a:spcPts val="1225"/>
+              </a:lnSpc>
+              <a:spcBef>
+                <a:spcPts val="0"/>
+              </a:spcBef>
+              <a:spcAft>
+                <a:spcPts val="0"/>
+              </a:spcAft>
+            </a:pPr>
+            <a:r>
+              <a:rPr sz="900" b="1" i="0" spc="90">
+                <a:solidFill>
+                  <a:srgbClr val="5B4BD6"/>
+                </a:solidFill>
+                <a:latin typeface="Noto Sans"/>
+              </a:rPr>
+              <a:t>RETURNING</a:t>
+            </a:r>
+          </a:p>
+        </p:txBody>
+      </p:sp>
+      <p:sp>
+        <p:nvSpPr>
+          <p:cNvPr id="19" name="Text"/>
+          <p:cNvSpPr txBox="1"/>
+          <p:nvPr/>
+        </p:nvSpPr>
+        <p:spPr>
+          <a:xfrm>
+            <a:off x="8119467" y="4583112"/>
+            <a:ext cx="3252775" cy="438150"/>
+          </a:xfrm>
+          <a:prstGeom prst="rect">
+            <a:avLst/>
+          </a:prstGeom>
+          <a:noFill/>
+        </p:spPr>
+        <p:txBody>
+          <a:bodyPr wrap="square" lIns="0" rIns="0" tIns="0" bIns="0" anchor="t">
+            <a:noAutofit/>
+          </a:bodyPr>
+          <a:lstStyle/>
+          <a:p>
+            <a:pPr algn="l">
+              <a:lnSpc>
+                <a:spcPts val="1725"/>
+              </a:lnSpc>
+              <a:spcBef>
+                <a:spcPts val="0"/>
+              </a:spcBef>
+              <a:spcAft>
+                <a:spcPts val="0"/>
+              </a:spcAft>
+            </a:pPr>
+            <a:r>
+              <a:rPr sz="1250" b="0" i="0">
                 <a:solidFill>
                   <a:srgbClr val="1D2433"/>
                 </a:solidFill>
                 <a:latin typeface="Noto Sans"/>
               </a:rPr>
-              <a:t>One rule said out loud</a:t>
-            </a:r>
-          </a:p>
-        </p:txBody>
-      </p:sp>
-      <p:sp>
-        <p:nvSpPr>
-          <p:cNvPr id="14" name="Box"/>
-          <p:cNvSpPr/>
-          <p:nvPr/>
-        </p:nvSpPr>
-        <p:spPr>
-          <a:xfrm>
-            <a:off x="990600" y="4049216"/>
-            <a:ext cx="101600" cy="101600"/>
-          </a:xfrm>
-          <a:prstGeom prst="roundRect">
-            <a:avLst>
-              <a:gd name="adj" fmla="val 25000"/>
-            </a:avLst>
-          </a:prstGeom>
-          <a:solidFill>
-            <a:srgbClr val="5B4BD6"/>
-          </a:solidFill>
-          <a:ln>
-            <a:noFill/>
-          </a:ln>
-          <a:effectLst/>
-        </p:spPr>
-        <p:txBody>
-          <a:bodyPr rtlCol="0" anchor="ctr"/>
-          <a:lstStyle/>
-          <a:p>
-            <a:pPr algn="ctr"/>
-          </a:p>
-        </p:txBody>
-      </p:sp>
-      <p:sp>
-        <p:nvSpPr>
-          <p:cNvPr id="15" name="Text"/>
-          <p:cNvSpPr txBox="1"/>
-          <p:nvPr/>
-        </p:nvSpPr>
-        <p:spPr>
-          <a:xfrm>
-            <a:off x="1257300" y="3954284"/>
-            <a:ext cx="4682998" cy="291465"/>
-          </a:xfrm>
-          <a:prstGeom prst="rect">
-            <a:avLst/>
-          </a:prstGeom>
-          <a:noFill/>
-        </p:spPr>
-        <p:txBody>
-          <a:bodyPr wrap="square" lIns="0" rIns="0" tIns="0" bIns="0" anchor="t">
-            <a:noAutofit/>
-          </a:bodyPr>
-          <a:lstStyle/>
-          <a:p>
-            <a:pPr algn="l">
-              <a:lnSpc>
-                <a:spcPts val="2295"/>
-              </a:lnSpc>
-              <a:spcBef>
-                <a:spcPts val="0"/>
-              </a:spcBef>
-              <a:spcAft>
-                <a:spcPts val="0"/>
-              </a:spcAft>
-            </a:pPr>
-            <a:r>
-              <a:rPr sz="1700" b="0" i="0">
-                <a:solidFill>
-                  <a:srgbClr val="1D2433"/>
-                </a:solidFill>
-                <a:latin typeface="Noto Sans"/>
-              </a:rPr>
-              <a:t>Saturday mornings, always</a:t>
-            </a:r>
-          </a:p>
-        </p:txBody>
-      </p:sp>
-      <p:sp>
-        <p:nvSpPr>
-          <p:cNvPr id="16" name="Box"/>
-          <p:cNvSpPr/>
-          <p:nvPr/>
-        </p:nvSpPr>
-        <p:spPr>
-          <a:xfrm>
-            <a:off x="6184900" y="2159000"/>
-            <a:ext cx="5245100" cy="2384822"/>
-          </a:xfrm>
-          <a:prstGeom prst="roundRect">
-            <a:avLst>
-              <a:gd name="adj" fmla="val 4260"/>
-            </a:avLst>
-          </a:prstGeom>
-          <a:solidFill>
-            <a:srgbClr val="D0453D"/>
-          </a:solidFill>
-          <a:ln>
-            <a:noFill/>
-          </a:ln>
-          <a:effectLst/>
-        </p:spPr>
-        <p:txBody>
-          <a:bodyPr rtlCol="0" anchor="ctr"/>
-          <a:lstStyle/>
-          <a:p>
-            <a:pPr algn="ctr"/>
-          </a:p>
-        </p:txBody>
-      </p:sp>
-      <p:sp>
-        <p:nvSpPr>
-          <p:cNvPr id="17" name="Box"/>
-          <p:cNvSpPr/>
-          <p:nvPr/>
-        </p:nvSpPr>
-        <p:spPr>
-          <a:xfrm>
-            <a:off x="6184900" y="2222500"/>
-            <a:ext cx="5245100" cy="2321322"/>
-          </a:xfrm>
-          <a:prstGeom prst="roundRect">
-            <a:avLst>
-              <a:gd name="adj" fmla="val 1641"/>
-            </a:avLst>
-          </a:prstGeom>
-          <a:solidFill>
-            <a:srgbClr val="FFFFFF"/>
-          </a:solidFill>
-          <a:ln>
-            <a:noFill/>
-          </a:ln>
-          <a:effectLst/>
-        </p:spPr>
-        <p:txBody>
-          <a:bodyPr rtlCol="0" anchor="ctr"/>
-          <a:lstStyle/>
-          <a:p>
-            <a:pPr algn="ctr"/>
-          </a:p>
-        </p:txBody>
-      </p:sp>
-      <p:sp>
-        <p:nvSpPr>
-          <p:cNvPr id="18" name="Text"/>
-          <p:cNvSpPr txBox="1"/>
-          <p:nvPr/>
-        </p:nvSpPr>
-        <p:spPr>
-          <a:xfrm>
-            <a:off x="6388100" y="2412022"/>
-            <a:ext cx="4983861" cy="294056"/>
-          </a:xfrm>
-          <a:prstGeom prst="rect">
-            <a:avLst/>
-          </a:prstGeom>
-          <a:noFill/>
-        </p:spPr>
-        <p:txBody>
-          <a:bodyPr wrap="square" lIns="0" rIns="0" tIns="0" bIns="0" anchor="t">
-            <a:noAutofit/>
-          </a:bodyPr>
-          <a:lstStyle/>
-          <a:p>
-            <a:pPr algn="l">
-              <a:lnSpc>
-                <a:spcPts val="2315"/>
-              </a:lnSpc>
-              <a:spcBef>
-                <a:spcPts val="0"/>
-              </a:spcBef>
-              <a:spcAft>
-                <a:spcPts val="0"/>
-              </a:spcAft>
-            </a:pPr>
-            <a:r>
-              <a:rPr sz="1700" b="1" i="0">
-                <a:solidFill>
-                  <a:srgbClr val="D0453D"/>
-                </a:solidFill>
-                <a:latin typeface="Noto Sans"/>
-              </a:rPr>
-              <a:t>What does not</a:t>
-            </a:r>
-          </a:p>
-        </p:txBody>
-      </p:sp>
-      <p:sp>
-        <p:nvSpPr>
-          <p:cNvPr id="19" name="Box"/>
-          <p:cNvSpPr/>
-          <p:nvPr/>
-        </p:nvSpPr>
-        <p:spPr>
-          <a:xfrm>
-            <a:off x="6413500" y="2870200"/>
-            <a:ext cx="101600" cy="101600"/>
-          </a:xfrm>
-          <a:prstGeom prst="roundRect">
-            <a:avLst>
-              <a:gd name="adj" fmla="val 25000"/>
-            </a:avLst>
-          </a:prstGeom>
-          <a:solidFill>
-            <a:srgbClr val="5B4BD6"/>
-          </a:solidFill>
-          <a:ln>
-            <a:noFill/>
-          </a:ln>
-          <a:effectLst/>
-        </p:spPr>
-        <p:txBody>
-          <a:bodyPr rtlCol="0" anchor="ctr"/>
-          <a:lstStyle/>
-          <a:p>
-            <a:pPr algn="ctr"/>
-          </a:p>
-        </p:txBody>
-      </p:sp>
-      <p:sp>
-        <p:nvSpPr>
-          <p:cNvPr id="20" name="Text"/>
-          <p:cNvSpPr txBox="1"/>
-          <p:nvPr/>
-        </p:nvSpPr>
-        <p:spPr>
-          <a:xfrm>
-            <a:off x="6680200" y="2775268"/>
-            <a:ext cx="4682998" cy="291465"/>
-          </a:xfrm>
-          <a:prstGeom prst="rect">
-            <a:avLst/>
-          </a:prstGeom>
-          <a:noFill/>
-        </p:spPr>
-        <p:txBody>
-          <a:bodyPr wrap="square" lIns="0" rIns="0" tIns="0" bIns="0" anchor="t">
-            <a:noAutofit/>
-          </a:bodyPr>
-          <a:lstStyle/>
-          <a:p>
-            <a:pPr algn="l">
-              <a:lnSpc>
-                <a:spcPts val="2295"/>
-              </a:lnSpc>
-              <a:spcBef>
-                <a:spcPts val="0"/>
-              </a:spcBef>
-              <a:spcAft>
-                <a:spcPts val="0"/>
-              </a:spcAft>
-            </a:pPr>
-            <a:r>
-              <a:rPr sz="1700" b="0" i="0">
-                <a:solidFill>
-                  <a:srgbClr val="1D2433"/>
-                </a:solidFill>
-                <a:latin typeface="Noto Sans"/>
-              </a:rPr>
-              <a:t>Tools with no home</a:t>
-            </a:r>
-          </a:p>
-        </p:txBody>
-      </p:sp>
-      <p:sp>
-        <p:nvSpPr>
-          <p:cNvPr id="21" name="Box"/>
-          <p:cNvSpPr/>
-          <p:nvPr/>
-        </p:nvSpPr>
-        <p:spPr>
-          <a:xfrm>
-            <a:off x="6413500" y="3263205"/>
-            <a:ext cx="101600" cy="101600"/>
-          </a:xfrm>
-          <a:prstGeom prst="roundRect">
-            <a:avLst>
-              <a:gd name="adj" fmla="val 25000"/>
-            </a:avLst>
-          </a:prstGeom>
-          <a:solidFill>
-            <a:srgbClr val="5B4BD6"/>
-          </a:solidFill>
-          <a:ln>
-            <a:noFill/>
-          </a:ln>
-          <a:effectLst/>
-        </p:spPr>
-        <p:txBody>
-          <a:bodyPr rtlCol="0" anchor="ctr"/>
-          <a:lstStyle/>
-          <a:p>
-            <a:pPr algn="ctr"/>
-          </a:p>
-        </p:txBody>
-      </p:sp>
-      <p:sp>
-        <p:nvSpPr>
-          <p:cNvPr id="22" name="Text"/>
-          <p:cNvSpPr txBox="1"/>
-          <p:nvPr/>
-        </p:nvSpPr>
-        <p:spPr>
-          <a:xfrm>
-            <a:off x="6680200" y="3168273"/>
-            <a:ext cx="4682998" cy="291465"/>
-          </a:xfrm>
-          <a:prstGeom prst="rect">
-            <a:avLst/>
-          </a:prstGeom>
-          <a:noFill/>
-        </p:spPr>
-        <p:txBody>
-          <a:bodyPr wrap="square" lIns="0" rIns="0" tIns="0" bIns="0" anchor="t">
-            <a:noAutofit/>
-          </a:bodyPr>
-          <a:lstStyle/>
-          <a:p>
-            <a:pPr algn="l">
-              <a:lnSpc>
-                <a:spcPts val="2295"/>
-              </a:lnSpc>
-              <a:spcBef>
-                <a:spcPts val="0"/>
-              </a:spcBef>
-              <a:spcAft>
-                <a:spcPts val="0"/>
-              </a:spcAft>
-            </a:pPr>
-            <a:r>
-              <a:rPr sz="1700" b="0" i="0">
-                <a:solidFill>
-                  <a:srgbClr val="1D2433"/>
-                </a:solidFill>
-                <a:latin typeface="Noto Sans"/>
-              </a:rPr>
-              <a:t>Rules on a long notice board</a:t>
-            </a:r>
-          </a:p>
-        </p:txBody>
-      </p:sp>
-      <p:sp>
-        <p:nvSpPr>
-          <p:cNvPr id="23" name="Box"/>
-          <p:cNvSpPr/>
-          <p:nvPr/>
-        </p:nvSpPr>
-        <p:spPr>
-          <a:xfrm>
-            <a:off x="6413500" y="3656211"/>
-            <a:ext cx="101600" cy="101600"/>
-          </a:xfrm>
-          <a:prstGeom prst="roundRect">
-            <a:avLst>
-              <a:gd name="adj" fmla="val 25000"/>
-            </a:avLst>
-          </a:prstGeom>
-          <a:solidFill>
-            <a:srgbClr val="5B4BD6"/>
-          </a:solidFill>
-          <a:ln>
-            <a:noFill/>
-          </a:ln>
-          <a:effectLst/>
-        </p:spPr>
-        <p:txBody>
-          <a:bodyPr rtlCol="0" anchor="ctr"/>
-          <a:lstStyle/>
-          <a:p>
-            <a:pPr algn="ctr"/>
-          </a:p>
-        </p:txBody>
-      </p:sp>
-      <p:sp>
-        <p:nvSpPr>
-          <p:cNvPr id="24" name="Text"/>
-          <p:cNvSpPr txBox="1"/>
-          <p:nvPr/>
-        </p:nvSpPr>
-        <p:spPr>
-          <a:xfrm>
-            <a:off x="6680200" y="3561278"/>
-            <a:ext cx="4682998" cy="291465"/>
-          </a:xfrm>
-          <a:prstGeom prst="rect">
-            <a:avLst/>
-          </a:prstGeom>
-          <a:noFill/>
-        </p:spPr>
-        <p:txBody>
-          <a:bodyPr wrap="square" lIns="0" rIns="0" tIns="0" bIns="0" anchor="t">
-            <a:noAutofit/>
-          </a:bodyPr>
-          <a:lstStyle/>
-          <a:p>
-            <a:pPr algn="l">
-              <a:lnSpc>
-                <a:spcPts val="2295"/>
-              </a:lnSpc>
-              <a:spcBef>
-                <a:spcPts val="0"/>
-              </a:spcBef>
-              <a:spcAft>
-                <a:spcPts val="0"/>
-              </a:spcAft>
-            </a:pPr>
-            <a:r>
-              <a:rPr sz="1700" b="0" i="0">
-                <a:solidFill>
-                  <a:srgbClr val="1D2433"/>
-                </a:solidFill>
-                <a:latin typeface="Noto Sans"/>
-              </a:rPr>
-              <a:t>Fines nobody collects</a:t>
-            </a:r>
-          </a:p>
-        </p:txBody>
-      </p:sp>
-      <p:sp>
-        <p:nvSpPr>
-          <p:cNvPr id="25" name="Box"/>
-          <p:cNvSpPr/>
-          <p:nvPr/>
-        </p:nvSpPr>
-        <p:spPr>
-          <a:xfrm>
-            <a:off x="6413500" y="4049216"/>
-            <a:ext cx="101600" cy="101600"/>
-          </a:xfrm>
-          <a:prstGeom prst="roundRect">
-            <a:avLst>
-              <a:gd name="adj" fmla="val 25000"/>
-            </a:avLst>
-          </a:prstGeom>
-          <a:solidFill>
-            <a:srgbClr val="5B4BD6"/>
-          </a:solidFill>
-          <a:ln>
-            <a:noFill/>
-          </a:ln>
-          <a:effectLst/>
-        </p:spPr>
-        <p:txBody>
-          <a:bodyPr rtlCol="0" anchor="ctr"/>
-          <a:lstStyle/>
-          <a:p>
-            <a:pPr algn="ctr"/>
-          </a:p>
-        </p:txBody>
-      </p:sp>
-      <p:sp>
-        <p:nvSpPr>
-          <p:cNvPr id="26" name="Text"/>
-          <p:cNvSpPr txBox="1"/>
-          <p:nvPr/>
-        </p:nvSpPr>
-        <p:spPr>
-          <a:xfrm>
-            <a:off x="6680200" y="3954284"/>
-            <a:ext cx="4682998" cy="291465"/>
-          </a:xfrm>
-          <a:prstGeom prst="rect">
-            <a:avLst/>
-          </a:prstGeom>
-          <a:noFill/>
-        </p:spPr>
-        <p:txBody>
-          <a:bodyPr wrap="square" lIns="0" rIns="0" tIns="0" bIns="0" anchor="t">
-            <a:noAutofit/>
-          </a:bodyPr>
-          <a:lstStyle/>
-          <a:p>
-            <a:pPr algn="l">
-              <a:lnSpc>
-                <a:spcPts val="2295"/>
-              </a:lnSpc>
-              <a:spcBef>
-                <a:spcPts val="0"/>
-              </a:spcBef>
-              <a:spcAft>
-                <a:spcPts val="0"/>
-              </a:spcAft>
-            </a:pPr>
-            <a:r>
-              <a:rPr sz="1700" b="0" i="0">
-                <a:solidFill>
-                  <a:srgbClr val="1D2433"/>
-                </a:solidFill>
-                <a:latin typeface="Noto Sans"/>
-              </a:rPr>
-              <a:t>Opening whenever someone is free</a:t>
-            </a:r>
-          </a:p>
-        </p:txBody>
-      </p:sp>
-      <p:sp>
-        <p:nvSpPr>
-          <p:cNvPr id="27" name="Box"/>
+              <a:t>A tool hung back clean is the only sign-off it needs.</a:t>
+            </a:r>
+          </a:p>
+        </p:txBody>
+      </p:sp>
+      <p:sp>
+        <p:nvSpPr>
+          <p:cNvPr id="20" name="Box"/>
           <p:cNvSpPr/>
           <p:nvPr/>
         </p:nvSpPr>
@@ -15707,7 +17174,7 @@
       </p:sp>
       <p:sp>
         <p:nvSpPr>
-          <p:cNvPr id="28" name="Text"/>
+          <p:cNvPr id="21" name="Text"/>
           <p:cNvSpPr txBox="1"/>
           <p:nvPr/>
         </p:nvSpPr>
@@ -15761,7 +17228,7 @@
       </p:sp>
       <p:sp>
         <p:nvSpPr>
-          <p:cNvPr id="29" name="Text"/>
+          <p:cNvPr id="22" name="Text"/>
           <p:cNvSpPr txBox="1"/>
           <p:nvPr/>
         </p:nvSpPr>
@@ -15799,7 +17266,7 @@
                 </a:solidFill>
                 <a:latin typeface="Noto Sans"/>
               </a:rPr>
-              <a:t>9 / 12</a:t>
+              <a:t>9 / 13</a:t>
             </a:r>
           </a:p>
         </p:txBody>

</xml_diff>